<commit_message>
slides: settle section 1; slide 5 as points, outline is the master
Slide 5 drops its table for four points: what the solver, the supervised
network and ours each optimise, and the shared test. Slide 2's loss links
now use the same box style as the model diagram. The outline records each
settled slide and states that the deck is rebuilt from it.
</commit_message>
<xml_diff>
--- a/slides/DEM_deck_v2.pptx
+++ b/slides/DEM_deck_v2.pptx
@@ -9896,7 +9896,7 @@
         </p:nvSpPr>
         <p:spPr>
           <a:xfrm>
-            <a:off x="365760" y="1563624"/>
+            <a:off x="365760" y="1536192"/>
             <a:ext cx="1325880" cy="548640"/>
           </a:xfrm>
           <a:prstGeom prst="rect">
@@ -9949,8 +9949,8 @@
         </p:nvSpPr>
         <p:spPr>
           <a:xfrm>
-            <a:off x="1783080" y="1508760"/>
-            <a:ext cx="1115568" cy="603504"/>
+            <a:off x="1783080" y="1463040"/>
+            <a:ext cx="1051560" cy="640080"/>
           </a:xfrm>
           <a:prstGeom prst="roundRect">
             <a:avLst>
@@ -10014,8 +10014,8 @@
         </p:nvSpPr>
         <p:spPr>
           <a:xfrm>
-            <a:off x="3172968" y="1508760"/>
-            <a:ext cx="1115568" cy="603504"/>
+            <a:off x="3090672" y="1463040"/>
+            <a:ext cx="1051560" cy="640080"/>
           </a:xfrm>
           <a:prstGeom prst="roundRect">
             <a:avLst>
@@ -10068,8 +10068,8 @@
         </p:nvSpPr>
         <p:spPr>
           <a:xfrm>
-            <a:off x="4562856" y="1508760"/>
-            <a:ext cx="1115568" cy="603504"/>
+            <a:off x="4398264" y="1463040"/>
+            <a:ext cx="1051560" cy="640080"/>
           </a:xfrm>
           <a:prstGeom prst="roundRect">
             <a:avLst>
@@ -10125,16 +10125,88 @@
           </a:p>
         </p:txBody>
       </p:sp>
+      <p:cxnSp>
+        <p:nvCxnSpPr>
+          <p:cNvPr id="8" name="Connector 7"/>
+          <p:cNvCxnSpPr/>
+          <p:nvPr/>
+        </p:nvCxnSpPr>
+        <p:spPr>
+          <a:xfrm>
+            <a:off x="2834640" y="1783080"/>
+            <a:ext cx="256032" cy="0"/>
+          </a:xfrm>
+          <a:prstGeom prst="line">
+            <a:avLst/>
+          </a:prstGeom>
+          <a:ln w="19050">
+            <a:solidFill>
+              <a:srgbClr val="57068C"/>
+            </a:solidFill>
+            <a:tailEnd type="triangle"/>
+          </a:ln>
+        </p:spPr>
+        <p:style>
+          <a:lnRef idx="2">
+            <a:schemeClr val="accent1"/>
+          </a:lnRef>
+          <a:fillRef idx="0">
+            <a:schemeClr val="accent1"/>
+          </a:fillRef>
+          <a:effectRef idx="1">
+            <a:schemeClr val="accent1"/>
+          </a:effectRef>
+          <a:fontRef idx="minor">
+            <a:schemeClr val="tx1"/>
+          </a:fontRef>
+        </p:style>
+      </p:cxnSp>
+      <p:cxnSp>
+        <p:nvCxnSpPr>
+          <p:cNvPr id="9" name="Connector 8"/>
+          <p:cNvCxnSpPr/>
+          <p:nvPr/>
+        </p:nvCxnSpPr>
+        <p:spPr>
+          <a:xfrm>
+            <a:off x="4142232" y="1783080"/>
+            <a:ext cx="256032" cy="0"/>
+          </a:xfrm>
+          <a:prstGeom prst="line">
+            <a:avLst/>
+          </a:prstGeom>
+          <a:ln w="19050">
+            <a:solidFill>
+              <a:srgbClr val="57068C"/>
+            </a:solidFill>
+            <a:tailEnd type="triangle"/>
+          </a:ln>
+        </p:spPr>
+        <p:style>
+          <a:lnRef idx="2">
+            <a:schemeClr val="accent1"/>
+          </a:lnRef>
+          <a:fillRef idx="0">
+            <a:schemeClr val="accent1"/>
+          </a:fillRef>
+          <a:effectRef idx="1">
+            <a:schemeClr val="accent1"/>
+          </a:effectRef>
+          <a:fontRef idx="minor">
+            <a:schemeClr val="tx1"/>
+          </a:fontRef>
+        </p:style>
+      </p:cxnSp>
       <p:sp>
         <p:nvSpPr>
-          <p:cNvPr id="8" name="Rounded Rectangle 7"/>
+          <p:cNvPr id="10" name="Rounded Rectangle 9"/>
           <p:cNvSpPr/>
           <p:nvPr/>
         </p:nvSpPr>
         <p:spPr>
           <a:xfrm>
-            <a:off x="5952744" y="1508760"/>
-            <a:ext cx="1115568" cy="603504"/>
+            <a:off x="6016752" y="1463040"/>
+            <a:ext cx="1051560" cy="640080"/>
           </a:xfrm>
           <a:prstGeom prst="roundRect">
             <a:avLst>
@@ -10192,86 +10264,14 @@
       </p:sp>
       <p:cxnSp>
         <p:nvCxnSpPr>
-          <p:cNvPr id="9" name="Connector 8"/>
-          <p:cNvCxnSpPr/>
-          <p:nvPr/>
-        </p:nvCxnSpPr>
-        <p:spPr>
-          <a:xfrm>
-            <a:off x="2898648" y="1810512"/>
-            <a:ext cx="274320" cy="0"/>
-          </a:xfrm>
-          <a:prstGeom prst="line">
-            <a:avLst/>
-          </a:prstGeom>
-          <a:ln w="19050">
-            <a:solidFill>
-              <a:srgbClr val="57068C"/>
-            </a:solidFill>
-            <a:tailEnd type="triangle"/>
-          </a:ln>
-        </p:spPr>
-        <p:style>
-          <a:lnRef idx="2">
-            <a:schemeClr val="accent1"/>
-          </a:lnRef>
-          <a:fillRef idx="0">
-            <a:schemeClr val="accent1"/>
-          </a:fillRef>
-          <a:effectRef idx="1">
-            <a:schemeClr val="accent1"/>
-          </a:effectRef>
-          <a:fontRef idx="minor">
-            <a:schemeClr val="tx1"/>
-          </a:fontRef>
-        </p:style>
-      </p:cxnSp>
-      <p:cxnSp>
-        <p:nvCxnSpPr>
-          <p:cNvPr id="10" name="Connector 9"/>
-          <p:cNvCxnSpPr/>
-          <p:nvPr/>
-        </p:nvCxnSpPr>
-        <p:spPr>
-          <a:xfrm>
-            <a:off x="4288536" y="1810512"/>
-            <a:ext cx="274320" cy="0"/>
-          </a:xfrm>
-          <a:prstGeom prst="line">
-            <a:avLst/>
-          </a:prstGeom>
-          <a:ln w="19050">
-            <a:solidFill>
-              <a:srgbClr val="57068C"/>
-            </a:solidFill>
-            <a:tailEnd type="triangle"/>
-          </a:ln>
-        </p:spPr>
-        <p:style>
-          <a:lnRef idx="2">
-            <a:schemeClr val="accent1"/>
-          </a:lnRef>
-          <a:fillRef idx="0">
-            <a:schemeClr val="accent1"/>
-          </a:fillRef>
-          <a:effectRef idx="1">
-            <a:schemeClr val="accent1"/>
-          </a:effectRef>
-          <a:fontRef idx="minor">
-            <a:schemeClr val="tx1"/>
-          </a:fontRef>
-        </p:style>
-      </p:cxnSp>
-      <p:cxnSp>
-        <p:nvCxnSpPr>
           <p:cNvPr id="11" name="Connector 10"/>
           <p:cNvCxnSpPr/>
           <p:nvPr/>
         </p:nvCxnSpPr>
         <p:spPr>
           <a:xfrm>
-            <a:off x="5678424" y="1810512"/>
-            <a:ext cx="274320" cy="0"/>
+            <a:off x="5449824" y="1783080"/>
+            <a:ext cx="566928" cy="0"/>
           </a:xfrm>
           <a:prstGeom prst="line">
             <a:avLst/>
@@ -10300,33 +10300,49 @@
       </p:cxnSp>
       <p:sp>
         <p:nvSpPr>
-          <p:cNvPr id="12" name="TextBox 11"/>
-          <p:cNvSpPr txBox="1"/>
+          <p:cNvPr id="12" name="Rounded Rectangle 11"/>
+          <p:cNvSpPr/>
           <p:nvPr/>
         </p:nvSpPr>
         <p:spPr>
           <a:xfrm>
-            <a:off x="5586984" y="1563624"/>
-            <a:ext cx="457200" cy="182880"/>
-          </a:xfrm>
-          <a:prstGeom prst="rect">
-            <a:avLst/>
-          </a:prstGeom>
-          <a:noFill/>
-        </p:spPr>
+            <a:off x="5522976" y="1664208"/>
+            <a:ext cx="420624" cy="237744"/>
+          </a:xfrm>
+          <a:prstGeom prst="roundRect">
+            <a:avLst>
+              <a:gd name="adj" fmla="val 6000"/>
+            </a:avLst>
+          </a:prstGeom>
+          <a:solidFill>
+            <a:srgbClr val="E3DFE9"/>
+          </a:solidFill>
+          <a:ln>
+            <a:noFill/>
+          </a:ln>
+          <a:effectLst/>
+        </p:spPr>
+        <p:style>
+          <a:lnRef idx="1">
+            <a:schemeClr val="accent1"/>
+          </a:lnRef>
+          <a:fillRef idx="3">
+            <a:schemeClr val="accent1"/>
+          </a:fillRef>
+          <a:effectRef idx="2">
+            <a:schemeClr val="accent1"/>
+          </a:effectRef>
+          <a:fontRef idx="minor">
+            <a:schemeClr val="lt1"/>
+          </a:fontRef>
+        </p:style>
         <p:txBody>
-          <a:bodyPr wrap="square" anchor="t" lIns="0" rIns="0" tIns="0" bIns="0">
-            <a:spAutoFit/>
-          </a:bodyPr>
+          <a:bodyPr rtlCol="0" anchor="ctr" lIns="36576" rIns="36576" wrap="square"/>
           <a:lstStyle/>
           <a:p>
-            <a:pPr algn="ctr">
-              <a:spcAft>
-                <a:spcPts val="0"/>
-              </a:spcAft>
-            </a:pPr>
+            <a:pPr algn="ctr"/>
             <a:r>
-              <a:rPr sz="900" b="1" i="0">
+              <a:rPr sz="900" b="1">
                 <a:solidFill>
                   <a:srgbClr val="57068C"/>
                 </a:solidFill>
@@ -10344,7 +10360,7 @@
         </p:nvSpPr>
         <p:spPr>
           <a:xfrm>
-            <a:off x="365760" y="2660904"/>
+            <a:off x="365760" y="2633472"/>
             <a:ext cx="1325880" cy="548640"/>
           </a:xfrm>
           <a:prstGeom prst="rect">
@@ -10397,8 +10413,8 @@
         </p:nvSpPr>
         <p:spPr>
           <a:xfrm>
-            <a:off x="1783080" y="2606040"/>
-            <a:ext cx="1115568" cy="603504"/>
+            <a:off x="1783080" y="2560320"/>
+            <a:ext cx="1051560" cy="640080"/>
           </a:xfrm>
           <a:prstGeom prst="roundRect">
             <a:avLst>
@@ -10462,8 +10478,8 @@
         </p:nvSpPr>
         <p:spPr>
           <a:xfrm>
-            <a:off x="3172968" y="2606040"/>
-            <a:ext cx="1115568" cy="603504"/>
+            <a:off x="3090672" y="2560320"/>
+            <a:ext cx="1051560" cy="640080"/>
           </a:xfrm>
           <a:prstGeom prst="roundRect">
             <a:avLst>
@@ -10516,8 +10532,8 @@
         </p:nvSpPr>
         <p:spPr>
           <a:xfrm>
-            <a:off x="4562856" y="2606040"/>
-            <a:ext cx="1115568" cy="603504"/>
+            <a:off x="4398264" y="2560320"/>
+            <a:ext cx="1051560" cy="640080"/>
           </a:xfrm>
           <a:prstGeom prst="roundRect">
             <a:avLst>
@@ -10581,8 +10597,8 @@
         </p:nvSpPr>
         <p:spPr>
           <a:xfrm>
-            <a:off x="5952744" y="2606040"/>
-            <a:ext cx="1115568" cy="603504"/>
+            <a:off x="5705856" y="2560320"/>
+            <a:ext cx="1051560" cy="640080"/>
           </a:xfrm>
           <a:prstGeom prst="roundRect">
             <a:avLst>
@@ -10638,16 +10654,124 @@
           </a:p>
         </p:txBody>
       </p:sp>
+      <p:cxnSp>
+        <p:nvCxnSpPr>
+          <p:cNvPr id="18" name="Connector 17"/>
+          <p:cNvCxnSpPr/>
+          <p:nvPr/>
+        </p:nvCxnSpPr>
+        <p:spPr>
+          <a:xfrm>
+            <a:off x="2834640" y="2880360"/>
+            <a:ext cx="256032" cy="0"/>
+          </a:xfrm>
+          <a:prstGeom prst="line">
+            <a:avLst/>
+          </a:prstGeom>
+          <a:ln w="19050">
+            <a:solidFill>
+              <a:srgbClr val="57068C"/>
+            </a:solidFill>
+            <a:tailEnd type="triangle"/>
+          </a:ln>
+        </p:spPr>
+        <p:style>
+          <a:lnRef idx="2">
+            <a:schemeClr val="accent1"/>
+          </a:lnRef>
+          <a:fillRef idx="0">
+            <a:schemeClr val="accent1"/>
+          </a:fillRef>
+          <a:effectRef idx="1">
+            <a:schemeClr val="accent1"/>
+          </a:effectRef>
+          <a:fontRef idx="minor">
+            <a:schemeClr val="tx1"/>
+          </a:fontRef>
+        </p:style>
+      </p:cxnSp>
+      <p:cxnSp>
+        <p:nvCxnSpPr>
+          <p:cNvPr id="19" name="Connector 18"/>
+          <p:cNvCxnSpPr/>
+          <p:nvPr/>
+        </p:nvCxnSpPr>
+        <p:spPr>
+          <a:xfrm>
+            <a:off x="4142232" y="2880360"/>
+            <a:ext cx="256032" cy="0"/>
+          </a:xfrm>
+          <a:prstGeom prst="line">
+            <a:avLst/>
+          </a:prstGeom>
+          <a:ln w="19050">
+            <a:solidFill>
+              <a:srgbClr val="57068C"/>
+            </a:solidFill>
+            <a:tailEnd type="triangle"/>
+          </a:ln>
+        </p:spPr>
+        <p:style>
+          <a:lnRef idx="2">
+            <a:schemeClr val="accent1"/>
+          </a:lnRef>
+          <a:fillRef idx="0">
+            <a:schemeClr val="accent1"/>
+          </a:fillRef>
+          <a:effectRef idx="1">
+            <a:schemeClr val="accent1"/>
+          </a:effectRef>
+          <a:fontRef idx="minor">
+            <a:schemeClr val="tx1"/>
+          </a:fontRef>
+        </p:style>
+      </p:cxnSp>
+      <p:cxnSp>
+        <p:nvCxnSpPr>
+          <p:cNvPr id="20" name="Connector 19"/>
+          <p:cNvCxnSpPr/>
+          <p:nvPr/>
+        </p:nvCxnSpPr>
+        <p:spPr>
+          <a:xfrm>
+            <a:off x="5449824" y="2880360"/>
+            <a:ext cx="256032" cy="0"/>
+          </a:xfrm>
+          <a:prstGeom prst="line">
+            <a:avLst/>
+          </a:prstGeom>
+          <a:ln w="19050">
+            <a:solidFill>
+              <a:srgbClr val="57068C"/>
+            </a:solidFill>
+            <a:tailEnd type="triangle"/>
+          </a:ln>
+        </p:spPr>
+        <p:style>
+          <a:lnRef idx="2">
+            <a:schemeClr val="accent1"/>
+          </a:lnRef>
+          <a:fillRef idx="0">
+            <a:schemeClr val="accent1"/>
+          </a:fillRef>
+          <a:effectRef idx="1">
+            <a:schemeClr val="accent1"/>
+          </a:effectRef>
+          <a:fontRef idx="minor">
+            <a:schemeClr val="tx1"/>
+          </a:fontRef>
+        </p:style>
+      </p:cxnSp>
       <p:sp>
         <p:nvSpPr>
-          <p:cNvPr id="18" name="Rounded Rectangle 17"/>
+          <p:cNvPr id="21" name="Rounded Rectangle 20"/>
           <p:cNvSpPr/>
           <p:nvPr/>
         </p:nvSpPr>
         <p:spPr>
           <a:xfrm>
-            <a:off x="7342632" y="2606040"/>
-            <a:ext cx="1115568" cy="603504"/>
+            <a:off x="7324344" y="2560320"/>
+            <a:ext cx="1051560" cy="640080"/>
           </a:xfrm>
           <a:prstGeom prst="roundRect">
             <a:avLst>
@@ -10690,116 +10814,19 @@
               <a:t>Observed AIA</a:t>
             </a:r>
           </a:p>
+          <a:p>
+            <a:pPr algn="ctr"/>
+            <a:r>
+              <a:rPr sz="900">
+                <a:solidFill>
+                  <a:srgbClr val="333333"/>
+                </a:solidFill>
+              </a:rPr>
+              <a:t>6 channels</a:t>
+            </a:r>
+          </a:p>
         </p:txBody>
       </p:sp>
-      <p:cxnSp>
-        <p:nvCxnSpPr>
-          <p:cNvPr id="19" name="Connector 18"/>
-          <p:cNvCxnSpPr/>
-          <p:nvPr/>
-        </p:nvCxnSpPr>
-        <p:spPr>
-          <a:xfrm>
-            <a:off x="2898648" y="2907792"/>
-            <a:ext cx="274320" cy="0"/>
-          </a:xfrm>
-          <a:prstGeom prst="line">
-            <a:avLst/>
-          </a:prstGeom>
-          <a:ln w="19050">
-            <a:solidFill>
-              <a:srgbClr val="57068C"/>
-            </a:solidFill>
-            <a:tailEnd type="triangle"/>
-          </a:ln>
-        </p:spPr>
-        <p:style>
-          <a:lnRef idx="2">
-            <a:schemeClr val="accent1"/>
-          </a:lnRef>
-          <a:fillRef idx="0">
-            <a:schemeClr val="accent1"/>
-          </a:fillRef>
-          <a:effectRef idx="1">
-            <a:schemeClr val="accent1"/>
-          </a:effectRef>
-          <a:fontRef idx="minor">
-            <a:schemeClr val="tx1"/>
-          </a:fontRef>
-        </p:style>
-      </p:cxnSp>
-      <p:cxnSp>
-        <p:nvCxnSpPr>
-          <p:cNvPr id="20" name="Connector 19"/>
-          <p:cNvCxnSpPr/>
-          <p:nvPr/>
-        </p:nvCxnSpPr>
-        <p:spPr>
-          <a:xfrm>
-            <a:off x="4288536" y="2907792"/>
-            <a:ext cx="274320" cy="0"/>
-          </a:xfrm>
-          <a:prstGeom prst="line">
-            <a:avLst/>
-          </a:prstGeom>
-          <a:ln w="19050">
-            <a:solidFill>
-              <a:srgbClr val="57068C"/>
-            </a:solidFill>
-            <a:tailEnd type="triangle"/>
-          </a:ln>
-        </p:spPr>
-        <p:style>
-          <a:lnRef idx="2">
-            <a:schemeClr val="accent1"/>
-          </a:lnRef>
-          <a:fillRef idx="0">
-            <a:schemeClr val="accent1"/>
-          </a:fillRef>
-          <a:effectRef idx="1">
-            <a:schemeClr val="accent1"/>
-          </a:effectRef>
-          <a:fontRef idx="minor">
-            <a:schemeClr val="tx1"/>
-          </a:fontRef>
-        </p:style>
-      </p:cxnSp>
-      <p:cxnSp>
-        <p:nvCxnSpPr>
-          <p:cNvPr id="21" name="Connector 20"/>
-          <p:cNvCxnSpPr/>
-          <p:nvPr/>
-        </p:nvCxnSpPr>
-        <p:spPr>
-          <a:xfrm>
-            <a:off x="5678424" y="2907792"/>
-            <a:ext cx="274320" cy="0"/>
-          </a:xfrm>
-          <a:prstGeom prst="line">
-            <a:avLst/>
-          </a:prstGeom>
-          <a:ln w="19050">
-            <a:solidFill>
-              <a:srgbClr val="57068C"/>
-            </a:solidFill>
-            <a:tailEnd type="triangle"/>
-          </a:ln>
-        </p:spPr>
-        <p:style>
-          <a:lnRef idx="2">
-            <a:schemeClr val="accent1"/>
-          </a:lnRef>
-          <a:fillRef idx="0">
-            <a:schemeClr val="accent1"/>
-          </a:fillRef>
-          <a:effectRef idx="1">
-            <a:schemeClr val="accent1"/>
-          </a:effectRef>
-          <a:fontRef idx="minor">
-            <a:schemeClr val="tx1"/>
-          </a:fontRef>
-        </p:style>
-      </p:cxnSp>
       <p:cxnSp>
         <p:nvCxnSpPr>
           <p:cNvPr id="22" name="Connector 21"/>
@@ -10808,8 +10835,8 @@
         </p:nvCxnSpPr>
         <p:spPr>
           <a:xfrm>
-            <a:off x="7068312" y="2907792"/>
-            <a:ext cx="274320" cy="0"/>
+            <a:off x="6757416" y="2880360"/>
+            <a:ext cx="566928" cy="0"/>
           </a:xfrm>
           <a:prstGeom prst="line">
             <a:avLst/>
@@ -10838,33 +10865,49 @@
       </p:cxnSp>
       <p:sp>
         <p:nvSpPr>
-          <p:cNvPr id="23" name="TextBox 22"/>
-          <p:cNvSpPr txBox="1"/>
+          <p:cNvPr id="23" name="Rounded Rectangle 22"/>
+          <p:cNvSpPr/>
           <p:nvPr/>
         </p:nvSpPr>
         <p:spPr>
           <a:xfrm>
-            <a:off x="6976872" y="2660904"/>
-            <a:ext cx="457200" cy="182880"/>
-          </a:xfrm>
-          <a:prstGeom prst="rect">
-            <a:avLst/>
-          </a:prstGeom>
-          <a:noFill/>
-        </p:spPr>
+            <a:off x="6830568" y="2761488"/>
+            <a:ext cx="420624" cy="237744"/>
+          </a:xfrm>
+          <a:prstGeom prst="roundRect">
+            <a:avLst>
+              <a:gd name="adj" fmla="val 6000"/>
+            </a:avLst>
+          </a:prstGeom>
+          <a:solidFill>
+            <a:srgbClr val="E3DFE9"/>
+          </a:solidFill>
+          <a:ln>
+            <a:noFill/>
+          </a:ln>
+          <a:effectLst/>
+        </p:spPr>
+        <p:style>
+          <a:lnRef idx="1">
+            <a:schemeClr val="accent1"/>
+          </a:lnRef>
+          <a:fillRef idx="3">
+            <a:schemeClr val="accent1"/>
+          </a:fillRef>
+          <a:effectRef idx="2">
+            <a:schemeClr val="accent1"/>
+          </a:effectRef>
+          <a:fontRef idx="minor">
+            <a:schemeClr val="lt1"/>
+          </a:fontRef>
+        </p:style>
         <p:txBody>
-          <a:bodyPr wrap="square" anchor="t" lIns="0" rIns="0" tIns="0" bIns="0">
-            <a:spAutoFit/>
-          </a:bodyPr>
+          <a:bodyPr rtlCol="0" anchor="ctr" lIns="36576" rIns="36576" wrap="square"/>
           <a:lstStyle/>
           <a:p>
-            <a:pPr algn="ctr">
-              <a:spcAft>
-                <a:spcPts val="0"/>
-              </a:spcAft>
-            </a:pPr>
+            <a:pPr algn="ctr"/>
             <a:r>
-              <a:rPr sz="900" b="1" i="0">
+              <a:rPr sz="900" b="1">
                 <a:solidFill>
                   <a:srgbClr val="57068C"/>
                 </a:solidFill>
@@ -10882,7 +10925,7 @@
         </p:nvSpPr>
         <p:spPr>
           <a:xfrm>
-            <a:off x="365760" y="3611880"/>
+            <a:off x="365760" y="3566160"/>
             <a:ext cx="8412480" cy="457200"/>
           </a:xfrm>
           <a:prstGeom prst="rect">
@@ -12500,626 +12543,16 @@
           </a:p>
         </p:txBody>
       </p:sp>
-      <p:graphicFrame>
-        <p:nvGraphicFramePr>
-          <p:cNvPr id="3" name="Table 2"/>
-          <p:cNvGraphicFramePr>
-            <a:graphicFrameLocks noGrp="1"/>
-          </p:cNvGraphicFramePr>
-          <p:nvPr/>
-        </p:nvGraphicFramePr>
-        <p:xfrm>
-          <a:off x="365760" y="960120"/>
-          <a:ext cx="8412480" cy="2011680"/>
-        </p:xfrm>
-        <a:graphic>
-          <a:graphicData uri="http://schemas.openxmlformats.org/drawingml/2006/table">
-            <a:tbl>
-              <a:tblPr firstRow="1" bandRow="1"/>
-              <a:tblGrid>
-                <a:gridCol w="1577340"/>
-                <a:gridCol w="2208276"/>
-                <a:gridCol w="2103120"/>
-                <a:gridCol w="2523744"/>
-              </a:tblGrid>
-              <a:tr h="502920">
-                <a:tc>
-                  <a:txBody>
-                    <a:bodyPr wrap="square"/>
-                    <a:lstStyle/>
-                    <a:p>
-                      <a:pPr algn="l"/>
-                      <a:r>
-                        <a:rPr sz="1100" b="1">
-                          <a:solidFill>
-                            <a:srgbClr val="FFFFFF"/>
-                          </a:solidFill>
-                        </a:rPr>
-                        <a:t/>
-                      </a:r>
-                    </a:p>
-                  </a:txBody>
-                  <a:tcPr marL="54864" marR="54864" marT="27432" marB="27432" anchor="ctr">
-                    <a:lnL w="0">
-                      <a:noFill/>
-                    </a:lnL>
-                    <a:lnR w="0">
-                      <a:noFill/>
-                    </a:lnR>
-                    <a:lnT w="0">
-                      <a:noFill/>
-                    </a:lnT>
-                    <a:lnB w="6350">
-                      <a:solidFill>
-                        <a:srgbClr val="D9D3E3"/>
-                      </a:solidFill>
-                    </a:lnB>
-                    <a:solidFill>
-                      <a:srgbClr val="57068C"/>
-                    </a:solidFill>
-                  </a:tcPr>
-                </a:tc>
-                <a:tc>
-                  <a:txBody>
-                    <a:bodyPr wrap="square"/>
-                    <a:lstStyle/>
-                    <a:p>
-                      <a:pPr algn="l"/>
-                      <a:r>
-                        <a:rPr sz="1100" b="1">
-                          <a:solidFill>
-                            <a:srgbClr val="FFFFFF"/>
-                          </a:solidFill>
-                        </a:rPr>
-                        <a:t>Solver (BP, ElasticNet)</a:t>
-                      </a:r>
-                    </a:p>
-                  </a:txBody>
-                  <a:tcPr marL="54864" marR="54864" marT="27432" marB="27432" anchor="ctr">
-                    <a:lnL w="0">
-                      <a:noFill/>
-                    </a:lnL>
-                    <a:lnR w="0">
-                      <a:noFill/>
-                    </a:lnR>
-                    <a:lnT w="0">
-                      <a:noFill/>
-                    </a:lnT>
-                    <a:lnB w="6350">
-                      <a:solidFill>
-                        <a:srgbClr val="D9D3E3"/>
-                      </a:solidFill>
-                    </a:lnB>
-                    <a:solidFill>
-                      <a:srgbClr val="57068C"/>
-                    </a:solidFill>
-                  </a:tcPr>
-                </a:tc>
-                <a:tc>
-                  <a:txBody>
-                    <a:bodyPr wrap="square"/>
-                    <a:lstStyle/>
-                    <a:p>
-                      <a:pPr algn="l"/>
-                      <a:r>
-                        <a:rPr sz="1100" b="1">
-                          <a:solidFill>
-                            <a:srgbClr val="FFFFFF"/>
-                          </a:solidFill>
-                        </a:rPr>
-                        <a:t>Supervised network</a:t>
-                      </a:r>
-                    </a:p>
-                  </a:txBody>
-                  <a:tcPr marL="54864" marR="54864" marT="27432" marB="27432" anchor="ctr">
-                    <a:lnL w="0">
-                      <a:noFill/>
-                    </a:lnL>
-                    <a:lnR w="0">
-                      <a:noFill/>
-                    </a:lnR>
-                    <a:lnT w="0">
-                      <a:noFill/>
-                    </a:lnT>
-                    <a:lnB w="6350">
-                      <a:solidFill>
-                        <a:srgbClr val="D9D3E3"/>
-                      </a:solidFill>
-                    </a:lnB>
-                    <a:solidFill>
-                      <a:srgbClr val="57068C"/>
-                    </a:solidFill>
-                  </a:tcPr>
-                </a:tc>
-                <a:tc>
-                  <a:txBody>
-                    <a:bodyPr wrap="square"/>
-                    <a:lstStyle/>
-                    <a:p>
-                      <a:pPr algn="l"/>
-                      <a:r>
-                        <a:rPr sz="1100" b="1">
-                          <a:solidFill>
-                            <a:srgbClr val="FFFFFF"/>
-                          </a:solidFill>
-                        </a:rPr>
-                        <a:t>Label-free network (ours)</a:t>
-                      </a:r>
-                    </a:p>
-                  </a:txBody>
-                  <a:tcPr marL="54864" marR="54864" marT="27432" marB="27432" anchor="ctr">
-                    <a:lnL w="0">
-                      <a:noFill/>
-                    </a:lnL>
-                    <a:lnR w="0">
-                      <a:noFill/>
-                    </a:lnR>
-                    <a:lnT w="0">
-                      <a:noFill/>
-                    </a:lnT>
-                    <a:lnB w="6350">
-                      <a:solidFill>
-                        <a:srgbClr val="D9D3E3"/>
-                      </a:solidFill>
-                    </a:lnB>
-                    <a:solidFill>
-                      <a:srgbClr val="57068C"/>
-                    </a:solidFill>
-                  </a:tcPr>
-                </a:tc>
-              </a:tr>
-              <a:tr h="502920">
-                <a:tc>
-                  <a:txBody>
-                    <a:bodyPr wrap="square"/>
-                    <a:lstStyle/>
-                    <a:p>
-                      <a:pPr algn="l"/>
-                      <a:r>
-                        <a:rPr sz="1100" b="1">
-                          <a:solidFill>
-                            <a:srgbClr val="333333"/>
-                          </a:solidFill>
-                        </a:rPr>
-                        <a:t>How it gets a DEM</a:t>
-                      </a:r>
-                    </a:p>
-                  </a:txBody>
-                  <a:tcPr marL="54864" marR="54864" marT="27432" marB="27432" anchor="ctr">
-                    <a:lnL w="0">
-                      <a:noFill/>
-                    </a:lnL>
-                    <a:lnR w="0">
-                      <a:noFill/>
-                    </a:lnR>
-                    <a:lnT w="0">
-                      <a:noFill/>
-                    </a:lnT>
-                    <a:lnB w="6350">
-                      <a:solidFill>
-                        <a:srgbClr val="D9D3E3"/>
-                      </a:solidFill>
-                    </a:lnB>
-                    <a:solidFill>
-                      <a:srgbClr val="FFFFFF"/>
-                    </a:solidFill>
-                  </a:tcPr>
-                </a:tc>
-                <a:tc>
-                  <a:txBody>
-                    <a:bodyPr wrap="square"/>
-                    <a:lstStyle/>
-                    <a:p>
-                      <a:pPr algn="l"/>
-                      <a:r>
-                        <a:rPr sz="1100" b="0">
-                          <a:solidFill>
-                            <a:srgbClr val="333333"/>
-                          </a:solidFill>
-                        </a:rPr>
-                        <a:t>Optimises the objective, per pixel</a:t>
-                      </a:r>
-                    </a:p>
-                  </a:txBody>
-                  <a:tcPr marL="54864" marR="54864" marT="27432" marB="27432" anchor="ctr">
-                    <a:lnL w="0">
-                      <a:noFill/>
-                    </a:lnL>
-                    <a:lnR w="0">
-                      <a:noFill/>
-                    </a:lnR>
-                    <a:lnT w="0">
-                      <a:noFill/>
-                    </a:lnT>
-                    <a:lnB w="6350">
-                      <a:solidFill>
-                        <a:srgbClr val="D9D3E3"/>
-                      </a:solidFill>
-                    </a:lnB>
-                    <a:solidFill>
-                      <a:srgbClr val="FFFFFF"/>
-                    </a:solidFill>
-                  </a:tcPr>
-                </a:tc>
-                <a:tc>
-                  <a:txBody>
-                    <a:bodyPr wrap="square"/>
-                    <a:lstStyle/>
-                    <a:p>
-                      <a:pPr algn="l"/>
-                      <a:r>
-                        <a:rPr sz="1100" b="0">
-                          <a:solidFill>
-                            <a:srgbClr val="333333"/>
-                          </a:solidFill>
-                        </a:rPr>
-                        <a:t>Predicts the solver's DEM</a:t>
-                      </a:r>
-                    </a:p>
-                  </a:txBody>
-                  <a:tcPr marL="54864" marR="54864" marT="27432" marB="27432" anchor="ctr">
-                    <a:lnL w="0">
-                      <a:noFill/>
-                    </a:lnL>
-                    <a:lnR w="0">
-                      <a:noFill/>
-                    </a:lnR>
-                    <a:lnT w="0">
-                      <a:noFill/>
-                    </a:lnT>
-                    <a:lnB w="6350">
-                      <a:solidFill>
-                        <a:srgbClr val="D9D3E3"/>
-                      </a:solidFill>
-                    </a:lnB>
-                    <a:solidFill>
-                      <a:srgbClr val="FFFFFF"/>
-                    </a:solidFill>
-                  </a:tcPr>
-                </a:tc>
-                <a:tc>
-                  <a:txBody>
-                    <a:bodyPr wrap="square"/>
-                    <a:lstStyle/>
-                    <a:p>
-                      <a:pPr algn="l"/>
-                      <a:r>
-                        <a:rPr sz="1100" b="0">
-                          <a:solidFill>
-                            <a:srgbClr val="333333"/>
-                          </a:solidFill>
-                        </a:rPr>
-                        <a:t>Minimises the solver's objective, learned over all pixels</a:t>
-                      </a:r>
-                    </a:p>
-                  </a:txBody>
-                  <a:tcPr marL="54864" marR="54864" marT="27432" marB="27432" anchor="ctr">
-                    <a:lnL w="0">
-                      <a:noFill/>
-                    </a:lnL>
-                    <a:lnR w="0">
-                      <a:noFill/>
-                    </a:lnR>
-                    <a:lnT w="0">
-                      <a:noFill/>
-                    </a:lnT>
-                    <a:lnB w="6350">
-                      <a:solidFill>
-                        <a:srgbClr val="D9D3E3"/>
-                      </a:solidFill>
-                    </a:lnB>
-                    <a:solidFill>
-                      <a:srgbClr val="FFFFFF"/>
-                    </a:solidFill>
-                  </a:tcPr>
-                </a:tc>
-              </a:tr>
-              <a:tr h="502920">
-                <a:tc>
-                  <a:txBody>
-                    <a:bodyPr wrap="square"/>
-                    <a:lstStyle/>
-                    <a:p>
-                      <a:pPr algn="l"/>
-                      <a:r>
-                        <a:rPr sz="1100" b="1">
-                          <a:solidFill>
-                            <a:srgbClr val="333333"/>
-                          </a:solidFill>
-                        </a:rPr>
-                        <a:t>Trained on solver DEMs</a:t>
-                      </a:r>
-                    </a:p>
-                  </a:txBody>
-                  <a:tcPr marL="54864" marR="54864" marT="27432" marB="27432" anchor="ctr">
-                    <a:lnL w="0">
-                      <a:noFill/>
-                    </a:lnL>
-                    <a:lnR w="0">
-                      <a:noFill/>
-                    </a:lnR>
-                    <a:lnT w="0">
-                      <a:noFill/>
-                    </a:lnT>
-                    <a:lnB w="6350">
-                      <a:solidFill>
-                        <a:srgbClr val="D9D3E3"/>
-                      </a:solidFill>
-                    </a:lnB>
-                    <a:solidFill>
-                      <a:srgbClr val="FFFFFF"/>
-                    </a:solidFill>
-                  </a:tcPr>
-                </a:tc>
-                <a:tc>
-                  <a:txBody>
-                    <a:bodyPr wrap="square"/>
-                    <a:lstStyle/>
-                    <a:p>
-                      <a:pPr algn="l"/>
-                      <a:r>
-                        <a:rPr sz="1100" b="0">
-                          <a:solidFill>
-                            <a:srgbClr val="333333"/>
-                          </a:solidFill>
-                        </a:rPr>
-                        <a:t>No training</a:t>
-                      </a:r>
-                    </a:p>
-                  </a:txBody>
-                  <a:tcPr marL="54864" marR="54864" marT="27432" marB="27432" anchor="ctr">
-                    <a:lnL w="0">
-                      <a:noFill/>
-                    </a:lnL>
-                    <a:lnR w="0">
-                      <a:noFill/>
-                    </a:lnR>
-                    <a:lnT w="0">
-                      <a:noFill/>
-                    </a:lnT>
-                    <a:lnB w="6350">
-                      <a:solidFill>
-                        <a:srgbClr val="D9D3E3"/>
-                      </a:solidFill>
-                    </a:lnB>
-                    <a:solidFill>
-                      <a:srgbClr val="FFFFFF"/>
-                    </a:solidFill>
-                  </a:tcPr>
-                </a:tc>
-                <a:tc>
-                  <a:txBody>
-                    <a:bodyPr wrap="square"/>
-                    <a:lstStyle/>
-                    <a:p>
-                      <a:pPr algn="l"/>
-                      <a:r>
-                        <a:rPr sz="1100" b="0">
-                          <a:solidFill>
-                            <a:srgbClr val="333333"/>
-                          </a:solidFill>
-                        </a:rPr>
-                        <a:t>Yes</a:t>
-                      </a:r>
-                    </a:p>
-                  </a:txBody>
-                  <a:tcPr marL="54864" marR="54864" marT="27432" marB="27432" anchor="ctr">
-                    <a:lnL w="0">
-                      <a:noFill/>
-                    </a:lnL>
-                    <a:lnR w="0">
-                      <a:noFill/>
-                    </a:lnR>
-                    <a:lnT w="0">
-                      <a:noFill/>
-                    </a:lnT>
-                    <a:lnB w="6350">
-                      <a:solidFill>
-                        <a:srgbClr val="D9D3E3"/>
-                      </a:solidFill>
-                    </a:lnB>
-                    <a:solidFill>
-                      <a:srgbClr val="FFFFFF"/>
-                    </a:solidFill>
-                  </a:tcPr>
-                </a:tc>
-                <a:tc>
-                  <a:txBody>
-                    <a:bodyPr wrap="square"/>
-                    <a:lstStyle/>
-                    <a:p>
-                      <a:pPr algn="l"/>
-                      <a:r>
-                        <a:rPr sz="1100" b="0">
-                          <a:solidFill>
-                            <a:srgbClr val="333333"/>
-                          </a:solidFill>
-                        </a:rPr>
-                        <a:t>No</a:t>
-                      </a:r>
-                    </a:p>
-                  </a:txBody>
-                  <a:tcPr marL="54864" marR="54864" marT="27432" marB="27432" anchor="ctr">
-                    <a:lnL w="0">
-                      <a:noFill/>
-                    </a:lnL>
-                    <a:lnR w="0">
-                      <a:noFill/>
-                    </a:lnR>
-                    <a:lnT w="0">
-                      <a:noFill/>
-                    </a:lnT>
-                    <a:lnB w="6350">
-                      <a:solidFill>
-                        <a:srgbClr val="D9D3E3"/>
-                      </a:solidFill>
-                    </a:lnB>
-                    <a:solidFill>
-                      <a:srgbClr val="FFFFFF"/>
-                    </a:solidFill>
-                  </a:tcPr>
-                </a:tc>
-              </a:tr>
-              <a:tr h="502920">
-                <a:tc>
-                  <a:txBody>
-                    <a:bodyPr wrap="square"/>
-                    <a:lstStyle/>
-                    <a:p>
-                      <a:pPr algn="l"/>
-                      <a:r>
-                        <a:rPr sz="1100" b="1">
-                          <a:solidFill>
-                            <a:srgbClr val="333333"/>
-                          </a:solidFill>
-                        </a:rPr>
-                        <a:t>Cost per image</a:t>
-                      </a:r>
-                    </a:p>
-                  </a:txBody>
-                  <a:tcPr marL="54864" marR="54864" marT="27432" marB="27432" anchor="ctr">
-                    <a:lnL w="0">
-                      <a:noFill/>
-                    </a:lnL>
-                    <a:lnR w="0">
-                      <a:noFill/>
-                    </a:lnR>
-                    <a:lnT w="0">
-                      <a:noFill/>
-                    </a:lnT>
-                    <a:lnB w="6350">
-                      <a:solidFill>
-                        <a:srgbClr val="D9D3E3"/>
-                      </a:solidFill>
-                    </a:lnB>
-                    <a:solidFill>
-                      <a:srgbClr val="FFFFFF"/>
-                    </a:solidFill>
-                  </a:tcPr>
-                </a:tc>
-                <a:tc>
-                  <a:txBody>
-                    <a:bodyPr wrap="square"/>
-                    <a:lstStyle/>
-                    <a:p>
-                      <a:pPr algn="l"/>
-                      <a:r>
-                        <a:rPr sz="1100" b="0">
-                          <a:solidFill>
-                            <a:srgbClr val="333333"/>
-                          </a:solidFill>
-                        </a:rPr>
-                        <a:t>One optimisation per pixel</a:t>
-                      </a:r>
-                    </a:p>
-                  </a:txBody>
-                  <a:tcPr marL="54864" marR="54864" marT="27432" marB="27432" anchor="ctr">
-                    <a:lnL w="0">
-                      <a:noFill/>
-                    </a:lnL>
-                    <a:lnR w="0">
-                      <a:noFill/>
-                    </a:lnR>
-                    <a:lnT w="0">
-                      <a:noFill/>
-                    </a:lnT>
-                    <a:lnB w="6350">
-                      <a:solidFill>
-                        <a:srgbClr val="D9D3E3"/>
-                      </a:solidFill>
-                    </a:lnB>
-                    <a:solidFill>
-                      <a:srgbClr val="FFFFFF"/>
-                    </a:solidFill>
-                  </a:tcPr>
-                </a:tc>
-                <a:tc>
-                  <a:txBody>
-                    <a:bodyPr wrap="square"/>
-                    <a:lstStyle/>
-                    <a:p>
-                      <a:pPr algn="l"/>
-                      <a:r>
-                        <a:rPr sz="1100" b="0">
-                          <a:solidFill>
-                            <a:srgbClr val="333333"/>
-                          </a:solidFill>
-                        </a:rPr>
-                        <a:t>One forward pass</a:t>
-                      </a:r>
-                    </a:p>
-                  </a:txBody>
-                  <a:tcPr marL="54864" marR="54864" marT="27432" marB="27432" anchor="ctr">
-                    <a:lnL w="0">
-                      <a:noFill/>
-                    </a:lnL>
-                    <a:lnR w="0">
-                      <a:noFill/>
-                    </a:lnR>
-                    <a:lnT w="0">
-                      <a:noFill/>
-                    </a:lnT>
-                    <a:lnB w="6350">
-                      <a:solidFill>
-                        <a:srgbClr val="D9D3E3"/>
-                      </a:solidFill>
-                    </a:lnB>
-                    <a:solidFill>
-                      <a:srgbClr val="FFFFFF"/>
-                    </a:solidFill>
-                  </a:tcPr>
-                </a:tc>
-                <a:tc>
-                  <a:txBody>
-                    <a:bodyPr wrap="square"/>
-                    <a:lstStyle/>
-                    <a:p>
-                      <a:pPr algn="l"/>
-                      <a:r>
-                        <a:rPr sz="1100" b="0">
-                          <a:solidFill>
-                            <a:srgbClr val="333333"/>
-                          </a:solidFill>
-                        </a:rPr>
-                        <a:t>One forward pass</a:t>
-                      </a:r>
-                    </a:p>
-                  </a:txBody>
-                  <a:tcPr marL="54864" marR="54864" marT="27432" marB="27432" anchor="ctr">
-                    <a:lnL w="0">
-                      <a:noFill/>
-                    </a:lnL>
-                    <a:lnR w="0">
-                      <a:noFill/>
-                    </a:lnR>
-                    <a:lnT w="0">
-                      <a:noFill/>
-                    </a:lnT>
-                    <a:lnB w="6350">
-                      <a:solidFill>
-                        <a:srgbClr val="D9D3E3"/>
-                      </a:solidFill>
-                    </a:lnB>
-                    <a:solidFill>
-                      <a:srgbClr val="FFFFFF"/>
-                    </a:solidFill>
-                  </a:tcPr>
-                </a:tc>
-              </a:tr>
-            </a:tbl>
-          </a:graphicData>
-        </a:graphic>
-      </p:graphicFrame>
       <p:sp>
         <p:nvSpPr>
-          <p:cNvPr id="4" name="TextBox 3"/>
+          <p:cNvPr id="3" name="TextBox 2"/>
           <p:cNvSpPr txBox="1"/>
           <p:nvPr/>
         </p:nvSpPr>
         <p:spPr>
           <a:xfrm>
-            <a:off x="365760" y="3200400"/>
-            <a:ext cx="8412480" cy="1097280"/>
+            <a:off x="365760" y="1005840"/>
+            <a:ext cx="8412480" cy="3017520"/>
           </a:xfrm>
           <a:prstGeom prst="rect">
             <a:avLst/>
@@ -13134,7 +12567,7 @@
           <a:p>
             <a:pPr algn="l" marL="182880" indent="-182880">
               <a:spcAft>
-                <a:spcPts val="600"/>
+                <a:spcPts val="1400"/>
               </a:spcAft>
               <a:buClr>
                 <a:srgbClr val="333333"/>
@@ -13142,18 +12575,26 @@
               <a:buChar char="•"/>
             </a:pPr>
             <a:r>
-              <a:rPr sz="1250" b="0" i="0">
+              <a:rPr sz="1400" b="1" i="0">
+                <a:solidFill>
+                  <a:srgbClr val="57068C"/>
+                </a:solidFill>
+              </a:rPr>
+              <a:t>Solver (BP, ElasticNet): </a:t>
+            </a:r>
+            <a:r>
+              <a:rPr sz="1400" b="0" i="0">
                 <a:solidFill>
                   <a:srgbClr val="333333"/>
                 </a:solidFill>
               </a:rPr>
-              <a:t>Test: 153 days never seen in training, identical pixels for every method.</a:t>
+              <a:t>optimises its objective for each pixel. This is the reference.</a:t>
             </a:r>
           </a:p>
           <a:p>
             <a:pPr algn="l" marL="182880" indent="-182880">
               <a:spcAft>
-                <a:spcPts val="600"/>
+                <a:spcPts val="1400"/>
               </a:spcAft>
               <a:buClr>
                 <a:srgbClr val="333333"/>
@@ -13161,12 +12602,74 @@
               <a:buChar char="•"/>
             </a:pPr>
             <a:r>
-              <a:rPr sz="1250" b="0" i="0">
+              <a:rPr sz="1400" b="1" i="0">
+                <a:solidFill>
+                  <a:srgbClr val="57068C"/>
+                </a:solidFill>
+              </a:rPr>
+              <a:t>Supervised network: </a:t>
+            </a:r>
+            <a:r>
+              <a:rPr sz="1400" b="0" i="0">
                 <a:solidFill>
                   <a:srgbClr val="333333"/>
                 </a:solidFill>
               </a:rPr>
-              <a:t>DEM metrics compare each network with the solver; AIA reconstruction compares all three with the observation.</a:t>
+              <a:t>learns to predict the solver's DEMs, so it needs them as labels.</a:t>
+            </a:r>
+          </a:p>
+          <a:p>
+            <a:pPr algn="l" marL="182880" indent="-182880">
+              <a:spcAft>
+                <a:spcPts val="1400"/>
+              </a:spcAft>
+              <a:buClr>
+                <a:srgbClr val="333333"/>
+              </a:buClr>
+              <a:buChar char="•"/>
+            </a:pPr>
+            <a:r>
+              <a:rPr sz="1400" b="1" i="0">
+                <a:solidFill>
+                  <a:srgbClr val="57068C"/>
+                </a:solidFill>
+              </a:rPr>
+              <a:t>Label-free network (ours): </a:t>
+            </a:r>
+            <a:r>
+              <a:rPr sz="1400" b="0" i="0">
+                <a:solidFill>
+                  <a:srgbClr val="333333"/>
+                </a:solidFill>
+              </a:rPr>
+              <a:t>learns to minimise the solver's objective, with no labels.</a:t>
+            </a:r>
+          </a:p>
+          <a:p>
+            <a:pPr algn="l" marL="182880" indent="-182880">
+              <a:spcAft>
+                <a:spcPts val="1400"/>
+              </a:spcAft>
+              <a:buClr>
+                <a:srgbClr val="333333"/>
+              </a:buClr>
+              <a:buChar char="•"/>
+            </a:pPr>
+            <a:r>
+              <a:rPr sz="1400" b="1" i="0">
+                <a:solidFill>
+                  <a:srgbClr val="57068C"/>
+                </a:solidFill>
+              </a:rPr>
+              <a:t>Same test for all: </a:t>
+            </a:r>
+            <a:r>
+              <a:rPr sz="1400" b="0" i="0">
+                <a:solidFill>
+                  <a:srgbClr val="333333"/>
+                </a:solidFill>
+              </a:rPr>
+              <a:t>153 days never seen in training, identical pixels. DEM metrics against the solver; AIA reconstruction against the observation.</a:t>
             </a:r>
           </a:p>
         </p:txBody>

</xml_diff>

<commit_message>
slides: section 2 draft, the loss comparison
One slide: of five losses optimised directly per pixel, the fit-only ones
reconstruct AIA about 12x better than BP but land about 5x further from its
DEM, while BP's own band and L1 terms reproduce it. Numbers and the
optimiser result go in the notes.
</commit_message>
<xml_diff>
--- a/slides/DEM_deck_v2.pptx
+++ b/slides/DEM_deck_v2.pptx
@@ -13,6 +13,7 @@
     <p:sldId id="258" r:id="rId18"/>
     <p:sldId id="259" r:id="rId19"/>
     <p:sldId id="260" r:id="rId20"/>
+    <p:sldId id="261" r:id="rId21"/>
   </p:sldIdLst>
   <p:sldSz cy="5143500" cx="9144000"/>
   <p:notesSz cx="6858000" cy="9144000"/>
@@ -1030,6 +1031,64 @@
           <a:p>
             <a:r>
               <a:t>Data: 1,223 Hofmeister-deconvolved timestamps, split by day into 917 train, 153 validation and 153 test. The networks never see a test day in training. DEM metrics compare each network with the solver's DEM: MSE, total-emission error and W1. AIA reconstruction compares all three with the observation: MAE and MSE.</a:t>
+            </a:r>
+          </a:p>
+        </p:txBody>
+      </p:sp>
+    </p:spTree>
+  </p:cSld>
+  <p:clrMapOvr>
+    <a:masterClrMapping/>
+  </p:clrMapOvr>
+</p:notes>
+</file>
+
+<file path=ppt/notesSlides/notesSlide6.xml><?xml version="1.0" encoding="utf-8"?>
+<p:notes xmlns:a="http://schemas.openxmlformats.org/drawingml/2006/main" xmlns:p="http://schemas.openxmlformats.org/presentationml/2006/main" xmlns:r="http://schemas.openxmlformats.org/officeDocument/2006/relationships">
+  <p:cSld>
+    <p:spTree>
+      <p:nvGrpSpPr>
+        <p:cNvPr id="1" name=""/>
+        <p:cNvGrpSpPr/>
+        <p:nvPr/>
+      </p:nvGrpSpPr>
+      <p:grpSpPr>
+        <a:xfrm>
+          <a:off x="0" y="0"/>
+          <a:ext cx="0" cy="0"/>
+          <a:chOff x="0" y="0"/>
+          <a:chExt cx="0" cy="0"/>
+        </a:xfrm>
+      </p:grpSpPr>
+      <p:sp>
+        <p:nvSpPr>
+          <p:cNvPr id="2" name="Slide Image Placeholder 1"/>
+          <p:cNvSpPr>
+            <a:spLocks noGrp="1"/>
+          </p:cNvSpPr>
+          <p:nvPr>
+            <p:ph type="sldImg" idx="2"/>
+          </p:nvPr>
+        </p:nvSpPr>
+        <p:spPr/>
+      </p:sp>
+      <p:sp>
+        <p:nvSpPr>
+          <p:cNvPr id="3" name="Notes Placeholder 2"/>
+          <p:cNvSpPr>
+            <a:spLocks noGrp="1"/>
+          </p:cNvSpPr>
+          <p:nvPr>
+            <p:ph type="body" idx="1"/>
+          </p:nvPr>
+        </p:nvSpPr>
+        <p:spPr/>
+        <p:txBody>
+          <a:bodyPr/>
+          <a:lstStyle/>
+          <a:p>
+            <a:r>
+              <a:t>Before any network, five losses optimised directly per pixel on 4 timestamps. Averages: AIA MAE against the observation, BP 5.2, barrier 5.0, barrier plus fit 2.6, fit-only 0.40 to 0.44. DEM MAE against BP: barrier 0.034, barrier plus fit 0.043, fit-only 0.18 to 0.20. W1 on the brightest 5% of pixels: 0.030 and 0.033 against 0.15 to 0.18. Six equations, eighteen unknowns: many DEMs fit within noise, so whatever breaks the tie decides the shape. L-BFGS and Adam reach the same curves; SGD often fails to converge.</a:t>
             </a:r>
           </a:p>
         </p:txBody>
@@ -12682,6 +12741,242 @@
 </p:sld>
 </file>
 
+<file path=ppt/slides/slide6.xml><?xml version="1.0" encoding="utf-8"?>
+<p:sld xmlns:a="http://schemas.openxmlformats.org/drawingml/2006/main" xmlns:p="http://schemas.openxmlformats.org/presentationml/2006/main" xmlns:r="http://schemas.openxmlformats.org/officeDocument/2006/relationships">
+  <p:cSld>
+    <p:spTree>
+      <p:nvGrpSpPr>
+        <p:cNvPr id="1" name=""/>
+        <p:cNvGrpSpPr/>
+        <p:nvPr/>
+      </p:nvGrpSpPr>
+      <p:grpSpPr/>
+      <p:sp>
+        <p:nvSpPr>
+          <p:cNvPr id="2" name="TextBox 1"/>
+          <p:cNvSpPr txBox="1"/>
+          <p:nvPr/>
+        </p:nvSpPr>
+        <p:spPr>
+          <a:xfrm>
+            <a:off x="265176" y="219456"/>
+            <a:ext cx="8503920" cy="566928"/>
+          </a:xfrm>
+          <a:prstGeom prst="rect">
+            <a:avLst/>
+          </a:prstGeom>
+          <a:noFill/>
+        </p:spPr>
+        <p:txBody>
+          <a:bodyPr wrap="square" anchor="t" lIns="0" rIns="0" tIns="0" bIns="0">
+            <a:spAutoFit/>
+          </a:bodyPr>
+          <a:lstStyle/>
+          <a:p>
+            <a:pPr algn="l">
+              <a:spcAft>
+                <a:spcPts val="600"/>
+              </a:spcAft>
+            </a:pPr>
+            <a:r>
+              <a:rPr sz="2000" b="1" i="0">
+                <a:solidFill>
+                  <a:srgbClr val="57068C"/>
+                </a:solidFill>
+              </a:rPr>
+              <a:t>Six channels underdetermine the DEM: the regulariser picks it</a:t>
+            </a:r>
+          </a:p>
+        </p:txBody>
+      </p:sp>
+      <p:sp>
+        <p:nvSpPr>
+          <p:cNvPr id="3" name="TextBox 2"/>
+          <p:cNvSpPr txBox="1"/>
+          <p:nvPr/>
+        </p:nvSpPr>
+        <p:spPr>
+          <a:xfrm>
+            <a:off x="365760" y="914400"/>
+            <a:ext cx="8412480" cy="1371600"/>
+          </a:xfrm>
+          <a:prstGeom prst="rect">
+            <a:avLst/>
+          </a:prstGeom>
+          <a:noFill/>
+        </p:spPr>
+        <p:txBody>
+          <a:bodyPr wrap="square" anchor="t" lIns="0" rIns="0" tIns="0" bIns="0">
+            <a:spAutoFit/>
+          </a:bodyPr>
+          <a:lstStyle/>
+          <a:p>
+            <a:pPr algn="l" marL="182880" indent="-182880">
+              <a:spcAft>
+                <a:spcPts val="500"/>
+              </a:spcAft>
+              <a:buClr>
+                <a:srgbClr val="333333"/>
+              </a:buClr>
+              <a:buChar char="•"/>
+            </a:pPr>
+            <a:r>
+              <a:rPr sz="1250" b="0" i="0">
+                <a:solidFill>
+                  <a:srgbClr val="333333"/>
+                </a:solidFill>
+              </a:rPr>
+              <a:t>Before any network: five losses optimised directly, pixel by pixel, on 4 timestamps, each compared with BP.</a:t>
+            </a:r>
+          </a:p>
+          <a:p>
+            <a:pPr algn="l" marL="182880" indent="-182880">
+              <a:spcAft>
+                <a:spcPts val="500"/>
+              </a:spcAft>
+              <a:buClr>
+                <a:srgbClr val="333333"/>
+              </a:buClr>
+              <a:buChar char="•"/>
+            </a:pPr>
+            <a:r>
+              <a:rPr sz="1250" b="0" i="0">
+                <a:solidFill>
+                  <a:srgbClr val="333333"/>
+                </a:solidFill>
+              </a:rPr>
+              <a:t>Fit-only losses (χ² + smoothness, max entropy, Tikhonov) reconstruct AIA ~12x better than BP, yet land ~5x further from its DEM.</a:t>
+            </a:r>
+          </a:p>
+          <a:p>
+            <a:pPr algn="l" marL="182880" indent="-182880">
+              <a:spcAft>
+                <a:spcPts val="500"/>
+              </a:spcAft>
+              <a:buClr>
+                <a:srgbClr val="333333"/>
+              </a:buClr>
+              <a:buChar char="•"/>
+            </a:pPr>
+            <a:r>
+              <a:rPr sz="1250" b="0" i="0">
+                <a:solidFill>
+                  <a:srgbClr val="333333"/>
+                </a:solidFill>
+              </a:rPr>
+              <a:t>BP's own terms (noise band + L1) land on BP's DEM: MAE 0.03 vs 0.18–0.20.</a:t>
+            </a:r>
+          </a:p>
+        </p:txBody>
+      </p:sp>
+      <p:pic>
+        <p:nvPicPr>
+          <p:cNvPr id="4" name="Picture 3" descr="loss_pixels.png"/>
+          <p:cNvPicPr>
+            <a:picLocks noChangeAspect="1"/>
+          </p:cNvPicPr>
+          <p:nvPr/>
+        </p:nvPicPr>
+        <p:blipFill>
+          <a:blip r:embed="rId3"/>
+          <a:stretch>
+            <a:fillRect/>
+          </a:stretch>
+        </p:blipFill>
+        <p:spPr>
+          <a:xfrm>
+            <a:off x="365760" y="1949398"/>
+            <a:ext cx="8412480" cy="1807060"/>
+          </a:xfrm>
+          <a:prstGeom prst="rect">
+            <a:avLst/>
+          </a:prstGeom>
+        </p:spPr>
+      </p:pic>
+      <p:sp>
+        <p:nvSpPr>
+          <p:cNvPr id="5" name="TextBox 4"/>
+          <p:cNvSpPr txBox="1"/>
+          <p:nvPr/>
+        </p:nvSpPr>
+        <p:spPr>
+          <a:xfrm>
+            <a:off x="365760" y="3794760"/>
+            <a:ext cx="8412480" cy="274320"/>
+          </a:xfrm>
+          <a:prstGeom prst="rect">
+            <a:avLst/>
+          </a:prstGeom>
+          <a:noFill/>
+        </p:spPr>
+        <p:txBody>
+          <a:bodyPr wrap="square" anchor="t" lIns="0" rIns="0" tIns="0" bIns="0">
+            <a:spAutoFit/>
+          </a:bodyPr>
+          <a:lstStyle/>
+          <a:p>
+            <a:pPr algn="l">
+              <a:spcAft>
+                <a:spcPts val="0"/>
+              </a:spcAft>
+            </a:pPr>
+            <a:r>
+              <a:rPr sz="950" b="0" i="1">
+                <a:solidFill>
+                  <a:srgbClr val="6B6B6B"/>
+                </a:solidFill>
+              </a:rPr>
+              <a:t>Two example pixels; BP in black. Legend MAE is AIA reconstruction error.</a:t>
+            </a:r>
+          </a:p>
+        </p:txBody>
+      </p:sp>
+      <p:sp>
+        <p:nvSpPr>
+          <p:cNvPr id="6" name="TextBox 5"/>
+          <p:cNvSpPr txBox="1"/>
+          <p:nvPr/>
+        </p:nvSpPr>
+        <p:spPr>
+          <a:xfrm>
+            <a:off x="365760" y="4114800"/>
+            <a:ext cx="8412480" cy="274320"/>
+          </a:xfrm>
+          <a:prstGeom prst="rect">
+            <a:avLst/>
+          </a:prstGeom>
+          <a:noFill/>
+        </p:spPr>
+        <p:txBody>
+          <a:bodyPr wrap="square" anchor="t" lIns="0" rIns="0" tIns="0" bIns="0">
+            <a:spAutoFit/>
+          </a:bodyPr>
+          <a:lstStyle/>
+          <a:p>
+            <a:pPr algn="l">
+              <a:spcAft>
+                <a:spcPts val="600"/>
+              </a:spcAft>
+            </a:pPr>
+            <a:r>
+              <a:rPr sz="1250" b="1" i="0">
+                <a:solidFill>
+                  <a:srgbClr val="57068C"/>
+                </a:solidFill>
+              </a:rPr>
+              <a:t>So the network has to train on the solver's objective, not on fit.</a:t>
+            </a:r>
+          </a:p>
+        </p:txBody>
+      </p:sp>
+    </p:spTree>
+  </p:cSld>
+  <p:clrMapOvr>
+    <a:masterClrMapping/>
+  </p:clrMapOvr>
+</p:sld>
+</file>
+
 <file path=ppt/theme/theme1.xml><?xml version="1.0" encoding="utf-8"?>
 <a:theme xmlns:a="http://schemas.openxmlformats.org/drawingml/2006/main" xmlns:r="http://schemas.openxmlformats.org/officeDocument/2006/relationships" name="NYU Elegant">
   <a:themeElements>

</xml_diff>

<commit_message>
slides: say why the model predicts basis weights
Both solvers solve for weights on the same 54-function basis and apply
their L1 term to them, so predicting those weights keeps the network in the
solver's space of DEMs. Slide 3 now states this; the notes give the detail.
</commit_message>
<xml_diff>
--- a/slides/DEM_deck_v2.pptx
+++ b/slides/DEM_deck_v2.pptx
@@ -914,7 +914,7 @@
           <a:lstStyle/>
           <a:p>
             <a:r>
-              <a:t>Only the MLP is learned. The basis B and the response R are the same ones the solver uses, so the network searches the same space of DEMs the solver does. Per pixel: six log-intensities in, four hidden layers of 232 with SiLU, 54 non-negative basis weights out; DEM = B times w over 18 bins, logT 5.5 to 7.2; predicted AIA = R times DEM. 176k parameters, one forward pass per pixel.</a:t>
+              <a:t>The solvers never solve for the 18 bins directly: both solve for weights on a fixed basis, a spike and two Gaussians at each bin, and report DEM = B times x. We predict the same weights, so the network searches the same space of DEMs the solver does, and BP's sparsity criterion means the same thing for both. Only the MLP is learned. Per pixel: six log-intensities in, four hidden layers of 232 with SiLU, 54 non-negative basis weights out; DEM = B times w over 18 bins, logT 5.5 to 7.2; predicted AIA = R times DEM. 176k parameters, one forward pass per pixel.</a:t>
             </a:r>
           </a:p>
         </p:txBody>
@@ -11260,7 +11260,7 @@
                   <a:srgbClr val="333333"/>
                 </a:solidFill>
               </a:rPr>
-              <a:t>54, all ≥ 0</a:t>
+              <a:t>54 ≥ 0, as in the solver</a:t>
             </a:r>
           </a:p>
         </p:txBody>
@@ -11708,8 +11708,8 @@
         </p:nvSpPr>
         <p:spPr>
           <a:xfrm>
-            <a:off x="365760" y="3246120"/>
-            <a:ext cx="8412480" cy="1097280"/>
+            <a:off x="365760" y="3154680"/>
+            <a:ext cx="8412480" cy="1280160"/>
           </a:xfrm>
           <a:prstGeom prst="rect">
             <a:avLst/>
@@ -11724,7 +11724,7 @@
           <a:p>
             <a:pPr algn="l" marL="182880" indent="-182880">
               <a:spcAft>
-                <a:spcPts val="600"/>
+                <a:spcPts val="400"/>
               </a:spcAft>
               <a:buClr>
                 <a:srgbClr val="333333"/>
@@ -11732,7 +11732,7 @@
               <a:buChar char="•"/>
             </a:pPr>
             <a:r>
-              <a:rPr sz="1250" b="0" i="0">
+              <a:rPr sz="1200" b="0" i="0">
                 <a:solidFill>
                   <a:srgbClr val="333333"/>
                 </a:solidFill>
@@ -11743,7 +11743,7 @@
           <a:p>
             <a:pPr algn="l" marL="182880" indent="-182880">
               <a:spcAft>
-                <a:spcPts val="600"/>
+                <a:spcPts val="400"/>
               </a:spcAft>
               <a:buClr>
                 <a:srgbClr val="333333"/>
@@ -11751,18 +11751,26 @@
               <a:buChar char="•"/>
             </a:pPr>
             <a:r>
-              <a:rPr sz="1250" b="0" i="0">
+              <a:rPr sz="1200" b="1" i="0">
+                <a:solidFill>
+                  <a:srgbClr val="57068C"/>
+                </a:solidFill>
+              </a:rPr>
+              <a:t>Why weights, not bins: the solvers work this way. </a:t>
+            </a:r>
+            <a:r>
+              <a:rPr sz="1200" b="0" i="0">
                 <a:solidFill>
                   <a:srgbClr val="333333"/>
                 </a:solidFill>
               </a:rPr>
-              <a:t>DEM = B·w and predicted AIA = R·DEM, with B and R fixed: only the MLP is learned.</a:t>
+              <a:t>BP and ElasticNet solve for the same 54 weights (at each of 18 bins, a spike and Gaussians 0.1 and 0.2 dex wide), and their L1 term acts on those weights.</a:t>
             </a:r>
           </a:p>
           <a:p>
             <a:pPr algn="l" marL="182880" indent="-182880">
               <a:spcAft>
-                <a:spcPts val="600"/>
+                <a:spcPts val="400"/>
               </a:spcAft>
               <a:buClr>
                 <a:srgbClr val="333333"/>
@@ -11770,7 +11778,26 @@
               <a:buChar char="•"/>
             </a:pPr>
             <a:r>
-              <a:rPr sz="1250" b="0" i="0">
+              <a:rPr sz="1200" b="0" i="0">
+                <a:solidFill>
+                  <a:srgbClr val="333333"/>
+                </a:solidFill>
+              </a:rPr>
+              <a:t>DEM = B·w over 18 bins; predicted AIA = R·DEM. B and R are fixed; only the MLP is learned.</a:t>
+            </a:r>
+          </a:p>
+          <a:p>
+            <a:pPr algn="l" marL="182880" indent="-182880">
+              <a:spcAft>
+                <a:spcPts val="400"/>
+              </a:spcAft>
+              <a:buClr>
+                <a:srgbClr val="333333"/>
+              </a:buClr>
+              <a:buChar char="•"/>
+            </a:pPr>
+            <a:r>
+              <a:rPr sz="1200" b="0" i="0">
                 <a:solidFill>
                   <a:srgbClr val="333333"/>
                 </a:solidFill>

</xml_diff>

<commit_message>
slides: data slide closes section 1
A to-scale timeline of the chronological split (train Jan 2014 - Jun 2015,
validation to Sep 2015, test to Dec 2015) and five points on the images,
preprocessing, what each model trains on and the test set's size. The loss
comparison moves to slide 7.
</commit_message>
<xml_diff>
--- a/slides/DEM_deck_v2.pptx
+++ b/slides/DEM_deck_v2.pptx
@@ -14,6 +14,7 @@
     <p:sldId id="259" r:id="rId19"/>
     <p:sldId id="260" r:id="rId20"/>
     <p:sldId id="261" r:id="rId21"/>
+    <p:sldId id="262" r:id="rId22"/>
   </p:sldIdLst>
   <p:sldSz cy="5143500" cx="9144000"/>
   <p:notesSz cx="6858000" cy="9144000"/>
@@ -1044,6 +1045,64 @@
 </file>
 
 <file path=ppt/notesSlides/notesSlide6.xml><?xml version="1.0" encoding="utf-8"?>
+<p:notes xmlns:a="http://schemas.openxmlformats.org/drawingml/2006/main" xmlns:p="http://schemas.openxmlformats.org/presentationml/2006/main" xmlns:r="http://schemas.openxmlformats.org/officeDocument/2006/relationships">
+  <p:cSld>
+    <p:spTree>
+      <p:nvGrpSpPr>
+        <p:cNvPr id="1" name=""/>
+        <p:cNvGrpSpPr/>
+        <p:nvPr/>
+      </p:nvGrpSpPr>
+      <p:grpSpPr>
+        <a:xfrm>
+          <a:off x="0" y="0"/>
+          <a:ext cx="0" cy="0"/>
+          <a:chOff x="0" y="0"/>
+          <a:chExt cx="0" cy="0"/>
+        </a:xfrm>
+      </p:grpSpPr>
+      <p:sp>
+        <p:nvSpPr>
+          <p:cNvPr id="2" name="Slide Image Placeholder 1"/>
+          <p:cNvSpPr>
+            <a:spLocks noGrp="1"/>
+          </p:cNvSpPr>
+          <p:nvPr>
+            <p:ph type="sldImg" idx="2"/>
+          </p:nvPr>
+        </p:nvSpPr>
+        <p:spPr/>
+      </p:sp>
+      <p:sp>
+        <p:nvSpPr>
+          <p:cNvPr id="3" name="Notes Placeholder 2"/>
+          <p:cNvSpPr>
+            <a:spLocks noGrp="1"/>
+          </p:cNvSpPr>
+          <p:nvPr>
+            <p:ph type="body" idx="1"/>
+          </p:nvPr>
+        </p:nvSpPr>
+        <p:spPr/>
+        <p:txBody>
+          <a:bodyPr/>
+          <a:lstStyle/>
+          <a:p>
+            <a:r>
+              <a:t>The split is chronological, so every test image is later than anything seen in training. Each epoch draws 512 pixels from each of 58,688 training blocks: 917 images times 64 blocks of 256 squared. The test set uses 64 random 128-squared blocks of each test image per solver target, five targets per image: one clean solve and four re-solves under simulated photon noise of the same observation. Pixels where deconvolution clamped a bright channel to zero, about 5%, are excluded.</a:t>
+            </a:r>
+          </a:p>
+        </p:txBody>
+      </p:sp>
+    </p:spTree>
+  </p:cSld>
+  <p:clrMapOvr>
+    <a:masterClrMapping/>
+  </p:clrMapOvr>
+</p:notes>
+</file>
+
+<file path=ppt/notesSlides/notesSlide7.xml><?xml version="1.0" encoding="utf-8"?>
 <p:notes xmlns:a="http://schemas.openxmlformats.org/drawingml/2006/main" xmlns:p="http://schemas.openxmlformats.org/presentationml/2006/main" xmlns:r="http://schemas.openxmlformats.org/officeDocument/2006/relationships">
   <p:cSld>
     <p:spTree>
@@ -12811,6 +12870,527 @@
                   <a:srgbClr val="57068C"/>
                 </a:solidFill>
               </a:rPr>
+              <a:t>Data: two years of full-disk AIA, split in time</a:t>
+            </a:r>
+          </a:p>
+        </p:txBody>
+      </p:sp>
+      <p:sp>
+        <p:nvSpPr>
+          <p:cNvPr id="3" name="Rounded Rectangle 2"/>
+          <p:cNvSpPr/>
+          <p:nvPr/>
+        </p:nvSpPr>
+        <p:spPr>
+          <a:xfrm>
+            <a:off x="365760" y="1005840"/>
+            <a:ext cx="6067425" cy="566928"/>
+          </a:xfrm>
+          <a:prstGeom prst="roundRect">
+            <a:avLst>
+              <a:gd name="adj" fmla="val 6000"/>
+            </a:avLst>
+          </a:prstGeom>
+          <a:solidFill>
+            <a:srgbClr val="57068C"/>
+          </a:solidFill>
+          <a:ln>
+            <a:noFill/>
+          </a:ln>
+          <a:effectLst/>
+        </p:spPr>
+        <p:style>
+          <a:lnRef idx="1">
+            <a:schemeClr val="accent1"/>
+          </a:lnRef>
+          <a:fillRef idx="3">
+            <a:schemeClr val="accent1"/>
+          </a:fillRef>
+          <a:effectRef idx="2">
+            <a:schemeClr val="accent1"/>
+          </a:effectRef>
+          <a:fontRef idx="minor">
+            <a:schemeClr val="lt1"/>
+          </a:fontRef>
+        </p:style>
+        <p:txBody>
+          <a:bodyPr rtlCol="0" anchor="ctr" lIns="36576" rIns="36576" wrap="square"/>
+          <a:lstStyle/>
+          <a:p>
+            <a:pPr algn="ctr"/>
+            <a:r>
+              <a:rPr sz="1150" b="1">
+                <a:solidFill>
+                  <a:srgbClr val="FFFFFF"/>
+                </a:solidFill>
+              </a:rPr>
+              <a:t>Train</a:t>
+            </a:r>
+          </a:p>
+          <a:p>
+            <a:pPr algn="ctr"/>
+            <a:r>
+              <a:rPr sz="950">
+                <a:solidFill>
+                  <a:srgbClr val="FFFFFF"/>
+                </a:solidFill>
+              </a:rPr>
+              <a:t>917 images</a:t>
+            </a:r>
+          </a:p>
+        </p:txBody>
+      </p:sp>
+      <p:sp>
+        <p:nvSpPr>
+          <p:cNvPr id="4" name="Rounded Rectangle 3"/>
+          <p:cNvSpPr/>
+          <p:nvPr/>
+        </p:nvSpPr>
+        <p:spPr>
+          <a:xfrm>
+            <a:off x="6478905" y="1005840"/>
+            <a:ext cx="1109472" cy="566928"/>
+          </a:xfrm>
+          <a:prstGeom prst="roundRect">
+            <a:avLst>
+              <a:gd name="adj" fmla="val 6000"/>
+            </a:avLst>
+          </a:prstGeom>
+          <a:solidFill>
+            <a:srgbClr val="E3DFE9"/>
+          </a:solidFill>
+          <a:ln>
+            <a:noFill/>
+          </a:ln>
+          <a:effectLst/>
+        </p:spPr>
+        <p:style>
+          <a:lnRef idx="1">
+            <a:schemeClr val="accent1"/>
+          </a:lnRef>
+          <a:fillRef idx="3">
+            <a:schemeClr val="accent1"/>
+          </a:fillRef>
+          <a:effectRef idx="2">
+            <a:schemeClr val="accent1"/>
+          </a:effectRef>
+          <a:fontRef idx="minor">
+            <a:schemeClr val="lt1"/>
+          </a:fontRef>
+        </p:style>
+        <p:txBody>
+          <a:bodyPr rtlCol="0" anchor="ctr" lIns="36576" rIns="36576" wrap="square"/>
+          <a:lstStyle/>
+          <a:p>
+            <a:pPr algn="ctr"/>
+            <a:r>
+              <a:rPr sz="1150" b="1">
+                <a:solidFill>
+                  <a:srgbClr val="57068C"/>
+                </a:solidFill>
+              </a:rPr>
+              <a:t>Validation</a:t>
+            </a:r>
+          </a:p>
+          <a:p>
+            <a:pPr algn="ctr"/>
+            <a:r>
+              <a:rPr sz="950">
+                <a:solidFill>
+                  <a:srgbClr val="57068C"/>
+                </a:solidFill>
+              </a:rPr>
+              <a:t>153</a:t>
+            </a:r>
+          </a:p>
+        </p:txBody>
+      </p:sp>
+      <p:sp>
+        <p:nvSpPr>
+          <p:cNvPr id="5" name="Rounded Rectangle 4"/>
+          <p:cNvSpPr/>
+          <p:nvPr/>
+        </p:nvSpPr>
+        <p:spPr>
+          <a:xfrm>
+            <a:off x="7634097" y="1005840"/>
+            <a:ext cx="1144143" cy="566928"/>
+          </a:xfrm>
+          <a:prstGeom prst="roundRect">
+            <a:avLst>
+              <a:gd name="adj" fmla="val 6000"/>
+            </a:avLst>
+          </a:prstGeom>
+          <a:solidFill>
+            <a:srgbClr val="330662"/>
+          </a:solidFill>
+          <a:ln>
+            <a:noFill/>
+          </a:ln>
+          <a:effectLst/>
+        </p:spPr>
+        <p:style>
+          <a:lnRef idx="1">
+            <a:schemeClr val="accent1"/>
+          </a:lnRef>
+          <a:fillRef idx="3">
+            <a:schemeClr val="accent1"/>
+          </a:fillRef>
+          <a:effectRef idx="2">
+            <a:schemeClr val="accent1"/>
+          </a:effectRef>
+          <a:fontRef idx="minor">
+            <a:schemeClr val="lt1"/>
+          </a:fontRef>
+        </p:style>
+        <p:txBody>
+          <a:bodyPr rtlCol="0" anchor="ctr" lIns="36576" rIns="36576" wrap="square"/>
+          <a:lstStyle/>
+          <a:p>
+            <a:pPr algn="ctr"/>
+            <a:r>
+              <a:rPr sz="1150" b="1">
+                <a:solidFill>
+                  <a:srgbClr val="FFFFFF"/>
+                </a:solidFill>
+              </a:rPr>
+              <a:t>Test</a:t>
+            </a:r>
+          </a:p>
+          <a:p>
+            <a:pPr algn="ctr"/>
+            <a:r>
+              <a:rPr sz="950">
+                <a:solidFill>
+                  <a:srgbClr val="FFFFFF"/>
+                </a:solidFill>
+              </a:rPr>
+              <a:t>153</a:t>
+            </a:r>
+          </a:p>
+        </p:txBody>
+      </p:sp>
+      <p:sp>
+        <p:nvSpPr>
+          <p:cNvPr id="6" name="TextBox 5"/>
+          <p:cNvSpPr txBox="1"/>
+          <p:nvPr/>
+        </p:nvSpPr>
+        <p:spPr>
+          <a:xfrm>
+            <a:off x="365760" y="1618488"/>
+            <a:ext cx="822960" cy="228600"/>
+          </a:xfrm>
+          <a:prstGeom prst="rect">
+            <a:avLst/>
+          </a:prstGeom>
+          <a:noFill/>
+        </p:spPr>
+        <p:txBody>
+          <a:bodyPr wrap="square" anchor="t" lIns="0" rIns="0" tIns="0" bIns="0">
+            <a:spAutoFit/>
+          </a:bodyPr>
+          <a:lstStyle/>
+          <a:p>
+            <a:pPr algn="l">
+              <a:spcAft>
+                <a:spcPts val="600"/>
+              </a:spcAft>
+            </a:pPr>
+            <a:r>
+              <a:rPr sz="950" b="0" i="0">
+                <a:solidFill>
+                  <a:srgbClr val="6B6B6B"/>
+                </a:solidFill>
+              </a:rPr>
+              <a:t>Jan 2014</a:t>
+            </a:r>
+          </a:p>
+        </p:txBody>
+      </p:sp>
+      <p:sp>
+        <p:nvSpPr>
+          <p:cNvPr id="7" name="TextBox 6"/>
+          <p:cNvSpPr txBox="1"/>
+          <p:nvPr/>
+        </p:nvSpPr>
+        <p:spPr>
+          <a:xfrm>
+            <a:off x="6088380" y="1618488"/>
+            <a:ext cx="822960" cy="228600"/>
+          </a:xfrm>
+          <a:prstGeom prst="rect">
+            <a:avLst/>
+          </a:prstGeom>
+          <a:noFill/>
+        </p:spPr>
+        <p:txBody>
+          <a:bodyPr wrap="square" anchor="t" lIns="0" rIns="0" tIns="0" bIns="0">
+            <a:spAutoFit/>
+          </a:bodyPr>
+          <a:lstStyle/>
+          <a:p>
+            <a:pPr algn="ctr">
+              <a:spcAft>
+                <a:spcPts val="600"/>
+              </a:spcAft>
+            </a:pPr>
+            <a:r>
+              <a:rPr sz="950" b="0" i="0">
+                <a:solidFill>
+                  <a:srgbClr val="6B6B6B"/>
+                </a:solidFill>
+              </a:rPr>
+              <a:t>Jun 2015</a:t>
+            </a:r>
+          </a:p>
+        </p:txBody>
+      </p:sp>
+      <p:sp>
+        <p:nvSpPr>
+          <p:cNvPr id="8" name="TextBox 7"/>
+          <p:cNvSpPr txBox="1"/>
+          <p:nvPr/>
+        </p:nvSpPr>
+        <p:spPr>
+          <a:xfrm>
+            <a:off x="7210043" y="1618488"/>
+            <a:ext cx="822960" cy="228600"/>
+          </a:xfrm>
+          <a:prstGeom prst="rect">
+            <a:avLst/>
+          </a:prstGeom>
+          <a:noFill/>
+        </p:spPr>
+        <p:txBody>
+          <a:bodyPr wrap="square" anchor="t" lIns="0" rIns="0" tIns="0" bIns="0">
+            <a:spAutoFit/>
+          </a:bodyPr>
+          <a:lstStyle/>
+          <a:p>
+            <a:pPr algn="ctr">
+              <a:spcAft>
+                <a:spcPts val="600"/>
+              </a:spcAft>
+            </a:pPr>
+            <a:r>
+              <a:rPr sz="950" b="0" i="0">
+                <a:solidFill>
+                  <a:srgbClr val="6B6B6B"/>
+                </a:solidFill>
+              </a:rPr>
+              <a:t>Sep 2015</a:t>
+            </a:r>
+          </a:p>
+        </p:txBody>
+      </p:sp>
+      <p:sp>
+        <p:nvSpPr>
+          <p:cNvPr id="9" name="TextBox 8"/>
+          <p:cNvSpPr txBox="1"/>
+          <p:nvPr/>
+        </p:nvSpPr>
+        <p:spPr>
+          <a:xfrm>
+            <a:off x="7955280" y="1618488"/>
+            <a:ext cx="822960" cy="228600"/>
+          </a:xfrm>
+          <a:prstGeom prst="rect">
+            <a:avLst/>
+          </a:prstGeom>
+          <a:noFill/>
+        </p:spPr>
+        <p:txBody>
+          <a:bodyPr wrap="square" anchor="t" lIns="0" rIns="0" tIns="0" bIns="0">
+            <a:spAutoFit/>
+          </a:bodyPr>
+          <a:lstStyle/>
+          <a:p>
+            <a:pPr algn="r">
+              <a:spcAft>
+                <a:spcPts val="600"/>
+              </a:spcAft>
+            </a:pPr>
+            <a:r>
+              <a:rPr sz="950" b="0" i="0">
+                <a:solidFill>
+                  <a:srgbClr val="6B6B6B"/>
+                </a:solidFill>
+              </a:rPr>
+              <a:t>Dec 2015</a:t>
+            </a:r>
+          </a:p>
+        </p:txBody>
+      </p:sp>
+      <p:sp>
+        <p:nvSpPr>
+          <p:cNvPr id="10" name="TextBox 9"/>
+          <p:cNvSpPr txBox="1"/>
+          <p:nvPr/>
+        </p:nvSpPr>
+        <p:spPr>
+          <a:xfrm>
+            <a:off x="365760" y="2011680"/>
+            <a:ext cx="8412480" cy="2377440"/>
+          </a:xfrm>
+          <a:prstGeom prst="rect">
+            <a:avLst/>
+          </a:prstGeom>
+          <a:noFill/>
+        </p:spPr>
+        <p:txBody>
+          <a:bodyPr wrap="square" anchor="t" lIns="0" rIns="0" tIns="0" bIns="0">
+            <a:spAutoFit/>
+          </a:bodyPr>
+          <a:lstStyle/>
+          <a:p>
+            <a:pPr algn="l" marL="182880" indent="-182880">
+              <a:spcAft>
+                <a:spcPts val="700"/>
+              </a:spcAft>
+              <a:buClr>
+                <a:srgbClr val="333333"/>
+              </a:buClr>
+              <a:buChar char="•"/>
+            </a:pPr>
+            <a:r>
+              <a:rPr sz="1250" b="0" i="0">
+                <a:solidFill>
+                  <a:srgbClr val="333333"/>
+                </a:solidFill>
+              </a:rPr>
+              <a:t>SDO/AIA, 6 EUV channels, about two images a day in 2014–2015: 1,223 full-disk images.</a:t>
+            </a:r>
+          </a:p>
+          <a:p>
+            <a:pPr algn="l" marL="182880" indent="-182880">
+              <a:spcAft>
+                <a:spcPts val="700"/>
+              </a:spcAft>
+              <a:buClr>
+                <a:srgbClr val="333333"/>
+              </a:buClr>
+              <a:buChar char="•"/>
+            </a:pPr>
+            <a:r>
+              <a:rPr sz="1250" b="0" i="0">
+                <a:solidFill>
+                  <a:srgbClr val="333333"/>
+                </a:solidFill>
+              </a:rPr>
+              <a:t>PSF-deconvolved (Hofmeister); a noise σ per pixel and channel from the AIA error model; DEMs on a 2048² grid.</a:t>
+            </a:r>
+          </a:p>
+          <a:p>
+            <a:pPr algn="l" marL="182880" indent="-182880">
+              <a:spcAft>
+                <a:spcPts val="700"/>
+              </a:spcAft>
+              <a:buClr>
+                <a:srgbClr val="333333"/>
+              </a:buClr>
+              <a:buChar char="•"/>
+            </a:pPr>
+            <a:r>
+              <a:rPr sz="1250" b="0" i="0">
+                <a:solidFill>
+                  <a:srgbClr val="333333"/>
+                </a:solidFill>
+              </a:rPr>
+              <a:t>Our model trains on AIA and σ only: ~30M pixels per epoch, 40 epochs.</a:t>
+            </a:r>
+          </a:p>
+          <a:p>
+            <a:pPr algn="l" marL="182880" indent="-182880">
+              <a:spcAft>
+                <a:spcPts val="700"/>
+              </a:spcAft>
+              <a:buClr>
+                <a:srgbClr val="333333"/>
+              </a:buClr>
+              <a:buChar char="•"/>
+            </a:pPr>
+            <a:r>
+              <a:rPr sz="1250" b="0" i="0">
+                <a:solidFill>
+                  <a:srgbClr val="333333"/>
+                </a:solidFill>
+              </a:rPr>
+              <a:t>Solver DEMs (BP, ElasticNet) for every image: labels for the supervised model, evaluation only for ours.</a:t>
+            </a:r>
+          </a:p>
+          <a:p>
+            <a:pPr algn="l" marL="182880" indent="-182880">
+              <a:spcAft>
+                <a:spcPts val="700"/>
+              </a:spcAft>
+              <a:buClr>
+                <a:srgbClr val="333333"/>
+              </a:buClr>
+              <a:buChar char="•"/>
+            </a:pPr>
+            <a:r>
+              <a:rPr sz="1250" b="0" i="0">
+                <a:solidFill>
+                  <a:srgbClr val="333333"/>
+                </a:solidFill>
+              </a:rPr>
+              <a:t>Test: ~700M pixel DEMs per solver, the clean solve plus 4 noise re-solves.</a:t>
+            </a:r>
+          </a:p>
+        </p:txBody>
+      </p:sp>
+    </p:spTree>
+  </p:cSld>
+  <p:clrMapOvr>
+    <a:masterClrMapping/>
+  </p:clrMapOvr>
+</p:sld>
+</file>
+
+<file path=ppt/slides/slide7.xml><?xml version="1.0" encoding="utf-8"?>
+<p:sld xmlns:a="http://schemas.openxmlformats.org/drawingml/2006/main" xmlns:p="http://schemas.openxmlformats.org/presentationml/2006/main" xmlns:r="http://schemas.openxmlformats.org/officeDocument/2006/relationships">
+  <p:cSld>
+    <p:spTree>
+      <p:nvGrpSpPr>
+        <p:cNvPr id="1" name=""/>
+        <p:cNvGrpSpPr/>
+        <p:nvPr/>
+      </p:nvGrpSpPr>
+      <p:grpSpPr/>
+      <p:sp>
+        <p:nvSpPr>
+          <p:cNvPr id="2" name="TextBox 1"/>
+          <p:cNvSpPr txBox="1"/>
+          <p:nvPr/>
+        </p:nvSpPr>
+        <p:spPr>
+          <a:xfrm>
+            <a:off x="265176" y="219456"/>
+            <a:ext cx="8503920" cy="566928"/>
+          </a:xfrm>
+          <a:prstGeom prst="rect">
+            <a:avLst/>
+          </a:prstGeom>
+          <a:noFill/>
+        </p:spPr>
+        <p:txBody>
+          <a:bodyPr wrap="square" anchor="t" lIns="0" rIns="0" tIns="0" bIns="0">
+            <a:spAutoFit/>
+          </a:bodyPr>
+          <a:lstStyle/>
+          <a:p>
+            <a:pPr algn="l">
+              <a:spcAft>
+                <a:spcPts val="600"/>
+              </a:spcAft>
+            </a:pPr>
+            <a:r>
+              <a:rPr sz="2000" b="1" i="0">
+                <a:solidFill>
+                  <a:srgbClr val="57068C"/>
+                </a:solidFill>
+              </a:rPr>
               <a:t>Six channels underdetermine the DEM: the regulariser picks it</a:t>
             </a:r>
           </a:p>

</xml_diff>

<commit_message>
slides: take the Google Slides edits into the outline and build
Part dividers on the template's BIG_NUMBER layout, 'Model' in the training
loops, 'Label-free (unsupervised)', and no '(ours)' or bold lead-in on the
model and routes slides. The data slide, added after that download, stays.
The outline notes that edits made in Google Slides must be copied back
before a rebuild.
</commit_message>
<xml_diff>
--- a/slides/DEM_deck_v2.pptx
+++ b/slides/DEM_deck_v2.pptx
@@ -15,6 +15,8 @@
     <p:sldId id="260" r:id="rId20"/>
     <p:sldId id="261" r:id="rId21"/>
     <p:sldId id="262" r:id="rId22"/>
+    <p:sldId id="263" r:id="rId23"/>
+    <p:sldId id="264" r:id="rId24"/>
   </p:sldIdLst>
   <p:sldSz cy="5143500" cx="9144000"/>
   <p:notesSz cx="6858000" cy="9144000"/>
@@ -9932,1143 +9934,33 @@
       <p:grpSpPr/>
       <p:sp>
         <p:nvSpPr>
-          <p:cNvPr id="2" name="TextBox 1"/>
-          <p:cNvSpPr txBox="1"/>
-          <p:nvPr/>
+          <p:cNvPr id="2" name="Title 1"/>
+          <p:cNvSpPr>
+            <a:spLocks noGrp="1"/>
+          </p:cNvSpPr>
+          <p:nvPr>
+            <p:ph type="title"/>
+          </p:nvPr>
         </p:nvSpPr>
         <p:spPr>
           <a:xfrm>
-            <a:off x="265176" y="219456"/>
-            <a:ext cx="8503920" cy="566928"/>
-          </a:xfrm>
-          <a:prstGeom prst="rect">
-            <a:avLst/>
-          </a:prstGeom>
-          <a:noFill/>
+            <a:off x="311700" y="846450"/>
+            <a:ext cx="8520600" cy="1671000"/>
+          </a:xfrm>
         </p:spPr>
         <p:txBody>
-          <a:bodyPr wrap="square" anchor="t" lIns="0" rIns="0" tIns="0" bIns="0">
-            <a:spAutoFit/>
-          </a:bodyPr>
-          <a:lstStyle/>
-          <a:p>
-            <a:pPr algn="l">
-              <a:spcAft>
-                <a:spcPts val="600"/>
-              </a:spcAft>
-            </a:pPr>
-            <a:r>
-              <a:rPr sz="2000" b="1" i="0">
-                <a:solidFill>
-                  <a:srgbClr val="57068C"/>
-                </a:solidFill>
-              </a:rPr>
-              <a:t>Same physics, different training signal</a:t>
-            </a:r>
-          </a:p>
-        </p:txBody>
-      </p:sp>
-      <p:sp>
-        <p:nvSpPr>
-          <p:cNvPr id="3" name="TextBox 2"/>
-          <p:cNvSpPr txBox="1"/>
-          <p:nvPr/>
-        </p:nvSpPr>
-        <p:spPr>
-          <a:xfrm>
-            <a:off x="365760" y="914400"/>
-            <a:ext cx="8412480" cy="365760"/>
-          </a:xfrm>
-          <a:prstGeom prst="rect">
-            <a:avLst/>
-          </a:prstGeom>
-          <a:noFill/>
-        </p:spPr>
-        <p:txBody>
-          <a:bodyPr wrap="square" anchor="t" lIns="0" rIns="0" tIns="0" bIns="0">
-            <a:spAutoFit/>
-          </a:bodyPr>
-          <a:lstStyle/>
-          <a:p>
-            <a:pPr algn="l">
-              <a:spcAft>
-                <a:spcPts val="600"/>
-              </a:spcAft>
-            </a:pPr>
-            <a:r>
-              <a:rPr sz="1250" b="0" i="0">
-                <a:solidFill>
-                  <a:srgbClr val="333333"/>
-                </a:solidFill>
-              </a:rPr>
-              <a:t>Solvers (BP, ElasticNet) run one optimisation per pixel: accurate, but slow at full resolution.</a:t>
-            </a:r>
-          </a:p>
-        </p:txBody>
-      </p:sp>
-      <p:sp>
-        <p:nvSpPr>
-          <p:cNvPr id="4" name="TextBox 3"/>
-          <p:cNvSpPr txBox="1"/>
-          <p:nvPr/>
-        </p:nvSpPr>
-        <p:spPr>
-          <a:xfrm>
-            <a:off x="365760" y="1536192"/>
-            <a:ext cx="1325880" cy="548640"/>
-          </a:xfrm>
-          <a:prstGeom prst="rect">
-            <a:avLst/>
-          </a:prstGeom>
-          <a:noFill/>
-        </p:spPr>
-        <p:txBody>
-          <a:bodyPr wrap="square" anchor="t" lIns="0" rIns="0" tIns="0" bIns="0">
-            <a:spAutoFit/>
-          </a:bodyPr>
-          <a:lstStyle/>
-          <a:p>
-            <a:pPr algn="l">
-              <a:spcAft>
-                <a:spcPts val="200"/>
-              </a:spcAft>
-            </a:pPr>
-            <a:r>
-              <a:rPr sz="1250" b="1" i="0">
-                <a:solidFill>
-                  <a:srgbClr val="57068C"/>
-                </a:solidFill>
-              </a:rPr>
-              <a:t>Supervised</a:t>
-            </a:r>
-          </a:p>
-          <a:p>
-            <a:pPr algn="l">
-              <a:spcAft>
-                <a:spcPts val="200"/>
-              </a:spcAft>
-            </a:pPr>
-            <a:r>
-              <a:rPr sz="1000" b="0" i="0">
-                <a:solidFill>
-                  <a:srgbClr val="6B6B6B"/>
-                </a:solidFill>
-              </a:rPr>
-              <a:t>learns the solver's DEMs</a:t>
-            </a:r>
-          </a:p>
-        </p:txBody>
-      </p:sp>
-      <p:sp>
-        <p:nvSpPr>
-          <p:cNvPr id="5" name="Rounded Rectangle 4"/>
-          <p:cNvSpPr/>
-          <p:nvPr/>
-        </p:nvSpPr>
-        <p:spPr>
-          <a:xfrm>
-            <a:off x="1783080" y="1463040"/>
-            <a:ext cx="1051560" cy="640080"/>
-          </a:xfrm>
-          <a:prstGeom prst="roundRect">
-            <a:avLst>
-              <a:gd name="adj" fmla="val 6000"/>
-            </a:avLst>
-          </a:prstGeom>
-          <a:solidFill>
-            <a:srgbClr val="F4F1F8"/>
-          </a:solidFill>
-          <a:ln>
-            <a:noFill/>
-          </a:ln>
-          <a:effectLst/>
-        </p:spPr>
-        <p:style>
-          <a:lnRef idx="1">
-            <a:schemeClr val="accent1"/>
-          </a:lnRef>
-          <a:fillRef idx="3">
-            <a:schemeClr val="accent1"/>
-          </a:fillRef>
-          <a:effectRef idx="2">
-            <a:schemeClr val="accent1"/>
-          </a:effectRef>
-          <a:fontRef idx="minor">
-            <a:schemeClr val="lt1"/>
-          </a:fontRef>
-        </p:style>
-        <p:txBody>
-          <a:bodyPr rtlCol="0" anchor="ctr" lIns="36576" rIns="36576" wrap="square"/>
+          <a:bodyPr/>
           <a:lstStyle/>
           <a:p>
             <a:pPr algn="ctr"/>
             <a:r>
-              <a:rPr sz="1100" b="1">
-                <a:solidFill>
-                  <a:srgbClr val="57068C"/>
-                </a:solidFill>
-              </a:rPr>
-              <a:t>Observed AIA</a:t>
+              <a:rPr sz="4100"/>
+              <a:t>Part 1</a:t>
             </a:r>
-          </a:p>
-          <a:p>
-            <a:pPr algn="ctr"/>
+            <a:br/>
             <a:r>
-              <a:rPr sz="900">
-                <a:solidFill>
-                  <a:srgbClr val="333333"/>
-                </a:solidFill>
-              </a:rPr>
-              <a:t>6 channels</a:t>
-            </a:r>
-          </a:p>
-        </p:txBody>
-      </p:sp>
-      <p:sp>
-        <p:nvSpPr>
-          <p:cNvPr id="6" name="Rounded Rectangle 5"/>
-          <p:cNvSpPr/>
-          <p:nvPr/>
-        </p:nvSpPr>
-        <p:spPr>
-          <a:xfrm>
-            <a:off x="3090672" y="1463040"/>
-            <a:ext cx="1051560" cy="640080"/>
-          </a:xfrm>
-          <a:prstGeom prst="roundRect">
-            <a:avLst>
-              <a:gd name="adj" fmla="val 6000"/>
-            </a:avLst>
-          </a:prstGeom>
-          <a:solidFill>
-            <a:srgbClr val="57068C"/>
-          </a:solidFill>
-          <a:ln>
-            <a:noFill/>
-          </a:ln>
-          <a:effectLst/>
-        </p:spPr>
-        <p:style>
-          <a:lnRef idx="1">
-            <a:schemeClr val="accent1"/>
-          </a:lnRef>
-          <a:fillRef idx="3">
-            <a:schemeClr val="accent1"/>
-          </a:fillRef>
-          <a:effectRef idx="2">
-            <a:schemeClr val="accent1"/>
-          </a:effectRef>
-          <a:fontRef idx="minor">
-            <a:schemeClr val="lt1"/>
-          </a:fontRef>
-        </p:style>
-        <p:txBody>
-          <a:bodyPr rtlCol="0" anchor="ctr" lIns="36576" rIns="36576" wrap="square"/>
-          <a:lstStyle/>
-          <a:p>
-            <a:pPr algn="ctr"/>
-            <a:r>
-              <a:rPr sz="1100" b="1">
-                <a:solidFill>
-                  <a:srgbClr val="FFFFFF"/>
-                </a:solidFill>
-              </a:rPr>
-              <a:t>Network</a:t>
-            </a:r>
-          </a:p>
-        </p:txBody>
-      </p:sp>
-      <p:sp>
-        <p:nvSpPr>
-          <p:cNvPr id="7" name="Rounded Rectangle 6"/>
-          <p:cNvSpPr/>
-          <p:nvPr/>
-        </p:nvSpPr>
-        <p:spPr>
-          <a:xfrm>
-            <a:off x="4398264" y="1463040"/>
-            <a:ext cx="1051560" cy="640080"/>
-          </a:xfrm>
-          <a:prstGeom prst="roundRect">
-            <a:avLst>
-              <a:gd name="adj" fmla="val 6000"/>
-            </a:avLst>
-          </a:prstGeom>
-          <a:solidFill>
-            <a:srgbClr val="F4F1F8"/>
-          </a:solidFill>
-          <a:ln>
-            <a:noFill/>
-          </a:ln>
-          <a:effectLst/>
-        </p:spPr>
-        <p:style>
-          <a:lnRef idx="1">
-            <a:schemeClr val="accent1"/>
-          </a:lnRef>
-          <a:fillRef idx="3">
-            <a:schemeClr val="accent1"/>
-          </a:fillRef>
-          <a:effectRef idx="2">
-            <a:schemeClr val="accent1"/>
-          </a:effectRef>
-          <a:fontRef idx="minor">
-            <a:schemeClr val="lt1"/>
-          </a:fontRef>
-        </p:style>
-        <p:txBody>
-          <a:bodyPr rtlCol="0" anchor="ctr" lIns="36576" rIns="36576" wrap="square"/>
-          <a:lstStyle/>
-          <a:p>
-            <a:pPr algn="ctr"/>
-            <a:r>
-              <a:rPr sz="1100" b="1">
-                <a:solidFill>
-                  <a:srgbClr val="57068C"/>
-                </a:solidFill>
-              </a:rPr>
-              <a:t>DEM</a:t>
-            </a:r>
-          </a:p>
-          <a:p>
-            <a:pPr algn="ctr"/>
-            <a:r>
-              <a:rPr sz="900">
-                <a:solidFill>
-                  <a:srgbClr val="333333"/>
-                </a:solidFill>
-              </a:rPr>
-              <a:t>18 bins</a:t>
-            </a:r>
-          </a:p>
-        </p:txBody>
-      </p:sp>
-      <p:cxnSp>
-        <p:nvCxnSpPr>
-          <p:cNvPr id="8" name="Connector 7"/>
-          <p:cNvCxnSpPr/>
-          <p:nvPr/>
-        </p:nvCxnSpPr>
-        <p:spPr>
-          <a:xfrm>
-            <a:off x="2834640" y="1783080"/>
-            <a:ext cx="256032" cy="0"/>
-          </a:xfrm>
-          <a:prstGeom prst="line">
-            <a:avLst/>
-          </a:prstGeom>
-          <a:ln w="19050">
-            <a:solidFill>
-              <a:srgbClr val="57068C"/>
-            </a:solidFill>
-            <a:tailEnd type="triangle"/>
-          </a:ln>
-        </p:spPr>
-        <p:style>
-          <a:lnRef idx="2">
-            <a:schemeClr val="accent1"/>
-          </a:lnRef>
-          <a:fillRef idx="0">
-            <a:schemeClr val="accent1"/>
-          </a:fillRef>
-          <a:effectRef idx="1">
-            <a:schemeClr val="accent1"/>
-          </a:effectRef>
-          <a:fontRef idx="minor">
-            <a:schemeClr val="tx1"/>
-          </a:fontRef>
-        </p:style>
-      </p:cxnSp>
-      <p:cxnSp>
-        <p:nvCxnSpPr>
-          <p:cNvPr id="9" name="Connector 8"/>
-          <p:cNvCxnSpPr/>
-          <p:nvPr/>
-        </p:nvCxnSpPr>
-        <p:spPr>
-          <a:xfrm>
-            <a:off x="4142232" y="1783080"/>
-            <a:ext cx="256032" cy="0"/>
-          </a:xfrm>
-          <a:prstGeom prst="line">
-            <a:avLst/>
-          </a:prstGeom>
-          <a:ln w="19050">
-            <a:solidFill>
-              <a:srgbClr val="57068C"/>
-            </a:solidFill>
-            <a:tailEnd type="triangle"/>
-          </a:ln>
-        </p:spPr>
-        <p:style>
-          <a:lnRef idx="2">
-            <a:schemeClr val="accent1"/>
-          </a:lnRef>
-          <a:fillRef idx="0">
-            <a:schemeClr val="accent1"/>
-          </a:fillRef>
-          <a:effectRef idx="1">
-            <a:schemeClr val="accent1"/>
-          </a:effectRef>
-          <a:fontRef idx="minor">
-            <a:schemeClr val="tx1"/>
-          </a:fontRef>
-        </p:style>
-      </p:cxnSp>
-      <p:sp>
-        <p:nvSpPr>
-          <p:cNvPr id="10" name="Rounded Rectangle 9"/>
-          <p:cNvSpPr/>
-          <p:nvPr/>
-        </p:nvSpPr>
-        <p:spPr>
-          <a:xfrm>
-            <a:off x="6016752" y="1463040"/>
-            <a:ext cx="1051560" cy="640080"/>
-          </a:xfrm>
-          <a:prstGeom prst="roundRect">
-            <a:avLst>
-              <a:gd name="adj" fmla="val 6000"/>
-            </a:avLst>
-          </a:prstGeom>
-          <a:solidFill>
-            <a:srgbClr val="ECEBE8"/>
-          </a:solidFill>
-          <a:ln>
-            <a:noFill/>
-          </a:ln>
-          <a:effectLst/>
-        </p:spPr>
-        <p:style>
-          <a:lnRef idx="1">
-            <a:schemeClr val="accent1"/>
-          </a:lnRef>
-          <a:fillRef idx="3">
-            <a:schemeClr val="accent1"/>
-          </a:fillRef>
-          <a:effectRef idx="2">
-            <a:schemeClr val="accent1"/>
-          </a:effectRef>
-          <a:fontRef idx="minor">
-            <a:schemeClr val="lt1"/>
-          </a:fontRef>
-        </p:style>
-        <p:txBody>
-          <a:bodyPr rtlCol="0" anchor="ctr" lIns="36576" rIns="36576" wrap="square"/>
-          <a:lstStyle/>
-          <a:p>
-            <a:pPr algn="ctr"/>
-            <a:r>
-              <a:rPr sz="1100" b="1">
-                <a:solidFill>
-                  <a:srgbClr val="333333"/>
-                </a:solidFill>
-              </a:rPr>
-              <a:t>Solver's DEM</a:t>
-            </a:r>
-          </a:p>
-          <a:p>
-            <a:pPr algn="ctr"/>
-            <a:r>
-              <a:rPr sz="900">
-                <a:solidFill>
-                  <a:srgbClr val="333333"/>
-                </a:solidFill>
-              </a:rPr>
-              <a:t>label</a:t>
-            </a:r>
-          </a:p>
-        </p:txBody>
-      </p:sp>
-      <p:cxnSp>
-        <p:nvCxnSpPr>
-          <p:cNvPr id="11" name="Connector 10"/>
-          <p:cNvCxnSpPr/>
-          <p:nvPr/>
-        </p:nvCxnSpPr>
-        <p:spPr>
-          <a:xfrm>
-            <a:off x="5449824" y="1783080"/>
-            <a:ext cx="566928" cy="0"/>
-          </a:xfrm>
-          <a:prstGeom prst="line">
-            <a:avLst/>
-          </a:prstGeom>
-          <a:ln w="19050">
-            <a:solidFill>
-              <a:srgbClr val="57068C"/>
-            </a:solidFill>
-            <a:prstDash val="dash"/>
-          </a:ln>
-        </p:spPr>
-        <p:style>
-          <a:lnRef idx="2">
-            <a:schemeClr val="accent1"/>
-          </a:lnRef>
-          <a:fillRef idx="0">
-            <a:schemeClr val="accent1"/>
-          </a:fillRef>
-          <a:effectRef idx="1">
-            <a:schemeClr val="accent1"/>
-          </a:effectRef>
-          <a:fontRef idx="minor">
-            <a:schemeClr val="tx1"/>
-          </a:fontRef>
-        </p:style>
-      </p:cxnSp>
-      <p:sp>
-        <p:nvSpPr>
-          <p:cNvPr id="12" name="Rounded Rectangle 11"/>
-          <p:cNvSpPr/>
-          <p:nvPr/>
-        </p:nvSpPr>
-        <p:spPr>
-          <a:xfrm>
-            <a:off x="5522976" y="1664208"/>
-            <a:ext cx="420624" cy="237744"/>
-          </a:xfrm>
-          <a:prstGeom prst="roundRect">
-            <a:avLst>
-              <a:gd name="adj" fmla="val 6000"/>
-            </a:avLst>
-          </a:prstGeom>
-          <a:solidFill>
-            <a:srgbClr val="E3DFE9"/>
-          </a:solidFill>
-          <a:ln>
-            <a:noFill/>
-          </a:ln>
-          <a:effectLst/>
-        </p:spPr>
-        <p:style>
-          <a:lnRef idx="1">
-            <a:schemeClr val="accent1"/>
-          </a:lnRef>
-          <a:fillRef idx="3">
-            <a:schemeClr val="accent1"/>
-          </a:fillRef>
-          <a:effectRef idx="2">
-            <a:schemeClr val="accent1"/>
-          </a:effectRef>
-          <a:fontRef idx="minor">
-            <a:schemeClr val="lt1"/>
-          </a:fontRef>
-        </p:style>
-        <p:txBody>
-          <a:bodyPr rtlCol="0" anchor="ctr" lIns="36576" rIns="36576" wrap="square"/>
-          <a:lstStyle/>
-          <a:p>
-            <a:pPr algn="ctr"/>
-            <a:r>
-              <a:rPr sz="900" b="1">
-                <a:solidFill>
-                  <a:srgbClr val="57068C"/>
-                </a:solidFill>
-              </a:rPr>
-              <a:t>loss</a:t>
-            </a:r>
-          </a:p>
-        </p:txBody>
-      </p:sp>
-      <p:sp>
-        <p:nvSpPr>
-          <p:cNvPr id="13" name="TextBox 12"/>
-          <p:cNvSpPr txBox="1"/>
-          <p:nvPr/>
-        </p:nvSpPr>
-        <p:spPr>
-          <a:xfrm>
-            <a:off x="365760" y="2633472"/>
-            <a:ext cx="1325880" cy="548640"/>
-          </a:xfrm>
-          <a:prstGeom prst="rect">
-            <a:avLst/>
-          </a:prstGeom>
-          <a:noFill/>
-        </p:spPr>
-        <p:txBody>
-          <a:bodyPr wrap="square" anchor="t" lIns="0" rIns="0" tIns="0" bIns="0">
-            <a:spAutoFit/>
-          </a:bodyPr>
-          <a:lstStyle/>
-          <a:p>
-            <a:pPr algn="l">
-              <a:spcAft>
-                <a:spcPts val="200"/>
-              </a:spcAft>
-            </a:pPr>
-            <a:r>
-              <a:rPr sz="1250" b="1" i="0">
-                <a:solidFill>
-                  <a:srgbClr val="57068C"/>
-                </a:solidFill>
-              </a:rPr>
-              <a:t>Label-free (ours)</a:t>
-            </a:r>
-          </a:p>
-          <a:p>
-            <a:pPr algn="l">
-              <a:spcAft>
-                <a:spcPts val="200"/>
-              </a:spcAft>
-            </a:pPr>
-            <a:r>
-              <a:rPr sz="1000" b="0" i="0">
-                <a:solidFill>
-                  <a:srgbClr val="6B6B6B"/>
-                </a:solidFill>
-              </a:rPr>
-              <a:t>learns the solver's objective</a:t>
-            </a:r>
-          </a:p>
-        </p:txBody>
-      </p:sp>
-      <p:sp>
-        <p:nvSpPr>
-          <p:cNvPr id="14" name="Rounded Rectangle 13"/>
-          <p:cNvSpPr/>
-          <p:nvPr/>
-        </p:nvSpPr>
-        <p:spPr>
-          <a:xfrm>
-            <a:off x="1783080" y="2560320"/>
-            <a:ext cx="1051560" cy="640080"/>
-          </a:xfrm>
-          <a:prstGeom prst="roundRect">
-            <a:avLst>
-              <a:gd name="adj" fmla="val 6000"/>
-            </a:avLst>
-          </a:prstGeom>
-          <a:solidFill>
-            <a:srgbClr val="F4F1F8"/>
-          </a:solidFill>
-          <a:ln>
-            <a:noFill/>
-          </a:ln>
-          <a:effectLst/>
-        </p:spPr>
-        <p:style>
-          <a:lnRef idx="1">
-            <a:schemeClr val="accent1"/>
-          </a:lnRef>
-          <a:fillRef idx="3">
-            <a:schemeClr val="accent1"/>
-          </a:fillRef>
-          <a:effectRef idx="2">
-            <a:schemeClr val="accent1"/>
-          </a:effectRef>
-          <a:fontRef idx="minor">
-            <a:schemeClr val="lt1"/>
-          </a:fontRef>
-        </p:style>
-        <p:txBody>
-          <a:bodyPr rtlCol="0" anchor="ctr" lIns="36576" rIns="36576" wrap="square"/>
-          <a:lstStyle/>
-          <a:p>
-            <a:pPr algn="ctr"/>
-            <a:r>
-              <a:rPr sz="1100" b="1">
-                <a:solidFill>
-                  <a:srgbClr val="57068C"/>
-                </a:solidFill>
-              </a:rPr>
-              <a:t>Observed AIA</a:t>
-            </a:r>
-          </a:p>
-          <a:p>
-            <a:pPr algn="ctr"/>
-            <a:r>
-              <a:rPr sz="900">
-                <a:solidFill>
-                  <a:srgbClr val="333333"/>
-                </a:solidFill>
-              </a:rPr>
-              <a:t>6 channels</a:t>
-            </a:r>
-          </a:p>
-        </p:txBody>
-      </p:sp>
-      <p:sp>
-        <p:nvSpPr>
-          <p:cNvPr id="15" name="Rounded Rectangle 14"/>
-          <p:cNvSpPr/>
-          <p:nvPr/>
-        </p:nvSpPr>
-        <p:spPr>
-          <a:xfrm>
-            <a:off x="3090672" y="2560320"/>
-            <a:ext cx="1051560" cy="640080"/>
-          </a:xfrm>
-          <a:prstGeom prst="roundRect">
-            <a:avLst>
-              <a:gd name="adj" fmla="val 6000"/>
-            </a:avLst>
-          </a:prstGeom>
-          <a:solidFill>
-            <a:srgbClr val="57068C"/>
-          </a:solidFill>
-          <a:ln>
-            <a:noFill/>
-          </a:ln>
-          <a:effectLst/>
-        </p:spPr>
-        <p:style>
-          <a:lnRef idx="1">
-            <a:schemeClr val="accent1"/>
-          </a:lnRef>
-          <a:fillRef idx="3">
-            <a:schemeClr val="accent1"/>
-          </a:fillRef>
-          <a:effectRef idx="2">
-            <a:schemeClr val="accent1"/>
-          </a:effectRef>
-          <a:fontRef idx="minor">
-            <a:schemeClr val="lt1"/>
-          </a:fontRef>
-        </p:style>
-        <p:txBody>
-          <a:bodyPr rtlCol="0" anchor="ctr" lIns="36576" rIns="36576" wrap="square"/>
-          <a:lstStyle/>
-          <a:p>
-            <a:pPr algn="ctr"/>
-            <a:r>
-              <a:rPr sz="1100" b="1">
-                <a:solidFill>
-                  <a:srgbClr val="FFFFFF"/>
-                </a:solidFill>
-              </a:rPr>
-              <a:t>Network</a:t>
-            </a:r>
-          </a:p>
-        </p:txBody>
-      </p:sp>
-      <p:sp>
-        <p:nvSpPr>
-          <p:cNvPr id="16" name="Rounded Rectangle 15"/>
-          <p:cNvSpPr/>
-          <p:nvPr/>
-        </p:nvSpPr>
-        <p:spPr>
-          <a:xfrm>
-            <a:off x="4398264" y="2560320"/>
-            <a:ext cx="1051560" cy="640080"/>
-          </a:xfrm>
-          <a:prstGeom prst="roundRect">
-            <a:avLst>
-              <a:gd name="adj" fmla="val 6000"/>
-            </a:avLst>
-          </a:prstGeom>
-          <a:solidFill>
-            <a:srgbClr val="F4F1F8"/>
-          </a:solidFill>
-          <a:ln>
-            <a:noFill/>
-          </a:ln>
-          <a:effectLst/>
-        </p:spPr>
-        <p:style>
-          <a:lnRef idx="1">
-            <a:schemeClr val="accent1"/>
-          </a:lnRef>
-          <a:fillRef idx="3">
-            <a:schemeClr val="accent1"/>
-          </a:fillRef>
-          <a:effectRef idx="2">
-            <a:schemeClr val="accent1"/>
-          </a:effectRef>
-          <a:fontRef idx="minor">
-            <a:schemeClr val="lt1"/>
-          </a:fontRef>
-        </p:style>
-        <p:txBody>
-          <a:bodyPr rtlCol="0" anchor="ctr" lIns="36576" rIns="36576" wrap="square"/>
-          <a:lstStyle/>
-          <a:p>
-            <a:pPr algn="ctr"/>
-            <a:r>
-              <a:rPr sz="1100" b="1">
-                <a:solidFill>
-                  <a:srgbClr val="57068C"/>
-                </a:solidFill>
-              </a:rPr>
-              <a:t>DEM</a:t>
-            </a:r>
-          </a:p>
-          <a:p>
-            <a:pPr algn="ctr"/>
-            <a:r>
-              <a:rPr sz="900">
-                <a:solidFill>
-                  <a:srgbClr val="333333"/>
-                </a:solidFill>
-              </a:rPr>
-              <a:t>18 bins</a:t>
-            </a:r>
-          </a:p>
-        </p:txBody>
-      </p:sp>
-      <p:sp>
-        <p:nvSpPr>
-          <p:cNvPr id="17" name="Rounded Rectangle 16"/>
-          <p:cNvSpPr/>
-          <p:nvPr/>
-        </p:nvSpPr>
-        <p:spPr>
-          <a:xfrm>
-            <a:off x="5705856" y="2560320"/>
-            <a:ext cx="1051560" cy="640080"/>
-          </a:xfrm>
-          <a:prstGeom prst="roundRect">
-            <a:avLst>
-              <a:gd name="adj" fmla="val 6000"/>
-            </a:avLst>
-          </a:prstGeom>
-          <a:solidFill>
-            <a:srgbClr val="F4F1F8"/>
-          </a:solidFill>
-          <a:ln>
-            <a:noFill/>
-          </a:ln>
-          <a:effectLst/>
-        </p:spPr>
-        <p:style>
-          <a:lnRef idx="1">
-            <a:schemeClr val="accent1"/>
-          </a:lnRef>
-          <a:fillRef idx="3">
-            <a:schemeClr val="accent1"/>
-          </a:fillRef>
-          <a:effectRef idx="2">
-            <a:schemeClr val="accent1"/>
-          </a:effectRef>
-          <a:fontRef idx="minor">
-            <a:schemeClr val="lt1"/>
-          </a:fontRef>
-        </p:style>
-        <p:txBody>
-          <a:bodyPr rtlCol="0" anchor="ctr" lIns="36576" rIns="36576" wrap="square"/>
-          <a:lstStyle/>
-          <a:p>
-            <a:pPr algn="ctr"/>
-            <a:r>
-              <a:rPr sz="1100" b="1">
-                <a:solidFill>
-                  <a:srgbClr val="57068C"/>
-                </a:solidFill>
-              </a:rPr>
-              <a:t>Predicted AIA</a:t>
-            </a:r>
-          </a:p>
-          <a:p>
-            <a:pPr algn="ctr"/>
-            <a:r>
-              <a:rPr sz="900">
-                <a:solidFill>
-                  <a:srgbClr val="333333"/>
-                </a:solidFill>
-              </a:rPr>
-              <a:t>via response R</a:t>
-            </a:r>
-          </a:p>
-        </p:txBody>
-      </p:sp>
-      <p:cxnSp>
-        <p:nvCxnSpPr>
-          <p:cNvPr id="18" name="Connector 17"/>
-          <p:cNvCxnSpPr/>
-          <p:nvPr/>
-        </p:nvCxnSpPr>
-        <p:spPr>
-          <a:xfrm>
-            <a:off x="2834640" y="2880360"/>
-            <a:ext cx="256032" cy="0"/>
-          </a:xfrm>
-          <a:prstGeom prst="line">
-            <a:avLst/>
-          </a:prstGeom>
-          <a:ln w="19050">
-            <a:solidFill>
-              <a:srgbClr val="57068C"/>
-            </a:solidFill>
-            <a:tailEnd type="triangle"/>
-          </a:ln>
-        </p:spPr>
-        <p:style>
-          <a:lnRef idx="2">
-            <a:schemeClr val="accent1"/>
-          </a:lnRef>
-          <a:fillRef idx="0">
-            <a:schemeClr val="accent1"/>
-          </a:fillRef>
-          <a:effectRef idx="1">
-            <a:schemeClr val="accent1"/>
-          </a:effectRef>
-          <a:fontRef idx="minor">
-            <a:schemeClr val="tx1"/>
-          </a:fontRef>
-        </p:style>
-      </p:cxnSp>
-      <p:cxnSp>
-        <p:nvCxnSpPr>
-          <p:cNvPr id="19" name="Connector 18"/>
-          <p:cNvCxnSpPr/>
-          <p:nvPr/>
-        </p:nvCxnSpPr>
-        <p:spPr>
-          <a:xfrm>
-            <a:off x="4142232" y="2880360"/>
-            <a:ext cx="256032" cy="0"/>
-          </a:xfrm>
-          <a:prstGeom prst="line">
-            <a:avLst/>
-          </a:prstGeom>
-          <a:ln w="19050">
-            <a:solidFill>
-              <a:srgbClr val="57068C"/>
-            </a:solidFill>
-            <a:tailEnd type="triangle"/>
-          </a:ln>
-        </p:spPr>
-        <p:style>
-          <a:lnRef idx="2">
-            <a:schemeClr val="accent1"/>
-          </a:lnRef>
-          <a:fillRef idx="0">
-            <a:schemeClr val="accent1"/>
-          </a:fillRef>
-          <a:effectRef idx="1">
-            <a:schemeClr val="accent1"/>
-          </a:effectRef>
-          <a:fontRef idx="minor">
-            <a:schemeClr val="tx1"/>
-          </a:fontRef>
-        </p:style>
-      </p:cxnSp>
-      <p:cxnSp>
-        <p:nvCxnSpPr>
-          <p:cNvPr id="20" name="Connector 19"/>
-          <p:cNvCxnSpPr/>
-          <p:nvPr/>
-        </p:nvCxnSpPr>
-        <p:spPr>
-          <a:xfrm>
-            <a:off x="5449824" y="2880360"/>
-            <a:ext cx="256032" cy="0"/>
-          </a:xfrm>
-          <a:prstGeom prst="line">
-            <a:avLst/>
-          </a:prstGeom>
-          <a:ln w="19050">
-            <a:solidFill>
-              <a:srgbClr val="57068C"/>
-            </a:solidFill>
-            <a:tailEnd type="triangle"/>
-          </a:ln>
-        </p:spPr>
-        <p:style>
-          <a:lnRef idx="2">
-            <a:schemeClr val="accent1"/>
-          </a:lnRef>
-          <a:fillRef idx="0">
-            <a:schemeClr val="accent1"/>
-          </a:fillRef>
-          <a:effectRef idx="1">
-            <a:schemeClr val="accent1"/>
-          </a:effectRef>
-          <a:fontRef idx="minor">
-            <a:schemeClr val="tx1"/>
-          </a:fontRef>
-        </p:style>
-      </p:cxnSp>
-      <p:sp>
-        <p:nvSpPr>
-          <p:cNvPr id="21" name="Rounded Rectangle 20"/>
-          <p:cNvSpPr/>
-          <p:nvPr/>
-        </p:nvSpPr>
-        <p:spPr>
-          <a:xfrm>
-            <a:off x="7324344" y="2560320"/>
-            <a:ext cx="1051560" cy="640080"/>
-          </a:xfrm>
-          <a:prstGeom prst="roundRect">
-            <a:avLst>
-              <a:gd name="adj" fmla="val 6000"/>
-            </a:avLst>
-          </a:prstGeom>
-          <a:solidFill>
-            <a:srgbClr val="ECEBE8"/>
-          </a:solidFill>
-          <a:ln>
-            <a:noFill/>
-          </a:ln>
-          <a:effectLst/>
-        </p:spPr>
-        <p:style>
-          <a:lnRef idx="1">
-            <a:schemeClr val="accent1"/>
-          </a:lnRef>
-          <a:fillRef idx="3">
-            <a:schemeClr val="accent1"/>
-          </a:fillRef>
-          <a:effectRef idx="2">
-            <a:schemeClr val="accent1"/>
-          </a:effectRef>
-          <a:fontRef idx="minor">
-            <a:schemeClr val="lt1"/>
-          </a:fontRef>
-        </p:style>
-        <p:txBody>
-          <a:bodyPr rtlCol="0" anchor="ctr" lIns="36576" rIns="36576" wrap="square"/>
-          <a:lstStyle/>
-          <a:p>
-            <a:pPr algn="ctr"/>
-            <a:r>
-              <a:rPr sz="1100" b="1">
-                <a:solidFill>
-                  <a:srgbClr val="333333"/>
-                </a:solidFill>
-              </a:rPr>
-              <a:t>Observed AIA</a:t>
-            </a:r>
-          </a:p>
-          <a:p>
-            <a:pPr algn="ctr"/>
-            <a:r>
-              <a:rPr sz="900">
-                <a:solidFill>
-                  <a:srgbClr val="333333"/>
-                </a:solidFill>
-              </a:rPr>
-              <a:t>6 channels</a:t>
-            </a:r>
-          </a:p>
-        </p:txBody>
-      </p:sp>
-      <p:cxnSp>
-        <p:nvCxnSpPr>
-          <p:cNvPr id="22" name="Connector 21"/>
-          <p:cNvCxnSpPr/>
-          <p:nvPr/>
-        </p:nvCxnSpPr>
-        <p:spPr>
-          <a:xfrm>
-            <a:off x="6757416" y="2880360"/>
-            <a:ext cx="566928" cy="0"/>
-          </a:xfrm>
-          <a:prstGeom prst="line">
-            <a:avLst/>
-          </a:prstGeom>
-          <a:ln w="19050">
-            <a:solidFill>
-              <a:srgbClr val="57068C"/>
-            </a:solidFill>
-            <a:prstDash val="dash"/>
-          </a:ln>
-        </p:spPr>
-        <p:style>
-          <a:lnRef idx="2">
-            <a:schemeClr val="accent1"/>
-          </a:lnRef>
-          <a:fillRef idx="0">
-            <a:schemeClr val="accent1"/>
-          </a:fillRef>
-          <a:effectRef idx="1">
-            <a:schemeClr val="accent1"/>
-          </a:effectRef>
-          <a:fontRef idx="minor">
-            <a:schemeClr val="tx1"/>
-          </a:fontRef>
-        </p:style>
-      </p:cxnSp>
-      <p:sp>
-        <p:nvSpPr>
-          <p:cNvPr id="23" name="Rounded Rectangle 22"/>
-          <p:cNvSpPr/>
-          <p:nvPr/>
-        </p:nvSpPr>
-        <p:spPr>
-          <a:xfrm>
-            <a:off x="6830568" y="2761488"/>
-            <a:ext cx="420624" cy="237744"/>
-          </a:xfrm>
-          <a:prstGeom prst="roundRect">
-            <a:avLst>
-              <a:gd name="adj" fmla="val 6000"/>
-            </a:avLst>
-          </a:prstGeom>
-          <a:solidFill>
-            <a:srgbClr val="E3DFE9"/>
-          </a:solidFill>
-          <a:ln>
-            <a:noFill/>
-          </a:ln>
-          <a:effectLst/>
-        </p:spPr>
-        <p:style>
-          <a:lnRef idx="1">
-            <a:schemeClr val="accent1"/>
-          </a:lnRef>
-          <a:fillRef idx="3">
-            <a:schemeClr val="accent1"/>
-          </a:fillRef>
-          <a:effectRef idx="2">
-            <a:schemeClr val="accent1"/>
-          </a:effectRef>
-          <a:fontRef idx="minor">
-            <a:schemeClr val="lt1"/>
-          </a:fontRef>
-        </p:style>
-        <p:txBody>
-          <a:bodyPr rtlCol="0" anchor="ctr" lIns="36576" rIns="36576" wrap="square"/>
-          <a:lstStyle/>
-          <a:p>
-            <a:pPr algn="ctr"/>
-            <a:r>
-              <a:rPr sz="900" b="1">
-                <a:solidFill>
-                  <a:srgbClr val="57068C"/>
-                </a:solidFill>
-              </a:rPr>
-              <a:t>loss</a:t>
-            </a:r>
-          </a:p>
-        </p:txBody>
-      </p:sp>
-      <p:sp>
-        <p:nvSpPr>
-          <p:cNvPr id="24" name="TextBox 23"/>
-          <p:cNvSpPr txBox="1"/>
-          <p:nvPr/>
-        </p:nvSpPr>
-        <p:spPr>
-          <a:xfrm>
-            <a:off x="365760" y="3566160"/>
-            <a:ext cx="8412480" cy="457200"/>
-          </a:xfrm>
-          <a:prstGeom prst="rect">
-            <a:avLst/>
-          </a:prstGeom>
-          <a:noFill/>
-        </p:spPr>
-        <p:txBody>
-          <a:bodyPr wrap="square" anchor="t" lIns="0" rIns="0" tIns="0" bIns="0">
-            <a:spAutoFit/>
-          </a:bodyPr>
-          <a:lstStyle/>
-          <a:p>
-            <a:pPr algn="l">
-              <a:spcAft>
-                <a:spcPts val="600"/>
-              </a:spcAft>
-            </a:pPr>
-            <a:r>
-              <a:rPr sz="1250" b="1" i="0">
-                <a:solidFill>
-                  <a:srgbClr val="57068C"/>
-                </a:solidFill>
-              </a:rPr>
-              <a:t>We never train on the solver's DEMs; we use them only to evaluate.</a:t>
+              <a:rPr sz="4100"/>
+              <a:t>Problem and approach</a:t>
             </a:r>
           </a:p>
         </p:txBody>
@@ -11124,21 +10016,112 @@
                   <a:srgbClr val="57068C"/>
                 </a:solidFill>
               </a:rPr>
-              <a:t>The model: a small MLP feeding a fixed forward model</a:t>
+              <a:t>Same physics, different training signal</a:t>
             </a:r>
           </a:p>
         </p:txBody>
       </p:sp>
       <p:sp>
         <p:nvSpPr>
-          <p:cNvPr id="3" name="Rounded Rectangle 2"/>
+          <p:cNvPr id="3" name="TextBox 2"/>
+          <p:cNvSpPr txBox="1"/>
+          <p:nvPr/>
+        </p:nvSpPr>
+        <p:spPr>
+          <a:xfrm>
+            <a:off x="365760" y="914400"/>
+            <a:ext cx="8412480" cy="365760"/>
+          </a:xfrm>
+          <a:prstGeom prst="rect">
+            <a:avLst/>
+          </a:prstGeom>
+          <a:noFill/>
+        </p:spPr>
+        <p:txBody>
+          <a:bodyPr wrap="square" anchor="t" lIns="0" rIns="0" tIns="0" bIns="0">
+            <a:spAutoFit/>
+          </a:bodyPr>
+          <a:lstStyle/>
+          <a:p>
+            <a:pPr algn="l">
+              <a:spcAft>
+                <a:spcPts val="600"/>
+              </a:spcAft>
+            </a:pPr>
+            <a:r>
+              <a:rPr sz="1250" b="0" i="0">
+                <a:solidFill>
+                  <a:srgbClr val="333333"/>
+                </a:solidFill>
+              </a:rPr>
+              <a:t>Solvers (BP, ElasticNet) run one optimisation per pixel: accurate, but slow at full resolution.</a:t>
+            </a:r>
+          </a:p>
+        </p:txBody>
+      </p:sp>
+      <p:sp>
+        <p:nvSpPr>
+          <p:cNvPr id="4" name="TextBox 3"/>
+          <p:cNvSpPr txBox="1"/>
+          <p:nvPr/>
+        </p:nvSpPr>
+        <p:spPr>
+          <a:xfrm>
+            <a:off x="365760" y="1536192"/>
+            <a:ext cx="1325880" cy="722376"/>
+          </a:xfrm>
+          <a:prstGeom prst="rect">
+            <a:avLst/>
+          </a:prstGeom>
+          <a:noFill/>
+        </p:spPr>
+        <p:txBody>
+          <a:bodyPr wrap="square" anchor="t" lIns="0" rIns="0" tIns="0" bIns="0">
+            <a:spAutoFit/>
+          </a:bodyPr>
+          <a:lstStyle/>
+          <a:p>
+            <a:pPr algn="l">
+              <a:spcAft>
+                <a:spcPts val="200"/>
+              </a:spcAft>
+            </a:pPr>
+            <a:r>
+              <a:rPr sz="1250" b="1" i="0">
+                <a:solidFill>
+                  <a:srgbClr val="57068C"/>
+                </a:solidFill>
+              </a:rPr>
+              <a:t>Supervised</a:t>
+            </a:r>
+          </a:p>
+          <a:p>
+            <a:pPr algn="l">
+              <a:spcAft>
+                <a:spcPts val="200"/>
+              </a:spcAft>
+            </a:pPr>
+            <a:r>
+              <a:rPr sz="1000" b="0" i="0">
+                <a:solidFill>
+                  <a:srgbClr val="6B6B6B"/>
+                </a:solidFill>
+              </a:rPr>
+              <a:t>learns the solver's DEMs</a:t>
+            </a:r>
+          </a:p>
+        </p:txBody>
+      </p:sp>
+      <p:sp>
+        <p:nvSpPr>
+          <p:cNvPr id="5" name="Rounded Rectangle 4"/>
           <p:cNvSpPr/>
           <p:nvPr/>
         </p:nvSpPr>
         <p:spPr>
           <a:xfrm>
-            <a:off x="365760" y="1188720"/>
-            <a:ext cx="1371600" cy="868680"/>
+            <a:off x="1783080" y="1463040"/>
+            <a:ext cx="1051560" cy="640080"/>
           </a:xfrm>
           <a:prstGeom prst="roundRect">
             <a:avLst>
@@ -11173,7 +10156,7 @@
           <a:p>
             <a:pPr algn="ctr"/>
             <a:r>
-              <a:rPr sz="1300" b="1">
+              <a:rPr sz="1100" b="1">
                 <a:solidFill>
                   <a:srgbClr val="57068C"/>
                 </a:solidFill>
@@ -11184,7 +10167,7 @@
           <a:p>
             <a:pPr algn="ctr"/>
             <a:r>
-              <a:rPr sz="1000">
+              <a:rPr sz="900">
                 <a:solidFill>
                   <a:srgbClr val="333333"/>
                 </a:solidFill>
@@ -11196,14 +10179,14 @@
       </p:sp>
       <p:sp>
         <p:nvSpPr>
-          <p:cNvPr id="4" name="Rounded Rectangle 3"/>
+          <p:cNvPr id="6" name="Rounded Rectangle 5"/>
           <p:cNvSpPr/>
           <p:nvPr/>
         </p:nvSpPr>
         <p:spPr>
           <a:xfrm>
-            <a:off x="2125980" y="1188720"/>
-            <a:ext cx="1371600" cy="868680"/>
+            <a:off x="3090672" y="1463040"/>
+            <a:ext cx="1051560" cy="640080"/>
           </a:xfrm>
           <a:prstGeom prst="roundRect">
             <a:avLst>
@@ -11238,37 +10221,26 @@
           <a:p>
             <a:pPr algn="ctr"/>
             <a:r>
-              <a:rPr sz="1300" b="1">
+              <a:rPr sz="1100" b="1">
                 <a:solidFill>
                   <a:srgbClr val="FFFFFF"/>
                 </a:solidFill>
               </a:rPr>
-              <a:t>MLP</a:t>
-            </a:r>
-          </a:p>
-          <a:p>
-            <a:pPr algn="ctr"/>
-            <a:r>
-              <a:rPr sz="1000">
-                <a:solidFill>
-                  <a:srgbClr val="FFFFFF"/>
-                </a:solidFill>
-              </a:rPr>
-              <a:t>176k params</a:t>
+              <a:t>Model</a:t>
             </a:r>
           </a:p>
         </p:txBody>
       </p:sp>
       <p:sp>
         <p:nvSpPr>
-          <p:cNvPr id="5" name="Rounded Rectangle 4"/>
+          <p:cNvPr id="7" name="Rounded Rectangle 6"/>
           <p:cNvSpPr/>
           <p:nvPr/>
         </p:nvSpPr>
         <p:spPr>
           <a:xfrm>
-            <a:off x="3886200" y="1188720"/>
-            <a:ext cx="1371600" cy="868680"/>
+            <a:off x="4398264" y="1463040"/>
+            <a:ext cx="1051560" cy="640080"/>
           </a:xfrm>
           <a:prstGeom prst="roundRect">
             <a:avLst>
@@ -11303,72 +10275,7 @@
           <a:p>
             <a:pPr algn="ctr"/>
             <a:r>
-              <a:rPr sz="1300" b="1">
-                <a:solidFill>
-                  <a:srgbClr val="57068C"/>
-                </a:solidFill>
-              </a:rPr>
-              <a:t>Basis weights</a:t>
-            </a:r>
-          </a:p>
-          <a:p>
-            <a:pPr algn="ctr"/>
-            <a:r>
-              <a:rPr sz="1000">
-                <a:solidFill>
-                  <a:srgbClr val="333333"/>
-                </a:solidFill>
-              </a:rPr>
-              <a:t>54, same as solver</a:t>
-            </a:r>
-          </a:p>
-        </p:txBody>
-      </p:sp>
-      <p:sp>
-        <p:nvSpPr>
-          <p:cNvPr id="6" name="Rounded Rectangle 5"/>
-          <p:cNvSpPr/>
-          <p:nvPr/>
-        </p:nvSpPr>
-        <p:spPr>
-          <a:xfrm>
-            <a:off x="5646420" y="1188720"/>
-            <a:ext cx="1371600" cy="868680"/>
-          </a:xfrm>
-          <a:prstGeom prst="roundRect">
-            <a:avLst>
-              <a:gd name="adj" fmla="val 6000"/>
-            </a:avLst>
-          </a:prstGeom>
-          <a:solidFill>
-            <a:srgbClr val="F4F1F8"/>
-          </a:solidFill>
-          <a:ln>
-            <a:noFill/>
-          </a:ln>
-          <a:effectLst/>
-        </p:spPr>
-        <p:style>
-          <a:lnRef idx="1">
-            <a:schemeClr val="accent1"/>
-          </a:lnRef>
-          <a:fillRef idx="3">
-            <a:schemeClr val="accent1"/>
-          </a:fillRef>
-          <a:effectRef idx="2">
-            <a:schemeClr val="accent1"/>
-          </a:effectRef>
-          <a:fontRef idx="minor">
-            <a:schemeClr val="lt1"/>
-          </a:fontRef>
-        </p:style>
-        <p:txBody>
-          <a:bodyPr rtlCol="0" anchor="ctr" lIns="36576" rIns="36576" wrap="square"/>
-          <a:lstStyle/>
-          <a:p>
-            <a:pPr algn="ctr"/>
-            <a:r>
-              <a:rPr sz="1300" b="1">
+              <a:rPr sz="1100" b="1">
                 <a:solidFill>
                   <a:srgbClr val="57068C"/>
                 </a:solidFill>
@@ -11379,77 +10286,12 @@
           <a:p>
             <a:pPr algn="ctr"/>
             <a:r>
-              <a:rPr sz="1000">
+              <a:rPr sz="900">
                 <a:solidFill>
                   <a:srgbClr val="333333"/>
                 </a:solidFill>
               </a:rPr>
-              <a:t>18 bins, logT 5.5–7.2</a:t>
-            </a:r>
-          </a:p>
-        </p:txBody>
-      </p:sp>
-      <p:sp>
-        <p:nvSpPr>
-          <p:cNvPr id="7" name="Rounded Rectangle 6"/>
-          <p:cNvSpPr/>
-          <p:nvPr/>
-        </p:nvSpPr>
-        <p:spPr>
-          <a:xfrm>
-            <a:off x="7406640" y="1188720"/>
-            <a:ext cx="1371600" cy="868680"/>
-          </a:xfrm>
-          <a:prstGeom prst="roundRect">
-            <a:avLst>
-              <a:gd name="adj" fmla="val 6000"/>
-            </a:avLst>
-          </a:prstGeom>
-          <a:solidFill>
-            <a:srgbClr val="F4F1F8"/>
-          </a:solidFill>
-          <a:ln>
-            <a:noFill/>
-          </a:ln>
-          <a:effectLst/>
-        </p:spPr>
-        <p:style>
-          <a:lnRef idx="1">
-            <a:schemeClr val="accent1"/>
-          </a:lnRef>
-          <a:fillRef idx="3">
-            <a:schemeClr val="accent1"/>
-          </a:fillRef>
-          <a:effectRef idx="2">
-            <a:schemeClr val="accent1"/>
-          </a:effectRef>
-          <a:fontRef idx="minor">
-            <a:schemeClr val="lt1"/>
-          </a:fontRef>
-        </p:style>
-        <p:txBody>
-          <a:bodyPr rtlCol="0" anchor="ctr" lIns="36576" rIns="36576" wrap="square"/>
-          <a:lstStyle/>
-          <a:p>
-            <a:pPr algn="ctr"/>
-            <a:r>
-              <a:rPr sz="1300" b="1">
-                <a:solidFill>
-                  <a:srgbClr val="57068C"/>
-                </a:solidFill>
-              </a:rPr>
-              <a:t>Predicted AIA</a:t>
-            </a:r>
-          </a:p>
-          <a:p>
-            <a:pPr algn="ctr"/>
-            <a:r>
-              <a:rPr sz="1000">
-                <a:solidFill>
-                  <a:srgbClr val="333333"/>
-                </a:solidFill>
-              </a:rPr>
-              <a:t>via response R</a:t>
+              <a:t>18 bins</a:t>
             </a:r>
           </a:p>
         </p:txBody>
@@ -11462,8 +10304,8 @@
         </p:nvCxnSpPr>
         <p:spPr>
           <a:xfrm>
-            <a:off x="1737360" y="1623060"/>
-            <a:ext cx="388620" cy="0"/>
+            <a:off x="2834640" y="1783080"/>
+            <a:ext cx="256032" cy="0"/>
           </a:xfrm>
           <a:prstGeom prst="line">
             <a:avLst/>
@@ -11498,8 +10340,8 @@
         </p:nvCxnSpPr>
         <p:spPr>
           <a:xfrm>
-            <a:off x="3497580" y="1623060"/>
-            <a:ext cx="388620" cy="0"/>
+            <a:off x="4142232" y="1783080"/>
+            <a:ext cx="256032" cy="0"/>
           </a:xfrm>
           <a:prstGeom prst="line">
             <a:avLst/>
@@ -11526,42 +10368,71 @@
           </a:fontRef>
         </p:style>
       </p:cxnSp>
-      <p:cxnSp>
-        <p:nvCxnSpPr>
-          <p:cNvPr id="10" name="Connector 9"/>
-          <p:cNvCxnSpPr/>
+      <p:sp>
+        <p:nvSpPr>
+          <p:cNvPr id="10" name="Rounded Rectangle 9"/>
+          <p:cNvSpPr/>
           <p:nvPr/>
-        </p:nvCxnSpPr>
-        <p:spPr>
-          <a:xfrm>
-            <a:off x="5257800" y="1623060"/>
-            <a:ext cx="388620" cy="0"/>
-          </a:xfrm>
-          <a:prstGeom prst="line">
-            <a:avLst/>
-          </a:prstGeom>
-          <a:ln w="19050">
-            <a:solidFill>
-              <a:srgbClr val="57068C"/>
-            </a:solidFill>
-            <a:tailEnd type="triangle"/>
+        </p:nvSpPr>
+        <p:spPr>
+          <a:xfrm>
+            <a:off x="6016752" y="1463040"/>
+            <a:ext cx="1051560" cy="640080"/>
+          </a:xfrm>
+          <a:prstGeom prst="roundRect">
+            <a:avLst>
+              <a:gd name="adj" fmla="val 6000"/>
+            </a:avLst>
+          </a:prstGeom>
+          <a:solidFill>
+            <a:srgbClr val="ECEBE8"/>
+          </a:solidFill>
+          <a:ln>
+            <a:noFill/>
           </a:ln>
+          <a:effectLst/>
         </p:spPr>
         <p:style>
-          <a:lnRef idx="2">
+          <a:lnRef idx="1">
             <a:schemeClr val="accent1"/>
           </a:lnRef>
-          <a:fillRef idx="0">
+          <a:fillRef idx="3">
             <a:schemeClr val="accent1"/>
           </a:fillRef>
-          <a:effectRef idx="1">
+          <a:effectRef idx="2">
             <a:schemeClr val="accent1"/>
           </a:effectRef>
           <a:fontRef idx="minor">
-            <a:schemeClr val="tx1"/>
+            <a:schemeClr val="lt1"/>
           </a:fontRef>
         </p:style>
-      </p:cxnSp>
+        <p:txBody>
+          <a:bodyPr rtlCol="0" anchor="ctr" lIns="36576" rIns="36576" wrap="square"/>
+          <a:lstStyle/>
+          <a:p>
+            <a:pPr algn="ctr"/>
+            <a:r>
+              <a:rPr sz="1100" b="1">
+                <a:solidFill>
+                  <a:srgbClr val="333333"/>
+                </a:solidFill>
+              </a:rPr>
+              <a:t>Solver's DEM</a:t>
+            </a:r>
+          </a:p>
+          <a:p>
+            <a:pPr algn="ctr"/>
+            <a:r>
+              <a:rPr sz="900">
+                <a:solidFill>
+                  <a:srgbClr val="333333"/>
+                </a:solidFill>
+              </a:rPr>
+              <a:t>label</a:t>
+            </a:r>
+          </a:p>
+        </p:txBody>
+      </p:sp>
       <p:cxnSp>
         <p:nvCxnSpPr>
           <p:cNvPr id="11" name="Connector 10"/>
@@ -11570,8 +10441,8 @@
         </p:nvCxnSpPr>
         <p:spPr>
           <a:xfrm>
-            <a:off x="7018020" y="1623060"/>
-            <a:ext cx="388620" cy="0"/>
+            <a:off x="5449824" y="1783080"/>
+            <a:ext cx="566928" cy="0"/>
           </a:xfrm>
           <a:prstGeom prst="line">
             <a:avLst/>
@@ -11580,7 +10451,7 @@
             <a:solidFill>
               <a:srgbClr val="57068C"/>
             </a:solidFill>
-            <a:tailEnd type="triangle"/>
+            <a:prstDash val="dash"/>
           </a:ln>
         </p:spPr>
         <p:style>
@@ -11606,8 +10477,8 @@
         </p:nvSpPr>
         <p:spPr>
           <a:xfrm>
-            <a:off x="2125980" y="2514600"/>
-            <a:ext cx="6652260" cy="548640"/>
+            <a:off x="5522976" y="1664208"/>
+            <a:ext cx="420624" cy="237744"/>
           </a:xfrm>
           <a:prstGeom prst="roundRect">
             <a:avLst>
@@ -11637,31 +10508,333 @@
           </a:fontRef>
         </p:style>
         <p:txBody>
-          <a:bodyPr rtlCol="0" anchor="ctr"/>
+          <a:bodyPr rtlCol="0" anchor="ctr" lIns="36576" rIns="36576" wrap="square"/>
           <a:lstStyle/>
           <a:p>
             <a:pPr algn="ctr"/>
             <a:r>
-              <a:rPr sz="1200" b="1">
+              <a:rPr sz="900" b="1">
                 <a:solidFill>
                   <a:srgbClr val="57068C"/>
                 </a:solidFill>
               </a:rPr>
-              <a:t>Loss: the solver's objective, predicted against observed AIA</a:t>
+              <a:t>loss</a:t>
+            </a:r>
+          </a:p>
+        </p:txBody>
+      </p:sp>
+      <p:sp>
+        <p:nvSpPr>
+          <p:cNvPr id="13" name="TextBox 12"/>
+          <p:cNvSpPr txBox="1"/>
+          <p:nvPr/>
+        </p:nvSpPr>
+        <p:spPr>
+          <a:xfrm>
+            <a:off x="365760" y="2633472"/>
+            <a:ext cx="1325880" cy="722376"/>
+          </a:xfrm>
+          <a:prstGeom prst="rect">
+            <a:avLst/>
+          </a:prstGeom>
+          <a:noFill/>
+        </p:spPr>
+        <p:txBody>
+          <a:bodyPr wrap="square" anchor="t" lIns="0" rIns="0" tIns="0" bIns="0">
+            <a:spAutoFit/>
+          </a:bodyPr>
+          <a:lstStyle/>
+          <a:p>
+            <a:pPr algn="l">
+              <a:spcAft>
+                <a:spcPts val="200"/>
+              </a:spcAft>
+            </a:pPr>
+            <a:r>
+              <a:rPr sz="1250" b="1" i="0">
+                <a:solidFill>
+                  <a:srgbClr val="57068C"/>
+                </a:solidFill>
+              </a:rPr>
+              <a:t>Label-free (unsupervised)</a:t>
+            </a:r>
+          </a:p>
+          <a:p>
+            <a:pPr algn="l">
+              <a:spcAft>
+                <a:spcPts val="200"/>
+              </a:spcAft>
+            </a:pPr>
+            <a:r>
+              <a:rPr sz="1000" b="0" i="0">
+                <a:solidFill>
+                  <a:srgbClr val="6B6B6B"/>
+                </a:solidFill>
+              </a:rPr>
+              <a:t>learns the solver's objective implicitly</a:t>
+            </a:r>
+          </a:p>
+        </p:txBody>
+      </p:sp>
+      <p:sp>
+        <p:nvSpPr>
+          <p:cNvPr id="14" name="Rounded Rectangle 13"/>
+          <p:cNvSpPr/>
+          <p:nvPr/>
+        </p:nvSpPr>
+        <p:spPr>
+          <a:xfrm>
+            <a:off x="1783080" y="2560320"/>
+            <a:ext cx="1051560" cy="640080"/>
+          </a:xfrm>
+          <a:prstGeom prst="roundRect">
+            <a:avLst>
+              <a:gd name="adj" fmla="val 6000"/>
+            </a:avLst>
+          </a:prstGeom>
+          <a:solidFill>
+            <a:srgbClr val="F4F1F8"/>
+          </a:solidFill>
+          <a:ln>
+            <a:noFill/>
+          </a:ln>
+          <a:effectLst/>
+        </p:spPr>
+        <p:style>
+          <a:lnRef idx="1">
+            <a:schemeClr val="accent1"/>
+          </a:lnRef>
+          <a:fillRef idx="3">
+            <a:schemeClr val="accent1"/>
+          </a:fillRef>
+          <a:effectRef idx="2">
+            <a:schemeClr val="accent1"/>
+          </a:effectRef>
+          <a:fontRef idx="minor">
+            <a:schemeClr val="lt1"/>
+          </a:fontRef>
+        </p:style>
+        <p:txBody>
+          <a:bodyPr rtlCol="0" anchor="ctr" lIns="36576" rIns="36576" wrap="square"/>
+          <a:lstStyle/>
+          <a:p>
+            <a:pPr algn="ctr"/>
+            <a:r>
+              <a:rPr sz="1100" b="1">
+                <a:solidFill>
+                  <a:srgbClr val="57068C"/>
+                </a:solidFill>
+              </a:rPr>
+              <a:t>Observed AIA</a:t>
+            </a:r>
+          </a:p>
+          <a:p>
+            <a:pPr algn="ctr"/>
+            <a:r>
+              <a:rPr sz="900">
+                <a:solidFill>
+                  <a:srgbClr val="333333"/>
+                </a:solidFill>
+              </a:rPr>
+              <a:t>6 channels</a:t>
+            </a:r>
+          </a:p>
+        </p:txBody>
+      </p:sp>
+      <p:sp>
+        <p:nvSpPr>
+          <p:cNvPr id="15" name="Rounded Rectangle 14"/>
+          <p:cNvSpPr/>
+          <p:nvPr/>
+        </p:nvSpPr>
+        <p:spPr>
+          <a:xfrm>
+            <a:off x="3090672" y="2560320"/>
+            <a:ext cx="1051560" cy="640080"/>
+          </a:xfrm>
+          <a:prstGeom prst="roundRect">
+            <a:avLst>
+              <a:gd name="adj" fmla="val 6000"/>
+            </a:avLst>
+          </a:prstGeom>
+          <a:solidFill>
+            <a:srgbClr val="57068C"/>
+          </a:solidFill>
+          <a:ln>
+            <a:noFill/>
+          </a:ln>
+          <a:effectLst/>
+        </p:spPr>
+        <p:style>
+          <a:lnRef idx="1">
+            <a:schemeClr val="accent1"/>
+          </a:lnRef>
+          <a:fillRef idx="3">
+            <a:schemeClr val="accent1"/>
+          </a:fillRef>
+          <a:effectRef idx="2">
+            <a:schemeClr val="accent1"/>
+          </a:effectRef>
+          <a:fontRef idx="minor">
+            <a:schemeClr val="lt1"/>
+          </a:fontRef>
+        </p:style>
+        <p:txBody>
+          <a:bodyPr rtlCol="0" anchor="ctr" lIns="36576" rIns="36576" wrap="square"/>
+          <a:lstStyle/>
+          <a:p>
+            <a:pPr algn="ctr"/>
+            <a:r>
+              <a:rPr sz="1100" b="1">
+                <a:solidFill>
+                  <a:srgbClr val="FFFFFF"/>
+                </a:solidFill>
+              </a:rPr>
+              <a:t>Model</a:t>
+            </a:r>
+          </a:p>
+        </p:txBody>
+      </p:sp>
+      <p:sp>
+        <p:nvSpPr>
+          <p:cNvPr id="16" name="Rounded Rectangle 15"/>
+          <p:cNvSpPr/>
+          <p:nvPr/>
+        </p:nvSpPr>
+        <p:spPr>
+          <a:xfrm>
+            <a:off x="4398264" y="2560320"/>
+            <a:ext cx="1051560" cy="640080"/>
+          </a:xfrm>
+          <a:prstGeom prst="roundRect">
+            <a:avLst>
+              <a:gd name="adj" fmla="val 6000"/>
+            </a:avLst>
+          </a:prstGeom>
+          <a:solidFill>
+            <a:srgbClr val="F4F1F8"/>
+          </a:solidFill>
+          <a:ln>
+            <a:noFill/>
+          </a:ln>
+          <a:effectLst/>
+        </p:spPr>
+        <p:style>
+          <a:lnRef idx="1">
+            <a:schemeClr val="accent1"/>
+          </a:lnRef>
+          <a:fillRef idx="3">
+            <a:schemeClr val="accent1"/>
+          </a:fillRef>
+          <a:effectRef idx="2">
+            <a:schemeClr val="accent1"/>
+          </a:effectRef>
+          <a:fontRef idx="minor">
+            <a:schemeClr val="lt1"/>
+          </a:fontRef>
+        </p:style>
+        <p:txBody>
+          <a:bodyPr rtlCol="0" anchor="ctr" lIns="36576" rIns="36576" wrap="square"/>
+          <a:lstStyle/>
+          <a:p>
+            <a:pPr algn="ctr"/>
+            <a:r>
+              <a:rPr sz="1100" b="1">
+                <a:solidFill>
+                  <a:srgbClr val="57068C"/>
+                </a:solidFill>
+              </a:rPr>
+              <a:t>DEM</a:t>
+            </a:r>
+          </a:p>
+          <a:p>
+            <a:pPr algn="ctr"/>
+            <a:r>
+              <a:rPr sz="900">
+                <a:solidFill>
+                  <a:srgbClr val="333333"/>
+                </a:solidFill>
+              </a:rPr>
+              <a:t>18 bins</a:t>
+            </a:r>
+          </a:p>
+        </p:txBody>
+      </p:sp>
+      <p:sp>
+        <p:nvSpPr>
+          <p:cNvPr id="17" name="Rounded Rectangle 16"/>
+          <p:cNvSpPr/>
+          <p:nvPr/>
+        </p:nvSpPr>
+        <p:spPr>
+          <a:xfrm>
+            <a:off x="5705856" y="2560320"/>
+            <a:ext cx="1051560" cy="640080"/>
+          </a:xfrm>
+          <a:prstGeom prst="roundRect">
+            <a:avLst>
+              <a:gd name="adj" fmla="val 6000"/>
+            </a:avLst>
+          </a:prstGeom>
+          <a:solidFill>
+            <a:srgbClr val="F4F1F8"/>
+          </a:solidFill>
+          <a:ln>
+            <a:noFill/>
+          </a:ln>
+          <a:effectLst/>
+        </p:spPr>
+        <p:style>
+          <a:lnRef idx="1">
+            <a:schemeClr val="accent1"/>
+          </a:lnRef>
+          <a:fillRef idx="3">
+            <a:schemeClr val="accent1"/>
+          </a:fillRef>
+          <a:effectRef idx="2">
+            <a:schemeClr val="accent1"/>
+          </a:effectRef>
+          <a:fontRef idx="minor">
+            <a:schemeClr val="lt1"/>
+          </a:fontRef>
+        </p:style>
+        <p:txBody>
+          <a:bodyPr rtlCol="0" anchor="ctr" lIns="36576" rIns="36576" wrap="square"/>
+          <a:lstStyle/>
+          <a:p>
+            <a:pPr algn="ctr"/>
+            <a:r>
+              <a:rPr sz="1100" b="1">
+                <a:solidFill>
+                  <a:srgbClr val="57068C"/>
+                </a:solidFill>
+              </a:rPr>
+              <a:t>Predicted AIA</a:t>
+            </a:r>
+          </a:p>
+          <a:p>
+            <a:pPr algn="ctr"/>
+            <a:r>
+              <a:rPr sz="900">
+                <a:solidFill>
+                  <a:srgbClr val="333333"/>
+                </a:solidFill>
+              </a:rPr>
+              <a:t>via response R</a:t>
             </a:r>
           </a:p>
         </p:txBody>
       </p:sp>
       <p:cxnSp>
         <p:nvCxnSpPr>
-          <p:cNvPr id="13" name="Connector 12"/>
+          <p:cNvPr id="18" name="Connector 17"/>
           <p:cNvCxnSpPr/>
           <p:nvPr/>
         </p:nvCxnSpPr>
         <p:spPr>
           <a:xfrm>
-            <a:off x="8092440" y="2057400"/>
-            <a:ext cx="0" cy="457200"/>
+            <a:off x="2834640" y="2880360"/>
+            <a:ext cx="256032" cy="0"/>
           </a:xfrm>
           <a:prstGeom prst="line">
             <a:avLst/>
@@ -11690,14 +10863,14 @@
       </p:cxnSp>
       <p:cxnSp>
         <p:nvCxnSpPr>
-          <p:cNvPr id="14" name="Connector 13"/>
+          <p:cNvPr id="19" name="Connector 18"/>
           <p:cNvCxnSpPr/>
           <p:nvPr/>
         </p:nvCxnSpPr>
         <p:spPr>
           <a:xfrm>
-            <a:off x="1051560" y="2057400"/>
-            <a:ext cx="0" cy="731520"/>
+            <a:off x="4142232" y="2880360"/>
+            <a:ext cx="256032" cy="0"/>
           </a:xfrm>
           <a:prstGeom prst="line">
             <a:avLst/>
@@ -11706,6 +10879,7 @@
             <a:solidFill>
               <a:srgbClr val="57068C"/>
             </a:solidFill>
+            <a:tailEnd type="triangle"/>
           </a:ln>
         </p:spPr>
         <p:style>
@@ -11725,14 +10899,14 @@
       </p:cxnSp>
       <p:cxnSp>
         <p:nvCxnSpPr>
-          <p:cNvPr id="15" name="Connector 14"/>
+          <p:cNvPr id="20" name="Connector 19"/>
           <p:cNvCxnSpPr/>
           <p:nvPr/>
         </p:nvCxnSpPr>
         <p:spPr>
           <a:xfrm>
-            <a:off x="1051560" y="2788920"/>
-            <a:ext cx="1074420" cy="0"/>
+            <a:off x="5449824" y="2880360"/>
+            <a:ext cx="256032" cy="0"/>
           </a:xfrm>
           <a:prstGeom prst="line">
             <a:avLst/>
@@ -11761,14 +10935,169 @@
       </p:cxnSp>
       <p:sp>
         <p:nvSpPr>
-          <p:cNvPr id="16" name="TextBox 15"/>
+          <p:cNvPr id="21" name="Rounded Rectangle 20"/>
+          <p:cNvSpPr/>
+          <p:nvPr/>
+        </p:nvSpPr>
+        <p:spPr>
+          <a:xfrm>
+            <a:off x="7324344" y="2560320"/>
+            <a:ext cx="1051560" cy="640080"/>
+          </a:xfrm>
+          <a:prstGeom prst="roundRect">
+            <a:avLst>
+              <a:gd name="adj" fmla="val 6000"/>
+            </a:avLst>
+          </a:prstGeom>
+          <a:solidFill>
+            <a:srgbClr val="ECEBE8"/>
+          </a:solidFill>
+          <a:ln>
+            <a:noFill/>
+          </a:ln>
+          <a:effectLst/>
+        </p:spPr>
+        <p:style>
+          <a:lnRef idx="1">
+            <a:schemeClr val="accent1"/>
+          </a:lnRef>
+          <a:fillRef idx="3">
+            <a:schemeClr val="accent1"/>
+          </a:fillRef>
+          <a:effectRef idx="2">
+            <a:schemeClr val="accent1"/>
+          </a:effectRef>
+          <a:fontRef idx="minor">
+            <a:schemeClr val="lt1"/>
+          </a:fontRef>
+        </p:style>
+        <p:txBody>
+          <a:bodyPr rtlCol="0" anchor="ctr" lIns="36576" rIns="36576" wrap="square"/>
+          <a:lstStyle/>
+          <a:p>
+            <a:pPr algn="ctr"/>
+            <a:r>
+              <a:rPr sz="1100" b="1">
+                <a:solidFill>
+                  <a:srgbClr val="333333"/>
+                </a:solidFill>
+              </a:rPr>
+              <a:t>Observed AIA</a:t>
+            </a:r>
+          </a:p>
+          <a:p>
+            <a:pPr algn="ctr"/>
+            <a:r>
+              <a:rPr sz="900">
+                <a:solidFill>
+                  <a:srgbClr val="333333"/>
+                </a:solidFill>
+              </a:rPr>
+              <a:t>6 channels</a:t>
+            </a:r>
+          </a:p>
+        </p:txBody>
+      </p:sp>
+      <p:cxnSp>
+        <p:nvCxnSpPr>
+          <p:cNvPr id="22" name="Connector 21"/>
+          <p:cNvCxnSpPr/>
+          <p:nvPr/>
+        </p:nvCxnSpPr>
+        <p:spPr>
+          <a:xfrm>
+            <a:off x="6757416" y="2880360"/>
+            <a:ext cx="566928" cy="0"/>
+          </a:xfrm>
+          <a:prstGeom prst="line">
+            <a:avLst/>
+          </a:prstGeom>
+          <a:ln w="19050">
+            <a:solidFill>
+              <a:srgbClr val="57068C"/>
+            </a:solidFill>
+            <a:prstDash val="dash"/>
+          </a:ln>
+        </p:spPr>
+        <p:style>
+          <a:lnRef idx="2">
+            <a:schemeClr val="accent1"/>
+          </a:lnRef>
+          <a:fillRef idx="0">
+            <a:schemeClr val="accent1"/>
+          </a:fillRef>
+          <a:effectRef idx="1">
+            <a:schemeClr val="accent1"/>
+          </a:effectRef>
+          <a:fontRef idx="minor">
+            <a:schemeClr val="tx1"/>
+          </a:fontRef>
+        </p:style>
+      </p:cxnSp>
+      <p:sp>
+        <p:nvSpPr>
+          <p:cNvPr id="23" name="Rounded Rectangle 22"/>
+          <p:cNvSpPr/>
+          <p:nvPr/>
+        </p:nvSpPr>
+        <p:spPr>
+          <a:xfrm>
+            <a:off x="6830568" y="2761488"/>
+            <a:ext cx="420624" cy="237744"/>
+          </a:xfrm>
+          <a:prstGeom prst="roundRect">
+            <a:avLst>
+              <a:gd name="adj" fmla="val 6000"/>
+            </a:avLst>
+          </a:prstGeom>
+          <a:solidFill>
+            <a:srgbClr val="E3DFE9"/>
+          </a:solidFill>
+          <a:ln>
+            <a:noFill/>
+          </a:ln>
+          <a:effectLst/>
+        </p:spPr>
+        <p:style>
+          <a:lnRef idx="1">
+            <a:schemeClr val="accent1"/>
+          </a:lnRef>
+          <a:fillRef idx="3">
+            <a:schemeClr val="accent1"/>
+          </a:fillRef>
+          <a:effectRef idx="2">
+            <a:schemeClr val="accent1"/>
+          </a:effectRef>
+          <a:fontRef idx="minor">
+            <a:schemeClr val="lt1"/>
+          </a:fontRef>
+        </p:style>
+        <p:txBody>
+          <a:bodyPr rtlCol="0" anchor="ctr" lIns="36576" rIns="36576" wrap="square"/>
+          <a:lstStyle/>
+          <a:p>
+            <a:pPr algn="ctr"/>
+            <a:r>
+              <a:rPr sz="900" b="1">
+                <a:solidFill>
+                  <a:srgbClr val="57068C"/>
+                </a:solidFill>
+              </a:rPr>
+              <a:t>loss</a:t>
+            </a:r>
+          </a:p>
+        </p:txBody>
+      </p:sp>
+      <p:sp>
+        <p:nvSpPr>
+          <p:cNvPr id="24" name="TextBox 23"/>
           <p:cNvSpPr txBox="1"/>
           <p:nvPr/>
         </p:nvSpPr>
         <p:spPr>
           <a:xfrm>
-            <a:off x="365760" y="3154680"/>
-            <a:ext cx="8412480" cy="1280160"/>
+            <a:off x="365760" y="3566160"/>
+            <a:ext cx="8412480" cy="457200"/>
           </a:xfrm>
           <a:prstGeom prst="rect">
             <a:avLst/>
@@ -11781,87 +11110,18 @@
           </a:bodyPr>
           <a:lstStyle/>
           <a:p>
-            <a:pPr algn="l" marL="182880" indent="-182880">
-              <a:spcAft>
-                <a:spcPts val="400"/>
-              </a:spcAft>
-              <a:buClr>
-                <a:srgbClr val="333333"/>
-              </a:buClr>
-              <a:buChar char="•"/>
+            <a:pPr algn="l">
+              <a:spcAft>
+                <a:spcPts val="600"/>
+              </a:spcAft>
             </a:pPr>
             <a:r>
-              <a:rPr sz="1200" b="0" i="0">
-                <a:solidFill>
-                  <a:srgbClr val="333333"/>
+              <a:rPr sz="1250" b="1" i="0">
+                <a:solidFill>
+                  <a:srgbClr val="57068C"/>
                 </a:solidFill>
               </a:rPr>
-              <a:t>6 log-intensities in; 4 hidden layers of 232, SiLU; 54 non-negative basis weights out.</a:t>
-            </a:r>
-          </a:p>
-          <a:p>
-            <a:pPr algn="l" marL="182880" indent="-182880">
-              <a:spcAft>
-                <a:spcPts val="400"/>
-              </a:spcAft>
-              <a:buClr>
-                <a:srgbClr val="333333"/>
-              </a:buClr>
-              <a:buChar char="•"/>
-            </a:pPr>
-            <a:r>
-              <a:rPr sz="1200" b="1" i="0">
-                <a:solidFill>
-                  <a:srgbClr val="57068C"/>
-                </a:solidFill>
-              </a:rPr>
-              <a:t>Why weights, not bins: the solvers work this way. </a:t>
-            </a:r>
-            <a:r>
-              <a:rPr sz="1200" b="0" i="0">
-                <a:solidFill>
-                  <a:srgbClr val="333333"/>
-                </a:solidFill>
-              </a:rPr>
-              <a:t>BP and ElasticNet solve for the same 54 weights (at each of 18 bins, a spike and Gaussians 0.1 and 0.2 dex wide), and their L1 term acts on those weights.</a:t>
-            </a:r>
-          </a:p>
-          <a:p>
-            <a:pPr algn="l" marL="182880" indent="-182880">
-              <a:spcAft>
-                <a:spcPts val="400"/>
-              </a:spcAft>
-              <a:buClr>
-                <a:srgbClr val="333333"/>
-              </a:buClr>
-              <a:buChar char="•"/>
-            </a:pPr>
-            <a:r>
-              <a:rPr sz="1200" b="0" i="0">
-                <a:solidFill>
-                  <a:srgbClr val="333333"/>
-                </a:solidFill>
-              </a:rPr>
-              <a:t>DEM = B·w over 18 bins; predicted AIA = R·DEM. B and R are fixed; only the MLP is learned.</a:t>
-            </a:r>
-          </a:p>
-          <a:p>
-            <a:pPr algn="l" marL="182880" indent="-182880">
-              <a:spcAft>
-                <a:spcPts val="400"/>
-              </a:spcAft>
-              <a:buClr>
-                <a:srgbClr val="333333"/>
-              </a:buClr>
-              <a:buChar char="•"/>
-            </a:pPr>
-            <a:r>
-              <a:rPr sz="1200" b="0" i="0">
-                <a:solidFill>
-                  <a:srgbClr val="333333"/>
-                </a:solidFill>
-              </a:rPr>
-              <a:t>176k parameters; one forward pass per pixel.</a:t>
+              <a:t>We never train on the solver's DEMs; we use them only to evaluate.</a:t>
             </a:r>
           </a:p>
         </p:txBody>
@@ -11917,6 +11177,791 @@
                   <a:srgbClr val="57068C"/>
                 </a:solidFill>
               </a:rPr>
+              <a:t>The model: a small MLP feeding a fixed forward model</a:t>
+            </a:r>
+          </a:p>
+        </p:txBody>
+      </p:sp>
+      <p:sp>
+        <p:nvSpPr>
+          <p:cNvPr id="3" name="Rounded Rectangle 2"/>
+          <p:cNvSpPr/>
+          <p:nvPr/>
+        </p:nvSpPr>
+        <p:spPr>
+          <a:xfrm>
+            <a:off x="365760" y="1188720"/>
+            <a:ext cx="1371600" cy="868680"/>
+          </a:xfrm>
+          <a:prstGeom prst="roundRect">
+            <a:avLst>
+              <a:gd name="adj" fmla="val 6000"/>
+            </a:avLst>
+          </a:prstGeom>
+          <a:solidFill>
+            <a:srgbClr val="F4F1F8"/>
+          </a:solidFill>
+          <a:ln>
+            <a:noFill/>
+          </a:ln>
+          <a:effectLst/>
+        </p:spPr>
+        <p:style>
+          <a:lnRef idx="1">
+            <a:schemeClr val="accent1"/>
+          </a:lnRef>
+          <a:fillRef idx="3">
+            <a:schemeClr val="accent1"/>
+          </a:fillRef>
+          <a:effectRef idx="2">
+            <a:schemeClr val="accent1"/>
+          </a:effectRef>
+          <a:fontRef idx="minor">
+            <a:schemeClr val="lt1"/>
+          </a:fontRef>
+        </p:style>
+        <p:txBody>
+          <a:bodyPr rtlCol="0" anchor="ctr" lIns="36576" rIns="36576" wrap="square"/>
+          <a:lstStyle/>
+          <a:p>
+            <a:pPr algn="ctr"/>
+            <a:r>
+              <a:rPr sz="1300" b="1">
+                <a:solidFill>
+                  <a:srgbClr val="57068C"/>
+                </a:solidFill>
+              </a:rPr>
+              <a:t>Observed AIA</a:t>
+            </a:r>
+          </a:p>
+          <a:p>
+            <a:pPr algn="ctr"/>
+            <a:r>
+              <a:rPr sz="1000">
+                <a:solidFill>
+                  <a:srgbClr val="333333"/>
+                </a:solidFill>
+              </a:rPr>
+              <a:t>6 channels</a:t>
+            </a:r>
+          </a:p>
+        </p:txBody>
+      </p:sp>
+      <p:sp>
+        <p:nvSpPr>
+          <p:cNvPr id="4" name="Rounded Rectangle 3"/>
+          <p:cNvSpPr/>
+          <p:nvPr/>
+        </p:nvSpPr>
+        <p:spPr>
+          <a:xfrm>
+            <a:off x="2125980" y="1188720"/>
+            <a:ext cx="1371600" cy="868680"/>
+          </a:xfrm>
+          <a:prstGeom prst="roundRect">
+            <a:avLst>
+              <a:gd name="adj" fmla="val 6000"/>
+            </a:avLst>
+          </a:prstGeom>
+          <a:solidFill>
+            <a:srgbClr val="57068C"/>
+          </a:solidFill>
+          <a:ln>
+            <a:noFill/>
+          </a:ln>
+          <a:effectLst/>
+        </p:spPr>
+        <p:style>
+          <a:lnRef idx="1">
+            <a:schemeClr val="accent1"/>
+          </a:lnRef>
+          <a:fillRef idx="3">
+            <a:schemeClr val="accent1"/>
+          </a:fillRef>
+          <a:effectRef idx="2">
+            <a:schemeClr val="accent1"/>
+          </a:effectRef>
+          <a:fontRef idx="minor">
+            <a:schemeClr val="lt1"/>
+          </a:fontRef>
+        </p:style>
+        <p:txBody>
+          <a:bodyPr rtlCol="0" anchor="ctr" lIns="36576" rIns="36576" wrap="square"/>
+          <a:lstStyle/>
+          <a:p>
+            <a:pPr algn="ctr"/>
+            <a:r>
+              <a:rPr sz="1300" b="1">
+                <a:solidFill>
+                  <a:srgbClr val="FFFFFF"/>
+                </a:solidFill>
+              </a:rPr>
+              <a:t>MLP</a:t>
+            </a:r>
+          </a:p>
+          <a:p>
+            <a:pPr algn="ctr"/>
+            <a:r>
+              <a:rPr sz="1000">
+                <a:solidFill>
+                  <a:srgbClr val="FFFFFF"/>
+                </a:solidFill>
+              </a:rPr>
+              <a:t>176k params</a:t>
+            </a:r>
+          </a:p>
+        </p:txBody>
+      </p:sp>
+      <p:sp>
+        <p:nvSpPr>
+          <p:cNvPr id="5" name="Rounded Rectangle 4"/>
+          <p:cNvSpPr/>
+          <p:nvPr/>
+        </p:nvSpPr>
+        <p:spPr>
+          <a:xfrm>
+            <a:off x="3886200" y="1188720"/>
+            <a:ext cx="1371600" cy="868680"/>
+          </a:xfrm>
+          <a:prstGeom prst="roundRect">
+            <a:avLst>
+              <a:gd name="adj" fmla="val 6000"/>
+            </a:avLst>
+          </a:prstGeom>
+          <a:solidFill>
+            <a:srgbClr val="F4F1F8"/>
+          </a:solidFill>
+          <a:ln>
+            <a:noFill/>
+          </a:ln>
+          <a:effectLst/>
+        </p:spPr>
+        <p:style>
+          <a:lnRef idx="1">
+            <a:schemeClr val="accent1"/>
+          </a:lnRef>
+          <a:fillRef idx="3">
+            <a:schemeClr val="accent1"/>
+          </a:fillRef>
+          <a:effectRef idx="2">
+            <a:schemeClr val="accent1"/>
+          </a:effectRef>
+          <a:fontRef idx="minor">
+            <a:schemeClr val="lt1"/>
+          </a:fontRef>
+        </p:style>
+        <p:txBody>
+          <a:bodyPr rtlCol="0" anchor="ctr" lIns="36576" rIns="36576" wrap="square"/>
+          <a:lstStyle/>
+          <a:p>
+            <a:pPr algn="ctr"/>
+            <a:r>
+              <a:rPr sz="1300" b="1">
+                <a:solidFill>
+                  <a:srgbClr val="57068C"/>
+                </a:solidFill>
+              </a:rPr>
+              <a:t>Basis weights</a:t>
+            </a:r>
+          </a:p>
+          <a:p>
+            <a:pPr algn="ctr"/>
+            <a:r>
+              <a:rPr sz="1000">
+                <a:solidFill>
+                  <a:srgbClr val="333333"/>
+                </a:solidFill>
+              </a:rPr>
+              <a:t>54, same as solver</a:t>
+            </a:r>
+          </a:p>
+        </p:txBody>
+      </p:sp>
+      <p:sp>
+        <p:nvSpPr>
+          <p:cNvPr id="6" name="Rounded Rectangle 5"/>
+          <p:cNvSpPr/>
+          <p:nvPr/>
+        </p:nvSpPr>
+        <p:spPr>
+          <a:xfrm>
+            <a:off x="5646420" y="1188720"/>
+            <a:ext cx="1371600" cy="868680"/>
+          </a:xfrm>
+          <a:prstGeom prst="roundRect">
+            <a:avLst>
+              <a:gd name="adj" fmla="val 6000"/>
+            </a:avLst>
+          </a:prstGeom>
+          <a:solidFill>
+            <a:srgbClr val="F4F1F8"/>
+          </a:solidFill>
+          <a:ln>
+            <a:noFill/>
+          </a:ln>
+          <a:effectLst/>
+        </p:spPr>
+        <p:style>
+          <a:lnRef idx="1">
+            <a:schemeClr val="accent1"/>
+          </a:lnRef>
+          <a:fillRef idx="3">
+            <a:schemeClr val="accent1"/>
+          </a:fillRef>
+          <a:effectRef idx="2">
+            <a:schemeClr val="accent1"/>
+          </a:effectRef>
+          <a:fontRef idx="minor">
+            <a:schemeClr val="lt1"/>
+          </a:fontRef>
+        </p:style>
+        <p:txBody>
+          <a:bodyPr rtlCol="0" anchor="ctr" lIns="36576" rIns="36576" wrap="square"/>
+          <a:lstStyle/>
+          <a:p>
+            <a:pPr algn="ctr"/>
+            <a:r>
+              <a:rPr sz="1300" b="1">
+                <a:solidFill>
+                  <a:srgbClr val="57068C"/>
+                </a:solidFill>
+              </a:rPr>
+              <a:t>DEM</a:t>
+            </a:r>
+          </a:p>
+          <a:p>
+            <a:pPr algn="ctr"/>
+            <a:r>
+              <a:rPr sz="1000">
+                <a:solidFill>
+                  <a:srgbClr val="333333"/>
+                </a:solidFill>
+              </a:rPr>
+              <a:t>18 bins, logT 5.5–7.2</a:t>
+            </a:r>
+          </a:p>
+        </p:txBody>
+      </p:sp>
+      <p:sp>
+        <p:nvSpPr>
+          <p:cNvPr id="7" name="Rounded Rectangle 6"/>
+          <p:cNvSpPr/>
+          <p:nvPr/>
+        </p:nvSpPr>
+        <p:spPr>
+          <a:xfrm>
+            <a:off x="7406640" y="1188720"/>
+            <a:ext cx="1371600" cy="868680"/>
+          </a:xfrm>
+          <a:prstGeom prst="roundRect">
+            <a:avLst>
+              <a:gd name="adj" fmla="val 6000"/>
+            </a:avLst>
+          </a:prstGeom>
+          <a:solidFill>
+            <a:srgbClr val="F4F1F8"/>
+          </a:solidFill>
+          <a:ln>
+            <a:noFill/>
+          </a:ln>
+          <a:effectLst/>
+        </p:spPr>
+        <p:style>
+          <a:lnRef idx="1">
+            <a:schemeClr val="accent1"/>
+          </a:lnRef>
+          <a:fillRef idx="3">
+            <a:schemeClr val="accent1"/>
+          </a:fillRef>
+          <a:effectRef idx="2">
+            <a:schemeClr val="accent1"/>
+          </a:effectRef>
+          <a:fontRef idx="minor">
+            <a:schemeClr val="lt1"/>
+          </a:fontRef>
+        </p:style>
+        <p:txBody>
+          <a:bodyPr rtlCol="0" anchor="ctr" lIns="36576" rIns="36576" wrap="square"/>
+          <a:lstStyle/>
+          <a:p>
+            <a:pPr algn="ctr"/>
+            <a:r>
+              <a:rPr sz="1300" b="1">
+                <a:solidFill>
+                  <a:srgbClr val="57068C"/>
+                </a:solidFill>
+              </a:rPr>
+              <a:t>Predicted AIA</a:t>
+            </a:r>
+          </a:p>
+          <a:p>
+            <a:pPr algn="ctr"/>
+            <a:r>
+              <a:rPr sz="1000">
+                <a:solidFill>
+                  <a:srgbClr val="333333"/>
+                </a:solidFill>
+              </a:rPr>
+              <a:t>via response R</a:t>
+            </a:r>
+          </a:p>
+        </p:txBody>
+      </p:sp>
+      <p:cxnSp>
+        <p:nvCxnSpPr>
+          <p:cNvPr id="8" name="Connector 7"/>
+          <p:cNvCxnSpPr/>
+          <p:nvPr/>
+        </p:nvCxnSpPr>
+        <p:spPr>
+          <a:xfrm>
+            <a:off x="1737360" y="1623060"/>
+            <a:ext cx="388620" cy="0"/>
+          </a:xfrm>
+          <a:prstGeom prst="line">
+            <a:avLst/>
+          </a:prstGeom>
+          <a:ln w="19050">
+            <a:solidFill>
+              <a:srgbClr val="57068C"/>
+            </a:solidFill>
+            <a:tailEnd type="triangle"/>
+          </a:ln>
+        </p:spPr>
+        <p:style>
+          <a:lnRef idx="2">
+            <a:schemeClr val="accent1"/>
+          </a:lnRef>
+          <a:fillRef idx="0">
+            <a:schemeClr val="accent1"/>
+          </a:fillRef>
+          <a:effectRef idx="1">
+            <a:schemeClr val="accent1"/>
+          </a:effectRef>
+          <a:fontRef idx="minor">
+            <a:schemeClr val="tx1"/>
+          </a:fontRef>
+        </p:style>
+      </p:cxnSp>
+      <p:cxnSp>
+        <p:nvCxnSpPr>
+          <p:cNvPr id="9" name="Connector 8"/>
+          <p:cNvCxnSpPr/>
+          <p:nvPr/>
+        </p:nvCxnSpPr>
+        <p:spPr>
+          <a:xfrm>
+            <a:off x="3497580" y="1623060"/>
+            <a:ext cx="388620" cy="0"/>
+          </a:xfrm>
+          <a:prstGeom prst="line">
+            <a:avLst/>
+          </a:prstGeom>
+          <a:ln w="19050">
+            <a:solidFill>
+              <a:srgbClr val="57068C"/>
+            </a:solidFill>
+            <a:tailEnd type="triangle"/>
+          </a:ln>
+        </p:spPr>
+        <p:style>
+          <a:lnRef idx="2">
+            <a:schemeClr val="accent1"/>
+          </a:lnRef>
+          <a:fillRef idx="0">
+            <a:schemeClr val="accent1"/>
+          </a:fillRef>
+          <a:effectRef idx="1">
+            <a:schemeClr val="accent1"/>
+          </a:effectRef>
+          <a:fontRef idx="minor">
+            <a:schemeClr val="tx1"/>
+          </a:fontRef>
+        </p:style>
+      </p:cxnSp>
+      <p:cxnSp>
+        <p:nvCxnSpPr>
+          <p:cNvPr id="10" name="Connector 9"/>
+          <p:cNvCxnSpPr/>
+          <p:nvPr/>
+        </p:nvCxnSpPr>
+        <p:spPr>
+          <a:xfrm>
+            <a:off x="5257800" y="1623060"/>
+            <a:ext cx="388620" cy="0"/>
+          </a:xfrm>
+          <a:prstGeom prst="line">
+            <a:avLst/>
+          </a:prstGeom>
+          <a:ln w="19050">
+            <a:solidFill>
+              <a:srgbClr val="57068C"/>
+            </a:solidFill>
+            <a:tailEnd type="triangle"/>
+          </a:ln>
+        </p:spPr>
+        <p:style>
+          <a:lnRef idx="2">
+            <a:schemeClr val="accent1"/>
+          </a:lnRef>
+          <a:fillRef idx="0">
+            <a:schemeClr val="accent1"/>
+          </a:fillRef>
+          <a:effectRef idx="1">
+            <a:schemeClr val="accent1"/>
+          </a:effectRef>
+          <a:fontRef idx="minor">
+            <a:schemeClr val="tx1"/>
+          </a:fontRef>
+        </p:style>
+      </p:cxnSp>
+      <p:cxnSp>
+        <p:nvCxnSpPr>
+          <p:cNvPr id="11" name="Connector 10"/>
+          <p:cNvCxnSpPr/>
+          <p:nvPr/>
+        </p:nvCxnSpPr>
+        <p:spPr>
+          <a:xfrm>
+            <a:off x="7018020" y="1623060"/>
+            <a:ext cx="388620" cy="0"/>
+          </a:xfrm>
+          <a:prstGeom prst="line">
+            <a:avLst/>
+          </a:prstGeom>
+          <a:ln w="19050">
+            <a:solidFill>
+              <a:srgbClr val="57068C"/>
+            </a:solidFill>
+            <a:tailEnd type="triangle"/>
+          </a:ln>
+        </p:spPr>
+        <p:style>
+          <a:lnRef idx="2">
+            <a:schemeClr val="accent1"/>
+          </a:lnRef>
+          <a:fillRef idx="0">
+            <a:schemeClr val="accent1"/>
+          </a:fillRef>
+          <a:effectRef idx="1">
+            <a:schemeClr val="accent1"/>
+          </a:effectRef>
+          <a:fontRef idx="minor">
+            <a:schemeClr val="tx1"/>
+          </a:fontRef>
+        </p:style>
+      </p:cxnSp>
+      <p:sp>
+        <p:nvSpPr>
+          <p:cNvPr id="12" name="Rounded Rectangle 11"/>
+          <p:cNvSpPr/>
+          <p:nvPr/>
+        </p:nvSpPr>
+        <p:spPr>
+          <a:xfrm>
+            <a:off x="2125980" y="2514600"/>
+            <a:ext cx="6652260" cy="548640"/>
+          </a:xfrm>
+          <a:prstGeom prst="roundRect">
+            <a:avLst>
+              <a:gd name="adj" fmla="val 6000"/>
+            </a:avLst>
+          </a:prstGeom>
+          <a:solidFill>
+            <a:srgbClr val="E3DFE9"/>
+          </a:solidFill>
+          <a:ln>
+            <a:noFill/>
+          </a:ln>
+          <a:effectLst/>
+        </p:spPr>
+        <p:style>
+          <a:lnRef idx="1">
+            <a:schemeClr val="accent1"/>
+          </a:lnRef>
+          <a:fillRef idx="3">
+            <a:schemeClr val="accent1"/>
+          </a:fillRef>
+          <a:effectRef idx="2">
+            <a:schemeClr val="accent1"/>
+          </a:effectRef>
+          <a:fontRef idx="minor">
+            <a:schemeClr val="lt1"/>
+          </a:fontRef>
+        </p:style>
+        <p:txBody>
+          <a:bodyPr rtlCol="0" anchor="ctr"/>
+          <a:lstStyle/>
+          <a:p>
+            <a:pPr algn="ctr"/>
+            <a:r>
+              <a:rPr sz="1200" b="1">
+                <a:solidFill>
+                  <a:srgbClr val="57068C"/>
+                </a:solidFill>
+              </a:rPr>
+              <a:t>Loss: the solver's objective, predicted against observed AIA</a:t>
+            </a:r>
+          </a:p>
+        </p:txBody>
+      </p:sp>
+      <p:cxnSp>
+        <p:nvCxnSpPr>
+          <p:cNvPr id="13" name="Connector 12"/>
+          <p:cNvCxnSpPr/>
+          <p:nvPr/>
+        </p:nvCxnSpPr>
+        <p:spPr>
+          <a:xfrm>
+            <a:off x="8092440" y="2057400"/>
+            <a:ext cx="0" cy="457200"/>
+          </a:xfrm>
+          <a:prstGeom prst="line">
+            <a:avLst/>
+          </a:prstGeom>
+          <a:ln w="19050">
+            <a:solidFill>
+              <a:srgbClr val="57068C"/>
+            </a:solidFill>
+            <a:tailEnd type="triangle"/>
+          </a:ln>
+        </p:spPr>
+        <p:style>
+          <a:lnRef idx="2">
+            <a:schemeClr val="accent1"/>
+          </a:lnRef>
+          <a:fillRef idx="0">
+            <a:schemeClr val="accent1"/>
+          </a:fillRef>
+          <a:effectRef idx="1">
+            <a:schemeClr val="accent1"/>
+          </a:effectRef>
+          <a:fontRef idx="minor">
+            <a:schemeClr val="tx1"/>
+          </a:fontRef>
+        </p:style>
+      </p:cxnSp>
+      <p:cxnSp>
+        <p:nvCxnSpPr>
+          <p:cNvPr id="14" name="Connector 13"/>
+          <p:cNvCxnSpPr/>
+          <p:nvPr/>
+        </p:nvCxnSpPr>
+        <p:spPr>
+          <a:xfrm>
+            <a:off x="1051560" y="2057400"/>
+            <a:ext cx="0" cy="731520"/>
+          </a:xfrm>
+          <a:prstGeom prst="line">
+            <a:avLst/>
+          </a:prstGeom>
+          <a:ln w="19050">
+            <a:solidFill>
+              <a:srgbClr val="57068C"/>
+            </a:solidFill>
+          </a:ln>
+        </p:spPr>
+        <p:style>
+          <a:lnRef idx="2">
+            <a:schemeClr val="accent1"/>
+          </a:lnRef>
+          <a:fillRef idx="0">
+            <a:schemeClr val="accent1"/>
+          </a:fillRef>
+          <a:effectRef idx="1">
+            <a:schemeClr val="accent1"/>
+          </a:effectRef>
+          <a:fontRef idx="minor">
+            <a:schemeClr val="tx1"/>
+          </a:fontRef>
+        </p:style>
+      </p:cxnSp>
+      <p:cxnSp>
+        <p:nvCxnSpPr>
+          <p:cNvPr id="15" name="Connector 14"/>
+          <p:cNvCxnSpPr/>
+          <p:nvPr/>
+        </p:nvCxnSpPr>
+        <p:spPr>
+          <a:xfrm>
+            <a:off x="1051560" y="2788920"/>
+            <a:ext cx="1074420" cy="0"/>
+          </a:xfrm>
+          <a:prstGeom prst="line">
+            <a:avLst/>
+          </a:prstGeom>
+          <a:ln w="19050">
+            <a:solidFill>
+              <a:srgbClr val="57068C"/>
+            </a:solidFill>
+            <a:tailEnd type="triangle"/>
+          </a:ln>
+        </p:spPr>
+        <p:style>
+          <a:lnRef idx="2">
+            <a:schemeClr val="accent1"/>
+          </a:lnRef>
+          <a:fillRef idx="0">
+            <a:schemeClr val="accent1"/>
+          </a:fillRef>
+          <a:effectRef idx="1">
+            <a:schemeClr val="accent1"/>
+          </a:effectRef>
+          <a:fontRef idx="minor">
+            <a:schemeClr val="tx1"/>
+          </a:fontRef>
+        </p:style>
+      </p:cxnSp>
+      <p:sp>
+        <p:nvSpPr>
+          <p:cNvPr id="16" name="TextBox 15"/>
+          <p:cNvSpPr txBox="1"/>
+          <p:nvPr/>
+        </p:nvSpPr>
+        <p:spPr>
+          <a:xfrm>
+            <a:off x="365760" y="3154680"/>
+            <a:ext cx="8412480" cy="1280160"/>
+          </a:xfrm>
+          <a:prstGeom prst="rect">
+            <a:avLst/>
+          </a:prstGeom>
+          <a:noFill/>
+        </p:spPr>
+        <p:txBody>
+          <a:bodyPr wrap="square" anchor="t" lIns="0" rIns="0" tIns="0" bIns="0">
+            <a:spAutoFit/>
+          </a:bodyPr>
+          <a:lstStyle/>
+          <a:p>
+            <a:pPr algn="l" marL="182880" indent="-182880">
+              <a:spcAft>
+                <a:spcPts val="400"/>
+              </a:spcAft>
+              <a:buClr>
+                <a:srgbClr val="333333"/>
+              </a:buClr>
+              <a:buChar char="•"/>
+            </a:pPr>
+            <a:r>
+              <a:rPr sz="1200" b="0" i="0">
+                <a:solidFill>
+                  <a:srgbClr val="333333"/>
+                </a:solidFill>
+              </a:rPr>
+              <a:t>6 log-intensities in; 4 hidden layers of 232, SiLU; 54 non-negative basis weights out.</a:t>
+            </a:r>
+          </a:p>
+          <a:p>
+            <a:pPr algn="l" marL="182880" indent="-182880">
+              <a:spcAft>
+                <a:spcPts val="400"/>
+              </a:spcAft>
+              <a:buClr>
+                <a:srgbClr val="333333"/>
+              </a:buClr>
+              <a:buChar char="•"/>
+            </a:pPr>
+            <a:r>
+              <a:rPr sz="1200" b="0" i="0">
+                <a:solidFill>
+                  <a:srgbClr val="333333"/>
+                </a:solidFill>
+              </a:rPr>
+              <a:t>BP and ElasticNet solve for the same 54 weights (at each of 18 bins, a spike and Gaussians 0.1 and 0.2 dex wide), and their L1 term acts on those weights.</a:t>
+            </a:r>
+          </a:p>
+          <a:p>
+            <a:pPr algn="l" marL="182880" indent="-182880">
+              <a:spcAft>
+                <a:spcPts val="400"/>
+              </a:spcAft>
+              <a:buClr>
+                <a:srgbClr val="333333"/>
+              </a:buClr>
+              <a:buChar char="•"/>
+            </a:pPr>
+            <a:r>
+              <a:rPr sz="1200" b="0" i="0">
+                <a:solidFill>
+                  <a:srgbClr val="333333"/>
+                </a:solidFill>
+              </a:rPr>
+              <a:t>DEM = B·w over 18 bins; predicted AIA = R·DEM. B and R are fixed; only the MLP is learned.</a:t>
+            </a:r>
+          </a:p>
+          <a:p>
+            <a:pPr algn="l" marL="182880" indent="-182880">
+              <a:spcAft>
+                <a:spcPts val="400"/>
+              </a:spcAft>
+              <a:buClr>
+                <a:srgbClr val="333333"/>
+              </a:buClr>
+              <a:buChar char="•"/>
+            </a:pPr>
+            <a:r>
+              <a:rPr sz="1200" b="0" i="0">
+                <a:solidFill>
+                  <a:srgbClr val="333333"/>
+                </a:solidFill>
+              </a:rPr>
+              <a:t>176k parameters; one forward pass per pixel.</a:t>
+            </a:r>
+          </a:p>
+        </p:txBody>
+      </p:sp>
+    </p:spTree>
+  </p:cSld>
+  <p:clrMapOvr>
+    <a:masterClrMapping/>
+  </p:clrMapOvr>
+</p:sld>
+</file>
+
+<file path=ppt/slides/slide5.xml><?xml version="1.0" encoding="utf-8"?>
+<p:sld xmlns:a="http://schemas.openxmlformats.org/drawingml/2006/main" xmlns:p="http://schemas.openxmlformats.org/presentationml/2006/main" xmlns:r="http://schemas.openxmlformats.org/officeDocument/2006/relationships">
+  <p:cSld>
+    <p:spTree>
+      <p:nvGrpSpPr>
+        <p:cNvPr id="1" name=""/>
+        <p:cNvGrpSpPr/>
+        <p:nvPr/>
+      </p:nvGrpSpPr>
+      <p:grpSpPr/>
+      <p:sp>
+        <p:nvSpPr>
+          <p:cNvPr id="2" name="TextBox 1"/>
+          <p:cNvSpPr txBox="1"/>
+          <p:nvPr/>
+        </p:nvSpPr>
+        <p:spPr>
+          <a:xfrm>
+            <a:off x="265176" y="219456"/>
+            <a:ext cx="8503920" cy="566928"/>
+          </a:xfrm>
+          <a:prstGeom prst="rect">
+            <a:avLst/>
+          </a:prstGeom>
+          <a:noFill/>
+        </p:spPr>
+        <p:txBody>
+          <a:bodyPr wrap="square" anchor="t" lIns="0" rIns="0" tIns="0" bIns="0">
+            <a:spAutoFit/>
+          </a:bodyPr>
+          <a:lstStyle/>
+          <a:p>
+            <a:pPr algn="l">
+              <a:spcAft>
+                <a:spcPts val="600"/>
+              </a:spcAft>
+            </a:pPr>
+            <a:r>
+              <a:rPr sz="2000" b="1" i="0">
+                <a:solidFill>
+                  <a:srgbClr val="57068C"/>
+                </a:solidFill>
+              </a:rPr>
               <a:t>The loss is the solver's own objective</a:t>
             </a:r>
           </a:p>
@@ -12640,7 +12685,7 @@
 </p:sld>
 </file>
 
-<file path=ppt/slides/slide5.xml><?xml version="1.0" encoding="utf-8"?>
+<file path=ppt/slides/slide6.xml><?xml version="1.0" encoding="utf-8"?>
 <p:sld xmlns:a="http://schemas.openxmlformats.org/drawingml/2006/main" xmlns:p="http://schemas.openxmlformats.org/presentationml/2006/main" xmlns:r="http://schemas.openxmlformats.org/officeDocument/2006/relationships">
   <p:cSld>
     <p:spTree>
@@ -12779,7 +12824,7 @@
                   <a:srgbClr val="57068C"/>
                 </a:solidFill>
               </a:rPr>
-              <a:t>Label-free network (ours): </a:t>
+              <a:t>Label-free network: </a:t>
             </a:r>
             <a:r>
               <a:rPr sz="1400" b="0" i="0">
@@ -12827,7 +12872,7 @@
 </p:sld>
 </file>
 
-<file path=ppt/slides/slide6.xml><?xml version="1.0" encoding="utf-8"?>
+<file path=ppt/slides/slide7.xml><?xml version="1.0" encoding="utf-8"?>
 <p:sld xmlns:a="http://schemas.openxmlformats.org/drawingml/2006/main" xmlns:p="http://schemas.openxmlformats.org/presentationml/2006/main" xmlns:r="http://schemas.openxmlformats.org/officeDocument/2006/relationships">
   <p:cSld>
     <p:spTree>
@@ -13348,7 +13393,58 @@
 </p:sld>
 </file>
 
-<file path=ppt/slides/slide7.xml><?xml version="1.0" encoding="utf-8"?>
+<file path=ppt/slides/slide8.xml><?xml version="1.0" encoding="utf-8"?>
+<p:sld xmlns:a="http://schemas.openxmlformats.org/drawingml/2006/main" xmlns:p="http://schemas.openxmlformats.org/presentationml/2006/main" xmlns:r="http://schemas.openxmlformats.org/officeDocument/2006/relationships">
+  <p:cSld>
+    <p:spTree>
+      <p:nvGrpSpPr>
+        <p:cNvPr id="1" name=""/>
+        <p:cNvGrpSpPr/>
+        <p:nvPr/>
+      </p:nvGrpSpPr>
+      <p:grpSpPr/>
+      <p:sp>
+        <p:nvSpPr>
+          <p:cNvPr id="2" name="Title 1"/>
+          <p:cNvSpPr>
+            <a:spLocks noGrp="1"/>
+          </p:cNvSpPr>
+          <p:nvPr>
+            <p:ph type="title"/>
+          </p:nvPr>
+        </p:nvSpPr>
+        <p:spPr>
+          <a:xfrm>
+            <a:off x="311700" y="846450"/>
+            <a:ext cx="8520600" cy="1671000"/>
+          </a:xfrm>
+        </p:spPr>
+        <p:txBody>
+          <a:bodyPr/>
+          <a:lstStyle/>
+          <a:p>
+            <a:pPr algn="ctr"/>
+            <a:r>
+              <a:rPr sz="4100"/>
+              <a:t>Part 2</a:t>
+            </a:r>
+            <a:br/>
+            <a:r>
+              <a:rPr sz="4100"/>
+              <a:t>Finding a trainable objective</a:t>
+            </a:r>
+          </a:p>
+        </p:txBody>
+      </p:sp>
+    </p:spTree>
+  </p:cSld>
+  <p:clrMapOvr>
+    <a:masterClrMapping/>
+  </p:clrMapOvr>
+</p:sld>
+</file>
+
+<file path=ppt/slides/slide9.xml><?xml version="1.0" encoding="utf-8"?>
 <p:sld xmlns:a="http://schemas.openxmlformats.org/drawingml/2006/main" xmlns:p="http://schemas.openxmlformats.org/presentationml/2006/main" xmlns:r="http://schemas.openxmlformats.org/officeDocument/2006/relationships">
   <p:cSld>
     <p:spTree>

</xml_diff>

<commit_message>
slides: drop the three-routes slide
Removed in Google Slides; the outline and build follow. The data slide is
now slide 6 and Part 1's last.
</commit_message>
<xml_diff>
--- a/slides/DEM_deck_v2.pptx
+++ b/slides/DEM_deck_v2.pptx
@@ -16,7 +16,6 @@
     <p:sldId id="261" r:id="rId21"/>
     <p:sldId id="262" r:id="rId22"/>
     <p:sldId id="263" r:id="rId23"/>
-    <p:sldId id="264" r:id="rId24"/>
   </p:sldIdLst>
   <p:sldSz cy="5143500" cx="9144000"/>
   <p:notesSz cx="6858000" cy="9144000"/>
@@ -1033,7 +1032,7 @@
           <a:lstStyle/>
           <a:p>
             <a:r>
-              <a:t>Data: 1,223 Hofmeister-deconvolved timestamps, split by day into 917 train, 153 validation and 153 test. The networks never see a test day in training. DEM metrics compare each network with the solver's DEM: MSE, total-emission error and W1. AIA reconstruction compares all three with the observation: MAE and MSE.</a:t>
+              <a:t>The split is chronological, so every test image is later than anything seen in training. Each epoch draws 512 pixels from each of 58,688 training blocks: 917 images times 64 blocks of 256 squared. The test set uses 64 random 128-squared blocks of each test image per solver target, five targets per image: one clean solve and four re-solves under simulated photon noise of the same observation. Pixels where deconvolution clamped a bright channel to zero, about 5%, are excluded.</a:t>
             </a:r>
           </a:p>
         </p:txBody>
@@ -1047,64 +1046,6 @@
 </file>
 
 <file path=ppt/notesSlides/notesSlide6.xml><?xml version="1.0" encoding="utf-8"?>
-<p:notes xmlns:a="http://schemas.openxmlformats.org/drawingml/2006/main" xmlns:p="http://schemas.openxmlformats.org/presentationml/2006/main" xmlns:r="http://schemas.openxmlformats.org/officeDocument/2006/relationships">
-  <p:cSld>
-    <p:spTree>
-      <p:nvGrpSpPr>
-        <p:cNvPr id="1" name=""/>
-        <p:cNvGrpSpPr/>
-        <p:nvPr/>
-      </p:nvGrpSpPr>
-      <p:grpSpPr>
-        <a:xfrm>
-          <a:off x="0" y="0"/>
-          <a:ext cx="0" cy="0"/>
-          <a:chOff x="0" y="0"/>
-          <a:chExt cx="0" cy="0"/>
-        </a:xfrm>
-      </p:grpSpPr>
-      <p:sp>
-        <p:nvSpPr>
-          <p:cNvPr id="2" name="Slide Image Placeholder 1"/>
-          <p:cNvSpPr>
-            <a:spLocks noGrp="1"/>
-          </p:cNvSpPr>
-          <p:nvPr>
-            <p:ph type="sldImg" idx="2"/>
-          </p:nvPr>
-        </p:nvSpPr>
-        <p:spPr/>
-      </p:sp>
-      <p:sp>
-        <p:nvSpPr>
-          <p:cNvPr id="3" name="Notes Placeholder 2"/>
-          <p:cNvSpPr>
-            <a:spLocks noGrp="1"/>
-          </p:cNvSpPr>
-          <p:nvPr>
-            <p:ph type="body" idx="1"/>
-          </p:nvPr>
-        </p:nvSpPr>
-        <p:spPr/>
-        <p:txBody>
-          <a:bodyPr/>
-          <a:lstStyle/>
-          <a:p>
-            <a:r>
-              <a:t>The split is chronological, so every test image is later than anything seen in training. Each epoch draws 512 pixels from each of 58,688 training blocks: 917 images times 64 blocks of 256 squared. The test set uses 64 random 128-squared blocks of each test image per solver target, five targets per image: one clean solve and four re-solves under simulated photon noise of the same observation. Pixels where deconvolution clamped a bright channel to zero, about 5%, are excluded.</a:t>
-            </a:r>
-          </a:p>
-        </p:txBody>
-      </p:sp>
-    </p:spTree>
-  </p:cSld>
-  <p:clrMapOvr>
-    <a:masterClrMapping/>
-  </p:clrMapOvr>
-</p:notes>
-</file>
-
-<file path=ppt/notesSlides/notesSlide7.xml><?xml version="1.0" encoding="utf-8"?>
 <p:notes xmlns:a="http://schemas.openxmlformats.org/drawingml/2006/main" xmlns:p="http://schemas.openxmlformats.org/presentationml/2006/main" xmlns:r="http://schemas.openxmlformats.org/officeDocument/2006/relationships">
   <p:cSld>
     <p:spTree>
@@ -12728,193 +12669,6 @@
                   <a:srgbClr val="57068C"/>
                 </a:solidFill>
               </a:rPr>
-              <a:t>Three routes to a DEM, compared on the same test</a:t>
-            </a:r>
-          </a:p>
-        </p:txBody>
-      </p:sp>
-      <p:sp>
-        <p:nvSpPr>
-          <p:cNvPr id="3" name="TextBox 2"/>
-          <p:cNvSpPr txBox="1"/>
-          <p:nvPr/>
-        </p:nvSpPr>
-        <p:spPr>
-          <a:xfrm>
-            <a:off x="365760" y="1005840"/>
-            <a:ext cx="8412480" cy="3017520"/>
-          </a:xfrm>
-          <a:prstGeom prst="rect">
-            <a:avLst/>
-          </a:prstGeom>
-          <a:noFill/>
-        </p:spPr>
-        <p:txBody>
-          <a:bodyPr wrap="square" anchor="t" lIns="0" rIns="0" tIns="0" bIns="0">
-            <a:spAutoFit/>
-          </a:bodyPr>
-          <a:lstStyle/>
-          <a:p>
-            <a:pPr algn="l" marL="182880" indent="-182880">
-              <a:spcAft>
-                <a:spcPts val="1400"/>
-              </a:spcAft>
-              <a:buClr>
-                <a:srgbClr val="333333"/>
-              </a:buClr>
-              <a:buChar char="•"/>
-            </a:pPr>
-            <a:r>
-              <a:rPr sz="1400" b="1" i="0">
-                <a:solidFill>
-                  <a:srgbClr val="57068C"/>
-                </a:solidFill>
-              </a:rPr>
-              <a:t>Solver (BP, ElasticNet): </a:t>
-            </a:r>
-            <a:r>
-              <a:rPr sz="1400" b="0" i="0">
-                <a:solidFill>
-                  <a:srgbClr val="333333"/>
-                </a:solidFill>
-              </a:rPr>
-              <a:t>optimises its objective for each pixel. This is the reference.</a:t>
-            </a:r>
-          </a:p>
-          <a:p>
-            <a:pPr algn="l" marL="182880" indent="-182880">
-              <a:spcAft>
-                <a:spcPts val="1400"/>
-              </a:spcAft>
-              <a:buClr>
-                <a:srgbClr val="333333"/>
-              </a:buClr>
-              <a:buChar char="•"/>
-            </a:pPr>
-            <a:r>
-              <a:rPr sz="1400" b="1" i="0">
-                <a:solidFill>
-                  <a:srgbClr val="57068C"/>
-                </a:solidFill>
-              </a:rPr>
-              <a:t>Supervised network: </a:t>
-            </a:r>
-            <a:r>
-              <a:rPr sz="1400" b="0" i="0">
-                <a:solidFill>
-                  <a:srgbClr val="333333"/>
-                </a:solidFill>
-              </a:rPr>
-              <a:t>learns to predict the solver's DEMs, so it needs them as labels.</a:t>
-            </a:r>
-          </a:p>
-          <a:p>
-            <a:pPr algn="l" marL="182880" indent="-182880">
-              <a:spcAft>
-                <a:spcPts val="1400"/>
-              </a:spcAft>
-              <a:buClr>
-                <a:srgbClr val="333333"/>
-              </a:buClr>
-              <a:buChar char="•"/>
-            </a:pPr>
-            <a:r>
-              <a:rPr sz="1400" b="1" i="0">
-                <a:solidFill>
-                  <a:srgbClr val="57068C"/>
-                </a:solidFill>
-              </a:rPr>
-              <a:t>Label-free network: </a:t>
-            </a:r>
-            <a:r>
-              <a:rPr sz="1400" b="0" i="0">
-                <a:solidFill>
-                  <a:srgbClr val="333333"/>
-                </a:solidFill>
-              </a:rPr>
-              <a:t>learns to minimise the solver's objective, with no labels.</a:t>
-            </a:r>
-          </a:p>
-          <a:p>
-            <a:pPr algn="l" marL="182880" indent="-182880">
-              <a:spcAft>
-                <a:spcPts val="1400"/>
-              </a:spcAft>
-              <a:buClr>
-                <a:srgbClr val="333333"/>
-              </a:buClr>
-              <a:buChar char="•"/>
-            </a:pPr>
-            <a:r>
-              <a:rPr sz="1400" b="1" i="0">
-                <a:solidFill>
-                  <a:srgbClr val="57068C"/>
-                </a:solidFill>
-              </a:rPr>
-              <a:t>Same test for all: </a:t>
-            </a:r>
-            <a:r>
-              <a:rPr sz="1400" b="0" i="0">
-                <a:solidFill>
-                  <a:srgbClr val="333333"/>
-                </a:solidFill>
-              </a:rPr>
-              <a:t>153 days never seen in training, identical pixels. DEM metrics against the solver; AIA reconstruction against the observation.</a:t>
-            </a:r>
-          </a:p>
-        </p:txBody>
-      </p:sp>
-    </p:spTree>
-  </p:cSld>
-  <p:clrMapOvr>
-    <a:masterClrMapping/>
-  </p:clrMapOvr>
-</p:sld>
-</file>
-
-<file path=ppt/slides/slide7.xml><?xml version="1.0" encoding="utf-8"?>
-<p:sld xmlns:a="http://schemas.openxmlformats.org/drawingml/2006/main" xmlns:p="http://schemas.openxmlformats.org/presentationml/2006/main" xmlns:r="http://schemas.openxmlformats.org/officeDocument/2006/relationships">
-  <p:cSld>
-    <p:spTree>
-      <p:nvGrpSpPr>
-        <p:cNvPr id="1" name=""/>
-        <p:cNvGrpSpPr/>
-        <p:nvPr/>
-      </p:nvGrpSpPr>
-      <p:grpSpPr/>
-      <p:sp>
-        <p:nvSpPr>
-          <p:cNvPr id="2" name="TextBox 1"/>
-          <p:cNvSpPr txBox="1"/>
-          <p:nvPr/>
-        </p:nvSpPr>
-        <p:spPr>
-          <a:xfrm>
-            <a:off x="265176" y="219456"/>
-            <a:ext cx="8503920" cy="566928"/>
-          </a:xfrm>
-          <a:prstGeom prst="rect">
-            <a:avLst/>
-          </a:prstGeom>
-          <a:noFill/>
-        </p:spPr>
-        <p:txBody>
-          <a:bodyPr wrap="square" anchor="t" lIns="0" rIns="0" tIns="0" bIns="0">
-            <a:spAutoFit/>
-          </a:bodyPr>
-          <a:lstStyle/>
-          <a:p>
-            <a:pPr algn="l">
-              <a:spcAft>
-                <a:spcPts val="600"/>
-              </a:spcAft>
-            </a:pPr>
-            <a:r>
-              <a:rPr sz="2000" b="1" i="0">
-                <a:solidFill>
-                  <a:srgbClr val="57068C"/>
-                </a:solidFill>
-              </a:rPr>
               <a:t>Data: two years of full-disk AIA, split in time</a:t>
             </a:r>
           </a:p>
@@ -13393,7 +13147,7 @@
 </p:sld>
 </file>
 
-<file path=ppt/slides/slide8.xml><?xml version="1.0" encoding="utf-8"?>
+<file path=ppt/slides/slide7.xml><?xml version="1.0" encoding="utf-8"?>
 <p:sld xmlns:a="http://schemas.openxmlformats.org/drawingml/2006/main" xmlns:p="http://schemas.openxmlformats.org/presentationml/2006/main" xmlns:r="http://schemas.openxmlformats.org/officeDocument/2006/relationships">
   <p:cSld>
     <p:spTree>
@@ -13444,7 +13198,7 @@
 </p:sld>
 </file>
 
-<file path=ppt/slides/slide9.xml><?xml version="1.0" encoding="utf-8"?>
+<file path=ppt/slides/slide8.xml><?xml version="1.0" encoding="utf-8"?>
 <p:sld xmlns:a="http://schemas.openxmlformats.org/drawingml/2006/main" xmlns:p="http://schemas.openxmlformats.org/presentationml/2006/main" xmlns:r="http://schemas.openxmlformats.org/officeDocument/2006/relationships">
   <p:cSld>
     <p:spTree>

</xml_diff>

<commit_message>
slides: section 3 draft, architecture on small data
Divider plus three slides: the first per-pixel MLP's noisy curves and the
patch CNN, the capacity-matched ablation as a dot plot against BP's 1.79,
and leave-one-image-out showing the CNN's edge gone on unseen days. Also
takes the data-slide wording edited in Google Slides. No figure of the noisy
MLP exists (checkpoint not kept); the v1 deck's noisy_nn.png showed the
direct-optimisation baselines instead, so it is not reused.
</commit_message>
<xml_diff>
--- a/slides/DEM_deck_v2.pptx
+++ b/slides/DEM_deck_v2.pptx
@@ -16,6 +16,10 @@
     <p:sldId id="261" r:id="rId21"/>
     <p:sldId id="262" r:id="rId22"/>
     <p:sldId id="263" r:id="rId23"/>
+    <p:sldId id="264" r:id="rId24"/>
+    <p:sldId id="265" r:id="rId25"/>
+    <p:sldId id="266" r:id="rId26"/>
+    <p:sldId id="267" r:id="rId27"/>
   </p:sldIdLst>
   <p:sldSz cy="5143500" cx="9144000"/>
   <p:notesSz cx="6858000" cy="9144000"/>
@@ -1091,6 +1095,180 @@
           <a:p>
             <a:r>
               <a:t>Before any network, five losses optimised directly per pixel on 4 timestamps. Averages: AIA MAE against the observation, BP 5.2, barrier 5.0, barrier plus fit 2.6, fit-only 0.40 to 0.44. DEM MAE against BP: barrier 0.034, barrier plus fit 0.043, fit-only 0.18 to 0.20. W1 on the brightest 5% of pixels: 0.030 and 0.033 against 0.15 to 0.18. Six equations, eighteen unknowns: many DEMs fit within noise, so whatever breaks the tie decides the shape. L-BFGS and Adam reach the same curves; SGD often fails to converge.</a:t>
+            </a:r>
+          </a:p>
+        </p:txBody>
+      </p:sp>
+    </p:spTree>
+  </p:cSld>
+  <p:clrMapOvr>
+    <a:masterClrMapping/>
+  </p:clrMapOvr>
+</p:notes>
+</file>
+
+<file path=ppt/notesSlides/notesSlide7.xml><?xml version="1.0" encoding="utf-8"?>
+<p:notes xmlns:a="http://schemas.openxmlformats.org/drawingml/2006/main" xmlns:p="http://schemas.openxmlformats.org/presentationml/2006/main" xmlns:r="http://schemas.openxmlformats.org/officeDocument/2006/relationships">
+  <p:cSld>
+    <p:spTree>
+      <p:nvGrpSpPr>
+        <p:cNvPr id="1" name=""/>
+        <p:cNvGrpSpPr/>
+        <p:nvPr/>
+      </p:nvGrpSpPr>
+      <p:grpSpPr>
+        <a:xfrm>
+          <a:off x="0" y="0"/>
+          <a:ext cx="0" cy="0"/>
+          <a:chOff x="0" y="0"/>
+          <a:chExt cx="0" cy="0"/>
+        </a:xfrm>
+      </p:grpSpPr>
+      <p:sp>
+        <p:nvSpPr>
+          <p:cNvPr id="2" name="Slide Image Placeholder 1"/>
+          <p:cNvSpPr>
+            <a:spLocks noGrp="1"/>
+          </p:cNvSpPr>
+          <p:nvPr>
+            <p:ph type="sldImg" idx="2"/>
+          </p:nvPr>
+        </p:nvSpPr>
+        <p:spPr/>
+      </p:sp>
+      <p:sp>
+        <p:nvSpPr>
+          <p:cNvPr id="3" name="Notes Placeholder 2"/>
+          <p:cNvSpPr>
+            <a:spLocks noGrp="1"/>
+          </p:cNvSpPr>
+          <p:nvPr>
+            <p:ph type="body" idx="1"/>
+          </p:nvPr>
+        </p:nvSpPr>
+        <p:spPr/>
+        <p:txBody>
+          <a:bodyPr/>
+          <a:lstStyle/>
+          <a:p>
+            <a:r>
+              <a:t>All of Part 3 uses four images: two X-class flares, quiet Sun and moderate activity. The first MLP is the same architecture as today's production model, four hidden layers with SiLU and a softplus output, at width 256 with raw intensities as input. Its noise was put down at the time to the overlapping basis amplifying small weight errors, and to the problem's non-uniqueness. Its checkpoint was not kept, so there is no figure of it.</a:t>
+            </a:r>
+          </a:p>
+        </p:txBody>
+      </p:sp>
+    </p:spTree>
+  </p:cSld>
+  <p:clrMapOvr>
+    <a:masterClrMapping/>
+  </p:clrMapOvr>
+</p:notes>
+</file>
+
+<file path=ppt/notesSlides/notesSlide8.xml><?xml version="1.0" encoding="utf-8"?>
+<p:notes xmlns:a="http://schemas.openxmlformats.org/drawingml/2006/main" xmlns:p="http://schemas.openxmlformats.org/presentationml/2006/main" xmlns:r="http://schemas.openxmlformats.org/officeDocument/2006/relationships">
+  <p:cSld>
+    <p:spTree>
+      <p:nvGrpSpPr>
+        <p:cNvPr id="1" name=""/>
+        <p:cNvGrpSpPr/>
+        <p:nvPr/>
+      </p:nvGrpSpPr>
+      <p:grpSpPr>
+        <a:xfrm>
+          <a:off x="0" y="0"/>
+          <a:ext cx="0" cy="0"/>
+          <a:chOff x="0" y="0"/>
+          <a:chExt cx="0" cy="0"/>
+        </a:xfrm>
+      </p:grpSpPr>
+      <p:sp>
+        <p:nvSpPr>
+          <p:cNvPr id="2" name="Slide Image Placeholder 1"/>
+          <p:cNvSpPr>
+            <a:spLocks noGrp="1"/>
+          </p:cNvSpPr>
+          <p:nvPr>
+            <p:ph type="sldImg" idx="2"/>
+          </p:nvPr>
+        </p:nvSpPr>
+        <p:spPr/>
+      </p:sp>
+      <p:sp>
+        <p:nvSpPr>
+          <p:cNvPr id="3" name="Notes Placeholder 2"/>
+          <p:cNvSpPr>
+            <a:spLocks noGrp="1"/>
+          </p:cNvSpPr>
+          <p:nvPr>
+            <p:ph type="body" idx="1"/>
+          </p:nvPr>
+        </p:nvSpPr>
+        <p:spPr/>
+        <p:txBody>
+          <a:bodyPr/>
+          <a:lstStyle/>
+          <a:p>
+            <a:r>
+              <a:t>The shuffled-patch CNN applies a fixed random permutation to the 81 patch pixels and nearly matches the CNN, so the gain came from neighbouring values more than from geometry. The flat-patch MLP was erratic across images: 1.61 on the X2.1 flare, 2.27 on quiet Sun. Capacity and setup were never fully separated: the 213k MLP took raw intensities, and at full scale a 176k MLP on log1p inputs is smooth.</a:t>
+            </a:r>
+          </a:p>
+        </p:txBody>
+      </p:sp>
+    </p:spTree>
+  </p:cSld>
+  <p:clrMapOvr>
+    <a:masterClrMapping/>
+  </p:clrMapOvr>
+</p:notes>
+</file>
+
+<file path=ppt/notesSlides/notesSlide9.xml><?xml version="1.0" encoding="utf-8"?>
+<p:notes xmlns:a="http://schemas.openxmlformats.org/drawingml/2006/main" xmlns:p="http://schemas.openxmlformats.org/presentationml/2006/main" xmlns:r="http://schemas.openxmlformats.org/officeDocument/2006/relationships">
+  <p:cSld>
+    <p:spTree>
+      <p:nvGrpSpPr>
+        <p:cNvPr id="1" name=""/>
+        <p:cNvGrpSpPr/>
+        <p:nvPr/>
+      </p:nvGrpSpPr>
+      <p:grpSpPr>
+        <a:xfrm>
+          <a:off x="0" y="0"/>
+          <a:ext cx="0" cy="0"/>
+          <a:chOff x="0" y="0"/>
+          <a:chExt cx="0" cy="0"/>
+        </a:xfrm>
+      </p:grpSpPr>
+      <p:sp>
+        <p:nvSpPr>
+          <p:cNvPr id="2" name="Slide Image Placeholder 1"/>
+          <p:cNvSpPr>
+            <a:spLocks noGrp="1"/>
+          </p:cNvSpPr>
+          <p:nvPr>
+            <p:ph type="sldImg" idx="2"/>
+          </p:nvPr>
+        </p:nvSpPr>
+        <p:spPr/>
+      </p:sp>
+      <p:sp>
+        <p:nvSpPr>
+          <p:cNvPr id="3" name="Notes Placeholder 2"/>
+          <p:cNvSpPr>
+            <a:spLocks noGrp="1"/>
+          </p:cNvSpPr>
+          <p:nvPr>
+            <p:ph type="body" idx="1"/>
+          </p:nvPr>
+        </p:nvSpPr>
+        <p:spPr/>
+        <p:txBody>
+          <a:bodyPr/>
+          <a:lstStyle/>
+          <a:p>
+            <a:r>
+              <a:t>Held-out sparsity by fold, MLP against CNN, with BP in brackets: X2.1 flare 1.59 vs 1.64 (1.97); quiet Sun 1.78 vs 1.61 (1.67); moderate 1.83 vs 1.83 (1.82); X1.6 flare 1.96 vs 2.31 (1.71). The ablation's in-sample edge, 1.70 vs 1.89, came from scoring pixels of images the model trained on. Four folds is a small sample; scaling is the real test.</a:t>
             </a:r>
           </a:p>
         </p:txBody>
@@ -9863,6 +10041,1530 @@
 </p:sld>
 </file>
 
+<file path=ppt/slides/slide10.xml><?xml version="1.0" encoding="utf-8"?>
+<p:sld xmlns:a="http://schemas.openxmlformats.org/drawingml/2006/main" xmlns:p="http://schemas.openxmlformats.org/presentationml/2006/main" xmlns:r="http://schemas.openxmlformats.org/officeDocument/2006/relationships">
+  <p:cSld>
+    <p:spTree>
+      <p:nvGrpSpPr>
+        <p:cNvPr id="1" name=""/>
+        <p:cNvGrpSpPr/>
+        <p:nvPr/>
+      </p:nvGrpSpPr>
+      <p:grpSpPr/>
+      <p:sp>
+        <p:nvSpPr>
+          <p:cNvPr id="2" name="TextBox 1"/>
+          <p:cNvSpPr txBox="1"/>
+          <p:nvPr/>
+        </p:nvSpPr>
+        <p:spPr>
+          <a:xfrm>
+            <a:off x="265176" y="219456"/>
+            <a:ext cx="8503920" cy="566928"/>
+          </a:xfrm>
+          <a:prstGeom prst="rect">
+            <a:avLst/>
+          </a:prstGeom>
+          <a:noFill/>
+        </p:spPr>
+        <p:txBody>
+          <a:bodyPr wrap="square" anchor="t" lIns="0" rIns="0" tIns="0" bIns="0">
+            <a:spAutoFit/>
+          </a:bodyPr>
+          <a:lstStyle/>
+          <a:p>
+            <a:pPr algn="l">
+              <a:spcAft>
+                <a:spcPts val="600"/>
+              </a:spcAft>
+            </a:pPr>
+            <a:r>
+              <a:rPr sz="2000" b="1" i="0">
+                <a:solidFill>
+                  <a:srgbClr val="57068C"/>
+                </a:solidFill>
+              </a:rPr>
+              <a:t>A per-pixel MLP drew noisy DEMs; a patch CNN fixed it</a:t>
+            </a:r>
+          </a:p>
+        </p:txBody>
+      </p:sp>
+      <p:sp>
+        <p:nvSpPr>
+          <p:cNvPr id="3" name="TextBox 2"/>
+          <p:cNvSpPr txBox="1"/>
+          <p:nvPr/>
+        </p:nvSpPr>
+        <p:spPr>
+          <a:xfrm>
+            <a:off x="365760" y="914400"/>
+            <a:ext cx="4937760" cy="3291840"/>
+          </a:xfrm>
+          <a:prstGeom prst="rect">
+            <a:avLst/>
+          </a:prstGeom>
+          <a:noFill/>
+        </p:spPr>
+        <p:txBody>
+          <a:bodyPr wrap="square" anchor="t" lIns="0" rIns="0" tIns="0" bIns="0">
+            <a:spAutoFit/>
+          </a:bodyPr>
+          <a:lstStyle/>
+          <a:p>
+            <a:pPr algn="l" marL="182880" indent="-182880">
+              <a:spcAft>
+                <a:spcPts val="1000"/>
+              </a:spcAft>
+              <a:buClr>
+                <a:srgbClr val="333333"/>
+              </a:buClr>
+              <a:buChar char="•"/>
+            </a:pPr>
+            <a:r>
+              <a:rPr sz="1250" b="1" i="0">
+                <a:solidFill>
+                  <a:srgbClr val="57068C"/>
+                </a:solidFill>
+              </a:rPr>
+              <a:t>First try: </a:t>
+            </a:r>
+            <a:r>
+              <a:rPr sz="1250" b="0" i="0">
+                <a:solidFill>
+                  <a:srgbClr val="333333"/>
+                </a:solidFill>
+              </a:rPr>
+              <a:t>the 6 intensities of one pixel → MLP (213k params) → 54 weights, trained on the BP loss over ~221k pixels. The loss converged, but per-pixel curves oscillated.</a:t>
+            </a:r>
+          </a:p>
+          <a:p>
+            <a:pPr algn="l" marL="182880" indent="-182880">
+              <a:spcAft>
+                <a:spcPts val="1000"/>
+              </a:spcAft>
+              <a:buClr>
+                <a:srgbClr val="333333"/>
+              </a:buClr>
+              <a:buChar char="•"/>
+            </a:pPr>
+            <a:r>
+              <a:rPr sz="1250" b="1" i="0">
+                <a:solidFill>
+                  <a:srgbClr val="57068C"/>
+                </a:solidFill>
+              </a:rPr>
+              <a:t>Patch CNN: </a:t>
+            </a:r>
+            <a:r>
+              <a:rPr sz="1250" b="0" i="0">
+                <a:solidFill>
+                  <a:srgbClr val="333333"/>
+                </a:solidFill>
+              </a:rPr>
+              <a:t>a 9×9 neighbourhood → CNN (~1.5M params) → 54 weights. Smooth, single-peaked curves at BP's temperatures, sparsity close to BP's on held-out pixels.</a:t>
+            </a:r>
+          </a:p>
+          <a:p>
+            <a:pPr algn="l" marL="182880" indent="-182880">
+              <a:spcAft>
+                <a:spcPts val="1000"/>
+              </a:spcAft>
+              <a:buClr>
+                <a:srgbClr val="333333"/>
+              </a:buClr>
+              <a:buChar char="•"/>
+            </a:pPr>
+            <a:r>
+              <a:rPr sz="1250" b="0" i="0">
+                <a:solidFill>
+                  <a:srgbClr val="333333"/>
+                </a:solidFill>
+              </a:rPr>
+              <a:t>Trained on one image, then on all 4 jointly; zeroing the neighbourhood for 10% of batches kept it usable on a single pixel.</a:t>
+            </a:r>
+          </a:p>
+        </p:txBody>
+      </p:sp>
+      <p:pic>
+        <p:nvPicPr>
+          <p:cNvPr id="4" name="Picture 3" descr="patch_cnn.png"/>
+          <p:cNvPicPr>
+            <a:picLocks noChangeAspect="1"/>
+          </p:cNvPicPr>
+          <p:nvPr/>
+        </p:nvPicPr>
+        <p:blipFill>
+          <a:blip r:embed="rId3"/>
+          <a:stretch>
+            <a:fillRect/>
+          </a:stretch>
+        </p:blipFill>
+        <p:spPr>
+          <a:xfrm>
+            <a:off x="5723610" y="822960"/>
+            <a:ext cx="2817420" cy="3200400"/>
+          </a:xfrm>
+          <a:prstGeom prst="rect">
+            <a:avLst/>
+          </a:prstGeom>
+        </p:spPr>
+      </p:pic>
+      <p:sp>
+        <p:nvSpPr>
+          <p:cNvPr id="5" name="TextBox 4"/>
+          <p:cNvSpPr txBox="1"/>
+          <p:nvPr/>
+        </p:nvSpPr>
+        <p:spPr>
+          <a:xfrm>
+            <a:off x="5486400" y="4069080"/>
+            <a:ext cx="3291840" cy="274320"/>
+          </a:xfrm>
+          <a:prstGeom prst="rect">
+            <a:avLst/>
+          </a:prstGeom>
+          <a:noFill/>
+        </p:spPr>
+        <p:txBody>
+          <a:bodyPr wrap="square" anchor="t" lIns="0" rIns="0" tIns="0" bIns="0">
+            <a:spAutoFit/>
+          </a:bodyPr>
+          <a:lstStyle/>
+          <a:p>
+            <a:pPr algn="l">
+              <a:spcAft>
+                <a:spcPts val="0"/>
+              </a:spcAft>
+            </a:pPr>
+            <a:r>
+              <a:rPr sz="950" b="0" i="1">
+                <a:solidFill>
+                  <a:srgbClr val="6B6B6B"/>
+                </a:solidFill>
+              </a:rPr>
+              <a:t>Patch CNN (dotted) vs BP, X2.1 flare image.</a:t>
+            </a:r>
+          </a:p>
+        </p:txBody>
+      </p:sp>
+    </p:spTree>
+  </p:cSld>
+  <p:clrMapOvr>
+    <a:masterClrMapping/>
+  </p:clrMapOvr>
+</p:sld>
+</file>
+
+<file path=ppt/slides/slide11.xml><?xml version="1.0" encoding="utf-8"?>
+<p:sld xmlns:a="http://schemas.openxmlformats.org/drawingml/2006/main" xmlns:p="http://schemas.openxmlformats.org/presentationml/2006/main" xmlns:r="http://schemas.openxmlformats.org/officeDocument/2006/relationships">
+  <p:cSld>
+    <p:spTree>
+      <p:nvGrpSpPr>
+        <p:cNvPr id="1" name=""/>
+        <p:cNvGrpSpPr/>
+        <p:nvPr/>
+      </p:nvGrpSpPr>
+      <p:grpSpPr/>
+      <p:sp>
+        <p:nvSpPr>
+          <p:cNvPr id="2" name="TextBox 1"/>
+          <p:cNvSpPr txBox="1"/>
+          <p:nvPr/>
+        </p:nvSpPr>
+        <p:spPr>
+          <a:xfrm>
+            <a:off x="265176" y="219456"/>
+            <a:ext cx="8503920" cy="566928"/>
+          </a:xfrm>
+          <a:prstGeom prst="rect">
+            <a:avLst/>
+          </a:prstGeom>
+          <a:noFill/>
+        </p:spPr>
+        <p:txBody>
+          <a:bodyPr wrap="square" anchor="t" lIns="0" rIns="0" tIns="0" bIns="0">
+            <a:spAutoFit/>
+          </a:bodyPr>
+          <a:lstStyle/>
+          <a:p>
+            <a:pPr algn="l">
+              <a:spcAft>
+                <a:spcPts val="600"/>
+              </a:spcAft>
+            </a:pPr>
+            <a:r>
+              <a:rPr sz="2000" b="1" i="0">
+                <a:solidFill>
+                  <a:srgbClr val="57068C"/>
+                </a:solidFill>
+              </a:rPr>
+              <a:t>Ablation: the noise was capacity, not missing context</a:t>
+            </a:r>
+          </a:p>
+        </p:txBody>
+      </p:sp>
+      <p:sp>
+        <p:nvSpPr>
+          <p:cNvPr id="3" name="TextBox 2"/>
+          <p:cNvSpPr txBox="1"/>
+          <p:nvPr/>
+        </p:nvSpPr>
+        <p:spPr>
+          <a:xfrm>
+            <a:off x="365760" y="1307592"/>
+            <a:ext cx="2286000" cy="256032"/>
+          </a:xfrm>
+          <a:prstGeom prst="rect">
+            <a:avLst/>
+          </a:prstGeom>
+          <a:noFill/>
+        </p:spPr>
+        <p:txBody>
+          <a:bodyPr wrap="square" anchor="t" lIns="0" rIns="0" tIns="0" bIns="0">
+            <a:spAutoFit/>
+          </a:bodyPr>
+          <a:lstStyle/>
+          <a:p>
+            <a:pPr algn="l">
+              <a:spcAft>
+                <a:spcPts val="600"/>
+              </a:spcAft>
+            </a:pPr>
+            <a:r>
+              <a:rPr sz="1200" b="1" i="0">
+                <a:solidFill>
+                  <a:srgbClr val="57068C"/>
+                </a:solidFill>
+              </a:rPr>
+              <a:t>Patch CNN</a:t>
+            </a:r>
+          </a:p>
+        </p:txBody>
+      </p:sp>
+      <p:cxnSp>
+        <p:nvCxnSpPr>
+          <p:cNvPr id="4" name="Connector 3"/>
+          <p:cNvCxnSpPr/>
+          <p:nvPr/>
+        </p:nvCxnSpPr>
+        <p:spPr>
+          <a:xfrm>
+            <a:off x="2743200" y="1426464"/>
+            <a:ext cx="5669280" cy="0"/>
+          </a:xfrm>
+          <a:prstGeom prst="line">
+            <a:avLst/>
+          </a:prstGeom>
+          <a:ln w="9525">
+            <a:solidFill>
+              <a:srgbClr val="ECEBE8"/>
+            </a:solidFill>
+          </a:ln>
+        </p:spPr>
+        <p:style>
+          <a:lnRef idx="2">
+            <a:schemeClr val="accent1"/>
+          </a:lnRef>
+          <a:fillRef idx="0">
+            <a:schemeClr val="accent1"/>
+          </a:fillRef>
+          <a:effectRef idx="1">
+            <a:schemeClr val="accent1"/>
+          </a:effectRef>
+          <a:fontRef idx="minor">
+            <a:schemeClr val="tx1"/>
+          </a:fontRef>
+        </p:style>
+      </p:cxnSp>
+      <p:sp>
+        <p:nvSpPr>
+          <p:cNvPr id="5" name="Oval 4"/>
+          <p:cNvSpPr/>
+          <p:nvPr/>
+        </p:nvSpPr>
+        <p:spPr>
+          <a:xfrm>
+            <a:off x="4082795" y="1348740"/>
+            <a:ext cx="155448" cy="155448"/>
+          </a:xfrm>
+          <a:prstGeom prst="ellipse">
+            <a:avLst/>
+          </a:prstGeom>
+          <a:solidFill>
+            <a:srgbClr val="57068C"/>
+          </a:solidFill>
+          <a:ln>
+            <a:noFill/>
+          </a:ln>
+          <a:effectLst/>
+        </p:spPr>
+        <p:style>
+          <a:lnRef idx="1">
+            <a:schemeClr val="accent1"/>
+          </a:lnRef>
+          <a:fillRef idx="3">
+            <a:schemeClr val="accent1"/>
+          </a:fillRef>
+          <a:effectRef idx="2">
+            <a:schemeClr val="accent1"/>
+          </a:effectRef>
+          <a:fontRef idx="minor">
+            <a:schemeClr val="lt1"/>
+          </a:fontRef>
+        </p:style>
+        <p:txBody>
+          <a:bodyPr rtlCol="0" anchor="ctr"/>
+          <a:lstStyle/>
+          <a:p>
+            <a:pPr algn="ctr"/>
+          </a:p>
+        </p:txBody>
+      </p:sp>
+      <p:sp>
+        <p:nvSpPr>
+          <p:cNvPr id="6" name="TextBox 5"/>
+          <p:cNvSpPr txBox="1"/>
+          <p:nvPr/>
+        </p:nvSpPr>
+        <p:spPr>
+          <a:xfrm>
+            <a:off x="4279391" y="1307592"/>
+            <a:ext cx="548640" cy="237744"/>
+          </a:xfrm>
+          <a:prstGeom prst="rect">
+            <a:avLst/>
+          </a:prstGeom>
+          <a:noFill/>
+        </p:spPr>
+        <p:txBody>
+          <a:bodyPr wrap="square" anchor="t" lIns="0" rIns="0" tIns="0" bIns="0">
+            <a:spAutoFit/>
+          </a:bodyPr>
+          <a:lstStyle/>
+          <a:p>
+            <a:pPr algn="l">
+              <a:spcAft>
+                <a:spcPts val="600"/>
+              </a:spcAft>
+            </a:pPr>
+            <a:r>
+              <a:rPr sz="1100" b="1" i="0">
+                <a:solidFill>
+                  <a:srgbClr val="57068C"/>
+                </a:solidFill>
+              </a:rPr>
+              <a:t>1.70</a:t>
+            </a:r>
+          </a:p>
+        </p:txBody>
+      </p:sp>
+      <p:sp>
+        <p:nvSpPr>
+          <p:cNvPr id="7" name="TextBox 6"/>
+          <p:cNvSpPr txBox="1"/>
+          <p:nvPr/>
+        </p:nvSpPr>
+        <p:spPr>
+          <a:xfrm>
+            <a:off x="365760" y="1691640"/>
+            <a:ext cx="2286000" cy="256032"/>
+          </a:xfrm>
+          <a:prstGeom prst="rect">
+            <a:avLst/>
+          </a:prstGeom>
+          <a:noFill/>
+        </p:spPr>
+        <p:txBody>
+          <a:bodyPr wrap="square" anchor="t" lIns="0" rIns="0" tIns="0" bIns="0">
+            <a:spAutoFit/>
+          </a:bodyPr>
+          <a:lstStyle/>
+          <a:p>
+            <a:pPr algn="l">
+              <a:spcAft>
+                <a:spcPts val="600"/>
+              </a:spcAft>
+            </a:pPr>
+            <a:r>
+              <a:rPr sz="1200" b="0" i="0">
+                <a:solidFill>
+                  <a:srgbClr val="333333"/>
+                </a:solidFill>
+              </a:rPr>
+              <a:t>Shuffled-patch CNN</a:t>
+            </a:r>
+          </a:p>
+        </p:txBody>
+      </p:sp>
+      <p:cxnSp>
+        <p:nvCxnSpPr>
+          <p:cNvPr id="8" name="Connector 7"/>
+          <p:cNvCxnSpPr/>
+          <p:nvPr/>
+        </p:nvCxnSpPr>
+        <p:spPr>
+          <a:xfrm>
+            <a:off x="2743200" y="1810512"/>
+            <a:ext cx="5669280" cy="0"/>
+          </a:xfrm>
+          <a:prstGeom prst="line">
+            <a:avLst/>
+          </a:prstGeom>
+          <a:ln w="9525">
+            <a:solidFill>
+              <a:srgbClr val="ECEBE8"/>
+            </a:solidFill>
+          </a:ln>
+        </p:spPr>
+        <p:style>
+          <a:lnRef idx="2">
+            <a:schemeClr val="accent1"/>
+          </a:lnRef>
+          <a:fillRef idx="0">
+            <a:schemeClr val="accent1"/>
+          </a:fillRef>
+          <a:effectRef idx="1">
+            <a:schemeClr val="accent1"/>
+          </a:effectRef>
+          <a:fontRef idx="minor">
+            <a:schemeClr val="tx1"/>
+          </a:fontRef>
+        </p:style>
+      </p:cxnSp>
+      <p:sp>
+        <p:nvSpPr>
+          <p:cNvPr id="9" name="Oval 8"/>
+          <p:cNvSpPr/>
+          <p:nvPr/>
+        </p:nvSpPr>
+        <p:spPr>
+          <a:xfrm>
+            <a:off x="6633971" y="1732788"/>
+            <a:ext cx="155448" cy="155448"/>
+          </a:xfrm>
+          <a:prstGeom prst="ellipse">
+            <a:avLst/>
+          </a:prstGeom>
+          <a:solidFill>
+            <a:srgbClr val="57068C"/>
+          </a:solidFill>
+          <a:ln>
+            <a:noFill/>
+          </a:ln>
+          <a:effectLst/>
+        </p:spPr>
+        <p:style>
+          <a:lnRef idx="1">
+            <a:schemeClr val="accent1"/>
+          </a:lnRef>
+          <a:fillRef idx="3">
+            <a:schemeClr val="accent1"/>
+          </a:fillRef>
+          <a:effectRef idx="2">
+            <a:schemeClr val="accent1"/>
+          </a:effectRef>
+          <a:fontRef idx="minor">
+            <a:schemeClr val="lt1"/>
+          </a:fontRef>
+        </p:style>
+        <p:txBody>
+          <a:bodyPr rtlCol="0" anchor="ctr"/>
+          <a:lstStyle/>
+          <a:p>
+            <a:pPr algn="ctr"/>
+          </a:p>
+        </p:txBody>
+      </p:sp>
+      <p:sp>
+        <p:nvSpPr>
+          <p:cNvPr id="10" name="TextBox 9"/>
+          <p:cNvSpPr txBox="1"/>
+          <p:nvPr/>
+        </p:nvSpPr>
+        <p:spPr>
+          <a:xfrm>
+            <a:off x="6830567" y="1691640"/>
+            <a:ext cx="548640" cy="237744"/>
+          </a:xfrm>
+          <a:prstGeom prst="rect">
+            <a:avLst/>
+          </a:prstGeom>
+          <a:noFill/>
+        </p:spPr>
+        <p:txBody>
+          <a:bodyPr wrap="square" anchor="t" lIns="0" rIns="0" tIns="0" bIns="0">
+            <a:spAutoFit/>
+          </a:bodyPr>
+          <a:lstStyle/>
+          <a:p>
+            <a:pPr algn="l">
+              <a:spcAft>
+                <a:spcPts val="600"/>
+              </a:spcAft>
+            </a:pPr>
+            <a:r>
+              <a:rPr sz="1100" b="1" i="0">
+                <a:solidFill>
+                  <a:srgbClr val="57068C"/>
+                </a:solidFill>
+              </a:rPr>
+              <a:t>1.88</a:t>
+            </a:r>
+          </a:p>
+        </p:txBody>
+      </p:sp>
+      <p:sp>
+        <p:nvSpPr>
+          <p:cNvPr id="11" name="TextBox 10"/>
+          <p:cNvSpPr txBox="1"/>
+          <p:nvPr/>
+        </p:nvSpPr>
+        <p:spPr>
+          <a:xfrm>
+            <a:off x="365760" y="2075688"/>
+            <a:ext cx="2286000" cy="256032"/>
+          </a:xfrm>
+          <a:prstGeom prst="rect">
+            <a:avLst/>
+          </a:prstGeom>
+          <a:noFill/>
+        </p:spPr>
+        <p:txBody>
+          <a:bodyPr wrap="square" anchor="t" lIns="0" rIns="0" tIns="0" bIns="0">
+            <a:spAutoFit/>
+          </a:bodyPr>
+          <a:lstStyle/>
+          <a:p>
+            <a:pPr algn="l">
+              <a:spcAft>
+                <a:spcPts val="600"/>
+              </a:spcAft>
+            </a:pPr>
+            <a:r>
+              <a:rPr sz="1200" b="0" i="0">
+                <a:solidFill>
+                  <a:srgbClr val="333333"/>
+                </a:solidFill>
+              </a:rPr>
+              <a:t>Centre-pixel MLP</a:t>
+            </a:r>
+          </a:p>
+        </p:txBody>
+      </p:sp>
+      <p:cxnSp>
+        <p:nvCxnSpPr>
+          <p:cNvPr id="12" name="Connector 11"/>
+          <p:cNvCxnSpPr/>
+          <p:nvPr/>
+        </p:nvCxnSpPr>
+        <p:spPr>
+          <a:xfrm>
+            <a:off x="2743200" y="2194560"/>
+            <a:ext cx="5669280" cy="0"/>
+          </a:xfrm>
+          <a:prstGeom prst="line">
+            <a:avLst/>
+          </a:prstGeom>
+          <a:ln w="9525">
+            <a:solidFill>
+              <a:srgbClr val="ECEBE8"/>
+            </a:solidFill>
+          </a:ln>
+        </p:spPr>
+        <p:style>
+          <a:lnRef idx="2">
+            <a:schemeClr val="accent1"/>
+          </a:lnRef>
+          <a:fillRef idx="0">
+            <a:schemeClr val="accent1"/>
+          </a:fillRef>
+          <a:effectRef idx="1">
+            <a:schemeClr val="accent1"/>
+          </a:effectRef>
+          <a:fontRef idx="minor">
+            <a:schemeClr val="tx1"/>
+          </a:fontRef>
+        </p:style>
+      </p:cxnSp>
+      <p:sp>
+        <p:nvSpPr>
+          <p:cNvPr id="13" name="Oval 12"/>
+          <p:cNvSpPr/>
+          <p:nvPr/>
+        </p:nvSpPr>
+        <p:spPr>
+          <a:xfrm>
+            <a:off x="6775703" y="2116836"/>
+            <a:ext cx="155448" cy="155448"/>
+          </a:xfrm>
+          <a:prstGeom prst="ellipse">
+            <a:avLst/>
+          </a:prstGeom>
+          <a:solidFill>
+            <a:srgbClr val="57068C"/>
+          </a:solidFill>
+          <a:ln>
+            <a:noFill/>
+          </a:ln>
+          <a:effectLst/>
+        </p:spPr>
+        <p:style>
+          <a:lnRef idx="1">
+            <a:schemeClr val="accent1"/>
+          </a:lnRef>
+          <a:fillRef idx="3">
+            <a:schemeClr val="accent1"/>
+          </a:fillRef>
+          <a:effectRef idx="2">
+            <a:schemeClr val="accent1"/>
+          </a:effectRef>
+          <a:fontRef idx="minor">
+            <a:schemeClr val="lt1"/>
+          </a:fontRef>
+        </p:style>
+        <p:txBody>
+          <a:bodyPr rtlCol="0" anchor="ctr"/>
+          <a:lstStyle/>
+          <a:p>
+            <a:pPr algn="ctr"/>
+          </a:p>
+        </p:txBody>
+      </p:sp>
+      <p:sp>
+        <p:nvSpPr>
+          <p:cNvPr id="14" name="TextBox 13"/>
+          <p:cNvSpPr txBox="1"/>
+          <p:nvPr/>
+        </p:nvSpPr>
+        <p:spPr>
+          <a:xfrm>
+            <a:off x="6972299" y="2075688"/>
+            <a:ext cx="548640" cy="237744"/>
+          </a:xfrm>
+          <a:prstGeom prst="rect">
+            <a:avLst/>
+          </a:prstGeom>
+          <a:noFill/>
+        </p:spPr>
+        <p:txBody>
+          <a:bodyPr wrap="square" anchor="t" lIns="0" rIns="0" tIns="0" bIns="0">
+            <a:spAutoFit/>
+          </a:bodyPr>
+          <a:lstStyle/>
+          <a:p>
+            <a:pPr algn="l">
+              <a:spcAft>
+                <a:spcPts val="600"/>
+              </a:spcAft>
+            </a:pPr>
+            <a:r>
+              <a:rPr sz="1100" b="1" i="0">
+                <a:solidFill>
+                  <a:srgbClr val="57068C"/>
+                </a:solidFill>
+              </a:rPr>
+              <a:t>1.89</a:t>
+            </a:r>
+          </a:p>
+        </p:txBody>
+      </p:sp>
+      <p:sp>
+        <p:nvSpPr>
+          <p:cNvPr id="15" name="TextBox 14"/>
+          <p:cNvSpPr txBox="1"/>
+          <p:nvPr/>
+        </p:nvSpPr>
+        <p:spPr>
+          <a:xfrm>
+            <a:off x="365760" y="2459736"/>
+            <a:ext cx="2286000" cy="256032"/>
+          </a:xfrm>
+          <a:prstGeom prst="rect">
+            <a:avLst/>
+          </a:prstGeom>
+          <a:noFill/>
+        </p:spPr>
+        <p:txBody>
+          <a:bodyPr wrap="square" anchor="t" lIns="0" rIns="0" tIns="0" bIns="0">
+            <a:spAutoFit/>
+          </a:bodyPr>
+          <a:lstStyle/>
+          <a:p>
+            <a:pPr algn="l">
+              <a:spcAft>
+                <a:spcPts val="600"/>
+              </a:spcAft>
+            </a:pPr>
+            <a:r>
+              <a:rPr sz="1200" b="0" i="0">
+                <a:solidFill>
+                  <a:srgbClr val="333333"/>
+                </a:solidFill>
+              </a:rPr>
+              <a:t>Flat-patch MLP</a:t>
+            </a:r>
+          </a:p>
+        </p:txBody>
+      </p:sp>
+      <p:cxnSp>
+        <p:nvCxnSpPr>
+          <p:cNvPr id="16" name="Connector 15"/>
+          <p:cNvCxnSpPr/>
+          <p:nvPr/>
+        </p:nvCxnSpPr>
+        <p:spPr>
+          <a:xfrm>
+            <a:off x="2743200" y="2578608"/>
+            <a:ext cx="5669280" cy="0"/>
+          </a:xfrm>
+          <a:prstGeom prst="line">
+            <a:avLst/>
+          </a:prstGeom>
+          <a:ln w="9525">
+            <a:solidFill>
+              <a:srgbClr val="ECEBE8"/>
+            </a:solidFill>
+          </a:ln>
+        </p:spPr>
+        <p:style>
+          <a:lnRef idx="2">
+            <a:schemeClr val="accent1"/>
+          </a:lnRef>
+          <a:fillRef idx="0">
+            <a:schemeClr val="accent1"/>
+          </a:fillRef>
+          <a:effectRef idx="1">
+            <a:schemeClr val="accent1"/>
+          </a:effectRef>
+          <a:fontRef idx="minor">
+            <a:schemeClr val="tx1"/>
+          </a:fontRef>
+        </p:style>
+      </p:cxnSp>
+      <p:sp>
+        <p:nvSpPr>
+          <p:cNvPr id="17" name="Oval 16"/>
+          <p:cNvSpPr/>
+          <p:nvPr/>
+        </p:nvSpPr>
+        <p:spPr>
+          <a:xfrm>
+            <a:off x="7626095" y="2500884"/>
+            <a:ext cx="155448" cy="155448"/>
+          </a:xfrm>
+          <a:prstGeom prst="ellipse">
+            <a:avLst/>
+          </a:prstGeom>
+          <a:solidFill>
+            <a:srgbClr val="57068C"/>
+          </a:solidFill>
+          <a:ln>
+            <a:noFill/>
+          </a:ln>
+          <a:effectLst/>
+        </p:spPr>
+        <p:style>
+          <a:lnRef idx="1">
+            <a:schemeClr val="accent1"/>
+          </a:lnRef>
+          <a:fillRef idx="3">
+            <a:schemeClr val="accent1"/>
+          </a:fillRef>
+          <a:effectRef idx="2">
+            <a:schemeClr val="accent1"/>
+          </a:effectRef>
+          <a:fontRef idx="minor">
+            <a:schemeClr val="lt1"/>
+          </a:fontRef>
+        </p:style>
+        <p:txBody>
+          <a:bodyPr rtlCol="0" anchor="ctr"/>
+          <a:lstStyle/>
+          <a:p>
+            <a:pPr algn="ctr"/>
+          </a:p>
+        </p:txBody>
+      </p:sp>
+      <p:sp>
+        <p:nvSpPr>
+          <p:cNvPr id="18" name="TextBox 17"/>
+          <p:cNvSpPr txBox="1"/>
+          <p:nvPr/>
+        </p:nvSpPr>
+        <p:spPr>
+          <a:xfrm>
+            <a:off x="7822691" y="2459736"/>
+            <a:ext cx="548640" cy="237744"/>
+          </a:xfrm>
+          <a:prstGeom prst="rect">
+            <a:avLst/>
+          </a:prstGeom>
+          <a:noFill/>
+        </p:spPr>
+        <p:txBody>
+          <a:bodyPr wrap="square" anchor="t" lIns="0" rIns="0" tIns="0" bIns="0">
+            <a:spAutoFit/>
+          </a:bodyPr>
+          <a:lstStyle/>
+          <a:p>
+            <a:pPr algn="l">
+              <a:spcAft>
+                <a:spcPts val="600"/>
+              </a:spcAft>
+            </a:pPr>
+            <a:r>
+              <a:rPr sz="1100" b="1" i="0">
+                <a:solidFill>
+                  <a:srgbClr val="57068C"/>
+                </a:solidFill>
+              </a:rPr>
+              <a:t>1.95</a:t>
+            </a:r>
+          </a:p>
+        </p:txBody>
+      </p:sp>
+      <p:cxnSp>
+        <p:nvCxnSpPr>
+          <p:cNvPr id="19" name="Connector 18"/>
+          <p:cNvCxnSpPr/>
+          <p:nvPr/>
+        </p:nvCxnSpPr>
+        <p:spPr>
+          <a:xfrm>
+            <a:off x="2743200" y="2770632"/>
+            <a:ext cx="5669280" cy="0"/>
+          </a:xfrm>
+          <a:prstGeom prst="line">
+            <a:avLst/>
+          </a:prstGeom>
+          <a:ln w="12700">
+            <a:solidFill>
+              <a:srgbClr val="B9B4C2"/>
+            </a:solidFill>
+          </a:ln>
+        </p:spPr>
+        <p:style>
+          <a:lnRef idx="2">
+            <a:schemeClr val="accent1"/>
+          </a:lnRef>
+          <a:fillRef idx="0">
+            <a:schemeClr val="accent1"/>
+          </a:fillRef>
+          <a:effectRef idx="1">
+            <a:schemeClr val="accent1"/>
+          </a:effectRef>
+          <a:fontRef idx="minor">
+            <a:schemeClr val="tx1"/>
+          </a:fontRef>
+        </p:style>
+      </p:cxnSp>
+      <p:sp>
+        <p:nvSpPr>
+          <p:cNvPr id="20" name="TextBox 19"/>
+          <p:cNvSpPr txBox="1"/>
+          <p:nvPr/>
+        </p:nvSpPr>
+        <p:spPr>
+          <a:xfrm>
+            <a:off x="2468880" y="2807208"/>
+            <a:ext cx="548640" cy="228600"/>
+          </a:xfrm>
+          <a:prstGeom prst="rect">
+            <a:avLst/>
+          </a:prstGeom>
+          <a:noFill/>
+        </p:spPr>
+        <p:txBody>
+          <a:bodyPr wrap="square" anchor="t" lIns="0" rIns="0" tIns="0" bIns="0">
+            <a:spAutoFit/>
+          </a:bodyPr>
+          <a:lstStyle/>
+          <a:p>
+            <a:pPr algn="ctr">
+              <a:spcAft>
+                <a:spcPts val="600"/>
+              </a:spcAft>
+            </a:pPr>
+            <a:r>
+              <a:rPr sz="1000" b="0" i="0">
+                <a:solidFill>
+                  <a:srgbClr val="6B6B6B"/>
+                </a:solidFill>
+              </a:rPr>
+              <a:t>1.6</a:t>
+            </a:r>
+          </a:p>
+        </p:txBody>
+      </p:sp>
+      <p:sp>
+        <p:nvSpPr>
+          <p:cNvPr id="21" name="TextBox 20"/>
+          <p:cNvSpPr txBox="1"/>
+          <p:nvPr/>
+        </p:nvSpPr>
+        <p:spPr>
+          <a:xfrm>
+            <a:off x="3886199" y="2807208"/>
+            <a:ext cx="548640" cy="228600"/>
+          </a:xfrm>
+          <a:prstGeom prst="rect">
+            <a:avLst/>
+          </a:prstGeom>
+          <a:noFill/>
+        </p:spPr>
+        <p:txBody>
+          <a:bodyPr wrap="square" anchor="t" lIns="0" rIns="0" tIns="0" bIns="0">
+            <a:spAutoFit/>
+          </a:bodyPr>
+          <a:lstStyle/>
+          <a:p>
+            <a:pPr algn="ctr">
+              <a:spcAft>
+                <a:spcPts val="600"/>
+              </a:spcAft>
+            </a:pPr>
+            <a:r>
+              <a:rPr sz="1000" b="0" i="0">
+                <a:solidFill>
+                  <a:srgbClr val="6B6B6B"/>
+                </a:solidFill>
+              </a:rPr>
+              <a:t>1.7</a:t>
+            </a:r>
+          </a:p>
+        </p:txBody>
+      </p:sp>
+      <p:sp>
+        <p:nvSpPr>
+          <p:cNvPr id="22" name="TextBox 21"/>
+          <p:cNvSpPr txBox="1"/>
+          <p:nvPr/>
+        </p:nvSpPr>
+        <p:spPr>
+          <a:xfrm>
+            <a:off x="5303520" y="2807208"/>
+            <a:ext cx="548640" cy="228600"/>
+          </a:xfrm>
+          <a:prstGeom prst="rect">
+            <a:avLst/>
+          </a:prstGeom>
+          <a:noFill/>
+        </p:spPr>
+        <p:txBody>
+          <a:bodyPr wrap="square" anchor="t" lIns="0" rIns="0" tIns="0" bIns="0">
+            <a:spAutoFit/>
+          </a:bodyPr>
+          <a:lstStyle/>
+          <a:p>
+            <a:pPr algn="ctr">
+              <a:spcAft>
+                <a:spcPts val="600"/>
+              </a:spcAft>
+            </a:pPr>
+            <a:r>
+              <a:rPr sz="1000" b="0" i="0">
+                <a:solidFill>
+                  <a:srgbClr val="6B6B6B"/>
+                </a:solidFill>
+              </a:rPr>
+              <a:t>1.8</a:t>
+            </a:r>
+          </a:p>
+        </p:txBody>
+      </p:sp>
+      <p:sp>
+        <p:nvSpPr>
+          <p:cNvPr id="23" name="TextBox 22"/>
+          <p:cNvSpPr txBox="1"/>
+          <p:nvPr/>
+        </p:nvSpPr>
+        <p:spPr>
+          <a:xfrm>
+            <a:off x="6720839" y="2807208"/>
+            <a:ext cx="548640" cy="228600"/>
+          </a:xfrm>
+          <a:prstGeom prst="rect">
+            <a:avLst/>
+          </a:prstGeom>
+          <a:noFill/>
+        </p:spPr>
+        <p:txBody>
+          <a:bodyPr wrap="square" anchor="t" lIns="0" rIns="0" tIns="0" bIns="0">
+            <a:spAutoFit/>
+          </a:bodyPr>
+          <a:lstStyle/>
+          <a:p>
+            <a:pPr algn="ctr">
+              <a:spcAft>
+                <a:spcPts val="600"/>
+              </a:spcAft>
+            </a:pPr>
+            <a:r>
+              <a:rPr sz="1000" b="0" i="0">
+                <a:solidFill>
+                  <a:srgbClr val="6B6B6B"/>
+                </a:solidFill>
+              </a:rPr>
+              <a:t>1.9</a:t>
+            </a:r>
+          </a:p>
+        </p:txBody>
+      </p:sp>
+      <p:sp>
+        <p:nvSpPr>
+          <p:cNvPr id="24" name="TextBox 23"/>
+          <p:cNvSpPr txBox="1"/>
+          <p:nvPr/>
+        </p:nvSpPr>
+        <p:spPr>
+          <a:xfrm>
+            <a:off x="8138160" y="2807208"/>
+            <a:ext cx="548640" cy="228600"/>
+          </a:xfrm>
+          <a:prstGeom prst="rect">
+            <a:avLst/>
+          </a:prstGeom>
+          <a:noFill/>
+        </p:spPr>
+        <p:txBody>
+          <a:bodyPr wrap="square" anchor="t" lIns="0" rIns="0" tIns="0" bIns="0">
+            <a:spAutoFit/>
+          </a:bodyPr>
+          <a:lstStyle/>
+          <a:p>
+            <a:pPr algn="ctr">
+              <a:spcAft>
+                <a:spcPts val="600"/>
+              </a:spcAft>
+            </a:pPr>
+            <a:r>
+              <a:rPr sz="1000" b="0" i="0">
+                <a:solidFill>
+                  <a:srgbClr val="6B6B6B"/>
+                </a:solidFill>
+              </a:rPr>
+              <a:t>2.0</a:t>
+            </a:r>
+          </a:p>
+        </p:txBody>
+      </p:sp>
+      <p:cxnSp>
+        <p:nvCxnSpPr>
+          <p:cNvPr id="25" name="Connector 24"/>
+          <p:cNvCxnSpPr/>
+          <p:nvPr/>
+        </p:nvCxnSpPr>
+        <p:spPr>
+          <a:xfrm>
+            <a:off x="5436108" y="1143000"/>
+            <a:ext cx="0" cy="1627632"/>
+          </a:xfrm>
+          <a:prstGeom prst="line">
+            <a:avLst/>
+          </a:prstGeom>
+          <a:ln w="15875">
+            <a:solidFill>
+              <a:srgbClr val="333333"/>
+            </a:solidFill>
+            <a:prstDash val="dash"/>
+          </a:ln>
+        </p:spPr>
+        <p:style>
+          <a:lnRef idx="2">
+            <a:schemeClr val="accent1"/>
+          </a:lnRef>
+          <a:fillRef idx="0">
+            <a:schemeClr val="accent1"/>
+          </a:fillRef>
+          <a:effectRef idx="1">
+            <a:schemeClr val="accent1"/>
+          </a:effectRef>
+          <a:fontRef idx="minor">
+            <a:schemeClr val="tx1"/>
+          </a:fontRef>
+        </p:style>
+      </p:cxnSp>
+      <p:sp>
+        <p:nvSpPr>
+          <p:cNvPr id="26" name="TextBox 25"/>
+          <p:cNvSpPr txBox="1"/>
+          <p:nvPr/>
+        </p:nvSpPr>
+        <p:spPr>
+          <a:xfrm>
+            <a:off x="4978908" y="886968"/>
+            <a:ext cx="914400" cy="237744"/>
+          </a:xfrm>
+          <a:prstGeom prst="rect">
+            <a:avLst/>
+          </a:prstGeom>
+          <a:noFill/>
+        </p:spPr>
+        <p:txBody>
+          <a:bodyPr wrap="square" anchor="t" lIns="0" rIns="0" tIns="0" bIns="0">
+            <a:spAutoFit/>
+          </a:bodyPr>
+          <a:lstStyle/>
+          <a:p>
+            <a:pPr algn="ctr">
+              <a:spcAft>
+                <a:spcPts val="600"/>
+              </a:spcAft>
+            </a:pPr>
+            <a:r>
+              <a:rPr sz="1100" b="1" i="0">
+                <a:solidFill>
+                  <a:srgbClr val="333333"/>
+                </a:solidFill>
+              </a:rPr>
+              <a:t>BP 1.79</a:t>
+            </a:r>
+          </a:p>
+        </p:txBody>
+      </p:sp>
+      <p:sp>
+        <p:nvSpPr>
+          <p:cNvPr id="27" name="TextBox 26"/>
+          <p:cNvSpPr txBox="1"/>
+          <p:nvPr/>
+        </p:nvSpPr>
+        <p:spPr>
+          <a:xfrm>
+            <a:off x="2743200" y="3026664"/>
+            <a:ext cx="5669280" cy="274320"/>
+          </a:xfrm>
+          <a:prstGeom prst="rect">
+            <a:avLst/>
+          </a:prstGeom>
+          <a:noFill/>
+        </p:spPr>
+        <p:txBody>
+          <a:bodyPr wrap="square" anchor="t" lIns="0" rIns="0" tIns="0" bIns="0">
+            <a:spAutoFit/>
+          </a:bodyPr>
+          <a:lstStyle/>
+          <a:p>
+            <a:pPr algn="l">
+              <a:spcAft>
+                <a:spcPts val="0"/>
+              </a:spcAft>
+            </a:pPr>
+            <a:r>
+              <a:rPr sz="950" b="0" i="1">
+                <a:solidFill>
+                  <a:srgbClr val="6B6B6B"/>
+                </a:solidFill>
+              </a:rPr>
+              <a:t>Effective number of active basis weights, mean over 4 images (lower = sparser).</a:t>
+            </a:r>
+          </a:p>
+        </p:txBody>
+      </p:sp>
+      <p:sp>
+        <p:nvSpPr>
+          <p:cNvPr id="28" name="TextBox 27"/>
+          <p:cNvSpPr txBox="1"/>
+          <p:nvPr/>
+        </p:nvSpPr>
+        <p:spPr>
+          <a:xfrm>
+            <a:off x="365760" y="3246120"/>
+            <a:ext cx="8412480" cy="1097280"/>
+          </a:xfrm>
+          <a:prstGeom prst="rect">
+            <a:avLst/>
+          </a:prstGeom>
+          <a:noFill/>
+        </p:spPr>
+        <p:txBody>
+          <a:bodyPr wrap="square" anchor="t" lIns="0" rIns="0" tIns="0" bIns="0">
+            <a:spAutoFit/>
+          </a:bodyPr>
+          <a:lstStyle/>
+          <a:p>
+            <a:pPr algn="l" marL="182880" indent="-182880">
+              <a:spcAft>
+                <a:spcPts val="500"/>
+              </a:spcAft>
+              <a:buClr>
+                <a:srgbClr val="333333"/>
+              </a:buClr>
+              <a:buChar char="•"/>
+            </a:pPr>
+            <a:r>
+              <a:rPr sz="1250" b="0" i="0">
+                <a:solidFill>
+                  <a:srgbClr val="333333"/>
+                </a:solidFill>
+              </a:rPr>
+              <a:t>Four variants at ~1.45M params, same BP loss, same 4 images.</a:t>
+            </a:r>
+          </a:p>
+          <a:p>
+            <a:pPr algn="l" marL="182880" indent="-182880">
+              <a:spcAft>
+                <a:spcPts val="500"/>
+              </a:spcAft>
+              <a:buClr>
+                <a:srgbClr val="333333"/>
+              </a:buClr>
+              <a:buChar char="•"/>
+            </a:pPr>
+            <a:r>
+              <a:rPr sz="1250" b="0" i="0">
+                <a:solidFill>
+                  <a:srgbClr val="333333"/>
+                </a:solidFill>
+              </a:rPr>
+              <a:t>A centre-pixel MLP this size was smooth too: the first MLP's noise was not about the neighbourhood.</a:t>
+            </a:r>
+          </a:p>
+          <a:p>
+            <a:pPr algn="l" marL="182880" indent="-182880">
+              <a:spcAft>
+                <a:spcPts val="500"/>
+              </a:spcAft>
+              <a:buClr>
+                <a:srgbClr val="333333"/>
+              </a:buClr>
+              <a:buChar char="•"/>
+            </a:pPr>
+            <a:r>
+              <a:rPr sz="1250" b="0" i="0">
+                <a:solidFill>
+                  <a:srgbClr val="333333"/>
+                </a:solidFill>
+              </a:rPr>
+              <a:t>The patch CNN was sparsest, but measured on held-out pixels of the training images.</a:t>
+            </a:r>
+          </a:p>
+        </p:txBody>
+      </p:sp>
+    </p:spTree>
+  </p:cSld>
+  <p:clrMapOvr>
+    <a:masterClrMapping/>
+  </p:clrMapOvr>
+</p:sld>
+</file>
+
+<file path=ppt/slides/slide12.xml><?xml version="1.0" encoding="utf-8"?>
+<p:sld xmlns:a="http://schemas.openxmlformats.org/drawingml/2006/main" xmlns:p="http://schemas.openxmlformats.org/presentationml/2006/main" xmlns:r="http://schemas.openxmlformats.org/officeDocument/2006/relationships">
+  <p:cSld>
+    <p:spTree>
+      <p:nvGrpSpPr>
+        <p:cNvPr id="1" name=""/>
+        <p:cNvGrpSpPr/>
+        <p:nvPr/>
+      </p:nvGrpSpPr>
+      <p:grpSpPr/>
+      <p:sp>
+        <p:nvSpPr>
+          <p:cNvPr id="2" name="TextBox 1"/>
+          <p:cNvSpPr txBox="1"/>
+          <p:nvPr/>
+        </p:nvSpPr>
+        <p:spPr>
+          <a:xfrm>
+            <a:off x="265176" y="219456"/>
+            <a:ext cx="8503920" cy="566928"/>
+          </a:xfrm>
+          <a:prstGeom prst="rect">
+            <a:avLst/>
+          </a:prstGeom>
+          <a:noFill/>
+        </p:spPr>
+        <p:txBody>
+          <a:bodyPr wrap="square" anchor="t" lIns="0" rIns="0" tIns="0" bIns="0">
+            <a:spAutoFit/>
+          </a:bodyPr>
+          <a:lstStyle/>
+          <a:p>
+            <a:pPr algn="l">
+              <a:spcAft>
+                <a:spcPts val="600"/>
+              </a:spcAft>
+            </a:pPr>
+            <a:r>
+              <a:rPr sz="2000" b="1" i="0">
+                <a:solidFill>
+                  <a:srgbClr val="57068C"/>
+                </a:solidFill>
+              </a:rPr>
+              <a:t>On unseen days, the patch CNN's edge disappeared</a:t>
+            </a:r>
+          </a:p>
+        </p:txBody>
+      </p:sp>
+      <p:sp>
+        <p:nvSpPr>
+          <p:cNvPr id="3" name="TextBox 2"/>
+          <p:cNvSpPr txBox="1"/>
+          <p:nvPr/>
+        </p:nvSpPr>
+        <p:spPr>
+          <a:xfrm>
+            <a:off x="365760" y="914400"/>
+            <a:ext cx="4937760" cy="3383280"/>
+          </a:xfrm>
+          <a:prstGeom prst="rect">
+            <a:avLst/>
+          </a:prstGeom>
+          <a:noFill/>
+        </p:spPr>
+        <p:txBody>
+          <a:bodyPr wrap="square" anchor="t" lIns="0" rIns="0" tIns="0" bIns="0">
+            <a:spAutoFit/>
+          </a:bodyPr>
+          <a:lstStyle/>
+          <a:p>
+            <a:pPr algn="l" marL="182880" indent="-182880">
+              <a:spcAft>
+                <a:spcPts val="900"/>
+              </a:spcAft>
+              <a:buClr>
+                <a:srgbClr val="333333"/>
+              </a:buClr>
+              <a:buChar char="•"/>
+            </a:pPr>
+            <a:r>
+              <a:rPr sz="1250" b="0" i="0">
+                <a:solidFill>
+                  <a:srgbClr val="333333"/>
+                </a:solidFill>
+              </a:rPr>
+              <a:t>Leave one image out: train on 3, test on the 4th; patch CNN and centre-pixel MLP, 4 folds.</a:t>
+            </a:r>
+          </a:p>
+          <a:p>
+            <a:pPr algn="l" marL="182880" indent="-182880">
+              <a:spcAft>
+                <a:spcPts val="900"/>
+              </a:spcAft>
+              <a:buClr>
+                <a:srgbClr val="333333"/>
+              </a:buClr>
+              <a:buChar char="•"/>
+            </a:pPr>
+            <a:r>
+              <a:rPr sz="1250" b="0" i="0">
+                <a:solidFill>
+                  <a:srgbClr val="333333"/>
+                </a:solidFill>
+              </a:rPr>
+              <a:t>Held-out sparsity: CNN lower on 1 day, MLP on 2, tied on 1; the MLP fit AIA better on 3 of 4.</a:t>
+            </a:r>
+          </a:p>
+          <a:p>
+            <a:pPr algn="l" marL="182880" indent="-182880">
+              <a:spcAft>
+                <a:spcPts val="900"/>
+              </a:spcAft>
+              <a:buClr>
+                <a:srgbClr val="333333"/>
+              </a:buClr>
+              <a:buChar char="•"/>
+            </a:pPr>
+            <a:r>
+              <a:rPr sz="1250" b="0" i="0">
+                <a:solidFill>
+                  <a:srgbClr val="333333"/>
+                </a:solidFill>
+              </a:rPr>
+              <a:t>Little overfitting (held-out within ±0.2 of in-sample on 3 folds), except the X1.6 flare: peaks too cool (logT ~6.1 vs BP ~6.4), with one other flare image in training.</a:t>
+            </a:r>
+          </a:p>
+          <a:p>
+            <a:pPr algn="l" marL="182880" indent="-182880">
+              <a:spcAft>
+                <a:spcPts val="900"/>
+              </a:spcAft>
+              <a:buClr>
+                <a:srgbClr val="333333"/>
+              </a:buClr>
+              <a:buChar char="•"/>
+            </a:pPr>
+            <a:r>
+              <a:rPr sz="1250" b="1" i="0">
+                <a:solidFill>
+                  <a:srgbClr val="57068C"/>
+                </a:solidFill>
+              </a:rPr>
+              <a:t>Carry the simpler centre-pixel MLP forward, and get more flare data → scaling.</a:t>
+            </a:r>
+          </a:p>
+        </p:txBody>
+      </p:sp>
+      <p:pic>
+        <p:nvPicPr>
+          <p:cNvPr id="4" name="Picture 3" descr="loo_flare.png"/>
+          <p:cNvPicPr>
+            <a:picLocks noChangeAspect="1"/>
+          </p:cNvPicPr>
+          <p:nvPr/>
+        </p:nvPicPr>
+        <p:blipFill>
+          <a:blip r:embed="rId3"/>
+          <a:stretch>
+            <a:fillRect/>
+          </a:stretch>
+        </p:blipFill>
+        <p:spPr>
+          <a:xfrm>
+            <a:off x="5486400" y="827579"/>
+            <a:ext cx="3291840" cy="3282601"/>
+          </a:xfrm>
+          <a:prstGeom prst="rect">
+            <a:avLst/>
+          </a:prstGeom>
+        </p:spPr>
+      </p:pic>
+      <p:sp>
+        <p:nvSpPr>
+          <p:cNvPr id="5" name="TextBox 4"/>
+          <p:cNvSpPr txBox="1"/>
+          <p:nvPr/>
+        </p:nvSpPr>
+        <p:spPr>
+          <a:xfrm>
+            <a:off x="5486400" y="4114800"/>
+            <a:ext cx="3291840" cy="274320"/>
+          </a:xfrm>
+          <a:prstGeom prst="rect">
+            <a:avLst/>
+          </a:prstGeom>
+          <a:noFill/>
+        </p:spPr>
+        <p:txBody>
+          <a:bodyPr wrap="square" anchor="t" lIns="0" rIns="0" tIns="0" bIns="0">
+            <a:spAutoFit/>
+          </a:bodyPr>
+          <a:lstStyle/>
+          <a:p>
+            <a:pPr algn="l">
+              <a:spcAft>
+                <a:spcPts val="0"/>
+              </a:spcAft>
+            </a:pPr>
+            <a:r>
+              <a:rPr sz="950" b="0" i="1">
+                <a:solidFill>
+                  <a:srgbClr val="6B6B6B"/>
+                </a:solidFill>
+              </a:rPr>
+              <a:t>Held-out X1.6 flare image: CNN and MLP (dashed) vs BP.</a:t>
+            </a:r>
+          </a:p>
+        </p:txBody>
+      </p:sp>
+    </p:spTree>
+  </p:cSld>
+  <p:clrMapOvr>
+    <a:masterClrMapping/>
+  </p:clrMapOvr>
+</p:sld>
+</file>
+
 <file path=ppt/slides/slide2.xml><?xml version="1.0" encoding="utf-8"?>
 <p:sld xmlns:a="http://schemas.openxmlformats.org/drawingml/2006/main" xmlns:p="http://schemas.openxmlformats.org/presentationml/2006/main" xmlns:r="http://schemas.openxmlformats.org/officeDocument/2006/relationships">
   <p:cSld>
@@ -13096,7 +14798,7 @@
                   <a:srgbClr val="333333"/>
                 </a:solidFill>
               </a:rPr>
-              <a:t>Our model trains on AIA and σ only: ~30M pixels per epoch, 40 epochs.</a:t>
+              <a:t>Our model trains on AIA and σ only: each training image is cut into 64 blocks of 256×256 per image. Each epoch draws 512 random pixels from each of the 58,688 blocks(917*64), for 40 epochs.</a:t>
             </a:r>
           </a:p>
           <a:p>
@@ -13134,7 +14836,7 @@
                   <a:srgbClr val="333333"/>
                 </a:solidFill>
               </a:rPr>
-              <a:t>Test: ~700M pixel DEMs per solver, the clean solve plus 4 noise re-solves.</a:t>
+              <a:t>Test: ~700M pixel DEMs per solver, the clean solve plus 4 noise re-solves(only supervised).</a:t>
             </a:r>
           </a:p>
         </p:txBody>
@@ -13422,6 +15124,57 @@
                 </a:solidFill>
               </a:rPr>
               <a:t>So the network has to train on the solver's objective, not on fit.</a:t>
+            </a:r>
+          </a:p>
+        </p:txBody>
+      </p:sp>
+    </p:spTree>
+  </p:cSld>
+  <p:clrMapOvr>
+    <a:masterClrMapping/>
+  </p:clrMapOvr>
+</p:sld>
+</file>
+
+<file path=ppt/slides/slide9.xml><?xml version="1.0" encoding="utf-8"?>
+<p:sld xmlns:a="http://schemas.openxmlformats.org/drawingml/2006/main" xmlns:p="http://schemas.openxmlformats.org/presentationml/2006/main" xmlns:r="http://schemas.openxmlformats.org/officeDocument/2006/relationships">
+  <p:cSld>
+    <p:spTree>
+      <p:nvGrpSpPr>
+        <p:cNvPr id="1" name=""/>
+        <p:cNvGrpSpPr/>
+        <p:nvPr/>
+      </p:nvGrpSpPr>
+      <p:grpSpPr/>
+      <p:sp>
+        <p:nvSpPr>
+          <p:cNvPr id="2" name="Title 1"/>
+          <p:cNvSpPr>
+            <a:spLocks noGrp="1"/>
+          </p:cNvSpPr>
+          <p:nvPr>
+            <p:ph type="title"/>
+          </p:nvPr>
+        </p:nvSpPr>
+        <p:spPr>
+          <a:xfrm>
+            <a:off x="311700" y="846450"/>
+            <a:ext cx="8520600" cy="1671000"/>
+          </a:xfrm>
+        </p:spPr>
+        <p:txBody>
+          <a:bodyPr/>
+          <a:lstStyle/>
+          <a:p>
+            <a:pPr algn="ctr"/>
+            <a:r>
+              <a:rPr sz="4100"/>
+              <a:t>Part 3</a:t>
+            </a:r>
+            <a:br/>
+            <a:r>
+              <a:rPr sz="4100"/>
+              <a:t>Architecture on small data</a:t>
             </a:r>
           </a:p>
         </p:txBody>

</xml_diff>

<commit_message>
slides: name the four small-data images; correct slides 11 and 12
Slide 10 names the four images (crops near disk centre, so they need not
contain the flare cores). Slide 11's notes said shuffling the patch barely
mattered; it was less sparse than the CNN on all four images. Slide 12 said
the MLP had lower sparsity on more days, which reads as better; measured as
closeness to BP, neither model is consistently ahead.
</commit_message>
<xml_diff>
--- a/slides/DEM_deck_v2.pptx
+++ b/slides/DEM_deck_v2.pptx
@@ -1210,7 +1210,7 @@
           <a:lstStyle/>
           <a:p>
             <a:r>
-              <a:t>The shuffled-patch CNN applies a fixed random permutation to the 81 patch pixels and nearly matches the CNN, so the gain came from neighbouring values more than from geometry. The flat-patch MLP was erratic across images: 1.61 on the X2.1 flare, 2.27 on quiet Sun. Capacity and setup were never fully separated: the 213k MLP took raw intensities, and at full scale a 176k MLP on log1p inputs is smooth.</a:t>
+              <a:t>The shuffled-patch CNN applies a fixed random permutation to the 81 patch pixels. It was less sparse than the CNN on all 4 images, 1.88 against 1.70 on average, level with the centre-pixel MLP, so the spatial arrangement of the neighbours mattered. The flat-patch MLP was erratic across images: 1.61 on the X2.1 flare, 2.27 on quiet Sun. Capacity and setup were never fully separated: the 213k MLP took raw intensities, and at full scale a 176k MLP on log1p inputs is smooth.</a:t>
             </a:r>
           </a:p>
         </p:txBody>
@@ -1268,7 +1268,7 @@
           <a:lstStyle/>
           <a:p>
             <a:r>
-              <a:t>Held-out sparsity by fold, MLP against CNN, with BP in brackets: X2.1 flare 1.59 vs 1.64 (1.97); quiet Sun 1.78 vs 1.61 (1.67); moderate 1.83 vs 1.83 (1.82); X1.6 flare 1.96 vs 2.31 (1.71). The ablation's in-sample edge, 1.70 vs 1.89, came from scoring pixels of images the model trained on. Four folds is a small sample; scaling is the real test.</a:t>
+              <a:t>Closer to BP's sparsity: the CNN on 2 images, the MLP on 1, one tie; the MLP is closer on average, 0.19 against 0.25, because of the X1.6 flare image. Held-out sparsity by fold, MLP against CNN, with BP in brackets: X2.1 flare 1.59 vs 1.64 (1.97); quiet Sun 1.78 vs 1.61 (1.67); moderate 1.83 vs 1.83 (1.82); X1.6 flare 1.96 vs 2.31 (1.71). The ablation's in-sample edge, 1.70 vs 1.89, came from scoring pixels of images the model trained on. Four folds is a small sample; scaling is the real test.</a:t>
             </a:r>
           </a:p>
         </p:txBody>
@@ -10097,8 +10097,46 @@
         </p:nvSpPr>
         <p:spPr>
           <a:xfrm>
-            <a:off x="365760" y="914400"/>
-            <a:ext cx="4937760" cy="3291840"/>
+            <a:off x="365760" y="868680"/>
+            <a:ext cx="8412480" cy="274320"/>
+          </a:xfrm>
+          <a:prstGeom prst="rect">
+            <a:avLst/>
+          </a:prstGeom>
+          <a:noFill/>
+        </p:spPr>
+        <p:txBody>
+          <a:bodyPr wrap="square" anchor="t" lIns="0" rIns="0" tIns="0" bIns="0">
+            <a:spAutoFit/>
+          </a:bodyPr>
+          <a:lstStyle/>
+          <a:p>
+            <a:pPr algn="l">
+              <a:spcAft>
+                <a:spcPts val="600"/>
+              </a:spcAft>
+            </a:pPr>
+            <a:r>
+              <a:rPr sz="1050" b="0" i="0">
+                <a:solidFill>
+                  <a:srgbClr val="6B6B6B"/>
+                </a:solidFill>
+              </a:rPr>
+              <a:t>4 images: X2.1 flare (2011-09-06), quiet Sun (2012-06-03), moderate activity (2013-11-13), X1.6 flare (2014-09-10); small crops near disk centre.</a:t>
+            </a:r>
+          </a:p>
+        </p:txBody>
+      </p:sp>
+      <p:sp>
+        <p:nvSpPr>
+          <p:cNvPr id="4" name="TextBox 3"/>
+          <p:cNvSpPr txBox="1"/>
+          <p:nvPr/>
+        </p:nvSpPr>
+        <p:spPr>
+          <a:xfrm>
+            <a:off x="365760" y="1280160"/>
+            <a:ext cx="4937760" cy="3017520"/>
           </a:xfrm>
           <a:prstGeom prst="rect">
             <a:avLst/>
@@ -10187,7 +10225,7 @@
       </p:sp>
       <p:pic>
         <p:nvPicPr>
-          <p:cNvPr id="4" name="Picture 3" descr="patch_cnn.png"/>
+          <p:cNvPr id="5" name="Picture 4" descr="patch_cnn.png"/>
           <p:cNvPicPr>
             <a:picLocks noChangeAspect="1"/>
           </p:cNvPicPr>
@@ -10211,7 +10249,7 @@
       </p:pic>
       <p:sp>
         <p:nvSpPr>
-          <p:cNvPr id="5" name="TextBox 4"/>
+          <p:cNvPr id="6" name="TextBox 5"/>
           <p:cNvSpPr txBox="1"/>
           <p:nvPr/>
         </p:nvSpPr>
@@ -11452,7 +11490,7 @@
                   <a:srgbClr val="333333"/>
                 </a:solidFill>
               </a:rPr>
-              <a:t>Held-out sparsity: CNN lower on 1 day, MLP on 2, tied on 1; the MLP fit AIA better on 3 of 4.</a:t>
+              <a:t>Neither is consistently closer to BP's sparsity on the unseen image; the MLP fits AIA better on 3 of 4.</a:t>
             </a:r>
           </a:p>
           <a:p>

</xml_diff>

<commit_message>
slides: say the training pixels were one fixed sample
Slide 6 now says 512 pixels per block were drawn once and reused, and adds
one line that redrawing them every epoch did worse on validation. The notes
explain it began as a sampler bug and give the retrain numbers.
</commit_message>
<xml_diff>
--- a/slides/DEM_deck_v2.pptx
+++ b/slides/DEM_deck_v2.pptx
@@ -1036,7 +1036,7 @@
           <a:lstStyle/>
           <a:p>
             <a:r>
-              <a:t>The split is chronological, so every test image is later than anything seen in training. Each epoch draws 512 pixels from each of 58,688 training blocks: 917 images times 64 blocks of 256 squared. The test set uses 64 random 128-squared blocks of each test image per solver target, five targets per image: one clean solve and four re-solves under simulated photon noise of the same observation. Pixels where deconvolution clamped a bright channel to zero, about 5%, are excluded.</a:t>
+              <a:t>The fixed sample was not a design choice at first: the sampler seeded each block's draw by the block alone, so every run reused the same pixels. Once found, we retrained both production models drawing fresh pixels every epoch, everything else identical: validation loss BP 2.156 to 2.237, ElasticNet 0.0582 to 0.0689, far beyond the 0.2 to 0.4% run-to-run spread; only ElasticNet's flare cores improved. The split is chronological, so every test image is later than anything seen in training. Each epoch draws 512 pixels from each of 58,688 training blocks: 917 images times 64 blocks of 256 squared. The test set uses 64 random 128-squared blocks of each test image per solver target, five targets per image: one clean solve and four re-solves under simulated photon noise of the same observation. Pixels where deconvolution clamped a bright channel to zero, about 5%, are excluded.</a:t>
             </a:r>
           </a:p>
         </p:txBody>
@@ -14836,7 +14836,26 @@
                   <a:srgbClr val="333333"/>
                 </a:solidFill>
               </a:rPr>
-              <a:t>Our model trains on AIA and σ only: each training image is cut into 64 blocks of 256×256 per image. Each epoch draws 512 random pixels from each of the 58,688 blocks(917*64), for 40 epochs.</a:t>
+              <a:t>Our model trains on AIA and σ only: each training image is cut into 64 blocks of 256×256 per image. 512 random pixels are drawn once from each of the 58,688 blocks(917*64), and that fixed ~30M-pixel sample is reused for 40 epochs.</a:t>
+            </a:r>
+          </a:p>
+          <a:p>
+            <a:pPr algn="l" marL="182880" indent="-182880">
+              <a:spcAft>
+                <a:spcPts val="700"/>
+              </a:spcAft>
+              <a:buClr>
+                <a:srgbClr val="333333"/>
+              </a:buClr>
+              <a:buChar char="•"/>
+            </a:pPr>
+            <a:r>
+              <a:rPr sz="1250" b="0" i="0">
+                <a:solidFill>
+                  <a:srgbClr val="333333"/>
+                </a:solidFill>
+              </a:rPr>
+              <a:t>Redrawing the pixels every epoch did worse on validation (BP +4%, ElasticNet +18%), so we kept the fixed sample.</a:t>
             </a:r>
           </a:p>
           <a:p>

</xml_diff>

<commit_message>
slides: reframe slides 10-11 on accuracy, not noise
The June per-pixel MLP, retrained with unchanged code, is smooth but further
from BP (DEM error 0.078 vs the patch CNN's 0.047). The 1.43M centre-pixel
MLP is closest of all (0.042), so the gap was size, not missing neighbours.
Slide 10 gets the new three-curve figure; slide 11's title and second point
follow the numbers.
</commit_message>
<xml_diff>
--- a/slides/DEM_deck_v2.pptx
+++ b/slides/DEM_deck_v2.pptx
@@ -1152,7 +1152,7 @@
           <a:lstStyle/>
           <a:p>
             <a:r>
-              <a:t>All of Part 3 uses four images: two X-class flares, quiet Sun and moderate activity. The first MLP is the same architecture as today's production model, four hidden layers with SiLU and a softplus output, at width 256 with raw intensities as input. Its noise was put down at the time to the overlapping basis amplifying small weight errors, and to the problem's non-uniqueness. Its checkpoint was not kept, so there is no figure of it.</a:t>
+              <a:t>The June write-up called the first MLP's curves noisy and oscillating, but no figure of them survives and its checkpoint was not kept. Retrained with the unchanged June code, its curves are smooth: none has three or more peaks. The real difference is accuracy, on 400 held-out pixels per image: mean DEM error against BP 0.078 against the CNN's 0.047, W1 0.055 against 0.048 dex. It had even seen these pixels in training. It is the same architecture as today's production model, at width 256 with raw intensities.</a:t>
             </a:r>
           </a:p>
         </p:txBody>
@@ -1210,7 +1210,7 @@
           <a:lstStyle/>
           <a:p>
             <a:r>
-              <a:t>The shuffled-patch CNN applies a fixed random permutation to the 81 patch pixels. It was less sparse than the CNN on all 4 images, 1.88 against 1.70 on average, level with the centre-pixel MLP, so the spatial arrangement of the neighbours mattered. The flat-patch MLP was erratic across images: 1.61 on the X2.1 flare, 2.27 on quiet Sun. Capacity and setup were never fully separated: the 213k MLP took raw intensities, and at full scale a 176k MLP on log1p inputs is smooth.</a:t>
+              <a:t>The shuffled-patch CNN applies a fixed random permutation to the 81 patch pixels. It was less sparse than the CNN on all 4 images, 1.88 against 1.70 on average, level with the centre-pixel MLP, so the spatial arrangement of the neighbours mattered. The flat-patch MLP was erratic across images: 1.61 on the X2.1 flare, 2.27 on quiet Sun. The centre-pixel MLP was closest to BP on 3 of 4 images; the CNN on the X1.6 flare. So the CNN's lower sparsity did not mean DEMs closer to BP. Capacity and input scaling were not separated: the 213k MLP took raw intensities, and at full scale a 176k MLP on log1p inputs does well.</a:t>
             </a:r>
           </a:p>
         </p:txBody>
@@ -10084,7 +10084,7 @@
                   <a:srgbClr val="57068C"/>
                 </a:solidFill>
               </a:rPr>
-              <a:t>A per-pixel MLP drew noisy DEMs; a patch CNN fixed it</a:t>
+              <a:t>A per-pixel MLP missed BP's shape; a patch CNN tracked it</a:t>
             </a:r>
           </a:p>
         </p:txBody>
@@ -10122,7 +10122,7 @@
                   <a:srgbClr val="6B6B6B"/>
                 </a:solidFill>
               </a:rPr>
-              <a:t>4 images: X2.1 flare (2011-09-06), quiet Sun (2012-06-03), moderate activity (2013-11-13), X1.6 flare (2014-09-10); small crops near disk centre.</a:t>
+              <a:t>4 images: X2.1 flare (2011), quiet Sun (2012), moderate activity (2013), X1.6 flare (2014); small crops near disk centre.</a:t>
             </a:r>
           </a:p>
         </p:txBody>
@@ -10172,7 +10172,7 @@
                   <a:srgbClr val="333333"/>
                 </a:solidFill>
               </a:rPr>
-              <a:t>the 6 intensities of one pixel → MLP (213k params) → 54 weights, trained on the BP loss over ~221k pixels. The loss converged, but per-pixel curves oscillated.</a:t>
+              <a:t>the 6 intensities of one pixel → MLP (213k params) → 54 weights, trained on the BP loss over ~221k pixels. Smooth, single-peaked curves, but further from BP: DEM error 0.078 vs the CNN's 0.047.</a:t>
             </a:r>
           </a:p>
           <a:p>
@@ -10199,7 +10199,7 @@
                   <a:srgbClr val="333333"/>
                 </a:solidFill>
               </a:rPr>
-              <a:t>a 9×9 neighbourhood → CNN (~1.5M params) → 54 weights. Smooth, single-peaked curves at BP's temperatures, sparsity close to BP's on held-out pixels.</a:t>
+              <a:t>a 9×9 neighbourhood → CNN (~1.5M params) → 54 weights. Tracked BP's shape, with sparsity close to BP's on held-out pixels.</a:t>
             </a:r>
           </a:p>
           <a:p>
@@ -10225,7 +10225,7 @@
       </p:sp>
       <p:pic>
         <p:nvPicPr>
-          <p:cNvPr id="5" name="Picture 4" descr="patch_cnn.png"/>
+          <p:cNvPr id="5" name="Picture 4" descr="first_mlp_vs_cnn.png"/>
           <p:cNvPicPr>
             <a:picLocks noChangeAspect="1"/>
           </p:cNvPicPr>
@@ -10239,8 +10239,8 @@
         </p:blipFill>
         <p:spPr>
           <a:xfrm>
-            <a:off x="5723610" y="822960"/>
-            <a:ext cx="2817420" cy="3200400"/>
+            <a:off x="6042660" y="1188720"/>
+            <a:ext cx="2179320" cy="2971800"/>
           </a:xfrm>
           <a:prstGeom prst="rect">
             <a:avLst/>
@@ -10255,7 +10255,7 @@
         </p:nvSpPr>
         <p:spPr>
           <a:xfrm>
-            <a:off x="5486400" y="4069080"/>
+            <a:off x="5486400" y="4206240"/>
             <a:ext cx="3291840" cy="274320"/>
           </a:xfrm>
           <a:prstGeom prst="rect">
@@ -10280,7 +10280,7 @@
                   <a:srgbClr val="6B6B6B"/>
                 </a:solidFill>
               </a:rPr>
-              <a:t>Patch CNN (dotted) vs BP, X2.1 flare image.</a:t>
+              <a:t>Held-out pixels, X2.1 flare image.</a:t>
             </a:r>
           </a:p>
         </p:txBody>
@@ -10336,7 +10336,7 @@
                   <a:srgbClr val="57068C"/>
                 </a:solidFill>
               </a:rPr>
-              <a:t>Ablation: the noise was capacity, not missing context</a:t>
+              <a:t>Ablation: the gap was capacity, not missing context</a:t>
             </a:r>
           </a:p>
         </p:txBody>
@@ -11354,7 +11354,7 @@
                   <a:srgbClr val="333333"/>
                 </a:solidFill>
               </a:rPr>
-              <a:t>A centre-pixel MLP this size was smooth too: the first MLP's noise was not about the neighbourhood.</a:t>
+              <a:t>Size, not neighbours, closed the gap: DEM error vs BP 0.042 for the 1.43M centre-pixel MLP, 0.047 for the patch CNN, 0.078 for the first MLP.</a:t>
             </a:r>
           </a:p>
           <a:p>

</xml_diff>

<commit_message>
slides + results: rebuild on the final models (BP 1.43M, ENet 360k)
The patch CNN loses to the MLP at scale with fresh pixels. Bigger helps the
typical pixel, but ElasticNet models of 722k and up blow up on a few bright
pixels the sampled validation never saw, so ElasticNet uses 360k. Parts 5-8,
the summary and the model slide now use these models' numbers and redrawn
figures; the outline is synced.
</commit_message>
<xml_diff>
--- a/slides/DEM_deck_v2.pptx
+++ b/slides/DEM_deck_v2.pptx
@@ -324,8 +324,8 @@
           <a:lstStyle/>
           <a:p>
             <a:r>
-              <a:rPr sz="1200" b="1"/>
-              <a:t>BP multi-peak recall by model size</a:t>
+              <a:rPr sz="1150" b="1"/>
+              <a:t>BP median pixel error by model size (lower is better)</a:t>
             </a:r>
           </a:p>
         </c:rich>
@@ -347,7 +347,7 @@
               <c:strCache>
                 <c:ptCount val="1"/>
                 <c:pt idx="0">
-                  <c:v>Multi-peak recall (%)</c:v>
+                  <c:v>BP median pixel error</c:v>
                 </c:pt>
               </c:strCache>
             </c:strRef>
@@ -373,31 +373,28 @@
           </c:marker>
           <c:cat>
             <c:strRef>
-              <c:f>Sheet1!$A$2:$A$9</c:f>
+              <c:f>Sheet1!$A$2:$A$8</c:f>
               <c:strCache>
-                <c:ptCount val="8"/>
+                <c:ptCount val="7"/>
                 <c:pt idx="0">
-                  <c:v>10k</c:v>
+                  <c:v>20k</c:v>
                 </c:pt>
                 <c:pt idx="1">
-                  <c:v>20k</c:v>
+                  <c:v>42k</c:v>
                 </c:pt>
                 <c:pt idx="2">
-                  <c:v>42k</c:v>
+                  <c:v>87k</c:v>
                 </c:pt>
                 <c:pt idx="3">
-                  <c:v>87k</c:v>
+                  <c:v>176k</c:v>
                 </c:pt>
                 <c:pt idx="4">
-                  <c:v>176k</c:v>
+                  <c:v>360k</c:v>
                 </c:pt>
                 <c:pt idx="5">
-                  <c:v>360k</c:v>
+                  <c:v>722k</c:v>
                 </c:pt>
                 <c:pt idx="6">
-                  <c:v>722k</c:v>
-                </c:pt>
-                <c:pt idx="7">
                   <c:v>1.43M</c:v>
                 </c:pt>
               </c:strCache>
@@ -405,33 +402,30 @@
           </c:cat>
           <c:val>
             <c:numRef>
-              <c:f>Sheet1!$B$2:$B$9</c:f>
+              <c:f>Sheet1!$B$2:$B$8</c:f>
               <c:numCache>
                 <c:formatCode>General</c:formatCode>
-                <c:ptCount val="8"/>
+                <c:ptCount val="7"/>
                 <c:pt idx="0">
-                  <c:v>21.4</c:v>
+                  <c:v>0.068</c:v>
                 </c:pt>
                 <c:pt idx="1">
-                  <c:v>7.6</c:v>
+                  <c:v>0.047</c:v>
                 </c:pt>
                 <c:pt idx="2">
-                  <c:v>8.9</c:v>
+                  <c:v>0.043</c:v>
                 </c:pt>
                 <c:pt idx="3">
-                  <c:v>8.1</c:v>
+                  <c:v>0.03</c:v>
                 </c:pt>
                 <c:pt idx="4">
-                  <c:v>26.3</c:v>
+                  <c:v>0.026</c:v>
                 </c:pt>
                 <c:pt idx="5">
-                  <c:v>27.1</c:v>
+                  <c:v>0.025</c:v>
                 </c:pt>
                 <c:pt idx="6">
-                  <c:v>27.7</c:v>
-                </c:pt>
-                <c:pt idx="7">
-                  <c:v>29.5</c:v>
+                  <c:v>0.023</c:v>
                 </c:pt>
               </c:numCache>
             </c:numRef>
@@ -439,7 +433,7 @@
           <c:smooth val="0"/>
         </c:ser>
         <c:dLbls>
-          <c:numFmt formatCode="0&quot;%&quot;" sourceLinked="0"/>
+          <c:numFmt formatCode="0.000" sourceLinked="0"/>
           <c:txPr>
             <a:bodyPr/>
             <a:lstStyle/>
@@ -492,7 +486,7 @@
       <c:valAx>
         <c:axId val="2140495176"/>
         <c:scaling>
-          <c:max val="35.0"/>
+          <c:max val="0.08"/>
           <c:min val="0.0"/>
         </c:scaling>
         <c:delete val="0"/>
@@ -1286,7 +1280,7 @@
           <a:lstStyle/>
           <a:p>
             <a:r>
-              <a:t>The fourth independent look at CNN against MLP: the ablation, leave-one-out, the 30-epoch run, and converged at scale. None found a CNN advantage on unseen days.</a:t>
+              <a:t>Both ~1.5M parameters, fresh pixels, same 917 training days; scored on the 153 test days. The MLP is better on the training objective at every percentile and in every brightness decile on BP (median 0.98 vs 1.01, p99 17.9 vs 18.8, p99.9 51 vs 57). The CNN reconstructs BP's AIA slightly better. This is the fifth comparison; none found a CNN advantage on unseen days.</a:t>
             </a:r>
           </a:p>
         </p:txBody>
@@ -1344,7 +1338,7 @@
           <a:lstStyle/>
           <a:p>
             <a:r>
-              <a:t>Average metrics alone would have picked a much smaller model: AIA MAE kept improving as recall collapsed. The 10k model fires at about the base rate, which is guessing, not detection. An earlier run up to 11M parameters found no further gain.</a:t>
+              <a:t>Fresh-pixel sweep, every width scored on the full test set (results/plots/17_sweep_resample). 10k collapsed (validation loss 61) and is left off the chart. BP validation loss: 2.155 at 1.43M, 2.148 at 360k (a tie within run-to-run noise), 2.237 at 176k. ElasticNet validation is best at 1.43M (0.0528), but its 722k and 1.43M models predict a few bright pixels orders of magnitude too bright: AIA MSE 41,849 and 908,611 against 650 at 360k. Validation scores a fixed sample of 512 pixels per block and never saw them. Multi-peak recall is 22-26% from 42k up; the fixed-sample sweep's cliff below 176k does not reproduce.</a:t>
             </a:r>
           </a:p>
         </p:txBody>
@@ -1402,7 +1396,7 @@
           <a:lstStyle/>
           <a:p>
             <a:r>
-              <a:t>Label-free trains on the observation through R; supervised trains on solver DEMs. So supervised wins the DEM-against-solver metric, and label-free wins reconstruction of the observation on most counts. EM error is the total-emission error; W1 is in dex.</a:t>
+              <a:t>Label-free trains on the observation through R; supervised trains on solver DEMs. Supervised wins the DEM-against-solver metric on both tracks. On ElasticNet we win total-emission error, W1 and AIA MAE (10 times lower); on BP we win W1 only, and the BP DEM MSE is set by flare cores (Part 7). EM error is the total-emission error; W1 is in dex.</a:t>
             </a:r>
           </a:p>
         </p:txBody>
@@ -1460,7 +1454,7 @@
           <a:lstStyle/>
           <a:p>
             <a:r>
-              <a:t>Per-pixel error is the squared error summed over the 18 bins. BP percentiles, label-free against supervised: median 0.030 vs 0.112, p90 5.1 vs 2.0, p99 117 vs 27.</a:t>
+              <a:t>Per-pixel error is the squared error summed over the 18 bins. BP percentiles, label-free against supervised: median 0.023 vs 0.112, p90 3.4 vs 2.0, p99 68 vs 27. ElasticNet: median 1.07 vs 1.12, p99 35.5 vs 35.5, p99.9 155 vs 178.</a:t>
             </a:r>
           </a:p>
         </p:txBody>
@@ -1518,7 +1512,7 @@
           <a:lstStyle/>
           <a:p>
             <a:r>
-              <a:t>Peaks are counted on the zero-padded curve with prominence 0.15 times the maximum, over the full test set. The fixed-sample model had the same recall (25%) at lower precision (46%).</a:t>
+              <a:t>Peaks are counted on the zero-padded curve with prominence 0.15 times the maximum, over the full test set. Self-consistency: 80 multi-peaked bright pixels, 30 BP re-solves each under photon noise; our deviation from BP is 0.96 times BP's own re-solve scatter (0.68 at single-peaked pixels). On ElasticNet both models find ~85% of multi-peaked pixels.</a:t>
             </a:r>
           </a:p>
         </p:txBody>
@@ -1576,7 +1570,7 @@
           <a:lstStyle/>
           <a:p>
             <a:r>
-              <a:t>ElasticNet flare cores are milder: 73% of the solver's emission, 40% multi-peaked. The fixed-sample BP model was less extreme, at 41% of the emission.</a:t>
+              <a:t>ElasticNet flare cores are close to the solver: 88% of its emission, peak 79% as high, and 20% multi-peaked against the solver's 21%.</a:t>
             </a:r>
           </a:p>
         </p:txBody>
@@ -1634,7 +1628,7 @@
           <a:lstStyle/>
           <a:p>
             <a:r>
-              <a:t>The supervised model's sqrt plus Fourier-feature input made flare cores worse, consistent with a training problem rather than an input-representation one.</a:t>
+              <a:t>On ElasticNet our flare-core reconstruction matches the solver's (94 A: 0.41 vs 0.55; cool channels 1.00 vs 0.98) and beats the supervised model's (0.70 to 0.76 on the cool channels). The supervised model's sqrt plus Fourier input made BP flare cores worse, consistent with a training problem rather than an input-representation one.</a:t>
             </a:r>
           </a:p>
         </p:txBody>
@@ -1692,7 +1686,7 @@
           <a:lstStyle/>
           <a:p>
             <a:r>
-              <a:t>The four things to remember. Numbers are from the fresh-pixel models on the shared test set: 153 days never seen in training.</a:t>
+              <a:t>The four things to remember. Numbers are from the final models (BP 1.43M, ElasticNet 360k, fresh pixels) on the shared test set: 153 days never seen in training.</a:t>
             </a:r>
           </a:p>
         </p:txBody>
@@ -1808,7 +1802,7 @@
           <a:lstStyle/>
           <a:p>
             <a:r>
-              <a:t>The solvers never solve for the 18 bins directly: both solve for weights on a fixed basis, a spike and two Gaussians at each bin, and report DEM = B times x. We predict the same weights, so the network searches the same space of DEMs the solver does, and BP's sparsity criterion means the same thing for both. Only the MLP is learned. Per pixel: six log-intensities in, four hidden layers of 232 with SiLU, 54 non-negative basis weights out; DEM = B times w over 18 bins, logT 5.5 to 7.2; predicted AIA = R times DEM. 176k parameters, one forward pass per pixel.</a:t>
+              <a:t>The solvers never solve for the 18 bins directly: both solve for weights on a fixed basis, a spike and two Gaussians at each bin, and report DEM = B times x. We predict the same weights, so the network searches the same space of DEMs the solver does, and BP's sparsity criterion means the same thing for both. Only the MLP is learned. Per pixel: six log-intensities in, four hidden layers with SiLU (680 wide for BP, 336 for ElasticNet), 54 non-negative basis weights out; DEM = B times w over 18 bins, logT 5.5 to 7.2; predicted AIA = R times DEM. One forward pass per pixel.</a:t>
             </a:r>
           </a:p>
         </p:txBody>
@@ -2098,7 +2092,7 @@
           <a:lstStyle/>
           <a:p>
             <a:r>
-              <a:t>The shuffled-patch CNN applies a fixed random permutation to the 81 patch pixels. It was less sparse than the CNN on all 4 images, 1.88 against 1.70 on average, level with the centre-pixel MLP, so the spatial arrangement of the neighbours mattered. The flat-patch MLP was erratic across images: 1.61 on the X2.1 flare, 2.27 on quiet Sun. The centre-pixel MLP was closest to BP on 3 of 4 images; the CNN on the X1.6 flare. So the CNN's lower sparsity did not mean DEMs closer to BP. Capacity and input scaling were not separated: the 213k MLP took raw intensities, and at full scale a 176k MLP on log1p inputs does well.</a:t>
+              <a:t>The shuffled-patch CNN applies a fixed random permutation to the 81 patch pixels. It was less sparse than the CNN on all 4 images, 1.88 against 1.70 on average, level with the centre-pixel MLP, so the spatial arrangement of the neighbours mattered. The flat-patch MLP was erratic across images: 1.61 on the X2.1 flare, 2.27 on quiet Sun. The centre-pixel MLP was closest to BP on 3 of 4 images; the CNN on the X1.6 flare. So the CNN's lower sparsity did not mean DEMs closer to BP. Capacity and input scaling were not separated: the 213k MLP took raw intensities, and at full scale MLPs on log1p inputs does well.</a:t>
             </a:r>
           </a:p>
         </p:txBody>
@@ -25142,7 +25136,7 @@
                   <a:srgbClr val="57068C"/>
                 </a:solidFill>
               </a:rPr>
-              <a:t>At scale, the centre-pixel MLP matched the patch CNN</a:t>
+              <a:t>At scale, the centre-pixel MLP beat the patch CNN</a:t>
             </a:r>
           </a:p>
         </p:txBody>
@@ -25184,7 +25178,7 @@
                   <a:srgbClr val="333333"/>
                 </a:solidFill>
               </a:rPr>
-              <a:t>Same 917 training days and losses, ~1.5M parameters each; scored on the 153 test days.</a:t>
+              <a:t>Same 917 training days and losses, ~1.5M parameters each, fresh pixels; scored on the 153 test days.</a:t>
             </a:r>
           </a:p>
         </p:txBody>
@@ -25199,18 +25193,18 @@
         </p:nvGraphicFramePr>
         <p:xfrm>
           <a:off x="365760" y="1417320"/>
-          <a:ext cx="8412480" cy="1316736"/>
+          <a:ext cx="8412477" cy="1645920"/>
         </p:xfrm>
         <a:graphic>
           <a:graphicData uri="http://schemas.openxmlformats.org/drawingml/2006/table">
             <a:tbl>
               <a:tblPr firstRow="1" bandRow="1"/>
               <a:tblGrid>
-                <a:gridCol w="2804160"/>
-                <a:gridCol w="1402080"/>
-                <a:gridCol w="1402080"/>
-                <a:gridCol w="1402080"/>
-                <a:gridCol w="1402080"/>
+                <a:gridCol w="2877953"/>
+                <a:gridCol w="1438976"/>
+                <a:gridCol w="1438976"/>
+                <a:gridCol w="1328286"/>
+                <a:gridCol w="1328286"/>
               </a:tblGrid>
               <a:tr h="329184">
                 <a:tc>
@@ -25407,6 +25401,370 @@
                             <a:srgbClr val="333333"/>
                           </a:solidFill>
                         </a:rPr>
+                        <a:t>Training objective (test)</a:t>
+                      </a:r>
+                    </a:p>
+                  </a:txBody>
+                  <a:tcPr marL="54864" marR="54864" marT="27432" marB="27432" anchor="ctr">
+                    <a:lnL w="0">
+                      <a:noFill/>
+                    </a:lnL>
+                    <a:lnR w="0">
+                      <a:noFill/>
+                    </a:lnR>
+                    <a:lnT w="0">
+                      <a:noFill/>
+                    </a:lnT>
+                    <a:lnB w="6350">
+                      <a:solidFill>
+                        <a:srgbClr val="D9D3E3"/>
+                      </a:solidFill>
+                    </a:lnB>
+                    <a:solidFill>
+                      <a:srgbClr val="FFFFFF"/>
+                    </a:solidFill>
+                  </a:tcPr>
+                </a:tc>
+                <a:tc>
+                  <a:txBody>
+                    <a:bodyPr wrap="square"/>
+                    <a:lstStyle/>
+                    <a:p>
+                      <a:pPr algn="r"/>
+                      <a:r>
+                        <a:rPr sz="1150" b="1">
+                          <a:solidFill>
+                            <a:srgbClr val="333333"/>
+                          </a:solidFill>
+                        </a:rPr>
+                        <a:t>2.07</a:t>
+                      </a:r>
+                    </a:p>
+                  </a:txBody>
+                  <a:tcPr marL="54864" marR="54864" marT="27432" marB="27432" anchor="ctr">
+                    <a:lnL w="0">
+                      <a:noFill/>
+                    </a:lnL>
+                    <a:lnR w="0">
+                      <a:noFill/>
+                    </a:lnR>
+                    <a:lnT w="0">
+                      <a:noFill/>
+                    </a:lnT>
+                    <a:lnB w="6350">
+                      <a:solidFill>
+                        <a:srgbClr val="D9D3E3"/>
+                      </a:solidFill>
+                    </a:lnB>
+                    <a:solidFill>
+                      <a:srgbClr val="FFFFFF"/>
+                    </a:solidFill>
+                  </a:tcPr>
+                </a:tc>
+                <a:tc>
+                  <a:txBody>
+                    <a:bodyPr wrap="square"/>
+                    <a:lstStyle/>
+                    <a:p>
+                      <a:pPr algn="r"/>
+                      <a:r>
+                        <a:rPr sz="1150" b="0">
+                          <a:solidFill>
+                            <a:srgbClr val="333333"/>
+                          </a:solidFill>
+                        </a:rPr>
+                        <a:t>2.24</a:t>
+                      </a:r>
+                    </a:p>
+                  </a:txBody>
+                  <a:tcPr marL="54864" marR="54864" marT="27432" marB="27432" anchor="ctr">
+                    <a:lnL w="0">
+                      <a:noFill/>
+                    </a:lnL>
+                    <a:lnR w="0">
+                      <a:noFill/>
+                    </a:lnR>
+                    <a:lnT w="0">
+                      <a:noFill/>
+                    </a:lnT>
+                    <a:lnB w="6350">
+                      <a:solidFill>
+                        <a:srgbClr val="D9D3E3"/>
+                      </a:solidFill>
+                    </a:lnB>
+                    <a:solidFill>
+                      <a:srgbClr val="FFFFFF"/>
+                    </a:solidFill>
+                  </a:tcPr>
+                </a:tc>
+                <a:tc>
+                  <a:txBody>
+                    <a:bodyPr wrap="square"/>
+                    <a:lstStyle/>
+                    <a:p>
+                      <a:pPr algn="r"/>
+                      <a:r>
+                        <a:rPr sz="1150" b="1">
+                          <a:solidFill>
+                            <a:srgbClr val="333333"/>
+                          </a:solidFill>
+                        </a:rPr>
+                        <a:t>0.057</a:t>
+                      </a:r>
+                    </a:p>
+                  </a:txBody>
+                  <a:tcPr marL="54864" marR="54864" marT="27432" marB="27432" anchor="ctr">
+                    <a:lnL w="0">
+                      <a:noFill/>
+                    </a:lnL>
+                    <a:lnR w="0">
+                      <a:noFill/>
+                    </a:lnR>
+                    <a:lnT w="0">
+                      <a:noFill/>
+                    </a:lnT>
+                    <a:lnB w="6350">
+                      <a:solidFill>
+                        <a:srgbClr val="D9D3E3"/>
+                      </a:solidFill>
+                    </a:lnB>
+                    <a:solidFill>
+                      <a:srgbClr val="FFFFFF"/>
+                    </a:solidFill>
+                  </a:tcPr>
+                </a:tc>
+                <a:tc>
+                  <a:txBody>
+                    <a:bodyPr wrap="square"/>
+                    <a:lstStyle/>
+                    <a:p>
+                      <a:pPr algn="r"/>
+                      <a:r>
+                        <a:rPr sz="1150" b="0">
+                          <a:solidFill>
+                            <a:srgbClr val="333333"/>
+                          </a:solidFill>
+                        </a:rPr>
+                        <a:t>0.245</a:t>
+                      </a:r>
+                    </a:p>
+                  </a:txBody>
+                  <a:tcPr marL="54864" marR="54864" marT="27432" marB="27432" anchor="ctr">
+                    <a:lnL w="0">
+                      <a:noFill/>
+                    </a:lnL>
+                    <a:lnR w="0">
+                      <a:noFill/>
+                    </a:lnR>
+                    <a:lnT w="0">
+                      <a:noFill/>
+                    </a:lnT>
+                    <a:lnB w="6350">
+                      <a:solidFill>
+                        <a:srgbClr val="D9D3E3"/>
+                      </a:solidFill>
+                    </a:lnB>
+                    <a:solidFill>
+                      <a:srgbClr val="FFFFFF"/>
+                    </a:solidFill>
+                  </a:tcPr>
+                </a:tc>
+              </a:tr>
+              <a:tr h="329184">
+                <a:tc>
+                  <a:txBody>
+                    <a:bodyPr wrap="square"/>
+                    <a:lstStyle/>
+                    <a:p>
+                      <a:pPr algn="l"/>
+                      <a:r>
+                        <a:rPr sz="1150" b="0">
+                          <a:solidFill>
+                            <a:srgbClr val="333333"/>
+                          </a:solidFill>
+                        </a:rPr>
+                        <a:t>BP objective: median / p99</a:t>
+                      </a:r>
+                    </a:p>
+                  </a:txBody>
+                  <a:tcPr marL="54864" marR="54864" marT="27432" marB="27432" anchor="ctr">
+                    <a:lnL w="0">
+                      <a:noFill/>
+                    </a:lnL>
+                    <a:lnR w="0">
+                      <a:noFill/>
+                    </a:lnR>
+                    <a:lnT w="0">
+                      <a:noFill/>
+                    </a:lnT>
+                    <a:lnB w="6350">
+                      <a:solidFill>
+                        <a:srgbClr val="D9D3E3"/>
+                      </a:solidFill>
+                    </a:lnB>
+                    <a:solidFill>
+                      <a:srgbClr val="FFFFFF"/>
+                    </a:solidFill>
+                  </a:tcPr>
+                </a:tc>
+                <a:tc>
+                  <a:txBody>
+                    <a:bodyPr wrap="square"/>
+                    <a:lstStyle/>
+                    <a:p>
+                      <a:pPr algn="r"/>
+                      <a:r>
+                        <a:rPr sz="1150" b="1">
+                          <a:solidFill>
+                            <a:srgbClr val="333333"/>
+                          </a:solidFill>
+                        </a:rPr>
+                        <a:t>0.98 / 17.9</a:t>
+                      </a:r>
+                    </a:p>
+                  </a:txBody>
+                  <a:tcPr marL="54864" marR="54864" marT="27432" marB="27432" anchor="ctr">
+                    <a:lnL w="0">
+                      <a:noFill/>
+                    </a:lnL>
+                    <a:lnR w="0">
+                      <a:noFill/>
+                    </a:lnR>
+                    <a:lnT w="0">
+                      <a:noFill/>
+                    </a:lnT>
+                    <a:lnB w="6350">
+                      <a:solidFill>
+                        <a:srgbClr val="D9D3E3"/>
+                      </a:solidFill>
+                    </a:lnB>
+                    <a:solidFill>
+                      <a:srgbClr val="FFFFFF"/>
+                    </a:solidFill>
+                  </a:tcPr>
+                </a:tc>
+                <a:tc>
+                  <a:txBody>
+                    <a:bodyPr wrap="square"/>
+                    <a:lstStyle/>
+                    <a:p>
+                      <a:pPr algn="r"/>
+                      <a:r>
+                        <a:rPr sz="1150" b="0">
+                          <a:solidFill>
+                            <a:srgbClr val="333333"/>
+                          </a:solidFill>
+                        </a:rPr>
+                        <a:t>1.01 / 18.8</a:t>
+                      </a:r>
+                    </a:p>
+                  </a:txBody>
+                  <a:tcPr marL="54864" marR="54864" marT="27432" marB="27432" anchor="ctr">
+                    <a:lnL w="0">
+                      <a:noFill/>
+                    </a:lnL>
+                    <a:lnR w="0">
+                      <a:noFill/>
+                    </a:lnR>
+                    <a:lnT w="0">
+                      <a:noFill/>
+                    </a:lnT>
+                    <a:lnB w="6350">
+                      <a:solidFill>
+                        <a:srgbClr val="D9D3E3"/>
+                      </a:solidFill>
+                    </a:lnB>
+                    <a:solidFill>
+                      <a:srgbClr val="FFFFFF"/>
+                    </a:solidFill>
+                  </a:tcPr>
+                </a:tc>
+                <a:tc>
+                  <a:txBody>
+                    <a:bodyPr wrap="square"/>
+                    <a:lstStyle/>
+                    <a:p>
+                      <a:pPr algn="r"/>
+                      <a:r>
+                        <a:rPr sz="1150" b="0">
+                          <a:solidFill>
+                            <a:srgbClr val="333333"/>
+                          </a:solidFill>
+                        </a:rPr>
+                        <a:t/>
+                      </a:r>
+                    </a:p>
+                  </a:txBody>
+                  <a:tcPr marL="54864" marR="54864" marT="27432" marB="27432" anchor="ctr">
+                    <a:lnL w="0">
+                      <a:noFill/>
+                    </a:lnL>
+                    <a:lnR w="0">
+                      <a:noFill/>
+                    </a:lnR>
+                    <a:lnT w="0">
+                      <a:noFill/>
+                    </a:lnT>
+                    <a:lnB w="6350">
+                      <a:solidFill>
+                        <a:srgbClr val="D9D3E3"/>
+                      </a:solidFill>
+                    </a:lnB>
+                    <a:solidFill>
+                      <a:srgbClr val="FFFFFF"/>
+                    </a:solidFill>
+                  </a:tcPr>
+                </a:tc>
+                <a:tc>
+                  <a:txBody>
+                    <a:bodyPr wrap="square"/>
+                    <a:lstStyle/>
+                    <a:p>
+                      <a:pPr algn="r"/>
+                      <a:r>
+                        <a:rPr sz="1150" b="0">
+                          <a:solidFill>
+                            <a:srgbClr val="333333"/>
+                          </a:solidFill>
+                        </a:rPr>
+                        <a:t/>
+                      </a:r>
+                    </a:p>
+                  </a:txBody>
+                  <a:tcPr marL="54864" marR="54864" marT="27432" marB="27432" anchor="ctr">
+                    <a:lnL w="0">
+                      <a:noFill/>
+                    </a:lnL>
+                    <a:lnR w="0">
+                      <a:noFill/>
+                    </a:lnR>
+                    <a:lnT w="0">
+                      <a:noFill/>
+                    </a:lnT>
+                    <a:lnB w="6350">
+                      <a:solidFill>
+                        <a:srgbClr val="D9D3E3"/>
+                      </a:solidFill>
+                    </a:lnB>
+                    <a:solidFill>
+                      <a:srgbClr val="FFFFFF"/>
+                    </a:solidFill>
+                  </a:tcPr>
+                </a:tc>
+              </a:tr>
+              <a:tr h="329184">
+                <a:tc>
+                  <a:txBody>
+                    <a:bodyPr wrap="square"/>
+                    <a:lstStyle/>
+                    <a:p>
+                      <a:pPr algn="l"/>
+                      <a:r>
+                        <a:rPr sz="1150" b="0">
+                          <a:solidFill>
+                            <a:srgbClr val="333333"/>
+                          </a:solidFill>
+                        </a:rPr>
                         <a:t>Sparsity (BP 1.79)</a:t>
                       </a:r>
                     </a:p>
@@ -25438,7 +25796,7 @@
                     <a:p>
                       <a:pPr algn="r"/>
                       <a:r>
-                        <a:rPr sz="1150" b="0">
+                        <a:rPr sz="1150" b="1">
                           <a:solidFill>
                             <a:srgbClr val="333333"/>
                           </a:solidFill>
@@ -25479,7 +25837,7 @@
                             <a:srgbClr val="333333"/>
                           </a:solidFill>
                         </a:rPr>
-                        <a:t>1.96</a:t>
+                        <a:t>2.03</a:t>
                       </a:r>
                     </a:p>
                   </a:txBody>
@@ -25515,7 +25873,7 @@
                             <a:srgbClr val="333333"/>
                           </a:solidFill>
                         </a:rPr>
-                        <a:t>3.68</a:t>
+                        <a:t>5.53</a:t>
                       </a:r>
                     </a:p>
                   </a:txBody>
@@ -25551,189 +25909,7 @@
                             <a:srgbClr val="333333"/>
                           </a:solidFill>
                         </a:rPr>
-                        <a:t>3.61</a:t>
-                      </a:r>
-                    </a:p>
-                  </a:txBody>
-                  <a:tcPr marL="54864" marR="54864" marT="27432" marB="27432" anchor="ctr">
-                    <a:lnL w="0">
-                      <a:noFill/>
-                    </a:lnL>
-                    <a:lnR w="0">
-                      <a:noFill/>
-                    </a:lnR>
-                    <a:lnT w="0">
-                      <a:noFill/>
-                    </a:lnT>
-                    <a:lnB w="6350">
-                      <a:solidFill>
-                        <a:srgbClr val="D9D3E3"/>
-                      </a:solidFill>
-                    </a:lnB>
-                    <a:solidFill>
-                      <a:srgbClr val="FFFFFF"/>
-                    </a:solidFill>
-                  </a:tcPr>
-                </a:tc>
-              </a:tr>
-              <a:tr h="329184">
-                <a:tc>
-                  <a:txBody>
-                    <a:bodyPr wrap="square"/>
-                    <a:lstStyle/>
-                    <a:p>
-                      <a:pPr algn="l"/>
-                      <a:r>
-                        <a:rPr sz="1150" b="0">
-                          <a:solidFill>
-                            <a:srgbClr val="333333"/>
-                          </a:solidFill>
-                        </a:rPr>
-                        <a:t>Training objective (val)</a:t>
-                      </a:r>
-                    </a:p>
-                  </a:txBody>
-                  <a:tcPr marL="54864" marR="54864" marT="27432" marB="27432" anchor="ctr">
-                    <a:lnL w="0">
-                      <a:noFill/>
-                    </a:lnL>
-                    <a:lnR w="0">
-                      <a:noFill/>
-                    </a:lnR>
-                    <a:lnT w="0">
-                      <a:noFill/>
-                    </a:lnT>
-                    <a:lnB w="6350">
-                      <a:solidFill>
-                        <a:srgbClr val="D9D3E3"/>
-                      </a:solidFill>
-                    </a:lnB>
-                    <a:solidFill>
-                      <a:srgbClr val="FFFFFF"/>
-                    </a:solidFill>
-                  </a:tcPr>
-                </a:tc>
-                <a:tc>
-                  <a:txBody>
-                    <a:bodyPr wrap="square"/>
-                    <a:lstStyle/>
-                    <a:p>
-                      <a:pPr algn="r"/>
-                      <a:r>
-                        <a:rPr sz="1150" b="0">
-                          <a:solidFill>
-                            <a:srgbClr val="333333"/>
-                          </a:solidFill>
-                        </a:rPr>
-                        <a:t>2.145</a:t>
-                      </a:r>
-                    </a:p>
-                  </a:txBody>
-                  <a:tcPr marL="54864" marR="54864" marT="27432" marB="27432" anchor="ctr">
-                    <a:lnL w="0">
-                      <a:noFill/>
-                    </a:lnL>
-                    <a:lnR w="0">
-                      <a:noFill/>
-                    </a:lnR>
-                    <a:lnT w="0">
-                      <a:noFill/>
-                    </a:lnT>
-                    <a:lnB w="6350">
-                      <a:solidFill>
-                        <a:srgbClr val="D9D3E3"/>
-                      </a:solidFill>
-                    </a:lnB>
-                    <a:solidFill>
-                      <a:srgbClr val="FFFFFF"/>
-                    </a:solidFill>
-                  </a:tcPr>
-                </a:tc>
-                <a:tc>
-                  <a:txBody>
-                    <a:bodyPr wrap="square"/>
-                    <a:lstStyle/>
-                    <a:p>
-                      <a:pPr algn="r"/>
-                      <a:r>
-                        <a:rPr sz="1150" b="0">
-                          <a:solidFill>
-                            <a:srgbClr val="333333"/>
-                          </a:solidFill>
-                        </a:rPr>
-                        <a:t>2.241</a:t>
-                      </a:r>
-                    </a:p>
-                  </a:txBody>
-                  <a:tcPr marL="54864" marR="54864" marT="27432" marB="27432" anchor="ctr">
-                    <a:lnL w="0">
-                      <a:noFill/>
-                    </a:lnL>
-                    <a:lnR w="0">
-                      <a:noFill/>
-                    </a:lnR>
-                    <a:lnT w="0">
-                      <a:noFill/>
-                    </a:lnT>
-                    <a:lnB w="6350">
-                      <a:solidFill>
-                        <a:srgbClr val="D9D3E3"/>
-                      </a:solidFill>
-                    </a:lnB>
-                    <a:solidFill>
-                      <a:srgbClr val="FFFFFF"/>
-                    </a:solidFill>
-                  </a:tcPr>
-                </a:tc>
-                <a:tc>
-                  <a:txBody>
-                    <a:bodyPr wrap="square"/>
-                    <a:lstStyle/>
-                    <a:p>
-                      <a:pPr algn="r"/>
-                      <a:r>
-                        <a:rPr sz="1150" b="0">
-                          <a:solidFill>
-                            <a:srgbClr val="333333"/>
-                          </a:solidFill>
-                        </a:rPr>
-                        <a:t>1.850</a:t>
-                      </a:r>
-                    </a:p>
-                  </a:txBody>
-                  <a:tcPr marL="54864" marR="54864" marT="27432" marB="27432" anchor="ctr">
-                    <a:lnL w="0">
-                      <a:noFill/>
-                    </a:lnL>
-                    <a:lnR w="0">
-                      <a:noFill/>
-                    </a:lnR>
-                    <a:lnT w="0">
-                      <a:noFill/>
-                    </a:lnT>
-                    <a:lnB w="6350">
-                      <a:solidFill>
-                        <a:srgbClr val="D9D3E3"/>
-                      </a:solidFill>
-                    </a:lnB>
-                    <a:solidFill>
-                      <a:srgbClr val="FFFFFF"/>
-                    </a:solidFill>
-                  </a:tcPr>
-                </a:tc>
-                <a:tc>
-                  <a:txBody>
-                    <a:bodyPr wrap="square"/>
-                    <a:lstStyle/>
-                    <a:p>
-                      <a:pPr algn="r"/>
-                      <a:r>
-                        <a:rPr sz="1150" b="0">
-                          <a:solidFill>
-                            <a:srgbClr val="333333"/>
-                          </a:solidFill>
-                        </a:rPr>
-                        <a:t>1.858</a:t>
+                        <a:t>5.17</a:t>
                       </a:r>
                     </a:p>
                   </a:txBody>
@@ -25807,7 +25983,79 @@
                             <a:srgbClr val="333333"/>
                           </a:solidFill>
                         </a:rPr>
-                        <a:t>4.88</a:t>
+                        <a:t>4.93</a:t>
+                      </a:r>
+                    </a:p>
+                  </a:txBody>
+                  <a:tcPr marL="54864" marR="54864" marT="27432" marB="27432" anchor="ctr">
+                    <a:lnL w="0">
+                      <a:noFill/>
+                    </a:lnL>
+                    <a:lnR w="0">
+                      <a:noFill/>
+                    </a:lnR>
+                    <a:lnT w="0">
+                      <a:noFill/>
+                    </a:lnT>
+                    <a:lnB w="6350">
+                      <a:solidFill>
+                        <a:srgbClr val="D9D3E3"/>
+                      </a:solidFill>
+                    </a:lnB>
+                    <a:solidFill>
+                      <a:srgbClr val="FFFFFF"/>
+                    </a:solidFill>
+                  </a:tcPr>
+                </a:tc>
+                <a:tc>
+                  <a:txBody>
+                    <a:bodyPr wrap="square"/>
+                    <a:lstStyle/>
+                    <a:p>
+                      <a:pPr algn="r"/>
+                      <a:r>
+                        <a:rPr sz="1150" b="1">
+                          <a:solidFill>
+                            <a:srgbClr val="333333"/>
+                          </a:solidFill>
+                        </a:rPr>
+                        <a:t>4.73</a:t>
+                      </a:r>
+                    </a:p>
+                  </a:txBody>
+                  <a:tcPr marL="54864" marR="54864" marT="27432" marB="27432" anchor="ctr">
+                    <a:lnL w="0">
+                      <a:noFill/>
+                    </a:lnL>
+                    <a:lnR w="0">
+                      <a:noFill/>
+                    </a:lnR>
+                    <a:lnT w="0">
+                      <a:noFill/>
+                    </a:lnT>
+                    <a:lnB w="6350">
+                      <a:solidFill>
+                        <a:srgbClr val="D9D3E3"/>
+                      </a:solidFill>
+                    </a:lnB>
+                    <a:solidFill>
+                      <a:srgbClr val="FFFFFF"/>
+                    </a:solidFill>
+                  </a:tcPr>
+                </a:tc>
+                <a:tc>
+                  <a:txBody>
+                    <a:bodyPr wrap="square"/>
+                    <a:lstStyle/>
+                    <a:p>
+                      <a:pPr algn="r"/>
+                      <a:r>
+                        <a:rPr sz="1150" b="1">
+                          <a:solidFill>
+                            <a:srgbClr val="333333"/>
+                          </a:solidFill>
+                        </a:rPr>
+                        <a:t>0.54</a:t>
                       </a:r>
                     </a:p>
                   </a:txBody>
@@ -25843,79 +26091,7 @@
                             <a:srgbClr val="333333"/>
                           </a:solidFill>
                         </a:rPr>
-                        <a:t>4.84</a:t>
-                      </a:r>
-                    </a:p>
-                  </a:txBody>
-                  <a:tcPr marL="54864" marR="54864" marT="27432" marB="27432" anchor="ctr">
-                    <a:lnL w="0">
-                      <a:noFill/>
-                    </a:lnL>
-                    <a:lnR w="0">
-                      <a:noFill/>
-                    </a:lnR>
-                    <a:lnT w="0">
-                      <a:noFill/>
-                    </a:lnT>
-                    <a:lnB w="6350">
-                      <a:solidFill>
-                        <a:srgbClr val="D9D3E3"/>
-                      </a:solidFill>
-                    </a:lnB>
-                    <a:solidFill>
-                      <a:srgbClr val="FFFFFF"/>
-                    </a:solidFill>
-                  </a:tcPr>
-                </a:tc>
-                <a:tc>
-                  <a:txBody>
-                    <a:bodyPr wrap="square"/>
-                    <a:lstStyle/>
-                    <a:p>
-                      <a:pPr algn="r"/>
-                      <a:r>
-                        <a:rPr sz="1150" b="0">
-                          <a:solidFill>
-                            <a:srgbClr val="333333"/>
-                          </a:solidFill>
-                        </a:rPr>
-                        <a:t>4.61</a:t>
-                      </a:r>
-                    </a:p>
-                  </a:txBody>
-                  <a:tcPr marL="54864" marR="54864" marT="27432" marB="27432" anchor="ctr">
-                    <a:lnL w="0">
-                      <a:noFill/>
-                    </a:lnL>
-                    <a:lnR w="0">
-                      <a:noFill/>
-                    </a:lnR>
-                    <a:lnT w="0">
-                      <a:noFill/>
-                    </a:lnT>
-                    <a:lnB w="6350">
-                      <a:solidFill>
-                        <a:srgbClr val="D9D3E3"/>
-                      </a:solidFill>
-                    </a:lnB>
-                    <a:solidFill>
-                      <a:srgbClr val="FFFFFF"/>
-                    </a:solidFill>
-                  </a:tcPr>
-                </a:tc>
-                <a:tc>
-                  <a:txBody>
-                    <a:bodyPr wrap="square"/>
-                    <a:lstStyle/>
-                    <a:p>
-                      <a:pPr algn="r"/>
-                      <a:r>
-                        <a:rPr sz="1150" b="0">
-                          <a:solidFill>
-                            <a:srgbClr val="333333"/>
-                          </a:solidFill>
-                        </a:rPr>
-                        <a:t>4.75</a:t>
+                        <a:t>0.82</a:t>
                       </a:r>
                     </a:p>
                   </a:txBody>
@@ -25952,7 +26128,7 @@
         </p:nvSpPr>
         <p:spPr>
           <a:xfrm>
-            <a:off x="365760" y="2880360"/>
+            <a:off x="365760" y="3246120"/>
             <a:ext cx="8412480" cy="365760"/>
           </a:xfrm>
           <a:prstGeom prst="rect">
@@ -25978,44 +26154,6 @@
                 </a:solidFill>
               </a:rPr>
               <a:t>The simplest model scales: no neighbourhood needed.</a:t>
-            </a:r>
-          </a:p>
-        </p:txBody>
-      </p:sp>
-      <p:sp>
-        <p:nvSpPr>
-          <p:cNvPr id="6" name="TextBox 5"/>
-          <p:cNvSpPr txBox="1"/>
-          <p:nvPr/>
-        </p:nvSpPr>
-        <p:spPr>
-          <a:xfrm>
-            <a:off x="365760" y="3291840"/>
-            <a:ext cx="8412480" cy="274320"/>
-          </a:xfrm>
-          <a:prstGeom prst="rect">
-            <a:avLst/>
-          </a:prstGeom>
-          <a:noFill/>
-        </p:spPr>
-        <p:txBody>
-          <a:bodyPr wrap="square" anchor="t" lIns="0" rIns="0" tIns="0" bIns="0">
-            <a:spAutoFit/>
-          </a:bodyPr>
-          <a:lstStyle/>
-          <a:p>
-            <a:pPr algn="l">
-              <a:spcAft>
-                <a:spcPts val="600"/>
-              </a:spcAft>
-            </a:pPr>
-            <a:r>
-              <a:rPr sz="1000" b="0" i="1">
-                <a:solidFill>
-                  <a:srgbClr val="6B6B6B"/>
-                </a:solidFill>
-              </a:rPr>
-              <a:t>Shown: earlier fixed-sample runs (ENet then used α = 1). The fresh-pixel rerun replaces them.</a:t>
             </a:r>
           </a:p>
         </p:txBody>
@@ -26071,7 +26209,7 @@
                   <a:srgbClr val="57068C"/>
                 </a:solidFill>
               </a:rPr>
-              <a:t>176k parameters are enough</a:t>
+              <a:t>Bigger helps, until ElasticNet turns unstable</a:t>
             </a:r>
           </a:p>
         </p:txBody>
@@ -26086,7 +26224,7 @@
         </p:nvGraphicFramePr>
         <p:xfrm>
           <a:off x="365760" y="914400"/>
-          <a:ext cx="5120640" cy="3017520"/>
+          <a:ext cx="4937760" cy="3017520"/>
         </p:xfrm>
         <a:graphic>
           <a:graphicData uri="http://schemas.openxmlformats.org/drawingml/2006/chart">
@@ -26102,8 +26240,8 @@
         </p:nvSpPr>
         <p:spPr>
           <a:xfrm>
-            <a:off x="5669280" y="1097280"/>
-            <a:ext cx="3108960" cy="2743200"/>
+            <a:off x="5486400" y="1005840"/>
+            <a:ext cx="3291840" cy="3108960"/>
           </a:xfrm>
           <a:prstGeom prst="rect">
             <a:avLst/>
@@ -26118,7 +26256,7 @@
           <a:p>
             <a:pPr algn="l" marL="182880" indent="-182880">
               <a:spcAft>
-                <a:spcPts val="1000"/>
+                <a:spcPts val="800"/>
               </a:spcAft>
               <a:buClr>
                 <a:srgbClr val="333333"/>
@@ -26131,13 +26269,13 @@
                   <a:srgbClr val="333333"/>
                 </a:solidFill>
               </a:rPr>
-              <a:t>MLP widths from 10k to 1.43M parameters, both tracks.</a:t>
+              <a:t>BP: error on the typical pixel falls steadily with size; validation picks 1.43M.</a:t>
             </a:r>
           </a:p>
           <a:p>
             <a:pPr algn="l" marL="182880" indent="-182880">
               <a:spcAft>
-                <a:spcPts val="1000"/>
+                <a:spcPts val="800"/>
               </a:spcAft>
               <a:buClr>
                 <a:srgbClr val="333333"/>
@@ -26150,13 +26288,32 @@
                   <a:srgbClr val="333333"/>
                 </a:solidFill>
               </a:rPr>
-              <a:t>Below 176k, detection of multi-peaked pixels collapses; above it, nothing we report improves.</a:t>
+              <a:t>ElasticNet: from 722k up, a few bright pixels blow up by orders of magnitude; 360k is the largest stable size.</a:t>
             </a:r>
           </a:p>
           <a:p>
             <a:pPr algn="l" marL="182880" indent="-182880">
               <a:spcAft>
-                <a:spcPts val="1000"/>
+                <a:spcPts val="800"/>
+              </a:spcAft>
+              <a:buClr>
+                <a:srgbClr val="333333"/>
+              </a:buClr>
+              <a:buChar char="•"/>
+            </a:pPr>
+            <a:r>
+              <a:rPr sz="1200" b="0" i="0">
+                <a:solidFill>
+                  <a:srgbClr val="333333"/>
+                </a:solidFill>
+              </a:rPr>
+              <a:t>With the old fixed sample nothing above 176k helped; with fresh pixels, size pays off.</a:t>
+            </a:r>
+          </a:p>
+          <a:p>
+            <a:pPr algn="l" marL="182880" indent="-182880">
+              <a:spcAft>
+                <a:spcPts val="800"/>
               </a:spcAft>
               <a:buClr>
                 <a:srgbClr val="333333"/>
@@ -26169,45 +26326,7 @@
                   <a:srgbClr val="57068C"/>
                 </a:solidFill>
               </a:rPr>
-              <a:t>Production: 4 hidden layers of 232, 176k parameters.</a:t>
-            </a:r>
-          </a:p>
-        </p:txBody>
-      </p:sp>
-      <p:sp>
-        <p:nvSpPr>
-          <p:cNvPr id="5" name="TextBox 4"/>
-          <p:cNvSpPr txBox="1"/>
-          <p:nvPr/>
-        </p:nvSpPr>
-        <p:spPr>
-          <a:xfrm>
-            <a:off x="365760" y="4069080"/>
-            <a:ext cx="8412480" cy="274320"/>
-          </a:xfrm>
-          <a:prstGeom prst="rect">
-            <a:avLst/>
-          </a:prstGeom>
-          <a:noFill/>
-        </p:spPr>
-        <p:txBody>
-          <a:bodyPr wrap="square" anchor="t" lIns="0" rIns="0" tIns="0" bIns="0">
-            <a:spAutoFit/>
-          </a:bodyPr>
-          <a:lstStyle/>
-          <a:p>
-            <a:pPr algn="l">
-              <a:spcAft>
-                <a:spcPts val="600"/>
-              </a:spcAft>
-            </a:pPr>
-            <a:r>
-              <a:rPr sz="1000" b="0" i="1">
-                <a:solidFill>
-                  <a:srgbClr val="6B6B6B"/>
-                </a:solidFill>
-              </a:rPr>
-              <a:t>Shown: earlier fixed-sample sweep. The fresh-pixel sweep replaces it.</a:t>
+              <a:t>Final: BP 1.43M, ElasticNet 360k.</a:t>
             </a:r>
           </a:p>
         </p:txBody>
@@ -26469,7 +26588,7 @@
                   <a:srgbClr val="57068C"/>
                 </a:solidFill>
               </a:rPr>
-              <a:t>Small is enough</a:t>
+              <a:t>Small models suffice</a:t>
             </a:r>
           </a:p>
         </p:txBody>
@@ -26507,7 +26626,7 @@
                   <a:srgbClr val="333333"/>
                 </a:solidFill>
               </a:rPr>
-              <a:t>A 176k-parameter MLP on one pixel's 6 intensities: one forward pass per pixel, no neighbourhood.</a:t>
+              <a:t>An MLP on one pixel's 6 intensities (1.43M parameters for BP, 360k for ElasticNet): one forward pass per pixel, no neighbourhood.</a:t>
             </a:r>
           </a:p>
         </p:txBody>
@@ -26591,7 +26710,7 @@
                   <a:srgbClr val="57068C"/>
                 </a:solidFill>
               </a:rPr>
-              <a:t>Typical pixels: closer to BP</a:t>
+              <a:t>Close to the supervised model</a:t>
             </a:r>
           </a:p>
         </p:txBody>
@@ -26629,7 +26748,7 @@
                   <a:srgbClr val="333333"/>
                 </a:solidFill>
               </a:rPr>
-              <a:t>Median pixel error 0.030 vs the supervised model's 0.112, and better AIA reconstruction (MSE, both tracks).</a:t>
+              <a:t>BP: typical-pixel error 5× lower (median 0.023 vs 0.112). ElasticNet: same error on 90% of pixels, 10× lower AIA error.</a:t>
             </a:r>
           </a:p>
         </p:txBody>
@@ -26751,7 +26870,7 @@
                   <a:srgbClr val="333333"/>
                 </a:solidFill>
               </a:rPr>
-              <a:t>0.01% of pixels, ~90% of the DEM error. There our model misses the hot channels: a training problem.</a:t>
+              <a:t>0.01% of pixels, ~90% of the BP error. There our BP model misses the hot channels: a training problem.</a:t>
             </a:r>
           </a:p>
         </p:txBody>
@@ -26896,7 +27015,7 @@
                   <a:srgbClr val="57068C"/>
                 </a:solidFill>
               </a:rPr>
-              <a:t>Against the supervised model: worse DEM MSE, better reconstruction</a:t>
+              <a:t>Against the supervised model: close on ElasticNet, behind on BP</a:t>
             </a:r>
           </a:p>
         </p:txBody>
@@ -26918,12 +27037,12 @@
             <a:tbl>
               <a:tblPr firstRow="1" bandRow="1"/>
               <a:tblGrid>
-                <a:gridCol w="2177347"/>
-                <a:gridCol w="1286614"/>
-                <a:gridCol w="1286614"/>
-                <a:gridCol w="1088673"/>
-                <a:gridCol w="1286614"/>
-                <a:gridCol w="1286614"/>
+                <a:gridCol w="2503714"/>
+                <a:gridCol w="1201782"/>
+                <a:gridCol w="1201782"/>
+                <a:gridCol w="1101634"/>
+                <a:gridCol w="1201782"/>
+                <a:gridCol w="1201782"/>
               </a:tblGrid>
               <a:tr h="384048">
                 <a:tc>
@@ -27156,7 +27275,7 @@
                             <a:srgbClr val="333333"/>
                           </a:solidFill>
                         </a:rPr>
-                        <a:t>BP, label-free</a:t>
+                        <a:t>BP, label-free (1.43M)</a:t>
                       </a:r>
                     </a:p>
                   </a:txBody>
@@ -27192,7 +27311,7 @@
                             <a:srgbClr val="333333"/>
                           </a:solidFill>
                         </a:rPr>
-                        <a:t>5.28</a:t>
+                        <a:t>5.10</a:t>
                       </a:r>
                     </a:p>
                   </a:txBody>
@@ -27228,7 +27347,7 @@
                             <a:srgbClr val="333333"/>
                           </a:solidFill>
                         </a:rPr>
-                        <a:t>25.5%</a:t>
+                        <a:t>20.2%</a:t>
                       </a:r>
                     </a:p>
                   </a:txBody>
@@ -27264,7 +27383,7 @@
                             <a:srgbClr val="333333"/>
                           </a:solidFill>
                         </a:rPr>
-                        <a:t>0.091</a:t>
+                        <a:t>0.084</a:t>
                       </a:r>
                     </a:p>
                   </a:txBody>
@@ -27300,7 +27419,7 @@
                             <a:srgbClr val="333333"/>
                           </a:solidFill>
                         </a:rPr>
-                        <a:t>4.35</a:t>
+                        <a:t>4.43</a:t>
                       </a:r>
                     </a:p>
                   </a:txBody>
@@ -27331,12 +27450,12 @@
                     <a:p>
                       <a:pPr algn="r"/>
                       <a:r>
-                        <a:rPr sz="1200" b="1">
+                        <a:rPr sz="1200" b="0">
                           <a:solidFill>
                             <a:srgbClr val="333333"/>
                           </a:solidFill>
                         </a:rPr>
-                        <a:t>93</a:t>
+                        <a:t>174</a:t>
                       </a:r>
                     </a:p>
                   </a:txBody>
@@ -27549,7 +27668,7 @@
                     <a:p>
                       <a:pPr algn="r"/>
                       <a:r>
-                        <a:rPr sz="1200" b="0">
+                        <a:rPr sz="1200" b="1">
                           <a:solidFill>
                             <a:srgbClr val="333333"/>
                           </a:solidFill>
@@ -27592,7 +27711,7 @@
                             <a:srgbClr val="333333"/>
                           </a:solidFill>
                         </a:rPr>
-                        <a:t>ENet, label-free</a:t>
+                        <a:t>ENet, label-free (360k)</a:t>
                       </a:r>
                     </a:p>
                   </a:txBody>
@@ -27628,7 +27747,7 @@
                             <a:srgbClr val="333333"/>
                           </a:solidFill>
                         </a:rPr>
-                        <a:t>0.79</a:t>
+                        <a:t>0.48</a:t>
                       </a:r>
                     </a:p>
                   </a:txBody>
@@ -27664,7 +27783,79 @@
                             <a:srgbClr val="333333"/>
                           </a:solidFill>
                         </a:rPr>
-                        <a:t>14.7%</a:t>
+                        <a:t>12.7%</a:t>
+                      </a:r>
+                    </a:p>
+                  </a:txBody>
+                  <a:tcPr marL="54864" marR="54864" marT="27432" marB="27432" anchor="ctr">
+                    <a:lnL w="0">
+                      <a:noFill/>
+                    </a:lnL>
+                    <a:lnR w="0">
+                      <a:noFill/>
+                    </a:lnR>
+                    <a:lnT w="0">
+                      <a:noFill/>
+                    </a:lnT>
+                    <a:lnB w="6350">
+                      <a:solidFill>
+                        <a:srgbClr val="D9D3E3"/>
+                      </a:solidFill>
+                    </a:lnB>
+                    <a:solidFill>
+                      <a:srgbClr val="FFFFFF"/>
+                    </a:solidFill>
+                  </a:tcPr>
+                </a:tc>
+                <a:tc>
+                  <a:txBody>
+                    <a:bodyPr wrap="square"/>
+                    <a:lstStyle/>
+                    <a:p>
+                      <a:pPr algn="r"/>
+                      <a:r>
+                        <a:rPr sz="1200" b="1">
+                          <a:solidFill>
+                            <a:srgbClr val="333333"/>
+                          </a:solidFill>
+                        </a:rPr>
+                        <a:t>0.111</a:t>
+                      </a:r>
+                    </a:p>
+                  </a:txBody>
+                  <a:tcPr marL="54864" marR="54864" marT="27432" marB="27432" anchor="ctr">
+                    <a:lnL w="0">
+                      <a:noFill/>
+                    </a:lnL>
+                    <a:lnR w="0">
+                      <a:noFill/>
+                    </a:lnR>
+                    <a:lnT w="0">
+                      <a:noFill/>
+                    </a:lnT>
+                    <a:lnB w="6350">
+                      <a:solidFill>
+                        <a:srgbClr val="D9D3E3"/>
+                      </a:solidFill>
+                    </a:lnB>
+                    <a:solidFill>
+                      <a:srgbClr val="FFFFFF"/>
+                    </a:solidFill>
+                  </a:tcPr>
+                </a:tc>
+                <a:tc>
+                  <a:txBody>
+                    <a:bodyPr wrap="square"/>
+                    <a:lstStyle/>
+                    <a:p>
+                      <a:pPr algn="r"/>
+                      <a:r>
+                        <a:rPr sz="1200" b="1">
+                          <a:solidFill>
+                            <a:srgbClr val="333333"/>
+                          </a:solidFill>
+                        </a:rPr>
+                        <a:t>0.60</a:t>
                       </a:r>
                     </a:p>
                   </a:txBody>
@@ -27700,79 +27891,7 @@
                             <a:srgbClr val="333333"/>
                           </a:solidFill>
                         </a:rPr>
-                        <a:t>0.126</a:t>
-                      </a:r>
-                    </a:p>
-                  </a:txBody>
-                  <a:tcPr marL="54864" marR="54864" marT="27432" marB="27432" anchor="ctr">
-                    <a:lnL w="0">
-                      <a:noFill/>
-                    </a:lnL>
-                    <a:lnR w="0">
-                      <a:noFill/>
-                    </a:lnR>
-                    <a:lnT w="0">
-                      <a:noFill/>
-                    </a:lnT>
-                    <a:lnB w="6350">
-                      <a:solidFill>
-                        <a:srgbClr val="D9D3E3"/>
-                      </a:solidFill>
-                    </a:lnB>
-                    <a:solidFill>
-                      <a:srgbClr val="FFFFFF"/>
-                    </a:solidFill>
-                  </a:tcPr>
-                </a:tc>
-                <a:tc>
-                  <a:txBody>
-                    <a:bodyPr wrap="square"/>
-                    <a:lstStyle/>
-                    <a:p>
-                      <a:pPr algn="r"/>
-                      <a:r>
-                        <a:rPr sz="1200" b="1">
-                          <a:solidFill>
-                            <a:srgbClr val="333333"/>
-                          </a:solidFill>
-                        </a:rPr>
-                        <a:t>0.72</a:t>
-                      </a:r>
-                    </a:p>
-                  </a:txBody>
-                  <a:tcPr marL="54864" marR="54864" marT="27432" marB="27432" anchor="ctr">
-                    <a:lnL w="0">
-                      <a:noFill/>
-                    </a:lnL>
-                    <a:lnR w="0">
-                      <a:noFill/>
-                    </a:lnR>
-                    <a:lnT w="0">
-                      <a:noFill/>
-                    </a:lnT>
-                    <a:lnB w="6350">
-                      <a:solidFill>
-                        <a:srgbClr val="D9D3E3"/>
-                      </a:solidFill>
-                    </a:lnB>
-                    <a:solidFill>
-                      <a:srgbClr val="FFFFFF"/>
-                    </a:solidFill>
-                  </a:tcPr>
-                </a:tc>
-                <a:tc>
-                  <a:txBody>
-                    <a:bodyPr wrap="square"/>
-                    <a:lstStyle/>
-                    <a:p>
-                      <a:pPr algn="r"/>
-                      <a:r>
-                        <a:rPr sz="1200" b="1">
-                          <a:solidFill>
-                            <a:srgbClr val="333333"/>
-                          </a:solidFill>
-                        </a:rPr>
-                        <a:t>414</a:t>
+                        <a:t>650</a:t>
                       </a:r>
                     </a:p>
                   </a:txBody>
@@ -27913,7 +28032,7 @@
                     <a:p>
                       <a:pPr algn="r"/>
                       <a:r>
-                        <a:rPr sz="1200" b="1">
+                        <a:rPr sz="1200" b="0">
                           <a:solidFill>
                             <a:srgbClr val="333333"/>
                           </a:solidFill>
@@ -27985,7 +28104,7 @@
                     <a:p>
                       <a:pPr algn="r"/>
                       <a:r>
-                        <a:rPr sz="1200" b="0">
+                        <a:rPr sz="1200" b="1">
                           <a:solidFill>
                             <a:srgbClr val="333333"/>
                           </a:solidFill>
@@ -28028,7 +28147,7 @@
         <p:spPr>
           <a:xfrm>
             <a:off x="365760" y="3108960"/>
-            <a:ext cx="8412480" cy="548640"/>
+            <a:ext cx="8412480" cy="822960"/>
           </a:xfrm>
           <a:prstGeom prst="rect">
             <a:avLst/>
@@ -28056,45 +28175,7 @@
                   <a:srgbClr val="333333"/>
                 </a:solidFill>
               </a:rPr>
-              <a:t>Bold = better. Supervised wins DEM MSE on both tracks; we win AIA MSE on both, and most of the rest on ElasticNet.</a:t>
-            </a:r>
-          </a:p>
-        </p:txBody>
-      </p:sp>
-      <p:sp>
-        <p:nvSpPr>
-          <p:cNvPr id="5" name="TextBox 4"/>
-          <p:cNvSpPr txBox="1"/>
-          <p:nvPr/>
-        </p:nvSpPr>
-        <p:spPr>
-          <a:xfrm>
-            <a:off x="365760" y="3703320"/>
-            <a:ext cx="8412480" cy="274320"/>
-          </a:xfrm>
-          <a:prstGeom prst="rect">
-            <a:avLst/>
-          </a:prstGeom>
-          <a:noFill/>
-        </p:spPr>
-        <p:txBody>
-          <a:bodyPr wrap="square" anchor="t" lIns="0" rIns="0" tIns="0" bIns="0">
-            <a:spAutoFit/>
-          </a:bodyPr>
-          <a:lstStyle/>
-          <a:p>
-            <a:pPr algn="l">
-              <a:spcAft>
-                <a:spcPts val="600"/>
-              </a:spcAft>
-            </a:pPr>
-            <a:r>
-              <a:rPr sz="1000" b="0" i="1">
-                <a:solidFill>
-                  <a:srgbClr val="6B6B6B"/>
-                </a:solidFill>
-              </a:rPr>
-              <a:t>The earlier fixed-sample models scored better on DEM MSE (BP 4.19, ENet 0.59).</a:t>
+              <a:t>Bold = better. ElasticNet: we win emission, W1 and AIA MAE (10× lower). BP: we win W1; the rest is set by flare cores (Part 7).</a:t>
             </a:r>
           </a:p>
         </p:txBody>
@@ -28234,7 +28315,7 @@
                   <a:srgbClr val="57068C"/>
                 </a:solidFill>
               </a:rPr>
-              <a:t>0.030 vs 0.112</a:t>
+              <a:t>0.023 vs 0.112</a:t>
             </a:r>
           </a:p>
         </p:txBody>
@@ -28272,7 +28353,7 @@
                   <a:srgbClr val="333333"/>
                 </a:solidFill>
               </a:rPr>
-              <a:t>BP median pixel error, ours vs supervised: ~4× better on the typical pixel</a:t>
+              <a:t>BP median pixel error, ours vs supervised: ~5× better on the typical pixel</a:t>
             </a:r>
           </a:p>
         </p:txBody>
@@ -28356,7 +28437,7 @@
                   <a:srgbClr val="57068C"/>
                 </a:solidFill>
               </a:rPr>
-              <a:t>97%</a:t>
+              <a:t>98%</a:t>
             </a:r>
           </a:p>
         </p:txBody>
@@ -28436,7 +28517,7 @@
                   <a:srgbClr val="333333"/>
                 </a:solidFill>
               </a:rPr>
-              <a:t>On the typical BP pixel we are ~4× closer to the solver than the supervised model.</a:t>
+              <a:t>On the typical BP pixel we are ~5× closer to the solver than the supervised model.</a:t>
             </a:r>
           </a:p>
           <a:p>
@@ -28455,7 +28536,7 @@
                   <a:srgbClr val="333333"/>
                 </a:solidFill>
               </a:rPr>
-              <a:t>From the 90th percentile up, supervised is better (p99: 27 vs 117).</a:t>
+              <a:t>From the 90th percentile up, supervised is better on BP (p99: 27 vs 68).</a:t>
             </a:r>
           </a:p>
           <a:p>
@@ -28474,7 +28555,7 @@
                   <a:srgbClr val="333333"/>
                 </a:solidFill>
               </a:rPr>
-              <a:t>The average is set by the worst 1% of pixels, for both models.</a:t>
+              <a:t>ElasticNet: ours is as good or better at the median, p99 and p99.9.</a:t>
             </a:r>
           </a:p>
           <a:p>
@@ -28493,7 +28574,7 @@
                   <a:srgbClr val="333333"/>
                 </a:solidFill>
               </a:rPr>
-              <a:t>ElasticNet: supervised is better at the median too (1.12 vs 1.70).</a:t>
+              <a:t>The BP average is set by the worst 1% of pixels, for both models.</a:t>
             </a:r>
           </a:p>
         </p:txBody>
@@ -28549,7 +28630,7 @@
                   <a:srgbClr val="57068C"/>
                 </a:solidFill>
               </a:rPr>
-              <a:t>Multi-peaked DEMs: we flag them precisely but find a quarter</a:t>
+              <a:t>Multi-peaked DEMs: we find a quarter, within BP's own noise</a:t>
             </a:r>
           </a:p>
         </p:txBody>
@@ -28917,7 +28998,7 @@
                             <a:srgbClr val="333333"/>
                           </a:solidFill>
                         </a:rPr>
-                        <a:t>5.0%</a:t>
+                        <a:t>8.8%</a:t>
                       </a:r>
                     </a:p>
                   </a:txBody>
@@ -28953,7 +29034,7 @@
                             <a:srgbClr val="333333"/>
                           </a:solidFill>
                         </a:rPr>
-                        <a:t>69%</a:t>
+                        <a:t>40%</a:t>
                       </a:r>
                     </a:p>
                   </a:txBody>
@@ -28989,7 +29070,7 @@
                             <a:srgbClr val="333333"/>
                           </a:solidFill>
                         </a:rPr>
-                        <a:t>25%</a:t>
+                        <a:t>26%</a:t>
                       </a:r>
                     </a:p>
                   </a:txBody>
@@ -29173,7 +29254,7 @@
         <p:spPr>
           <a:xfrm>
             <a:off x="365760" y="2697480"/>
-            <a:ext cx="8412480" cy="1097280"/>
+            <a:ext cx="8412480" cy="1280160"/>
           </a:xfrm>
           <a:prstGeom prst="rect">
             <a:avLst/>
@@ -29201,7 +29282,7 @@
                   <a:srgbClr val="333333"/>
                 </a:solidFill>
               </a:rPr>
-              <a:t>We flag few pixels, and most are right; the supervised model flags many and misses few.</a:t>
+              <a:t>We flag few pixels and are right more often; the supervised model flags many and misses few.</a:t>
             </a:r>
           </a:p>
           <a:p>
@@ -29220,45 +29301,7 @@
                   <a:srgbClr val="333333"/>
                 </a:solidFill>
               </a:rPr>
-              <a:t>Where BP is multi-peaked, our gap is about the size of BP's own re-solve scatter.</a:t>
-            </a:r>
-          </a:p>
-        </p:txBody>
-      </p:sp>
-      <p:sp>
-        <p:nvSpPr>
-          <p:cNvPr id="5" name="TextBox 4"/>
-          <p:cNvSpPr txBox="1"/>
-          <p:nvPr/>
-        </p:nvSpPr>
-        <p:spPr>
-          <a:xfrm>
-            <a:off x="365760" y="3749039"/>
-            <a:ext cx="8412480" cy="274320"/>
-          </a:xfrm>
-          <a:prstGeom prst="rect">
-            <a:avLst/>
-          </a:prstGeom>
-          <a:noFill/>
-        </p:spPr>
-        <p:txBody>
-          <a:bodyPr wrap="square" anchor="t" lIns="0" rIns="0" tIns="0" bIns="0">
-            <a:spAutoFit/>
-          </a:bodyPr>
-          <a:lstStyle/>
-          <a:p>
-            <a:pPr algn="l">
-              <a:spcAft>
-                <a:spcPts val="600"/>
-              </a:spcAft>
-            </a:pPr>
-            <a:r>
-              <a:rPr sz="1000" b="0" i="1">
-                <a:solidFill>
-                  <a:srgbClr val="6B6B6B"/>
-                </a:solidFill>
-              </a:rPr>
-              <a:t>Last point: earlier fixed-sample result; the fresh-pixel check is running.</a:t>
+              <a:t>Where BP is multi-peaked, our gap from BP is the size of BP's own re-solve scatter (0.96×): re-solving under photon noise moves BP's answer as much.</a:t>
             </a:r>
           </a:p>
         </p:txBody>
@@ -29403,7 +29446,7 @@
                   <a:srgbClr val="57068C"/>
                 </a:solidFill>
               </a:rPr>
-              <a:t>Flare cores, 1 pixel in 10,000, hold ~90% of the error</a:t>
+              <a:t>Flare cores, 1 pixel in 10,000, hold ~90% of the BP error</a:t>
             </a:r>
           </a:p>
         </p:txBody>
@@ -29445,7 +29488,7 @@
                   <a:srgbClr val="333333"/>
                 </a:solidFill>
               </a:rPr>
-              <a:t>Pixels at 32× the Bright cutoff or more: 0.01% of pixels, 88% of our BP DEM error, 90% of the supervised model's.</a:t>
+              <a:t>Pixels at 32× the Bright cutoff or more: 0.01% of pixels, 91% of our BP DEM error, 90% of the supervised model's.</a:t>
             </a:r>
           </a:p>
           <a:p>
@@ -29483,7 +29526,7 @@
                   <a:srgbClr val="333333"/>
                 </a:solidFill>
               </a:rPr>
-              <a:t>Ordinary Bright pixels (1–10×): 10% of pixels, 5.5% of the error, for both.</a:t>
+              <a:t>Ordinary Bright pixels (1–10×): 10% of pixels, 3.5% of our error (supervised 5.5%).</a:t>
             </a:r>
           </a:p>
         </p:txBody>
@@ -29563,7 +29606,7 @@
                   <a:srgbClr val="57068C"/>
                 </a:solidFill>
               </a:rPr>
-              <a:t>Relative to DEM size, our gap grows with brightness</a:t>
+              <a:t>On BP, our gap grows with brightness; on ElasticNet it stays small</a:t>
             </a:r>
           </a:p>
         </p:txBody>
@@ -29605,7 +29648,7 @@
                   <a:srgbClr val="333333"/>
                 </a:solidFill>
               </a:rPr>
-              <a:t>Our BP error / supervised error: 0.65 on the faintest pixels, 2.1 at 0.3–1×, 9 at 3–10×, 25 at 10–32×.</a:t>
+              <a:t>BP, our error / supervised: 0.66 on the faintest pixels, 1.8 at 0.3–1×, 5 at 3–10×, 22 at 10–32×.</a:t>
             </a:r>
           </a:p>
           <a:p>
@@ -29624,7 +29667,7 @@
                   <a:srgbClr val="333333"/>
                 </a:solidFill>
               </a:rPr>
-              <a:t>Supervised gets relatively better as pixels brighten; we get worse above ~3×. ElasticNet: 1.3–2.5 below 10×, ~6 at 10–32×.</a:t>
+              <a:t>ElasticNet: 1.0–1.07 below 3× (90% of pixels), 1.5 at 3–10×, 7 at 10–32×, 1.6 at flare cores.</a:t>
             </a:r>
           </a:p>
         </p:txBody>
@@ -29704,7 +29747,7 @@
                   <a:srgbClr val="57068C"/>
                 </a:solidFill>
               </a:rPr>
-              <a:t>At flare cores, the model under-predicts and runs too cool</a:t>
+              <a:t>At BP flare cores, the model under-predicts and runs too cool</a:t>
             </a:r>
           </a:p>
         </p:txBody>
@@ -29746,7 +29789,7 @@
                   <a:srgbClr val="333333"/>
                 </a:solidFill>
               </a:rPr>
-              <a:t>BP flare cores: 15% of the solver's emission, peak 12% as high, 0.6 dex too cool.</a:t>
+              <a:t>BP flare cores: 20% of the solver's emission, peak 14% as high, 0.5 dex too cool.</a:t>
             </a:r>
           </a:p>
           <a:p>
@@ -29765,7 +29808,7 @@
                   <a:srgbClr val="333333"/>
                 </a:solidFill>
               </a:rPr>
-              <a:t>89% of our flare-core DEMs have extra peaks (solver 18%); those spurious peaks are 81% of our BP error.</a:t>
+              <a:t>88% of our flare-core DEMs have extra peaks (solver 18%); those spurious peaks are 74% of our BP error.</a:t>
             </a:r>
           </a:p>
           <a:p>
@@ -29784,7 +29827,7 @@
                   <a:srgbClr val="333333"/>
                 </a:solidFill>
               </a:rPr>
-              <a:t>It tracks the solver's peak height up to a peak of ~50, then falls away.</a:t>
+              <a:t>It tracks the solver's peak height up to a peak of ~100, then falls away.</a:t>
             </a:r>
           </a:p>
         </p:txBody>
@@ -29902,7 +29945,7 @@
                   <a:srgbClr val="57068C"/>
                 </a:solidFill>
               </a:rPr>
-              <a:t>At flare cores, the model fails its own objective</a:t>
+              <a:t>At BP flare cores, the model fails its own objective</a:t>
             </a:r>
           </a:p>
         </p:txBody>
@@ -29944,7 +29987,7 @@
                   <a:srgbClr val="333333"/>
                 </a:solidFill>
               </a:rPr>
-              <a:t>The solver's DEM reproduces 92% of the observed 94 Å; ours reproduces 7% (131 Å: 35%). The cool channels are fit to within a few percent.</a:t>
+              <a:t>BP: the solver's DEM reproduces 92% of the observed 94 Å; ours reproduces 8% (131 Å: 36%). The cool channels are fit to within a few percent.</a:t>
             </a:r>
           </a:p>
           <a:p>
@@ -30165,7 +30208,7 @@
                   <a:srgbClr val="333333"/>
                 </a:solidFill>
               </a:rPr>
-              <a:t>of our Bright error comes from the solver's own spread across its 5 targets (ENet 4.8%)</a:t>
+              <a:t>of our BP Bright error comes from the solver's own spread across its 5 targets (ENet 6%)</a:t>
             </a:r>
           </a:p>
         </p:txBody>
@@ -30249,7 +30292,7 @@
                   <a:srgbClr val="57068C"/>
                 </a:solidFill>
               </a:rPr>
-              <a:t>1.3%</a:t>
+              <a:t>1.4%</a:t>
             </a:r>
           </a:p>
         </p:txBody>
@@ -30367,7 +30410,7 @@
                   <a:srgbClr val="57068C"/>
                 </a:solidFill>
               </a:rPr>
-              <a:t>What remains is the flare-core shortfall and the spurious peaks.</a:t>
+              <a:t>What remains is the BP flare-core shortfall and the spurious peaks.</a:t>
             </a:r>
           </a:p>
         </p:txBody>
@@ -30718,7 +30761,7 @@
               </a:spcAft>
             </a:pPr>
             <a:r>
-              <a:rPr sz="1250" b="0" i="0">
+              <a:rPr sz="1200" b="0" i="0">
                 <a:solidFill>
                   <a:srgbClr val="333333"/>
                 </a:solidFill>
@@ -30840,12 +30883,12 @@
               </a:spcAft>
             </a:pPr>
             <a:r>
-              <a:rPr sz="1250" b="0" i="0">
+              <a:rPr sz="1200" b="0" i="0">
                 <a:solidFill>
                   <a:srgbClr val="333333"/>
                 </a:solidFill>
               </a:rPr>
-              <a:t>A 176k centre-pixel MLP; the patch CNN's edge vanished on unseen days.</a:t>
+              <a:t>A centre-pixel MLP; the patch CNN never won on unseen days.</a:t>
             </a:r>
           </a:p>
         </p:txBody>
@@ -30929,7 +30972,7 @@
                   <a:srgbClr val="57068C"/>
                 </a:solidFill>
               </a:rPr>
-              <a:t>3. Heavy tails</a:t>
+              <a:t>3. Size needs data</a:t>
             </a:r>
           </a:p>
         </p:txBody>
@@ -30962,12 +31005,12 @@
               </a:spcAft>
             </a:pPr>
             <a:r>
-              <a:rPr sz="1250" b="0" i="0">
+              <a:rPr sz="1200" b="0" i="0">
                 <a:solidFill>
                   <a:srgbClr val="333333"/>
                 </a:solidFill>
               </a:rPr>
-              <a:t>Report medians and percentiles: a handful of pixels can own the mean.</a:t>
+              <a:t>With one fixed 30M-pixel sample, nothing above 176k helped; with fresh pixels, bigger keeps helping.</a:t>
             </a:r>
           </a:p>
         </p:txBody>
@@ -31051,7 +31094,7 @@
                   <a:srgbClr val="57068C"/>
                 </a:solidFill>
               </a:rPr>
-              <a:t>4. The open failure</a:t>
+              <a:t>4. Heavy tails</a:t>
             </a:r>
           </a:p>
         </p:txBody>
@@ -31084,12 +31127,12 @@
               </a:spcAft>
             </a:pPr>
             <a:r>
-              <a:rPr sz="1250" b="0" i="0">
+              <a:rPr sz="1200" b="0" i="0">
                 <a:solidFill>
                   <a:srgbClr val="333333"/>
                 </a:solidFill>
               </a:rPr>
-              <a:t>Flare cores. The model misses the hot channels there: a training problem.</a:t>
+              <a:t>Report medians and percentiles: a handful of pixels can own the mean, or blow up.</a:t>
             </a:r>
           </a:p>
         </p:txBody>
@@ -31173,7 +31216,7 @@
                   <a:srgbClr val="57068C"/>
                 </a:solidFill>
               </a:rPr>
-              <a:t>5. Tried, didn't help</a:t>
+              <a:t>5. The open failure</a:t>
             </a:r>
           </a:p>
         </p:txBody>
@@ -31206,12 +31249,134 @@
               </a:spcAft>
             </a:pPr>
             <a:r>
-              <a:rPr sz="1250" b="0" i="0">
+              <a:rPr sz="1200" b="0" i="0">
                 <a:solidFill>
                   <a:srgbClr val="333333"/>
                 </a:solidFill>
               </a:rPr>
-              <a:t>The supervised model's sqrt + Fourier input; fresh pixels vs one fixed sample.</a:t>
+              <a:t>BP flare cores. The model misses the hot channels there: a training problem.</a:t>
+            </a:r>
+          </a:p>
+        </p:txBody>
+      </p:sp>
+      <p:sp>
+        <p:nvSpPr>
+          <p:cNvPr id="18" name="Rounded Rectangle 17"/>
+          <p:cNvSpPr/>
+          <p:nvPr/>
+        </p:nvSpPr>
+        <p:spPr>
+          <a:xfrm>
+            <a:off x="6096000" y="2606040"/>
+            <a:ext cx="2682240" cy="1417320"/>
+          </a:xfrm>
+          <a:prstGeom prst="roundRect">
+            <a:avLst>
+              <a:gd name="adj" fmla="val 6000"/>
+            </a:avLst>
+          </a:prstGeom>
+          <a:solidFill>
+            <a:srgbClr val="F4F1F8"/>
+          </a:solidFill>
+          <a:ln>
+            <a:noFill/>
+          </a:ln>
+          <a:effectLst/>
+        </p:spPr>
+        <p:style>
+          <a:lnRef idx="1">
+            <a:schemeClr val="accent1"/>
+          </a:lnRef>
+          <a:fillRef idx="3">
+            <a:schemeClr val="accent1"/>
+          </a:fillRef>
+          <a:effectRef idx="2">
+            <a:schemeClr val="accent1"/>
+          </a:effectRef>
+          <a:fontRef idx="minor">
+            <a:schemeClr val="lt1"/>
+          </a:fontRef>
+        </p:style>
+        <p:txBody>
+          <a:bodyPr rtlCol="0" anchor="ctr"/>
+          <a:lstStyle/>
+          <a:p>
+            <a:pPr algn="ctr"/>
+          </a:p>
+        </p:txBody>
+      </p:sp>
+      <p:sp>
+        <p:nvSpPr>
+          <p:cNvPr id="19" name="TextBox 18"/>
+          <p:cNvSpPr txBox="1"/>
+          <p:nvPr/>
+        </p:nvSpPr>
+        <p:spPr>
+          <a:xfrm>
+            <a:off x="6260592" y="2734056"/>
+            <a:ext cx="2353056" cy="320040"/>
+          </a:xfrm>
+          <a:prstGeom prst="rect">
+            <a:avLst/>
+          </a:prstGeom>
+          <a:noFill/>
+        </p:spPr>
+        <p:txBody>
+          <a:bodyPr wrap="square" anchor="t" lIns="0" rIns="0" tIns="0" bIns="0">
+            <a:spAutoFit/>
+          </a:bodyPr>
+          <a:lstStyle/>
+          <a:p>
+            <a:pPr algn="l">
+              <a:spcAft>
+                <a:spcPts val="600"/>
+              </a:spcAft>
+            </a:pPr>
+            <a:r>
+              <a:rPr sz="1300" b="1" i="0">
+                <a:solidFill>
+                  <a:srgbClr val="57068C"/>
+                </a:solidFill>
+              </a:rPr>
+              <a:t>6. Tried, didn't help</a:t>
+            </a:r>
+          </a:p>
+        </p:txBody>
+      </p:sp>
+      <p:sp>
+        <p:nvSpPr>
+          <p:cNvPr id="20" name="TextBox 19"/>
+          <p:cNvSpPr txBox="1"/>
+          <p:nvPr/>
+        </p:nvSpPr>
+        <p:spPr>
+          <a:xfrm>
+            <a:off x="6260592" y="3081528"/>
+            <a:ext cx="2353056" cy="868680"/>
+          </a:xfrm>
+          <a:prstGeom prst="rect">
+            <a:avLst/>
+          </a:prstGeom>
+          <a:noFill/>
+        </p:spPr>
+        <p:txBody>
+          <a:bodyPr wrap="square" anchor="t" lIns="0" rIns="0" tIns="0" bIns="0">
+            <a:spAutoFit/>
+          </a:bodyPr>
+          <a:lstStyle/>
+          <a:p>
+            <a:pPr algn="l">
+              <a:spcAft>
+                <a:spcPts val="600"/>
+              </a:spcAft>
+            </a:pPr>
+            <a:r>
+              <a:rPr sz="1200" b="0" i="0">
+                <a:solidFill>
+                  <a:srgbClr val="333333"/>
+                </a:solidFill>
+              </a:rPr>
+              <a:t>The supervised model's sqrt + Fourier input made BP flare cores worse.</a:t>
             </a:r>
           </a:p>
         </p:txBody>
@@ -31384,12 +31549,12 @@
               </a:spcAft>
             </a:pPr>
             <a:r>
-              <a:rPr sz="1350" b="0" i="0">
+              <a:rPr sz="1300" b="0" i="0">
                 <a:solidFill>
                   <a:srgbClr val="333333"/>
                 </a:solidFill>
               </a:rPr>
-              <a:t>Oversample or up-weight the brightest pixels; handle the pathological pixels that dominate the loss.</a:t>
+              <a:t>BP: oversample or up-weight the brightest pixels. ElasticNet: keep big models from blowing up on rare pixels.</a:t>
             </a:r>
           </a:p>
         </p:txBody>
@@ -31449,6 +31614,128 @@
         <p:spPr>
           <a:xfrm>
             <a:off x="4828032" y="1133856"/>
+            <a:ext cx="3785616" cy="320040"/>
+          </a:xfrm>
+          <a:prstGeom prst="rect">
+            <a:avLst/>
+          </a:prstGeom>
+          <a:noFill/>
+        </p:spPr>
+        <p:txBody>
+          <a:bodyPr wrap="square" anchor="t" lIns="0" rIns="0" tIns="0" bIns="0">
+            <a:spAutoFit/>
+          </a:bodyPr>
+          <a:lstStyle/>
+          <a:p>
+            <a:pPr algn="l">
+              <a:spcAft>
+                <a:spcPts val="600"/>
+              </a:spcAft>
+            </a:pPr>
+            <a:r>
+              <a:rPr sz="1300" b="1" i="0">
+                <a:solidFill>
+                  <a:srgbClr val="57068C"/>
+                </a:solidFill>
+              </a:rPr>
+              <a:t>Validate on every pixel</a:t>
+            </a:r>
+          </a:p>
+        </p:txBody>
+      </p:sp>
+      <p:sp>
+        <p:nvSpPr>
+          <p:cNvPr id="8" name="TextBox 7"/>
+          <p:cNvSpPr txBox="1"/>
+          <p:nvPr/>
+        </p:nvSpPr>
+        <p:spPr>
+          <a:xfrm>
+            <a:off x="4828032" y="1481328"/>
+            <a:ext cx="3785616" cy="914400"/>
+          </a:xfrm>
+          <a:prstGeom prst="rect">
+            <a:avLst/>
+          </a:prstGeom>
+          <a:noFill/>
+        </p:spPr>
+        <p:txBody>
+          <a:bodyPr wrap="square" anchor="t" lIns="0" rIns="0" tIns="0" bIns="0">
+            <a:spAutoFit/>
+          </a:bodyPr>
+          <a:lstStyle/>
+          <a:p>
+            <a:pPr algn="l">
+              <a:spcAft>
+                <a:spcPts val="600"/>
+              </a:spcAft>
+            </a:pPr>
+            <a:r>
+              <a:rPr sz="1300" b="0" i="0">
+                <a:solidFill>
+                  <a:srgbClr val="333333"/>
+                </a:solidFill>
+              </a:rPr>
+              <a:t>A sampled validation set missed the ElasticNet blow-ups; score all pixels.</a:t>
+            </a:r>
+          </a:p>
+        </p:txBody>
+      </p:sp>
+      <p:sp>
+        <p:nvSpPr>
+          <p:cNvPr id="9" name="Rounded Rectangle 8"/>
+          <p:cNvSpPr/>
+          <p:nvPr/>
+        </p:nvSpPr>
+        <p:spPr>
+          <a:xfrm>
+            <a:off x="365760" y="2651760"/>
+            <a:ext cx="4114800" cy="1463040"/>
+          </a:xfrm>
+          <a:prstGeom prst="roundRect">
+            <a:avLst>
+              <a:gd name="adj" fmla="val 6000"/>
+            </a:avLst>
+          </a:prstGeom>
+          <a:solidFill>
+            <a:srgbClr val="F4F1F8"/>
+          </a:solidFill>
+          <a:ln>
+            <a:noFill/>
+          </a:ln>
+          <a:effectLst/>
+        </p:spPr>
+        <p:style>
+          <a:lnRef idx="1">
+            <a:schemeClr val="accent1"/>
+          </a:lnRef>
+          <a:fillRef idx="3">
+            <a:schemeClr val="accent1"/>
+          </a:fillRef>
+          <a:effectRef idx="2">
+            <a:schemeClr val="accent1"/>
+          </a:effectRef>
+          <a:fontRef idx="minor">
+            <a:schemeClr val="lt1"/>
+          </a:fontRef>
+        </p:style>
+        <p:txBody>
+          <a:bodyPr rtlCol="0" anchor="ctr"/>
+          <a:lstStyle/>
+          <a:p>
+            <a:pPr algn="ctr"/>
+          </a:p>
+        </p:txBody>
+      </p:sp>
+      <p:sp>
+        <p:nvSpPr>
+          <p:cNvPr id="10" name="TextBox 9"/>
+          <p:cNvSpPr txBox="1"/>
+          <p:nvPr/>
+        </p:nvSpPr>
+        <p:spPr>
+          <a:xfrm>
+            <a:off x="530352" y="2779776"/>
             <a:ext cx="3785616" cy="320040"/>
           </a:xfrm>
           <a:prstGeom prst="rect">
@@ -31480,13 +31767,13 @@
       </p:sp>
       <p:sp>
         <p:nvSpPr>
-          <p:cNvPr id="8" name="TextBox 7"/>
+          <p:cNvPr id="11" name="TextBox 10"/>
           <p:cNvSpPr txBox="1"/>
           <p:nvPr/>
         </p:nvSpPr>
         <p:spPr>
           <a:xfrm>
-            <a:off x="4828032" y="1481328"/>
+            <a:off x="530352" y="3127248"/>
             <a:ext cx="3785616" cy="914400"/>
           </a:xfrm>
           <a:prstGeom prst="rect">
@@ -31506,7 +31793,7 @@
               </a:spcAft>
             </a:pPr>
             <a:r>
-              <a:rPr sz="1350" b="0" i="0">
+              <a:rPr sz="1300" b="0" i="0">
                 <a:solidFill>
                   <a:srgbClr val="333333"/>
                 </a:solidFill>
@@ -31518,13 +31805,13 @@
       </p:sp>
       <p:sp>
         <p:nvSpPr>
-          <p:cNvPr id="9" name="Rounded Rectangle 8"/>
+          <p:cNvPr id="12" name="Rounded Rectangle 11"/>
           <p:cNvSpPr/>
           <p:nvPr/>
         </p:nvSpPr>
         <p:spPr>
           <a:xfrm>
-            <a:off x="365760" y="2651760"/>
+            <a:off x="4663440" y="2651760"/>
             <a:ext cx="4114800" cy="1463040"/>
           </a:xfrm>
           <a:prstGeom prst="roundRect">
@@ -31564,13 +31851,13 @@
       </p:sp>
       <p:sp>
         <p:nvSpPr>
-          <p:cNvPr id="10" name="TextBox 9"/>
+          <p:cNvPr id="13" name="TextBox 12"/>
           <p:cNvSpPr txBox="1"/>
           <p:nvPr/>
         </p:nvSpPr>
         <p:spPr>
           <a:xfrm>
-            <a:off x="530352" y="2779776"/>
+            <a:off x="4828032" y="2779776"/>
             <a:ext cx="3785616" cy="320040"/>
           </a:xfrm>
           <a:prstGeom prst="rect">
@@ -31595,20 +31882,20 @@
                   <a:srgbClr val="57068C"/>
                 </a:solidFill>
               </a:rPr>
-              <a:t>Uncertainty</a:t>
+              <a:t>Uncertainty, AIA + XRT</a:t>
             </a:r>
           </a:p>
         </p:txBody>
       </p:sp>
       <p:sp>
         <p:nvSpPr>
-          <p:cNvPr id="11" name="TextBox 10"/>
+          <p:cNvPr id="14" name="TextBox 13"/>
           <p:cNvSpPr txBox="1"/>
           <p:nvPr/>
         </p:nvSpPr>
         <p:spPr>
           <a:xfrm>
-            <a:off x="530352" y="3127248"/>
+            <a:off x="4828032" y="3127248"/>
             <a:ext cx="3785616" cy="914400"/>
           </a:xfrm>
           <a:prstGeom prst="rect">
@@ -31628,134 +31915,12 @@
               </a:spcAft>
             </a:pPr>
             <a:r>
-              <a:rPr sz="1350" b="0" i="0">
+              <a:rPr sz="1300" b="0" i="0">
                 <a:solidFill>
                   <a:srgbClr val="333333"/>
                 </a:solidFill>
               </a:rPr>
-              <a:t>A distribution over DEMs, trained on the solver's noisy re-solves.</a:t>
-            </a:r>
-          </a:p>
-        </p:txBody>
-      </p:sp>
-      <p:sp>
-        <p:nvSpPr>
-          <p:cNvPr id="12" name="Rounded Rectangle 11"/>
-          <p:cNvSpPr/>
-          <p:nvPr/>
-        </p:nvSpPr>
-        <p:spPr>
-          <a:xfrm>
-            <a:off x="4663440" y="2651760"/>
-            <a:ext cx="4114800" cy="1463040"/>
-          </a:xfrm>
-          <a:prstGeom prst="roundRect">
-            <a:avLst>
-              <a:gd name="adj" fmla="val 6000"/>
-            </a:avLst>
-          </a:prstGeom>
-          <a:solidFill>
-            <a:srgbClr val="F4F1F8"/>
-          </a:solidFill>
-          <a:ln>
-            <a:noFill/>
-          </a:ln>
-          <a:effectLst/>
-        </p:spPr>
-        <p:style>
-          <a:lnRef idx="1">
-            <a:schemeClr val="accent1"/>
-          </a:lnRef>
-          <a:fillRef idx="3">
-            <a:schemeClr val="accent1"/>
-          </a:fillRef>
-          <a:effectRef idx="2">
-            <a:schemeClr val="accent1"/>
-          </a:effectRef>
-          <a:fontRef idx="minor">
-            <a:schemeClr val="lt1"/>
-          </a:fontRef>
-        </p:style>
-        <p:txBody>
-          <a:bodyPr rtlCol="0" anchor="ctr"/>
-          <a:lstStyle/>
-          <a:p>
-            <a:pPr algn="ctr"/>
-          </a:p>
-        </p:txBody>
-      </p:sp>
-      <p:sp>
-        <p:nvSpPr>
-          <p:cNvPr id="13" name="TextBox 12"/>
-          <p:cNvSpPr txBox="1"/>
-          <p:nvPr/>
-        </p:nvSpPr>
-        <p:spPr>
-          <a:xfrm>
-            <a:off x="4828032" y="2779776"/>
-            <a:ext cx="3785616" cy="320040"/>
-          </a:xfrm>
-          <a:prstGeom prst="rect">
-            <a:avLst/>
-          </a:prstGeom>
-          <a:noFill/>
-        </p:spPr>
-        <p:txBody>
-          <a:bodyPr wrap="square" anchor="t" lIns="0" rIns="0" tIns="0" bIns="0">
-            <a:spAutoFit/>
-          </a:bodyPr>
-          <a:lstStyle/>
-          <a:p>
-            <a:pPr algn="l">
-              <a:spcAft>
-                <a:spcPts val="600"/>
-              </a:spcAft>
-            </a:pPr>
-            <a:r>
-              <a:rPr sz="1300" b="1" i="0">
-                <a:solidFill>
-                  <a:srgbClr val="57068C"/>
-                </a:solidFill>
-              </a:rPr>
-              <a:t>AIA + XRT</a:t>
-            </a:r>
-          </a:p>
-        </p:txBody>
-      </p:sp>
-      <p:sp>
-        <p:nvSpPr>
-          <p:cNvPr id="14" name="TextBox 13"/>
-          <p:cNvSpPr txBox="1"/>
-          <p:nvPr/>
-        </p:nvSpPr>
-        <p:spPr>
-          <a:xfrm>
-            <a:off x="4828032" y="3127248"/>
-            <a:ext cx="3785616" cy="914400"/>
-          </a:xfrm>
-          <a:prstGeom prst="rect">
-            <a:avLst/>
-          </a:prstGeom>
-          <a:noFill/>
-        </p:spPr>
-        <p:txBody>
-          <a:bodyPr wrap="square" anchor="t" lIns="0" rIns="0" tIns="0" bIns="0">
-            <a:spAutoFit/>
-          </a:bodyPr>
-          <a:lstStyle/>
-          <a:p>
-            <a:pPr algn="l">
-              <a:spcAft>
-                <a:spcPts val="600"/>
-              </a:spcAft>
-            </a:pPr>
-            <a:r>
-              <a:rPr sz="1350" b="0" i="0">
-                <a:solidFill>
-                  <a:srgbClr val="333333"/>
-                </a:solidFill>
-              </a:rPr>
-              <a:t>For the hot plasma AIA barely constrains.</a:t>
+              <a:t>A distribution over DEMs from the noisy re-solves; XRT for the hot plasma.</a:t>
             </a:r>
           </a:p>
         </p:txBody>
@@ -33257,7 +33422,7 @@
                   <a:srgbClr val="FFFFFF"/>
                 </a:solidFill>
               </a:rPr>
-              <a:t>176k params</a:t>
+              <a:t>1.43M / 360k</a:t>
             </a:r>
           </a:p>
         </p:txBody>
@@ -33799,7 +33964,7 @@
                   <a:srgbClr val="333333"/>
                 </a:solidFill>
               </a:rPr>
-              <a:t>6 log-intensities in; 4 hidden layers of 232, SiLU; 54 non-negative basis weights out.</a:t>
+              <a:t>6 log-intensities in; 4 hidden layers with SiLU; 54 non-negative basis weights out.</a:t>
             </a:r>
           </a:p>
           <a:p>
@@ -33856,7 +34021,7 @@
                   <a:srgbClr val="333333"/>
                 </a:solidFill>
               </a:rPr>
-              <a:t>176k parameters; one forward pass per pixel.</a:t>
+              <a:t>1.43M parameters for BP, 360k for ElasticNet (Part 5); one forward pass per pixel.</a:t>
             </a:r>
           </a:p>
         </p:txBody>
@@ -35124,7 +35289,7 @@
                   <a:srgbClr val="333333"/>
                 </a:solidFill>
               </a:rPr>
-              <a:t>Earlier runs reused one fixed ~30M-pixel sample (a sampler bug) and scored better on validation (BP 4%, ElasticNet 18%).</a:t>
+              <a:t>Earlier runs reused one fixed ~30M-pixel sample (a sampler bug); at the old 176k size it scored better on validation (BP 4%, ElasticNet 18%).</a:t>
             </a:r>
           </a:p>
           <a:p>

</xml_diff>

<commit_message>
slides: one 360k model for both tracks; slide 19 is the model choice
BP's own validation best is 360k (2.148; 1.43M ties at 2.155 but is worse
on nearly every test metric and 4x larger), and 360k is the largest stable
ElasticNet size, so both tracks now use it. Slide 19 states how the model
was chosen; the summary, model slide and Parts 6-7 use the 360k numbers and
redrawn figures. The BP 360k self-consistency is 0.97x at multi-peaked
pixels.
</commit_message>
<xml_diff>
--- a/slides/DEM_deck_v2.pptx
+++ b/slides/DEM_deck_v2.pptx
@@ -353,13 +353,15 @@
             </c:strRef>
           </c:tx>
           <c:spPr>
-            <a:ln w="28575">
+            <a:ln w="25400">
               <a:solidFill>
                 <a:srgbClr val="57068C"/>
               </a:solidFill>
             </a:ln>
           </c:spPr>
           <c:marker>
+            <c:symbol val="circle"/>
+            <c:size val="6"/>
             <c:spPr>
               <a:solidFill>
                 <a:srgbClr val="57068C"/>
@@ -371,6 +373,23 @@
               </a:ln>
             </c:spPr>
           </c:marker>
+          <c:dPt>
+            <c:idx val="4"/>
+            <c:marker>
+              <c:symbol val="circle"/>
+              <c:size val="13"/>
+              <c:spPr>
+                <a:solidFill>
+                  <a:srgbClr val="57068C"/>
+                </a:solidFill>
+                <a:ln>
+                  <a:solidFill>
+                    <a:srgbClr val="57068C"/>
+                  </a:solidFill>
+                </a:ln>
+              </c:spPr>
+            </c:marker>
+          </c:dPt>
           <c:cat>
             <c:strRef>
               <c:f>Sheet1!$A$2:$A$8</c:f>
@@ -1338,7 +1357,7 @@
           <a:lstStyle/>
           <a:p>
             <a:r>
-              <a:t>Fresh-pixel sweep, every width scored on the full test set (results/plots/17_sweep_resample). 10k collapsed (validation loss 61) and is left off the chart. BP validation loss: 2.155 at 1.43M, 2.148 at 360k (a tie within run-to-run noise), 2.237 at 176k. ElasticNet validation is best at 1.43M (0.0528), but its 722k and 1.43M models predict a few bright pixels orders of magnitude too bright: AIA MSE 41,849 and 908,611 against 650 at 360k. Validation scores a fixed sample of 512 pixels per block and never saw them. Multi-peak recall is 22-26% from 42k up; the fixed-sample sweep's cliff below 176k does not reproduce.</a:t>
+              <a:t>Fresh-pixel sweep, every width scored on the full test set (results/plots/17_sweep_resample). We choose by validation loss, never by test numbers. BP validation: 2.148 at 360k (best), 2.155 at 1.43M (a tie within run-to-run noise), 2.167 at 722k, 2.237 at 176k. ElasticNet validation is best at 1.43M (0.0528), but its 722k and 1.43M models predict a few bright pixels orders of magnitude too bright (AIA MSE 41,849 and 908,611 against 650 at 360k); validation scores a fixed 512 pixels per block and never saw them. 10k collapsed and is left off the chart. Multi-peak recall is 22-26% from 42k up; the fixed-sample cliff below 176k does not reproduce.</a:t>
             </a:r>
           </a:p>
         </p:txBody>
@@ -1396,7 +1415,7 @@
           <a:lstStyle/>
           <a:p>
             <a:r>
-              <a:t>Label-free trains on the observation through R; supervised trains on solver DEMs. Supervised wins the DEM-against-solver metric on both tracks. On ElasticNet we win total-emission error, W1 and AIA MAE (10 times lower); on BP we win W1 only, and the BP DEM MSE is set by flare cores (Part 7). EM error is the total-emission error; W1 is in dex.</a:t>
+              <a:t>Label-free trains on the observation through R; supervised trains on solver DEMs. Supervised wins the DEM-against-solver metric on both tracks. On ElasticNet we win total-emission error, W1 and AIA MAE (10 times lower); on BP we win W1 and AIA MSE, and the BP DEM MSE is set by flare cores (Part 7). EM error is the total-emission error; W1 is in dex.</a:t>
             </a:r>
           </a:p>
         </p:txBody>
@@ -1454,7 +1473,7 @@
           <a:lstStyle/>
           <a:p>
             <a:r>
-              <a:t>Per-pixel error is the squared error summed over the 18 bins. BP percentiles, label-free against supervised: median 0.023 vs 0.112, p90 3.4 vs 2.0, p99 68 vs 27. ElasticNet: median 1.07 vs 1.12, p99 35.5 vs 35.5, p99.9 155 vs 178.</a:t>
+              <a:t>Per-pixel error is the squared error summed over the 18 bins. BP percentiles, label-free against supervised: median 0.026 vs 0.112, p90 3.5 vs 2.0, p99 71 vs 27. ElasticNet: median 1.07 vs 1.12, p99 35.5 vs 35.5, p99.9 155 vs 178.</a:t>
             </a:r>
           </a:p>
         </p:txBody>
@@ -1512,7 +1531,7 @@
           <a:lstStyle/>
           <a:p>
             <a:r>
-              <a:t>Peaks are counted on the zero-padded curve with prominence 0.15 times the maximum, over the full test set. Self-consistency: 80 multi-peaked bright pixels, 30 BP re-solves each under photon noise; our deviation from BP is 0.96 times BP's own re-solve scatter (0.68 at single-peaked pixels). On ElasticNet both models find ~85% of multi-peaked pixels.</a:t>
+              <a:t>Peaks are counted on the zero-padded curve with prominence 0.15 times the maximum, over the full test set. Self-consistency: 80 multi-peaked bright pixels, 30 BP re-solves each under photon noise; our deviation from BP is 0.97 times BP's own re-solve scatter (0.70 at single-peaked pixels). On ElasticNet both models find ~85% of multi-peaked pixels.</a:t>
             </a:r>
           </a:p>
         </p:txBody>
@@ -1686,7 +1705,7 @@
           <a:lstStyle/>
           <a:p>
             <a:r>
-              <a:t>The four things to remember. Numbers are from the final models (BP 1.43M, ElasticNet 360k, fresh pixels) on the shared test set: 153 days never seen in training.</a:t>
+              <a:t>The four things to remember. Numbers are from the final models (one 360k MLP per track, fresh pixels) on the shared test set: 153 days never seen in training.</a:t>
             </a:r>
           </a:p>
         </p:txBody>
@@ -1802,7 +1821,7 @@
           <a:lstStyle/>
           <a:p>
             <a:r>
-              <a:t>The solvers never solve for the 18 bins directly: both solve for weights on a fixed basis, a spike and two Gaussians at each bin, and report DEM = B times x. We predict the same weights, so the network searches the same space of DEMs the solver does, and BP's sparsity criterion means the same thing for both. Only the MLP is learned. Per pixel: six log-intensities in, four hidden layers with SiLU (680 wide for BP, 336 for ElasticNet), 54 non-negative basis weights out; DEM = B times w over 18 bins, logT 5.5 to 7.2; predicted AIA = R times DEM. One forward pass per pixel.</a:t>
+              <a:t>The solvers never solve for the 18 bins directly: both solve for weights on a fixed basis, a spike and two Gaussians at each bin, and report DEM = B times x. We predict the same weights, so the network searches the same space of DEMs the solver does, and BP's sparsity criterion means the same thing for both. Only the MLP is learned. Per pixel: six log-intensities in, four hidden layers of 336 with SiLU, 54 non-negative basis weights out; DEM = B times w over 18 bins, logT 5.5 to 7.2; predicted AIA = R times DEM. 360k parameters, one forward pass per pixel. The size is chosen in Part 5.</a:t>
             </a:r>
           </a:p>
         </p:txBody>
@@ -25178,7 +25197,7 @@
                   <a:srgbClr val="333333"/>
                 </a:solidFill>
               </a:rPr>
-              <a:t>Same 917 training days and losses, ~1.5M parameters each, fresh pixels; scored on the 153 test days.</a:t>
+              <a:t>Same 917 training days and losses, matched at ~1.5M parameters each, fresh pixels; scored on the 153 test days. (The final model is smaller: next slide.)</a:t>
             </a:r>
           </a:p>
         </p:txBody>
@@ -26209,7 +26228,7 @@
                   <a:srgbClr val="57068C"/>
                 </a:solidFill>
               </a:rPr>
-              <a:t>Bigger helps, until ElasticNet turns unstable</a:t>
+              <a:t>Choosing the model: 360k parameters, for both tracks</a:t>
             </a:r>
           </a:p>
         </p:txBody>
@@ -26224,7 +26243,7 @@
         </p:nvGraphicFramePr>
         <p:xfrm>
           <a:off x="365760" y="914400"/>
-          <a:ext cx="4937760" cy="3017520"/>
+          <a:ext cx="4846320" cy="3017520"/>
         </p:xfrm>
         <a:graphic>
           <a:graphicData uri="http://schemas.openxmlformats.org/drawingml/2006/chart">
@@ -26240,8 +26259,8 @@
         </p:nvSpPr>
         <p:spPr>
           <a:xfrm>
-            <a:off x="5486400" y="1005840"/>
-            <a:ext cx="3291840" cy="3108960"/>
+            <a:off x="5440680" y="960120"/>
+            <a:ext cx="3337560" cy="3200400"/>
           </a:xfrm>
           <a:prstGeom prst="rect">
             <a:avLst/>
@@ -26256,7 +26275,7 @@
           <a:p>
             <a:pPr algn="l" marL="182880" indent="-182880">
               <a:spcAft>
-                <a:spcPts val="800"/>
+                <a:spcPts val="700"/>
               </a:spcAft>
               <a:buClr>
                 <a:srgbClr val="333333"/>
@@ -26264,18 +26283,18 @@
               <a:buChar char="•"/>
             </a:pPr>
             <a:r>
-              <a:rPr sz="1200" b="0" i="0">
+              <a:rPr sz="1150" b="0" i="0">
                 <a:solidFill>
                   <a:srgbClr val="333333"/>
                 </a:solidFill>
               </a:rPr>
-              <a:t>BP: error on the typical pixel falls steadily with size; validation picks 1.43M.</a:t>
+              <a:t>We choose by validation loss, never by the test set.</a:t>
             </a:r>
           </a:p>
           <a:p>
             <a:pPr algn="l" marL="182880" indent="-182880">
               <a:spcAft>
-                <a:spcPts val="800"/>
+                <a:spcPts val="700"/>
               </a:spcAft>
               <a:buClr>
                 <a:srgbClr val="333333"/>
@@ -26283,7 +26302,26 @@
               <a:buChar char="•"/>
             </a:pPr>
             <a:r>
-              <a:rPr sz="1200" b="0" i="0">
+              <a:rPr sz="1150" b="0" i="0">
+                <a:solidFill>
+                  <a:srgbClr val="333333"/>
+                </a:solidFill>
+              </a:rPr>
+              <a:t>BP: validation is best at 360k; 1.43M ties, but only nudges the typical pixel (0.026 → 0.023) at 4× the size and with worse tails.</a:t>
+            </a:r>
+          </a:p>
+          <a:p>
+            <a:pPr algn="l" marL="182880" indent="-182880">
+              <a:spcAft>
+                <a:spcPts val="700"/>
+              </a:spcAft>
+              <a:buClr>
+                <a:srgbClr val="333333"/>
+              </a:buClr>
+              <a:buChar char="•"/>
+            </a:pPr>
+            <a:r>
+              <a:rPr sz="1150" b="0" i="0">
                 <a:solidFill>
                   <a:srgbClr val="333333"/>
                 </a:solidFill>
@@ -26294,7 +26332,7 @@
           <a:p>
             <a:pPr algn="l" marL="182880" indent="-182880">
               <a:spcAft>
-                <a:spcPts val="800"/>
+                <a:spcPts val="700"/>
               </a:spcAft>
               <a:buClr>
                 <a:srgbClr val="333333"/>
@@ -26302,31 +26340,50 @@
               <a:buChar char="•"/>
             </a:pPr>
             <a:r>
-              <a:rPr sz="1200" b="0" i="0">
+              <a:rPr sz="1150" b="0" i="0">
                 <a:solidFill>
                   <a:srgbClr val="333333"/>
                 </a:solidFill>
               </a:rPr>
-              <a:t>With the old fixed sample nothing above 176k helped; with fresh pixels, size pays off.</a:t>
+              <a:t>With the old fixed sample nothing above 176k helped; with fresh pixels, size pays off up to here.</a:t>
             </a:r>
           </a:p>
-          <a:p>
-            <a:pPr algn="l" marL="182880" indent="-182880">
-              <a:spcAft>
-                <a:spcPts val="800"/>
-              </a:spcAft>
-              <a:buClr>
-                <a:srgbClr val="333333"/>
-              </a:buClr>
-              <a:buChar char="•"/>
+        </p:txBody>
+      </p:sp>
+      <p:sp>
+        <p:nvSpPr>
+          <p:cNvPr id="5" name="TextBox 4"/>
+          <p:cNvSpPr txBox="1"/>
+          <p:nvPr/>
+        </p:nvSpPr>
+        <p:spPr>
+          <a:xfrm>
+            <a:off x="365760" y="4023360"/>
+            <a:ext cx="8412480" cy="320040"/>
+          </a:xfrm>
+          <a:prstGeom prst="rect">
+            <a:avLst/>
+          </a:prstGeom>
+          <a:noFill/>
+        </p:spPr>
+        <p:txBody>
+          <a:bodyPr wrap="square" anchor="t" lIns="0" rIns="0" tIns="0" bIns="0">
+            <a:spAutoFit/>
+          </a:bodyPr>
+          <a:lstStyle/>
+          <a:p>
+            <a:pPr algn="l">
+              <a:spcAft>
+                <a:spcPts val="600"/>
+              </a:spcAft>
             </a:pPr>
             <a:r>
-              <a:rPr sz="1200" b="1" i="0">
+              <a:rPr sz="1300" b="1" i="0">
                 <a:solidFill>
                   <a:srgbClr val="57068C"/>
                 </a:solidFill>
               </a:rPr>
-              <a:t>Final: BP 1.43M, ElasticNet 360k.</a:t>
+              <a:t>Final: one 360k-parameter MLP per track (4 hidden layers of 336).</a:t>
             </a:r>
           </a:p>
         </p:txBody>
@@ -26588,7 +26645,7 @@
                   <a:srgbClr val="57068C"/>
                 </a:solidFill>
               </a:rPr>
-              <a:t>Small models suffice</a:t>
+              <a:t>Small is enough</a:t>
             </a:r>
           </a:p>
         </p:txBody>
@@ -26626,7 +26683,7 @@
                   <a:srgbClr val="333333"/>
                 </a:solidFill>
               </a:rPr>
-              <a:t>An MLP on one pixel's 6 intensities (1.43M parameters for BP, 360k for ElasticNet): one forward pass per pixel, no neighbourhood.</a:t>
+              <a:t>A 360k-parameter MLP on one pixel's 6 intensities: one forward pass per pixel, no neighbourhood.</a:t>
             </a:r>
           </a:p>
         </p:txBody>
@@ -26748,7 +26805,7 @@
                   <a:srgbClr val="333333"/>
                 </a:solidFill>
               </a:rPr>
-              <a:t>BP: typical-pixel error 5× lower (median 0.023 vs 0.112). ElasticNet: same error on 90% of pixels, 10× lower AIA error.</a:t>
+              <a:t>BP: typical-pixel error 4× lower (median 0.026 vs 0.112). ElasticNet: same error on 90% of pixels, 10× lower AIA error.</a:t>
             </a:r>
           </a:p>
         </p:txBody>
@@ -27015,7 +27072,7 @@
                   <a:srgbClr val="57068C"/>
                 </a:solidFill>
               </a:rPr>
-              <a:t>Against the supervised model: close on ElasticNet, behind on BP</a:t>
+              <a:t>Against supervised: close on ElasticNet, behind on BP's DEM error</a:t>
             </a:r>
           </a:p>
         </p:txBody>
@@ -27275,7 +27332,7 @@
                             <a:srgbClr val="333333"/>
                           </a:solidFill>
                         </a:rPr>
-                        <a:t>BP, label-free (1.43M)</a:t>
+                        <a:t>BP, label-free</a:t>
                       </a:r>
                     </a:p>
                   </a:txBody>
@@ -27311,7 +27368,7 @@
                             <a:srgbClr val="333333"/>
                           </a:solidFill>
                         </a:rPr>
-                        <a:t>5.10</a:t>
+                        <a:t>4.28</a:t>
                       </a:r>
                     </a:p>
                   </a:txBody>
@@ -27347,7 +27404,7 @@
                             <a:srgbClr val="333333"/>
                           </a:solidFill>
                         </a:rPr>
-                        <a:t>20.2%</a:t>
+                        <a:t>19.6%</a:t>
                       </a:r>
                     </a:p>
                   </a:txBody>
@@ -27383,7 +27440,7 @@
                             <a:srgbClr val="333333"/>
                           </a:solidFill>
                         </a:rPr>
-                        <a:t>0.084</a:t>
+                        <a:t>0.083</a:t>
                       </a:r>
                     </a:p>
                   </a:txBody>
@@ -27419,7 +27476,7 @@
                             <a:srgbClr val="333333"/>
                           </a:solidFill>
                         </a:rPr>
-                        <a:t>4.43</a:t>
+                        <a:t>4.34</a:t>
                       </a:r>
                     </a:p>
                   </a:txBody>
@@ -27450,12 +27507,12 @@
                     <a:p>
                       <a:pPr algn="r"/>
                       <a:r>
-                        <a:rPr sz="1200" b="0">
+                        <a:rPr sz="1200" b="1">
                           <a:solidFill>
                             <a:srgbClr val="333333"/>
                           </a:solidFill>
                         </a:rPr>
-                        <a:t>174</a:t>
+                        <a:t>83</a:t>
                       </a:r>
                     </a:p>
                   </a:txBody>
@@ -27668,7 +27725,7 @@
                     <a:p>
                       <a:pPr algn="r"/>
                       <a:r>
-                        <a:rPr sz="1200" b="1">
+                        <a:rPr sz="1200" b="0">
                           <a:solidFill>
                             <a:srgbClr val="333333"/>
                           </a:solidFill>
@@ -27711,7 +27768,7 @@
                             <a:srgbClr val="333333"/>
                           </a:solidFill>
                         </a:rPr>
-                        <a:t>ENet, label-free (360k)</a:t>
+                        <a:t>ENet, label-free</a:t>
                       </a:r>
                     </a:p>
                   </a:txBody>
@@ -28175,7 +28232,7 @@
                   <a:srgbClr val="333333"/>
                 </a:solidFill>
               </a:rPr>
-              <a:t>Bold = better. ElasticNet: we win emission, W1 and AIA MAE (10× lower). BP: we win W1; the rest is set by flare cores (Part 7).</a:t>
+              <a:t>Bold = better. ElasticNet: we win emission, W1 and AIA MAE (10× lower). BP: we win W1 and AIA MSE; the DEM error is set by flare cores (Part 7).</a:t>
             </a:r>
           </a:p>
         </p:txBody>
@@ -28315,7 +28372,7 @@
                   <a:srgbClr val="57068C"/>
                 </a:solidFill>
               </a:rPr>
-              <a:t>0.023 vs 0.112</a:t>
+              <a:t>0.026 vs 0.112</a:t>
             </a:r>
           </a:p>
         </p:txBody>
@@ -28353,7 +28410,7 @@
                   <a:srgbClr val="333333"/>
                 </a:solidFill>
               </a:rPr>
-              <a:t>BP median pixel error, ours vs supervised: ~5× better on the typical pixel</a:t>
+              <a:t>BP median pixel error, ours vs supervised: ~4× better on the typical pixel</a:t>
             </a:r>
           </a:p>
         </p:txBody>
@@ -28517,7 +28574,7 @@
                   <a:srgbClr val="333333"/>
                 </a:solidFill>
               </a:rPr>
-              <a:t>On the typical BP pixel we are ~5× closer to the solver than the supervised model.</a:t>
+              <a:t>On the typical BP pixel we are ~4× closer to the solver than the supervised model.</a:t>
             </a:r>
           </a:p>
           <a:p>
@@ -28536,7 +28593,7 @@
                   <a:srgbClr val="333333"/>
                 </a:solidFill>
               </a:rPr>
-              <a:t>From the 90th percentile up, supervised is better on BP (p99: 27 vs 68).</a:t>
+              <a:t>From the 90th percentile up, supervised is better on BP (p99: 27 vs 71).</a:t>
             </a:r>
           </a:p>
           <a:p>
@@ -28998,7 +29055,7 @@
                             <a:srgbClr val="333333"/>
                           </a:solidFill>
                         </a:rPr>
-                        <a:t>8.8%</a:t>
+                        <a:t>9.9%</a:t>
                       </a:r>
                     </a:p>
                   </a:txBody>
@@ -29034,7 +29091,7 @@
                             <a:srgbClr val="333333"/>
                           </a:solidFill>
                         </a:rPr>
-                        <a:t>40%</a:t>
+                        <a:t>36%</a:t>
                       </a:r>
                     </a:p>
                   </a:txBody>
@@ -29301,7 +29358,7 @@
                   <a:srgbClr val="333333"/>
                 </a:solidFill>
               </a:rPr>
-              <a:t>Where BP is multi-peaked, our gap from BP is the size of BP's own re-solve scatter (0.96×): re-solving under photon noise moves BP's answer as much.</a:t>
+              <a:t>Where BP is multi-peaked, our gap from BP is the size of BP's own re-solve scatter (0.97×): re-solving under photon noise moves BP's answer as much.</a:t>
             </a:r>
           </a:p>
         </p:txBody>
@@ -29488,7 +29545,7 @@
                   <a:srgbClr val="333333"/>
                 </a:solidFill>
               </a:rPr>
-              <a:t>Pixels at 32× the Bright cutoff or more: 0.01% of pixels, 91% of our BP DEM error, 90% of the supervised model's.</a:t>
+              <a:t>Pixels at 32× the Bright cutoff or more: 0.01% of pixels, 90% of our BP DEM error, 90% of the supervised model's.</a:t>
             </a:r>
           </a:p>
           <a:p>
@@ -29526,7 +29583,7 @@
                   <a:srgbClr val="333333"/>
                 </a:solidFill>
               </a:rPr>
-              <a:t>Ordinary Bright pixels (1–10×): 10% of pixels, 3.5% of our error (supervised 5.5%).</a:t>
+              <a:t>Ordinary Bright pixels (1–10×): 10% of pixels, 4% of our error (supervised 5.5%).</a:t>
             </a:r>
           </a:p>
         </p:txBody>
@@ -29648,7 +29705,7 @@
                   <a:srgbClr val="333333"/>
                 </a:solidFill>
               </a:rPr>
-              <a:t>BP, our error / supervised: 0.66 on the faintest pixels, 1.8 at 0.3–1×, 5 at 3–10×, 22 at 10–32×.</a:t>
+              <a:t>BP, our error / supervised: 0.64 on the faintest pixels, 1.8 at 0.3–1×, 5 at 3–10×, 18 at 10–32×.</a:t>
             </a:r>
           </a:p>
           <a:p>
@@ -29789,7 +29846,7 @@
                   <a:srgbClr val="333333"/>
                 </a:solidFill>
               </a:rPr>
-              <a:t>BP flare cores: 20% of the solver's emission, peak 14% as high, 0.5 dex too cool.</a:t>
+              <a:t>BP flare cores: 40% of the solver's emission, peak 23% as high, 0.2 dex too cool.</a:t>
             </a:r>
           </a:p>
           <a:p>
@@ -29808,7 +29865,7 @@
                   <a:srgbClr val="333333"/>
                 </a:solidFill>
               </a:rPr>
-              <a:t>88% of our flare-core DEMs have extra peaks (solver 18%); those spurious peaks are 74% of our BP error.</a:t>
+              <a:t>83% of our flare-core DEMs have extra peaks (solver 18%); those spurious peaks are 42% of our BP error.</a:t>
             </a:r>
           </a:p>
           <a:p>
@@ -29987,7 +30044,7 @@
                   <a:srgbClr val="333333"/>
                 </a:solidFill>
               </a:rPr>
-              <a:t>BP: the solver's DEM reproduces 92% of the observed 94 Å; ours reproduces 8% (131 Å: 36%). The cool channels are fit to within a few percent.</a:t>
+              <a:t>BP: the solver's DEM reproduces 92% of the observed 94 Å; ours reproduces 23% (131 Å: 76%). The cool channels are fit to within a few percent.</a:t>
             </a:r>
           </a:p>
           <a:p>
@@ -30170,7 +30227,7 @@
                   <a:srgbClr val="57068C"/>
                 </a:solidFill>
               </a:rPr>
-              <a:t>0.3%</a:t>
+              <a:t>0.4%</a:t>
             </a:r>
           </a:p>
         </p:txBody>
@@ -30292,7 +30349,7 @@
                   <a:srgbClr val="57068C"/>
                 </a:solidFill>
               </a:rPr>
-              <a:t>1.4%</a:t>
+              <a:t>1.2%</a:t>
             </a:r>
           </a:p>
         </p:txBody>
@@ -31010,7 +31067,7 @@
                   <a:srgbClr val="333333"/>
                 </a:solidFill>
               </a:rPr>
-              <a:t>With one fixed 30M-pixel sample, nothing above 176k helped; with fresh pixels, bigger keeps helping.</a:t>
+              <a:t>With one fixed 30M-pixel sample, nothing above 176k helped; with fresh pixels, size pays off up to 360k.</a:t>
             </a:r>
           </a:p>
         </p:txBody>
@@ -33422,7 +33479,7 @@
                   <a:srgbClr val="FFFFFF"/>
                 </a:solidFill>
               </a:rPr>
-              <a:t>1.43M / 360k</a:t>
+              <a:t>360k params</a:t>
             </a:r>
           </a:p>
         </p:txBody>
@@ -33964,7 +34021,7 @@
                   <a:srgbClr val="333333"/>
                 </a:solidFill>
               </a:rPr>
-              <a:t>6 log-intensities in; 4 hidden layers with SiLU; 54 non-negative basis weights out.</a:t>
+              <a:t>6 log-intensities in; 4 hidden layers of 336, SiLU; 54 non-negative basis weights out.</a:t>
             </a:r>
           </a:p>
           <a:p>
@@ -34021,7 +34078,7 @@
                   <a:srgbClr val="333333"/>
                 </a:solidFill>
               </a:rPr>
-              <a:t>1.43M parameters for BP, 360k for ElasticNet (Part 5); one forward pass per pixel.</a:t>
+              <a:t>360k parameters (size chosen in Part 5); one forward pass per pixel.</a:t>
             </a:r>
           </a:p>
         </p:txBody>

</xml_diff>

<commit_message>
slides + results: ElasticNet takes the sqrt + Fourier input; BP keeps log1p
On the 360k models, sqrt + Fourier input wins ElasticNet's validation (0.0533
vs 0.0575) and beats the supervised model on every headline metric; on BP it
ties on validation (2.1472 vs 2.1478) and does not help flare cores, so BP
keeps log1p. The final-model folder, figures and deck follow.
</commit_message>
<xml_diff>
--- a/slides/DEM_deck_v2.pptx
+++ b/slides/DEM_deck_v2.pptx
@@ -1357,7 +1357,7 @@
           <a:lstStyle/>
           <a:p>
             <a:r>
-              <a:t>Fresh-pixel sweep, every width scored on the full test set (results/plots/17_sweep_resample). We choose by validation loss, never by test numbers. BP validation: 2.148 at 360k (best), 2.155 at 1.43M (a tie within run-to-run noise), 2.167 at 722k, 2.237 at 176k. ElasticNet validation is best at 1.43M (0.0528), but its 722k and 1.43M models predict a few bright pixels orders of magnitude too bright (AIA MSE 41,849 and 908,611 against 650 at 360k); validation scores a fixed 512 pixels per block and never saw them. 10k collapsed and is left off the chart. Multi-peak recall is 22-26% from 42k up; the fixed-sample cliff below 176k does not reproduce.</a:t>
+              <a:t>Fresh-pixel sweep, every width scored on the full test set (results/plots/17_sweep_resample). We choose by validation loss, never by test numbers. BP validation: 2.148 at 360k (best), 2.155 at 1.43M (a tie within run-to-run noise), 2.167 at 722k, 2.237 at 176k. ElasticNet validation is best at 1.43M (0.0528), but its 722k and 1.43M models predict a few bright pixels orders of magnitude too bright (AIA MSE 41,849 and 908,611 against 650 at 360k); validation scores a fixed 512 pixels per block and never saw them. 10k collapsed and is left off the chart. Multi-peak recall is 22-26% from 42k up; the fixed-sample cliff below 176k does not reproduce. With the old fixed sample nothing above 176k helped; with fresh pixels size pays off up to 360k. Input encoding: BP validation 2.1472 with square root plus Fourier features against 2.1478 with log1p, a tie, so the simpler log1p stays; ElasticNet 0.0533 against 0.0575.</a:t>
             </a:r>
           </a:p>
         </p:txBody>
@@ -1415,7 +1415,7 @@
           <a:lstStyle/>
           <a:p>
             <a:r>
-              <a:t>Label-free trains on the observation through R; supervised trains on solver DEMs. Supervised wins the DEM-against-solver metric on both tracks. On ElasticNet we win total-emission error, W1 and AIA MAE (10 times lower); on BP we win W1 and AIA MSE, and the BP DEM MSE is set by flare cores (Part 7). EM error is the total-emission error; W1 is in dex.</a:t>
+              <a:t>Label-free trains on the observation through R; supervised trains on solver DEMs. Supervised wins the DEM-against-solver metric on BP. On ElasticNet, with the square-root plus Fourier input, we win all five, DEM MSE included (0.310 vs 0.318). On BP we win W1 and AIA MSE, and the BP DEM MSE is set by flare cores (Part 7). EM error is the total-emission error; W1 is in dex.</a:t>
             </a:r>
           </a:p>
         </p:txBody>
@@ -1473,7 +1473,7 @@
           <a:lstStyle/>
           <a:p>
             <a:r>
-              <a:t>Per-pixel error is the squared error summed over the 18 bins. BP percentiles, label-free against supervised: median 0.026 vs 0.112, p90 3.5 vs 2.0, p99 71 vs 27. ElasticNet: median 1.07 vs 1.12, p99 35.5 vs 35.5, p99.9 155 vs 178.</a:t>
+              <a:t>Per-pixel error is the squared error summed over the 18 bins. BP percentiles, label-free against supervised: median 0.026 vs 0.112, p90 3.5 vs 2.0, p99 71 vs 27. ElasticNet: median 0.85 vs 1.12, p99 30 vs 35, p99.9 102 vs 178.</a:t>
             </a:r>
           </a:p>
         </p:txBody>
@@ -1531,7 +1531,7 @@
           <a:lstStyle/>
           <a:p>
             <a:r>
-              <a:t>Peaks are counted on the zero-padded curve with prominence 0.15 times the maximum, over the full test set. Self-consistency: 80 multi-peaked bright pixels, 30 BP re-solves each under photon noise; our deviation from BP is 0.97 times BP's own re-solve scatter (0.70 at single-peaked pixels). On ElasticNet both models find ~85% of multi-peaked pixels.</a:t>
+              <a:t>Peaks are counted on the zero-padded curve with prominence 0.15 times the maximum, over the full test set. Self-consistency: 80 multi-peaked bright pixels, 30 BP re-solves each under photon noise; our deviation from BP is 0.97 times BP's own re-solve scatter (0.70 at single-peaked pixels). On ElasticNet both models find most multi-peaked pixels: ours 82% recall at 87% precision, supervised 84% at 80%.</a:t>
             </a:r>
           </a:p>
         </p:txBody>
@@ -1589,7 +1589,7 @@
           <a:lstStyle/>
           <a:p>
             <a:r>
-              <a:t>ElasticNet flare cores are close to the solver: 88% of its emission, peak 79% as high, and 20% multi-peaked against the solver's 21%.</a:t>
+              <a:t>ElasticNet flare cores match the solver: 99% of its emission, peak 101% as high, and 18% multi-peaked against the solver's 21%.</a:t>
             </a:r>
           </a:p>
         </p:txBody>
@@ -1647,7 +1647,7 @@
           <a:lstStyle/>
           <a:p>
             <a:r>
-              <a:t>On ElasticNet our flare-core reconstruction matches the solver's (94 A: 0.41 vs 0.55; cool channels 1.00 vs 0.98) and beats the supervised model's (0.70 to 0.76 on the cool channels). The supervised model's sqrt plus Fourier input made BP flare cores worse, consistent with a training problem rather than an input-representation one.</a:t>
+              <a:t>On ElasticNet our flare-core reconstruction matches the solver's (94 A: 0.53 vs 0.55; cool channels 0.97 vs 0.98 to 1.00) and beats the supervised model's (0.70 to 0.76 on the cool channels). On BP, the supervised model's square-root plus Fourier input does not fix flare cores either (94 A 0.15 vs 0.23), consistent with a training problem rather than an input-representation one.</a:t>
             </a:r>
           </a:p>
         </p:txBody>
@@ -1821,7 +1821,7 @@
           <a:lstStyle/>
           <a:p>
             <a:r>
-              <a:t>The solvers never solve for the 18 bins directly: both solve for weights on a fixed basis, a spike and two Gaussians at each bin, and report DEM = B times x. We predict the same weights, so the network searches the same space of DEMs the solver does, and BP's sparsity criterion means the same thing for both. Only the MLP is learned. Per pixel: six log-intensities in, four hidden layers of 336 with SiLU, 54 non-negative basis weights out; DEM = B times w over 18 bins, logT 5.5 to 7.2; predicted AIA = R times DEM. 360k parameters, one forward pass per pixel. The size is chosen in Part 5.</a:t>
+              <a:t>The solvers never solve for the 18 bins directly: both solve for weights on a fixed basis, a spike and two Gaussians at each bin, and report DEM = B times x. We predict the same weights, so the network searches the same space of DEMs the solver does, and BP's sparsity criterion means the same thing for both. Only the MLP is learned. Per pixel: six intensities in (log1p for BP; for ElasticNet the supervised model's encoding, square root then Fourier features), four hidden layers of 336 with SiLU, 54 non-negative basis weights out; DEM = B times w over 18 bins, logT 5.5 to 7.2; predicted AIA = R times DEM. 360k parameters, one forward pass per pixel. The size is chosen in Part 5.</a:t>
             </a:r>
           </a:p>
         </p:txBody>
@@ -26345,7 +26345,7 @@
                   <a:srgbClr val="333333"/>
                 </a:solidFill>
               </a:rPr>
-              <a:t>With the old fixed sample nothing above 176k helped; with fresh pixels, size pays off up to here.</a:t>
+              <a:t>Input, also by validation: log1p for BP (√ + Fourier ties); √ + Fourier features for ElasticNet (7% better).</a:t>
             </a:r>
           </a:p>
         </p:txBody>
@@ -26383,7 +26383,7 @@
                   <a:srgbClr val="57068C"/>
                 </a:solidFill>
               </a:rPr>
-              <a:t>Final: one 360k-parameter MLP per track (4 hidden layers of 336).</a:t>
+              <a:t>Final: one 360k MLP per track; ElasticNet with the √ + Fourier input.</a:t>
             </a:r>
           </a:p>
         </p:txBody>
@@ -26767,7 +26767,7 @@
                   <a:srgbClr val="57068C"/>
                 </a:solidFill>
               </a:rPr>
-              <a:t>Close to the supervised model</a:t>
+              <a:t>Beats the supervised model on ElasticNet</a:t>
             </a:r>
           </a:p>
         </p:txBody>
@@ -26805,7 +26805,7 @@
                   <a:srgbClr val="333333"/>
                 </a:solidFill>
               </a:rPr>
-              <a:t>BP: typical-pixel error 4× lower (median 0.026 vs 0.112). ElasticNet: same error on 90% of pixels, 10× lower AIA error.</a:t>
+              <a:t>ElasticNet: better on every metric, DEM error included. BP: typical-pixel error 4× lower (median 0.026 vs 0.112).</a:t>
             </a:r>
           </a:p>
         </p:txBody>
@@ -27072,7 +27072,7 @@
                   <a:srgbClr val="57068C"/>
                 </a:solidFill>
               </a:rPr>
-              <a:t>Against supervised: close on ElasticNet, behind on BP's DEM error</a:t>
+              <a:t>Against supervised: better on ElasticNet, behind on BP's DEM error</a:t>
             </a:r>
           </a:p>
         </p:txBody>
@@ -27799,12 +27799,12 @@
                     <a:p>
                       <a:pPr algn="r"/>
                       <a:r>
-                        <a:rPr sz="1200" b="0">
+                        <a:rPr sz="1200" b="1">
                           <a:solidFill>
                             <a:srgbClr val="333333"/>
                           </a:solidFill>
                         </a:rPr>
-                        <a:t>0.48</a:t>
+                        <a:t>0.31</a:t>
                       </a:r>
                     </a:p>
                   </a:txBody>
@@ -27840,7 +27840,7 @@
                             <a:srgbClr val="333333"/>
                           </a:solidFill>
                         </a:rPr>
-                        <a:t>12.7%</a:t>
+                        <a:t>12.2%</a:t>
                       </a:r>
                     </a:p>
                   </a:txBody>
@@ -27876,7 +27876,7 @@
                             <a:srgbClr val="333333"/>
                           </a:solidFill>
                         </a:rPr>
-                        <a:t>0.111</a:t>
+                        <a:t>0.103</a:t>
                       </a:r>
                     </a:p>
                   </a:txBody>
@@ -27912,7 +27912,7 @@
                             <a:srgbClr val="333333"/>
                           </a:solidFill>
                         </a:rPr>
-                        <a:t>0.60</a:t>
+                        <a:t>0.56</a:t>
                       </a:r>
                     </a:p>
                   </a:txBody>
@@ -27943,12 +27943,12 @@
                     <a:p>
                       <a:pPr algn="r"/>
                       <a:r>
-                        <a:rPr sz="1200" b="0">
+                        <a:rPr sz="1200" b="1">
                           <a:solidFill>
                             <a:srgbClr val="333333"/>
                           </a:solidFill>
                         </a:rPr>
-                        <a:t>650</a:t>
+                        <a:t>161</a:t>
                       </a:r>
                     </a:p>
                   </a:txBody>
@@ -28017,7 +28017,7 @@
                     <a:p>
                       <a:pPr algn="r"/>
                       <a:r>
-                        <a:rPr sz="1200" b="1">
+                        <a:rPr sz="1200" b="0">
                           <a:solidFill>
                             <a:srgbClr val="333333"/>
                           </a:solidFill>
@@ -28161,7 +28161,7 @@
                     <a:p>
                       <a:pPr algn="r"/>
                       <a:r>
-                        <a:rPr sz="1200" b="1">
+                        <a:rPr sz="1200" b="0">
                           <a:solidFill>
                             <a:srgbClr val="333333"/>
                           </a:solidFill>
@@ -28232,7 +28232,7 @@
                   <a:srgbClr val="333333"/>
                 </a:solidFill>
               </a:rPr>
-              <a:t>Bold = better. ElasticNet: we win emission, W1 and AIA MAE (10× lower). BP: we win W1 and AIA MSE; the DEM error is set by flare cores (Part 7).</a:t>
+              <a:t>Bold = better. ElasticNet: we win all five, DEM MSE included. BP: we win W1 and AIA MSE; the DEM error is set by flare cores (Part 7).</a:t>
             </a:r>
           </a:p>
         </p:txBody>
@@ -28612,7 +28612,7 @@
                   <a:srgbClr val="333333"/>
                 </a:solidFill>
               </a:rPr>
-              <a:t>ElasticNet: ours is as good or better at the median, p99 and p99.9.</a:t>
+              <a:t>ElasticNet: ours is better at the median, p99 and p99.9.</a:t>
             </a:r>
           </a:p>
           <a:p>
@@ -29663,7 +29663,7 @@
                   <a:srgbClr val="57068C"/>
                 </a:solidFill>
               </a:rPr>
-              <a:t>On BP, our gap grows with brightness; on ElasticNet it stays small</a:t>
+              <a:t>On BP, our gap grows with brightness; on ElasticNet we are ahead</a:t>
             </a:r>
           </a:p>
         </p:txBody>
@@ -29724,7 +29724,7 @@
                   <a:srgbClr val="333333"/>
                 </a:solidFill>
               </a:rPr>
-              <a:t>ElasticNet: 1.0–1.07 below 3× (90% of pixels), 1.5 at 3–10×, 7 at 10–32×, 1.6 at flare cores.</a:t>
+              <a:t>ElasticNet: ours is ahead from 0.1× to 32× (0.5–1.0), level on the faintest, 1.3 at flare cores.</a:t>
             </a:r>
           </a:p>
         </p:txBody>
@@ -30265,7 +30265,7 @@
                   <a:srgbClr val="333333"/>
                 </a:solidFill>
               </a:rPr>
-              <a:t>of our BP Bright error comes from the solver's own spread across its 5 targets (ENet 6%)</a:t>
+              <a:t>of our BP Bright error comes from the solver's own spread across its 5 targets (ENet 8%)</a:t>
             </a:r>
           </a:p>
         </p:txBody>
@@ -31395,7 +31395,7 @@
                   <a:srgbClr val="57068C"/>
                 </a:solidFill>
               </a:rPr>
-              <a:t>6. Tried, didn't help</a:t>
+              <a:t>6. Input encoding</a:t>
             </a:r>
           </a:p>
         </p:txBody>
@@ -31433,7 +31433,7 @@
                   <a:srgbClr val="333333"/>
                 </a:solidFill>
               </a:rPr>
-              <a:t>The supervised model's sqrt + Fourier input made BP flare cores worse.</a:t>
+              <a:t>The supervised model's √ + Fourier input lifts ElasticNet past the supervised model; on BP it changes nothing.</a:t>
             </a:r>
           </a:p>
         </p:txBody>
@@ -34021,7 +34021,7 @@
                   <a:srgbClr val="333333"/>
                 </a:solidFill>
               </a:rPr>
-              <a:t>6 log-intensities in; 4 hidden layers of 336, SiLU; 54 non-negative basis weights out.</a:t>
+              <a:t>6 intensities in (log1p for BP; √ + Fourier features for ElasticNet); 4 hidden layers of 336, SiLU; 54 non-negative basis weights out.</a:t>
             </a:r>
           </a:p>
           <a:p>

</xml_diff>

<commit_message>
slides: merge Google Slides edits (DEM MAE column, multi-peak slide dropped, heavy-tail bullet, Part 8 renamed)
Flare cores in the heavy-tail bullet are 1 in 10,000 (69,283 of 705M), not
1 in 70k. ElasticNet now wins all six columns of the results table.
</commit_message>
<xml_diff>
--- a/slides/DEM_deck_v2.pptx
+++ b/slides/DEM_deck_v2.pptx
@@ -40,7 +40,6 @@
     <p:sldId id="285" r:id="rId45"/>
     <p:sldId id="286" r:id="rId46"/>
     <p:sldId id="287" r:id="rId47"/>
-    <p:sldId id="288" r:id="rId48"/>
   </p:sldIdLst>
   <p:sldSz cy="5143500" cx="9144000"/>
   <p:notesSz cx="6858000" cy="9144000"/>
@@ -1415,7 +1414,7 @@
           <a:lstStyle/>
           <a:p>
             <a:r>
-              <a:t>Label-free trains on the observation through R; supervised trains on solver DEMs. Supervised wins the DEM-against-solver metric on BP. On ElasticNet, with the square-root plus Fourier input, we win all five, DEM MSE included (0.310 vs 0.318). On BP we win W1 and AIA MSE, and the BP DEM MSE is set by flare cores (Part 7). EM error is the total-emission error; W1 is in dex.</a:t>
+              <a:t>Label-free trains on the observation through R; supervised trains on solver DEMs. Supervised wins the DEM-against-solver metric on BP. On ElasticNet, with the square-root plus Fourier input, we win all six, DEM MAE and MSE included (MAE 0.151 vs 0.188, MSE 0.310 vs 0.318). On BP we win W1 and AIA MSE, and the BP DEM MSE is set by flare cores (Part 7). EM error is the total-emission error; W1 is in dex.</a:t>
             </a:r>
           </a:p>
         </p:txBody>
@@ -1531,7 +1530,7 @@
           <a:lstStyle/>
           <a:p>
             <a:r>
-              <a:t>Peaks are counted on the zero-padded curve with prominence 0.15 times the maximum, over the full test set. Self-consistency: 80 multi-peaked bright pixels, 30 BP re-solves each under photon noise; our deviation from BP is 0.97 times BP's own re-solve scatter (0.70 at single-peaked pixels). On ElasticNet both models find most multi-peaked pixels: ours 82% recall at 87% precision, supervised 84% at 80%.</a:t>
+              <a:t>ElasticNet flare cores match the solver: 99% of its emission, peak 101% as high, and 18% multi-peaked against the solver's 21%.</a:t>
             </a:r>
           </a:p>
         </p:txBody>
@@ -1545,64 +1544,6 @@
 </file>
 
 <file path=ppt/notesSlides/notesSlide18.xml><?xml version="1.0" encoding="utf-8"?>
-<p:notes xmlns:a="http://schemas.openxmlformats.org/drawingml/2006/main" xmlns:p="http://schemas.openxmlformats.org/presentationml/2006/main" xmlns:r="http://schemas.openxmlformats.org/officeDocument/2006/relationships">
-  <p:cSld>
-    <p:spTree>
-      <p:nvGrpSpPr>
-        <p:cNvPr id="1" name=""/>
-        <p:cNvGrpSpPr/>
-        <p:nvPr/>
-      </p:nvGrpSpPr>
-      <p:grpSpPr>
-        <a:xfrm>
-          <a:off x="0" y="0"/>
-          <a:ext cx="0" cy="0"/>
-          <a:chOff x="0" y="0"/>
-          <a:chExt cx="0" cy="0"/>
-        </a:xfrm>
-      </p:grpSpPr>
-      <p:sp>
-        <p:nvSpPr>
-          <p:cNvPr id="2" name="Slide Image Placeholder 1"/>
-          <p:cNvSpPr>
-            <a:spLocks noGrp="1"/>
-          </p:cNvSpPr>
-          <p:nvPr>
-            <p:ph type="sldImg" idx="2"/>
-          </p:nvPr>
-        </p:nvSpPr>
-        <p:spPr/>
-      </p:sp>
-      <p:sp>
-        <p:nvSpPr>
-          <p:cNvPr id="3" name="Notes Placeholder 2"/>
-          <p:cNvSpPr>
-            <a:spLocks noGrp="1"/>
-          </p:cNvSpPr>
-          <p:nvPr>
-            <p:ph type="body" idx="1"/>
-          </p:nvPr>
-        </p:nvSpPr>
-        <p:spPr/>
-        <p:txBody>
-          <a:bodyPr/>
-          <a:lstStyle/>
-          <a:p>
-            <a:r>
-              <a:t>ElasticNet flare cores match the solver: 99% of its emission, peak 101% as high, and 18% multi-peaked against the solver's 21%.</a:t>
-            </a:r>
-          </a:p>
-        </p:txBody>
-      </p:sp>
-    </p:spTree>
-  </p:cSld>
-  <p:clrMapOvr>
-    <a:masterClrMapping/>
-  </p:clrMapOvr>
-</p:notes>
-</file>
-
-<file path=ppt/notesSlides/notesSlide19.xml><?xml version="1.0" encoding="utf-8"?>
 <p:notes xmlns:a="http://schemas.openxmlformats.org/drawingml/2006/main" xmlns:p="http://schemas.openxmlformats.org/presentationml/2006/main" xmlns:r="http://schemas.openxmlformats.org/officeDocument/2006/relationships">
   <p:cSld>
     <p:spTree>
@@ -13188,7 +13129,7 @@
                   <a:srgbClr val="333333"/>
                 </a:solidFill>
               </a:rPr>
-              <a:t>We also report medians and percentiles: the error is extremely heavy-tailed (one pixel in 5 million once made up 94% of a model's mean loss).</a:t>
+              <a:t>We also report medians and percentiles: the error is extremely heavy-tailed. For our final BP model, the worst 1% of pixels hold 98% of the DEM error, and the flare cores (0.01% of pixels, 1 in 10,000) alone hold 90%.</a:t>
             </a:r>
           </a:p>
         </p:txBody>
@@ -26288,7 +26229,7 @@
                   <a:srgbClr val="333333"/>
                 </a:solidFill>
               </a:rPr>
-              <a:t>We choose by validation loss, never by the test set.</a:t>
+              <a:t>We choose by validation loss.</a:t>
             </a:r>
           </a:p>
           <a:p>
@@ -27087,19 +27028,20 @@
         </p:nvGraphicFramePr>
         <p:xfrm>
           <a:off x="365760" y="1005840"/>
-          <a:ext cx="8412476" cy="1920240"/>
+          <a:ext cx="8412480" cy="1920240"/>
         </p:xfrm>
         <a:graphic>
           <a:graphicData uri="http://schemas.openxmlformats.org/drawingml/2006/table">
             <a:tbl>
               <a:tblPr firstRow="1" bandRow="1"/>
               <a:tblGrid>
-                <a:gridCol w="2503714"/>
-                <a:gridCol w="1201782"/>
-                <a:gridCol w="1201782"/>
-                <a:gridCol w="1101634"/>
-                <a:gridCol w="1201782"/>
-                <a:gridCol w="1201782"/>
+                <a:gridCol w="2194560"/>
+                <a:gridCol w="1051560"/>
+                <a:gridCol w="1051560"/>
+                <a:gridCol w="1051560"/>
+                <a:gridCol w="960120"/>
+                <a:gridCol w="1051560"/>
+                <a:gridCol w="1051560"/>
               </a:tblGrid>
               <a:tr h="384048">
                 <a:tc>
@@ -27115,6 +27057,42 @@
                           </a:solidFill>
                         </a:rPr>
                         <a:t/>
+                      </a:r>
+                    </a:p>
+                  </a:txBody>
+                  <a:tcPr marL="54864" marR="54864" marT="27432" marB="27432" anchor="ctr">
+                    <a:lnL w="0">
+                      <a:noFill/>
+                    </a:lnL>
+                    <a:lnR w="0">
+                      <a:noFill/>
+                    </a:lnR>
+                    <a:lnT w="0">
+                      <a:noFill/>
+                    </a:lnT>
+                    <a:lnB w="6350">
+                      <a:solidFill>
+                        <a:srgbClr val="D9D3E3"/>
+                      </a:solidFill>
+                    </a:lnB>
+                    <a:solidFill>
+                      <a:srgbClr val="57068C"/>
+                    </a:solidFill>
+                  </a:tcPr>
+                </a:tc>
+                <a:tc>
+                  <a:txBody>
+                    <a:bodyPr wrap="square"/>
+                    <a:lstStyle/>
+                    <a:p>
+                      <a:pPr algn="r"/>
+                      <a:r>
+                        <a:rPr sz="1200" b="1">
+                          <a:solidFill>
+                            <a:srgbClr val="FFFFFF"/>
+                          </a:solidFill>
+                        </a:rPr>
+                        <a:t>DEM MAE</a:t>
                       </a:r>
                     </a:p>
                   </a:txBody>
@@ -27368,6 +27346,42 @@
                             <a:srgbClr val="333333"/>
                           </a:solidFill>
                         </a:rPr>
+                        <a:t>0.106</a:t>
+                      </a:r>
+                    </a:p>
+                  </a:txBody>
+                  <a:tcPr marL="54864" marR="54864" marT="27432" marB="27432" anchor="ctr">
+                    <a:lnL w="0">
+                      <a:noFill/>
+                    </a:lnL>
+                    <a:lnR w="0">
+                      <a:noFill/>
+                    </a:lnR>
+                    <a:lnT w="0">
+                      <a:noFill/>
+                    </a:lnT>
+                    <a:lnB w="6350">
+                      <a:solidFill>
+                        <a:srgbClr val="D9D3E3"/>
+                      </a:solidFill>
+                    </a:lnB>
+                    <a:solidFill>
+                      <a:srgbClr val="FFFFFF"/>
+                    </a:solidFill>
+                  </a:tcPr>
+                </a:tc>
+                <a:tc>
+                  <a:txBody>
+                    <a:bodyPr wrap="square"/>
+                    <a:lstStyle/>
+                    <a:p>
+                      <a:pPr algn="r"/>
+                      <a:r>
+                        <a:rPr sz="1200" b="0">
+                          <a:solidFill>
+                            <a:srgbClr val="333333"/>
+                          </a:solidFill>
+                        </a:rPr>
                         <a:t>4.28</a:t>
                       </a:r>
                     </a:p>
@@ -27551,6 +27565,42 @@
                           </a:solidFill>
                         </a:rPr>
                         <a:t>BP, supervised</a:t>
+                      </a:r>
+                    </a:p>
+                  </a:txBody>
+                  <a:tcPr marL="54864" marR="54864" marT="27432" marB="27432" anchor="ctr">
+                    <a:lnL w="0">
+                      <a:noFill/>
+                    </a:lnL>
+                    <a:lnR w="0">
+                      <a:noFill/>
+                    </a:lnR>
+                    <a:lnT w="0">
+                      <a:noFill/>
+                    </a:lnT>
+                    <a:lnB w="6350">
+                      <a:solidFill>
+                        <a:srgbClr val="D9D3E3"/>
+                      </a:solidFill>
+                    </a:lnB>
+                    <a:solidFill>
+                      <a:srgbClr val="FFFFFF"/>
+                    </a:solidFill>
+                  </a:tcPr>
+                </a:tc>
+                <a:tc>
+                  <a:txBody>
+                    <a:bodyPr wrap="square"/>
+                    <a:lstStyle/>
+                    <a:p>
+                      <a:pPr algn="r"/>
+                      <a:r>
+                        <a:rPr sz="1200" b="1">
+                          <a:solidFill>
+                            <a:srgbClr val="333333"/>
+                          </a:solidFill>
+                        </a:rPr>
+                        <a:t>0.100</a:t>
                       </a:r>
                     </a:p>
                   </a:txBody>
@@ -27804,6 +27854,42 @@
                             <a:srgbClr val="333333"/>
                           </a:solidFill>
                         </a:rPr>
+                        <a:t>0.151</a:t>
+                      </a:r>
+                    </a:p>
+                  </a:txBody>
+                  <a:tcPr marL="54864" marR="54864" marT="27432" marB="27432" anchor="ctr">
+                    <a:lnL w="0">
+                      <a:noFill/>
+                    </a:lnL>
+                    <a:lnR w="0">
+                      <a:noFill/>
+                    </a:lnR>
+                    <a:lnT w="0">
+                      <a:noFill/>
+                    </a:lnT>
+                    <a:lnB w="6350">
+                      <a:solidFill>
+                        <a:srgbClr val="D9D3E3"/>
+                      </a:solidFill>
+                    </a:lnB>
+                    <a:solidFill>
+                      <a:srgbClr val="FFFFFF"/>
+                    </a:solidFill>
+                  </a:tcPr>
+                </a:tc>
+                <a:tc>
+                  <a:txBody>
+                    <a:bodyPr wrap="square"/>
+                    <a:lstStyle/>
+                    <a:p>
+                      <a:pPr algn="r"/>
+                      <a:r>
+                        <a:rPr sz="1200" b="1">
+                          <a:solidFill>
+                            <a:srgbClr val="333333"/>
+                          </a:solidFill>
+                        </a:rPr>
                         <a:t>0.31</a:t>
                       </a:r>
                     </a:p>
@@ -28022,6 +28108,42 @@
                             <a:srgbClr val="333333"/>
                           </a:solidFill>
                         </a:rPr>
+                        <a:t>0.188</a:t>
+                      </a:r>
+                    </a:p>
+                  </a:txBody>
+                  <a:tcPr marL="54864" marR="54864" marT="27432" marB="27432" anchor="ctr">
+                    <a:lnL w="0">
+                      <a:noFill/>
+                    </a:lnL>
+                    <a:lnR w="0">
+                      <a:noFill/>
+                    </a:lnR>
+                    <a:lnT w="0">
+                      <a:noFill/>
+                    </a:lnT>
+                    <a:lnB w="6350">
+                      <a:solidFill>
+                        <a:srgbClr val="D9D3E3"/>
+                      </a:solidFill>
+                    </a:lnB>
+                    <a:solidFill>
+                      <a:srgbClr val="FFFFFF"/>
+                    </a:solidFill>
+                  </a:tcPr>
+                </a:tc>
+                <a:tc>
+                  <a:txBody>
+                    <a:bodyPr wrap="square"/>
+                    <a:lstStyle/>
+                    <a:p>
+                      <a:pPr algn="r"/>
+                      <a:r>
+                        <a:rPr sz="1200" b="0">
+                          <a:solidFill>
+                            <a:srgbClr val="333333"/>
+                          </a:solidFill>
+                        </a:rPr>
                         <a:t>0.32</a:t>
                       </a:r>
                     </a:p>
@@ -28232,7 +28354,7 @@
                   <a:srgbClr val="333333"/>
                 </a:solidFill>
               </a:rPr>
-              <a:t>Bold = better. ElasticNet: we win all five, DEM MSE included. BP: we win W1 and AIA MSE; the DEM error is set by flare cores (Part 7).</a:t>
+              <a:t>Bold = better. ElasticNet: we win all six, DEM MAE and MSE included. BP: we win W1 and AIA MSE; the DEM error is set by flare cores (Part 7).</a:t>
             </a:r>
           </a:p>
         </p:txBody>
@@ -28656,14 +28778,47 @@
       <p:grpSpPr/>
       <p:sp>
         <p:nvSpPr>
-          <p:cNvPr id="2" name="TextBox 1"/>
+          <p:cNvPr id="2" name="Title 1"/>
+          <p:cNvSpPr>
+            <a:spLocks noGrp="1"/>
+          </p:cNvSpPr>
+          <p:nvPr>
+            <p:ph type="title"/>
+          </p:nvPr>
+        </p:nvSpPr>
+        <p:spPr>
+          <a:xfrm>
+            <a:off x="311700" y="846450"/>
+            <a:ext cx="8520600" cy="1671000"/>
+          </a:xfrm>
+        </p:spPr>
+        <p:txBody>
+          <a:bodyPr/>
+          <a:lstStyle/>
+          <a:p>
+            <a:pPr algn="ctr"/>
+            <a:r>
+              <a:rPr sz="4100"/>
+              <a:t>Part 7</a:t>
+            </a:r>
+            <a:br/>
+            <a:r>
+              <a:rPr sz="4100"/>
+              <a:t>Failures: bright pixels</a:t>
+            </a:r>
+          </a:p>
+        </p:txBody>
+      </p:sp>
+      <p:sp>
+        <p:nvSpPr>
+          <p:cNvPr id="3" name="TextBox 2"/>
           <p:cNvSpPr txBox="1"/>
           <p:nvPr/>
         </p:nvSpPr>
         <p:spPr>
           <a:xfrm>
-            <a:off x="265176" y="219456"/>
-            <a:ext cx="8503920" cy="566928"/>
+            <a:off x="457200" y="2606040"/>
+            <a:ext cx="8229600" cy="457200"/>
           </a:xfrm>
           <a:prstGeom prst="rect">
             <a:avLst/>
@@ -28676,689 +28831,18 @@
           </a:bodyPr>
           <a:lstStyle/>
           <a:p>
-            <a:pPr algn="l">
+            <a:pPr algn="ctr">
               <a:spcAft>
                 <a:spcPts val="600"/>
               </a:spcAft>
             </a:pPr>
             <a:r>
-              <a:rPr sz="2000" b="1" i="0">
+              <a:rPr sz="1800" b="0" i="1">
                 <a:solidFill>
-                  <a:srgbClr val="57068C"/>
+                  <a:srgbClr val="6B6B6B"/>
                 </a:solidFill>
               </a:rPr>
-              <a:t>Multi-peaked DEMs: we find a quarter, within BP's own noise</a:t>
-            </a:r>
-          </a:p>
-        </p:txBody>
-      </p:sp>
-      <p:graphicFrame>
-        <p:nvGraphicFramePr>
-          <p:cNvPr id="3" name="Table 2"/>
-          <p:cNvGraphicFramePr>
-            <a:graphicFrameLocks noGrp="1"/>
-          </p:cNvGraphicFramePr>
-          <p:nvPr/>
-        </p:nvGraphicFramePr>
-        <p:xfrm>
-          <a:off x="365760" y="1005840"/>
-          <a:ext cx="5669280" cy="1463040"/>
-        </p:xfrm>
-        <a:graphic>
-          <a:graphicData uri="http://schemas.openxmlformats.org/drawingml/2006/table">
-            <a:tbl>
-              <a:tblPr firstRow="1" bandRow="1"/>
-              <a:tblGrid>
-                <a:gridCol w="1645920"/>
-                <a:gridCol w="1828800"/>
-                <a:gridCol w="1097280"/>
-                <a:gridCol w="1097280"/>
-              </a:tblGrid>
-              <a:tr h="365760">
-                <a:tc>
-                  <a:txBody>
-                    <a:bodyPr wrap="square"/>
-                    <a:lstStyle/>
-                    <a:p>
-                      <a:pPr algn="l"/>
-                      <a:r>
-                        <a:rPr sz="1200" b="1">
-                          <a:solidFill>
-                            <a:srgbClr val="FFFFFF"/>
-                          </a:solidFill>
-                        </a:rPr>
-                        <a:t>BP track</a:t>
-                      </a:r>
-                    </a:p>
-                  </a:txBody>
-                  <a:tcPr marL="54864" marR="54864" marT="27432" marB="27432" anchor="ctr">
-                    <a:lnL w="0">
-                      <a:noFill/>
-                    </a:lnL>
-                    <a:lnR w="0">
-                      <a:noFill/>
-                    </a:lnR>
-                    <a:lnT w="0">
-                      <a:noFill/>
-                    </a:lnT>
-                    <a:lnB w="6350">
-                      <a:solidFill>
-                        <a:srgbClr val="D9D3E3"/>
-                      </a:solidFill>
-                    </a:lnB>
-                    <a:solidFill>
-                      <a:srgbClr val="57068C"/>
-                    </a:solidFill>
-                  </a:tcPr>
-                </a:tc>
-                <a:tc>
-                  <a:txBody>
-                    <a:bodyPr wrap="square"/>
-                    <a:lstStyle/>
-                    <a:p>
-                      <a:pPr algn="r"/>
-                      <a:r>
-                        <a:rPr sz="1200" b="1">
-                          <a:solidFill>
-                            <a:srgbClr val="FFFFFF"/>
-                          </a:solidFill>
-                        </a:rPr>
-                        <a:t>Flagged multi-peaked</a:t>
-                      </a:r>
-                    </a:p>
-                  </a:txBody>
-                  <a:tcPr marL="54864" marR="54864" marT="27432" marB="27432" anchor="ctr">
-                    <a:lnL w="0">
-                      <a:noFill/>
-                    </a:lnL>
-                    <a:lnR w="0">
-                      <a:noFill/>
-                    </a:lnR>
-                    <a:lnT w="0">
-                      <a:noFill/>
-                    </a:lnT>
-                    <a:lnB w="6350">
-                      <a:solidFill>
-                        <a:srgbClr val="D9D3E3"/>
-                      </a:solidFill>
-                    </a:lnB>
-                    <a:solidFill>
-                      <a:srgbClr val="57068C"/>
-                    </a:solidFill>
-                  </a:tcPr>
-                </a:tc>
-                <a:tc>
-                  <a:txBody>
-                    <a:bodyPr wrap="square"/>
-                    <a:lstStyle/>
-                    <a:p>
-                      <a:pPr algn="r"/>
-                      <a:r>
-                        <a:rPr sz="1200" b="1">
-                          <a:solidFill>
-                            <a:srgbClr val="FFFFFF"/>
-                          </a:solidFill>
-                        </a:rPr>
-                        <a:t>Precision</a:t>
-                      </a:r>
-                    </a:p>
-                  </a:txBody>
-                  <a:tcPr marL="54864" marR="54864" marT="27432" marB="27432" anchor="ctr">
-                    <a:lnL w="0">
-                      <a:noFill/>
-                    </a:lnL>
-                    <a:lnR w="0">
-                      <a:noFill/>
-                    </a:lnR>
-                    <a:lnT w="0">
-                      <a:noFill/>
-                    </a:lnT>
-                    <a:lnB w="6350">
-                      <a:solidFill>
-                        <a:srgbClr val="D9D3E3"/>
-                      </a:solidFill>
-                    </a:lnB>
-                    <a:solidFill>
-                      <a:srgbClr val="57068C"/>
-                    </a:solidFill>
-                  </a:tcPr>
-                </a:tc>
-                <a:tc>
-                  <a:txBody>
-                    <a:bodyPr wrap="square"/>
-                    <a:lstStyle/>
-                    <a:p>
-                      <a:pPr algn="r"/>
-                      <a:r>
-                        <a:rPr sz="1200" b="1">
-                          <a:solidFill>
-                            <a:srgbClr val="FFFFFF"/>
-                          </a:solidFill>
-                        </a:rPr>
-                        <a:t>Recall</a:t>
-                      </a:r>
-                    </a:p>
-                  </a:txBody>
-                  <a:tcPr marL="54864" marR="54864" marT="27432" marB="27432" anchor="ctr">
-                    <a:lnL w="0">
-                      <a:noFill/>
-                    </a:lnL>
-                    <a:lnR w="0">
-                      <a:noFill/>
-                    </a:lnR>
-                    <a:lnT w="0">
-                      <a:noFill/>
-                    </a:lnT>
-                    <a:lnB w="6350">
-                      <a:solidFill>
-                        <a:srgbClr val="D9D3E3"/>
-                      </a:solidFill>
-                    </a:lnB>
-                    <a:solidFill>
-                      <a:srgbClr val="57068C"/>
-                    </a:solidFill>
-                  </a:tcPr>
-                </a:tc>
-              </a:tr>
-              <a:tr h="365760">
-                <a:tc>
-                  <a:txBody>
-                    <a:bodyPr wrap="square"/>
-                    <a:lstStyle/>
-                    <a:p>
-                      <a:pPr algn="l"/>
-                      <a:r>
-                        <a:rPr sz="1200" b="1">
-                          <a:solidFill>
-                            <a:srgbClr val="333333"/>
-                          </a:solidFill>
-                        </a:rPr>
-                        <a:t>Solver (BP)</a:t>
-                      </a:r>
-                    </a:p>
-                  </a:txBody>
-                  <a:tcPr marL="54864" marR="54864" marT="27432" marB="27432" anchor="ctr">
-                    <a:lnL w="0">
-                      <a:noFill/>
-                    </a:lnL>
-                    <a:lnR w="0">
-                      <a:noFill/>
-                    </a:lnR>
-                    <a:lnT w="0">
-                      <a:noFill/>
-                    </a:lnT>
-                    <a:lnB w="6350">
-                      <a:solidFill>
-                        <a:srgbClr val="D9D3E3"/>
-                      </a:solidFill>
-                    </a:lnB>
-                    <a:solidFill>
-                      <a:srgbClr val="FFFFFF"/>
-                    </a:solidFill>
-                  </a:tcPr>
-                </a:tc>
-                <a:tc>
-                  <a:txBody>
-                    <a:bodyPr wrap="square"/>
-                    <a:lstStyle/>
-                    <a:p>
-                      <a:pPr algn="r"/>
-                      <a:r>
-                        <a:rPr sz="1200" b="0">
-                          <a:solidFill>
-                            <a:srgbClr val="333333"/>
-                          </a:solidFill>
-                        </a:rPr>
-                        <a:t>13.5% of pixels</a:t>
-                      </a:r>
-                    </a:p>
-                  </a:txBody>
-                  <a:tcPr marL="54864" marR="54864" marT="27432" marB="27432" anchor="ctr">
-                    <a:lnL w="0">
-                      <a:noFill/>
-                    </a:lnL>
-                    <a:lnR w="0">
-                      <a:noFill/>
-                    </a:lnR>
-                    <a:lnT w="0">
-                      <a:noFill/>
-                    </a:lnT>
-                    <a:lnB w="6350">
-                      <a:solidFill>
-                        <a:srgbClr val="D9D3E3"/>
-                      </a:solidFill>
-                    </a:lnB>
-                    <a:solidFill>
-                      <a:srgbClr val="FFFFFF"/>
-                    </a:solidFill>
-                  </a:tcPr>
-                </a:tc>
-                <a:tc>
-                  <a:txBody>
-                    <a:bodyPr wrap="square"/>
-                    <a:lstStyle/>
-                    <a:p>
-                      <a:pPr algn="r"/>
-                      <a:r>
-                        <a:rPr sz="1200" b="0">
-                          <a:solidFill>
-                            <a:srgbClr val="333333"/>
-                          </a:solidFill>
-                        </a:rPr>
-                        <a:t/>
-                      </a:r>
-                    </a:p>
-                  </a:txBody>
-                  <a:tcPr marL="54864" marR="54864" marT="27432" marB="27432" anchor="ctr">
-                    <a:lnL w="0">
-                      <a:noFill/>
-                    </a:lnL>
-                    <a:lnR w="0">
-                      <a:noFill/>
-                    </a:lnR>
-                    <a:lnT w="0">
-                      <a:noFill/>
-                    </a:lnT>
-                    <a:lnB w="6350">
-                      <a:solidFill>
-                        <a:srgbClr val="D9D3E3"/>
-                      </a:solidFill>
-                    </a:lnB>
-                    <a:solidFill>
-                      <a:srgbClr val="FFFFFF"/>
-                    </a:solidFill>
-                  </a:tcPr>
-                </a:tc>
-                <a:tc>
-                  <a:txBody>
-                    <a:bodyPr wrap="square"/>
-                    <a:lstStyle/>
-                    <a:p>
-                      <a:pPr algn="r"/>
-                      <a:r>
-                        <a:rPr sz="1200" b="0">
-                          <a:solidFill>
-                            <a:srgbClr val="333333"/>
-                          </a:solidFill>
-                        </a:rPr>
-                        <a:t/>
-                      </a:r>
-                    </a:p>
-                  </a:txBody>
-                  <a:tcPr marL="54864" marR="54864" marT="27432" marB="27432" anchor="ctr">
-                    <a:lnL w="0">
-                      <a:noFill/>
-                    </a:lnL>
-                    <a:lnR w="0">
-                      <a:noFill/>
-                    </a:lnR>
-                    <a:lnT w="0">
-                      <a:noFill/>
-                    </a:lnT>
-                    <a:lnB w="6350">
-                      <a:solidFill>
-                        <a:srgbClr val="D9D3E3"/>
-                      </a:solidFill>
-                    </a:lnB>
-                    <a:solidFill>
-                      <a:srgbClr val="FFFFFF"/>
-                    </a:solidFill>
-                  </a:tcPr>
-                </a:tc>
-              </a:tr>
-              <a:tr h="365760">
-                <a:tc>
-                  <a:txBody>
-                    <a:bodyPr wrap="square"/>
-                    <a:lstStyle/>
-                    <a:p>
-                      <a:pPr algn="l"/>
-                      <a:r>
-                        <a:rPr sz="1200" b="1">
-                          <a:solidFill>
-                            <a:srgbClr val="333333"/>
-                          </a:solidFill>
-                        </a:rPr>
-                        <a:t>Label-free</a:t>
-                      </a:r>
-                    </a:p>
-                  </a:txBody>
-                  <a:tcPr marL="54864" marR="54864" marT="27432" marB="27432" anchor="ctr">
-                    <a:lnL w="0">
-                      <a:noFill/>
-                    </a:lnL>
-                    <a:lnR w="0">
-                      <a:noFill/>
-                    </a:lnR>
-                    <a:lnT w="0">
-                      <a:noFill/>
-                    </a:lnT>
-                    <a:lnB w="6350">
-                      <a:solidFill>
-                        <a:srgbClr val="D9D3E3"/>
-                      </a:solidFill>
-                    </a:lnB>
-                    <a:solidFill>
-                      <a:srgbClr val="FFFFFF"/>
-                    </a:solidFill>
-                  </a:tcPr>
-                </a:tc>
-                <a:tc>
-                  <a:txBody>
-                    <a:bodyPr wrap="square"/>
-                    <a:lstStyle/>
-                    <a:p>
-                      <a:pPr algn="r"/>
-                      <a:r>
-                        <a:rPr sz="1200" b="0">
-                          <a:solidFill>
-                            <a:srgbClr val="333333"/>
-                          </a:solidFill>
-                        </a:rPr>
-                        <a:t>9.9%</a:t>
-                      </a:r>
-                    </a:p>
-                  </a:txBody>
-                  <a:tcPr marL="54864" marR="54864" marT="27432" marB="27432" anchor="ctr">
-                    <a:lnL w="0">
-                      <a:noFill/>
-                    </a:lnL>
-                    <a:lnR w="0">
-                      <a:noFill/>
-                    </a:lnR>
-                    <a:lnT w="0">
-                      <a:noFill/>
-                    </a:lnT>
-                    <a:lnB w="6350">
-                      <a:solidFill>
-                        <a:srgbClr val="D9D3E3"/>
-                      </a:solidFill>
-                    </a:lnB>
-                    <a:solidFill>
-                      <a:srgbClr val="FFFFFF"/>
-                    </a:solidFill>
-                  </a:tcPr>
-                </a:tc>
-                <a:tc>
-                  <a:txBody>
-                    <a:bodyPr wrap="square"/>
-                    <a:lstStyle/>
-                    <a:p>
-                      <a:pPr algn="r"/>
-                      <a:r>
-                        <a:rPr sz="1200" b="0">
-                          <a:solidFill>
-                            <a:srgbClr val="333333"/>
-                          </a:solidFill>
-                        </a:rPr>
-                        <a:t>36%</a:t>
-                      </a:r>
-                    </a:p>
-                  </a:txBody>
-                  <a:tcPr marL="54864" marR="54864" marT="27432" marB="27432" anchor="ctr">
-                    <a:lnL w="0">
-                      <a:noFill/>
-                    </a:lnL>
-                    <a:lnR w="0">
-                      <a:noFill/>
-                    </a:lnR>
-                    <a:lnT w="0">
-                      <a:noFill/>
-                    </a:lnT>
-                    <a:lnB w="6350">
-                      <a:solidFill>
-                        <a:srgbClr val="D9D3E3"/>
-                      </a:solidFill>
-                    </a:lnB>
-                    <a:solidFill>
-                      <a:srgbClr val="FFFFFF"/>
-                    </a:solidFill>
-                  </a:tcPr>
-                </a:tc>
-                <a:tc>
-                  <a:txBody>
-                    <a:bodyPr wrap="square"/>
-                    <a:lstStyle/>
-                    <a:p>
-                      <a:pPr algn="r"/>
-                      <a:r>
-                        <a:rPr sz="1200" b="0">
-                          <a:solidFill>
-                            <a:srgbClr val="333333"/>
-                          </a:solidFill>
-                        </a:rPr>
-                        <a:t>26%</a:t>
-                      </a:r>
-                    </a:p>
-                  </a:txBody>
-                  <a:tcPr marL="54864" marR="54864" marT="27432" marB="27432" anchor="ctr">
-                    <a:lnL w="0">
-                      <a:noFill/>
-                    </a:lnL>
-                    <a:lnR w="0">
-                      <a:noFill/>
-                    </a:lnR>
-                    <a:lnT w="0">
-                      <a:noFill/>
-                    </a:lnT>
-                    <a:lnB w="6350">
-                      <a:solidFill>
-                        <a:srgbClr val="D9D3E3"/>
-                      </a:solidFill>
-                    </a:lnB>
-                    <a:solidFill>
-                      <a:srgbClr val="FFFFFF"/>
-                    </a:solidFill>
-                  </a:tcPr>
-                </a:tc>
-              </a:tr>
-              <a:tr h="365760">
-                <a:tc>
-                  <a:txBody>
-                    <a:bodyPr wrap="square"/>
-                    <a:lstStyle/>
-                    <a:p>
-                      <a:pPr algn="l"/>
-                      <a:r>
-                        <a:rPr sz="1200" b="1">
-                          <a:solidFill>
-                            <a:srgbClr val="333333"/>
-                          </a:solidFill>
-                        </a:rPr>
-                        <a:t>Supervised</a:t>
-                      </a:r>
-                    </a:p>
-                  </a:txBody>
-                  <a:tcPr marL="54864" marR="54864" marT="27432" marB="27432" anchor="ctr">
-                    <a:lnL w="0">
-                      <a:noFill/>
-                    </a:lnL>
-                    <a:lnR w="0">
-                      <a:noFill/>
-                    </a:lnR>
-                    <a:lnT w="0">
-                      <a:noFill/>
-                    </a:lnT>
-                    <a:lnB w="6350">
-                      <a:solidFill>
-                        <a:srgbClr val="D9D3E3"/>
-                      </a:solidFill>
-                    </a:lnB>
-                    <a:solidFill>
-                      <a:srgbClr val="FFFFFF"/>
-                    </a:solidFill>
-                  </a:tcPr>
-                </a:tc>
-                <a:tc>
-                  <a:txBody>
-                    <a:bodyPr wrap="square"/>
-                    <a:lstStyle/>
-                    <a:p>
-                      <a:pPr algn="r"/>
-                      <a:r>
-                        <a:rPr sz="1200" b="0">
-                          <a:solidFill>
-                            <a:srgbClr val="333333"/>
-                          </a:solidFill>
-                        </a:rPr>
-                        <a:t>41.1%</a:t>
-                      </a:r>
-                    </a:p>
-                  </a:txBody>
-                  <a:tcPr marL="54864" marR="54864" marT="27432" marB="27432" anchor="ctr">
-                    <a:lnL w="0">
-                      <a:noFill/>
-                    </a:lnL>
-                    <a:lnR w="0">
-                      <a:noFill/>
-                    </a:lnR>
-                    <a:lnT w="0">
-                      <a:noFill/>
-                    </a:lnT>
-                    <a:lnB w="6350">
-                      <a:solidFill>
-                        <a:srgbClr val="D9D3E3"/>
-                      </a:solidFill>
-                    </a:lnB>
-                    <a:solidFill>
-                      <a:srgbClr val="FFFFFF"/>
-                    </a:solidFill>
-                  </a:tcPr>
-                </a:tc>
-                <a:tc>
-                  <a:txBody>
-                    <a:bodyPr wrap="square"/>
-                    <a:lstStyle/>
-                    <a:p>
-                      <a:pPr algn="r"/>
-                      <a:r>
-                        <a:rPr sz="1200" b="0">
-                          <a:solidFill>
-                            <a:srgbClr val="333333"/>
-                          </a:solidFill>
-                        </a:rPr>
-                        <a:t>24%</a:t>
-                      </a:r>
-                    </a:p>
-                  </a:txBody>
-                  <a:tcPr marL="54864" marR="54864" marT="27432" marB="27432" anchor="ctr">
-                    <a:lnL w="0">
-                      <a:noFill/>
-                    </a:lnL>
-                    <a:lnR w="0">
-                      <a:noFill/>
-                    </a:lnR>
-                    <a:lnT w="0">
-                      <a:noFill/>
-                    </a:lnT>
-                    <a:lnB w="6350">
-                      <a:solidFill>
-                        <a:srgbClr val="D9D3E3"/>
-                      </a:solidFill>
-                    </a:lnB>
-                    <a:solidFill>
-                      <a:srgbClr val="FFFFFF"/>
-                    </a:solidFill>
-                  </a:tcPr>
-                </a:tc>
-                <a:tc>
-                  <a:txBody>
-                    <a:bodyPr wrap="square"/>
-                    <a:lstStyle/>
-                    <a:p>
-                      <a:pPr algn="r"/>
-                      <a:r>
-                        <a:rPr sz="1200" b="0">
-                          <a:solidFill>
-                            <a:srgbClr val="333333"/>
-                          </a:solidFill>
-                        </a:rPr>
-                        <a:t>72%</a:t>
-                      </a:r>
-                    </a:p>
-                  </a:txBody>
-                  <a:tcPr marL="54864" marR="54864" marT="27432" marB="27432" anchor="ctr">
-                    <a:lnL w="0">
-                      <a:noFill/>
-                    </a:lnL>
-                    <a:lnR w="0">
-                      <a:noFill/>
-                    </a:lnR>
-                    <a:lnT w="0">
-                      <a:noFill/>
-                    </a:lnT>
-                    <a:lnB w="6350">
-                      <a:solidFill>
-                        <a:srgbClr val="D9D3E3"/>
-                      </a:solidFill>
-                    </a:lnB>
-                    <a:solidFill>
-                      <a:srgbClr val="FFFFFF"/>
-                    </a:solidFill>
-                  </a:tcPr>
-                </a:tc>
-              </a:tr>
-            </a:tbl>
-          </a:graphicData>
-        </a:graphic>
-      </p:graphicFrame>
-      <p:sp>
-        <p:nvSpPr>
-          <p:cNvPr id="4" name="TextBox 3"/>
-          <p:cNvSpPr txBox="1"/>
-          <p:nvPr/>
-        </p:nvSpPr>
-        <p:spPr>
-          <a:xfrm>
-            <a:off x="365760" y="2697480"/>
-            <a:ext cx="8412480" cy="1280160"/>
-          </a:xfrm>
-          <a:prstGeom prst="rect">
-            <a:avLst/>
-          </a:prstGeom>
-          <a:noFill/>
-        </p:spPr>
-        <p:txBody>
-          <a:bodyPr wrap="square" anchor="t" lIns="0" rIns="0" tIns="0" bIns="0">
-            <a:spAutoFit/>
-          </a:bodyPr>
-          <a:lstStyle/>
-          <a:p>
-            <a:pPr algn="l" marL="182880" indent="-182880">
-              <a:spcAft>
-                <a:spcPts val="600"/>
-              </a:spcAft>
-              <a:buClr>
-                <a:srgbClr val="333333"/>
-              </a:buClr>
-              <a:buChar char="•"/>
-            </a:pPr>
-            <a:r>
-              <a:rPr sz="1250" b="0" i="0">
-                <a:solidFill>
-                  <a:srgbClr val="333333"/>
-                </a:solidFill>
-              </a:rPr>
-              <a:t>We flag few pixels and are right more often; the supervised model flags many and misses few.</a:t>
-            </a:r>
-          </a:p>
-          <a:p>
-            <a:pPr algn="l" marL="182880" indent="-182880">
-              <a:spcAft>
-                <a:spcPts val="600"/>
-              </a:spcAft>
-              <a:buClr>
-                <a:srgbClr val="333333"/>
-              </a:buClr>
-              <a:buChar char="•"/>
-            </a:pPr>
-            <a:r>
-              <a:rPr sz="1250" b="0" i="0">
-                <a:solidFill>
-                  <a:srgbClr val="333333"/>
-                </a:solidFill>
-              </a:rPr>
-              <a:t>Where BP is multi-peaked, our gap from BP is the size of BP's own re-solve scatter (0.97×): re-solving under photon noise moves BP's answer as much.</a:t>
+              <a:t>Where the error is, and why</a:t>
             </a:r>
           </a:p>
         </p:txBody>
@@ -29383,47 +28867,14 @@
       <p:grpSpPr/>
       <p:sp>
         <p:nvSpPr>
-          <p:cNvPr id="2" name="Title 1"/>
-          <p:cNvSpPr>
-            <a:spLocks noGrp="1"/>
-          </p:cNvSpPr>
-          <p:nvPr>
-            <p:ph type="title"/>
-          </p:nvPr>
-        </p:nvSpPr>
-        <p:spPr>
-          <a:xfrm>
-            <a:off x="311700" y="846450"/>
-            <a:ext cx="8520600" cy="1671000"/>
-          </a:xfrm>
-        </p:spPr>
-        <p:txBody>
-          <a:bodyPr/>
-          <a:lstStyle/>
-          <a:p>
-            <a:pPr algn="ctr"/>
-            <a:r>
-              <a:rPr sz="4100"/>
-              <a:t>Part 7</a:t>
-            </a:r>
-            <a:br/>
-            <a:r>
-              <a:rPr sz="4100"/>
-              <a:t>Failures: bright pixels</a:t>
-            </a:r>
-          </a:p>
-        </p:txBody>
-      </p:sp>
-      <p:sp>
-        <p:nvSpPr>
-          <p:cNvPr id="3" name="TextBox 2"/>
+          <p:cNvPr id="2" name="TextBox 1"/>
           <p:cNvSpPr txBox="1"/>
           <p:nvPr/>
         </p:nvSpPr>
         <p:spPr>
           <a:xfrm>
-            <a:off x="457200" y="2606040"/>
-            <a:ext cx="8229600" cy="457200"/>
+            <a:off x="265176" y="219456"/>
+            <a:ext cx="8503920" cy="566928"/>
           </a:xfrm>
           <a:prstGeom prst="rect">
             <a:avLst/>
@@ -29436,22 +28887,126 @@
           </a:bodyPr>
           <a:lstStyle/>
           <a:p>
-            <a:pPr algn="ctr">
+            <a:pPr algn="l">
               <a:spcAft>
                 <a:spcPts val="600"/>
               </a:spcAft>
             </a:pPr>
             <a:r>
-              <a:rPr sz="1800" b="0" i="1">
+              <a:rPr sz="2000" b="1" i="0">
                 <a:solidFill>
-                  <a:srgbClr val="6B6B6B"/>
+                  <a:srgbClr val="57068C"/>
                 </a:solidFill>
               </a:rPr>
-              <a:t>Where the error is, and why</a:t>
+              <a:t>Flare cores, 1 pixel in 10,000, hold ~90% of the BP error</a:t>
             </a:r>
           </a:p>
         </p:txBody>
       </p:sp>
+      <p:sp>
+        <p:nvSpPr>
+          <p:cNvPr id="3" name="TextBox 2"/>
+          <p:cNvSpPr txBox="1"/>
+          <p:nvPr/>
+        </p:nvSpPr>
+        <p:spPr>
+          <a:xfrm>
+            <a:off x="365760" y="914400"/>
+            <a:ext cx="3200400" cy="3383280"/>
+          </a:xfrm>
+          <a:prstGeom prst="rect">
+            <a:avLst/>
+          </a:prstGeom>
+          <a:noFill/>
+        </p:spPr>
+        <p:txBody>
+          <a:bodyPr wrap="square" anchor="t" lIns="0" rIns="0" tIns="0" bIns="0">
+            <a:spAutoFit/>
+          </a:bodyPr>
+          <a:lstStyle/>
+          <a:p>
+            <a:pPr algn="l" marL="182880" indent="-182880">
+              <a:spcAft>
+                <a:spcPts val="1000"/>
+              </a:spcAft>
+              <a:buClr>
+                <a:srgbClr val="333333"/>
+              </a:buClr>
+              <a:buChar char="•"/>
+            </a:pPr>
+            <a:r>
+              <a:rPr sz="1250" b="0" i="0">
+                <a:solidFill>
+                  <a:srgbClr val="333333"/>
+                </a:solidFill>
+              </a:rPr>
+              <a:t>Pixels at 32× the Bright cutoff or more: 0.01% of pixels, 90% of our BP DEM error, 90% of the supervised model's.</a:t>
+            </a:r>
+          </a:p>
+          <a:p>
+            <a:pPr algn="l" marL="182880" indent="-182880">
+              <a:spcAft>
+                <a:spcPts val="1000"/>
+              </a:spcAft>
+              <a:buClr>
+                <a:srgbClr val="333333"/>
+              </a:buClr>
+              <a:buChar char="•"/>
+            </a:pPr>
+            <a:r>
+              <a:rPr sz="1250" b="0" i="0">
+                <a:solidFill>
+                  <a:srgbClr val="333333"/>
+                </a:solidFill>
+              </a:rPr>
+              <a:t>So the squared-error metric itself is set by flare cores, for both models.</a:t>
+            </a:r>
+          </a:p>
+          <a:p>
+            <a:pPr algn="l" marL="182880" indent="-182880">
+              <a:spcAft>
+                <a:spcPts val="1000"/>
+              </a:spcAft>
+              <a:buClr>
+                <a:srgbClr val="333333"/>
+              </a:buClr>
+              <a:buChar char="•"/>
+            </a:pPr>
+            <a:r>
+              <a:rPr sz="1250" b="0" i="0">
+                <a:solidFill>
+                  <a:srgbClr val="333333"/>
+                </a:solidFill>
+              </a:rPr>
+              <a:t>Ordinary Bright pixels (1–10×): 10% of pixels, 4% of our error (supervised 5.5%).</a:t>
+            </a:r>
+          </a:p>
+        </p:txBody>
+      </p:sp>
+      <p:pic>
+        <p:nvPicPr>
+          <p:cNvPr id="4" name="Picture 3" descr="fig1_error_share_by_brightness.png"/>
+          <p:cNvPicPr>
+            <a:picLocks noChangeAspect="1"/>
+          </p:cNvPicPr>
+          <p:nvPr/>
+        </p:nvPicPr>
+        <p:blipFill>
+          <a:blip r:embed="rId2"/>
+          <a:stretch>
+            <a:fillRect/>
+          </a:stretch>
+        </p:blipFill>
+        <p:spPr>
+          <a:xfrm>
+            <a:off x="3703320" y="1159727"/>
+            <a:ext cx="5074920" cy="2846906"/>
+          </a:xfrm>
+          <a:prstGeom prst="rect">
+            <a:avLst/>
+          </a:prstGeom>
+        </p:spPr>
+      </p:pic>
     </p:spTree>
   </p:cSld>
   <p:clrMapOvr>
@@ -29503,7 +29058,7 @@
                   <a:srgbClr val="57068C"/>
                 </a:solidFill>
               </a:rPr>
-              <a:t>Flare cores, 1 pixel in 10,000, hold ~90% of the BP error</a:t>
+              <a:t>On BP, our gap grows with brightness; on ElasticNet we are ahead</a:t>
             </a:r>
           </a:p>
         </p:txBody>
@@ -29516,8 +29071,8 @@
         </p:nvSpPr>
         <p:spPr>
           <a:xfrm>
-            <a:off x="365760" y="914400"/>
-            <a:ext cx="3200400" cy="3383280"/>
+            <a:off x="365760" y="868680"/>
+            <a:ext cx="8412480" cy="822960"/>
           </a:xfrm>
           <a:prstGeom prst="rect">
             <a:avLst/>
@@ -29532,7 +29087,7 @@
           <a:p>
             <a:pPr algn="l" marL="182880" indent="-182880">
               <a:spcAft>
-                <a:spcPts val="1000"/>
+                <a:spcPts val="400"/>
               </a:spcAft>
               <a:buClr>
                 <a:srgbClr val="333333"/>
@@ -29540,18 +29095,18 @@
               <a:buChar char="•"/>
             </a:pPr>
             <a:r>
-              <a:rPr sz="1250" b="0" i="0">
+              <a:rPr sz="1200" b="0" i="0">
                 <a:solidFill>
                   <a:srgbClr val="333333"/>
                 </a:solidFill>
               </a:rPr>
-              <a:t>Pixels at 32× the Bright cutoff or more: 0.01% of pixels, 90% of our BP DEM error, 90% of the supervised model's.</a:t>
+              <a:t>BP, our error / supervised: 0.64 on the faintest pixels, 1.8 at 0.3–1×, 5 at 3–10×, 18 at 10–32×.</a:t>
             </a:r>
           </a:p>
           <a:p>
             <a:pPr algn="l" marL="182880" indent="-182880">
               <a:spcAft>
-                <a:spcPts val="1000"/>
+                <a:spcPts val="400"/>
               </a:spcAft>
               <a:buClr>
                 <a:srgbClr val="333333"/>
@@ -29559,38 +29114,19 @@
               <a:buChar char="•"/>
             </a:pPr>
             <a:r>
-              <a:rPr sz="1250" b="0" i="0">
+              <a:rPr sz="1200" b="0" i="0">
                 <a:solidFill>
                   <a:srgbClr val="333333"/>
                 </a:solidFill>
               </a:rPr>
-              <a:t>So the squared-error metric itself is set by flare cores, for both models.</a:t>
-            </a:r>
-          </a:p>
-          <a:p>
-            <a:pPr algn="l" marL="182880" indent="-182880">
-              <a:spcAft>
-                <a:spcPts val="1000"/>
-              </a:spcAft>
-              <a:buClr>
-                <a:srgbClr val="333333"/>
-              </a:buClr>
-              <a:buChar char="•"/>
-            </a:pPr>
-            <a:r>
-              <a:rPr sz="1250" b="0" i="0">
-                <a:solidFill>
-                  <a:srgbClr val="333333"/>
-                </a:solidFill>
-              </a:rPr>
-              <a:t>Ordinary Bright pixels (1–10×): 10% of pixels, 4% of our error (supervised 5.5%).</a:t>
+              <a:t>ElasticNet: ours is ahead from 0.1× to 32× (0.5–1.0), level on the faintest, 1.3 at flare cores.</a:t>
             </a:r>
           </a:p>
         </p:txBody>
       </p:sp>
       <p:pic>
         <p:nvPicPr>
-          <p:cNvPr id="4" name="Picture 3" descr="fig1_error_share_by_brightness.png"/>
+          <p:cNvPr id="4" name="Picture 3" descr="fig2_relative_error_by_brightness.png"/>
           <p:cNvPicPr>
             <a:picLocks noChangeAspect="1"/>
           </p:cNvPicPr>
@@ -29604,8 +29140,8 @@
         </p:blipFill>
         <p:spPr>
           <a:xfrm>
-            <a:off x="3703320" y="1159727"/>
-            <a:ext cx="5074920" cy="2846906"/>
+            <a:off x="1435395" y="1691640"/>
+            <a:ext cx="6273209" cy="2697480"/>
           </a:xfrm>
           <a:prstGeom prst="rect">
             <a:avLst/>
@@ -29663,7 +29199,7 @@
                   <a:srgbClr val="57068C"/>
                 </a:solidFill>
               </a:rPr>
-              <a:t>On BP, our gap grows with brightness; on ElasticNet we are ahead</a:t>
+              <a:t>At BP flare cores, the model under-predicts and runs too cool</a:t>
             </a:r>
           </a:p>
         </p:txBody>
@@ -29676,8 +29212,8 @@
         </p:nvSpPr>
         <p:spPr>
           <a:xfrm>
-            <a:off x="365760" y="868680"/>
-            <a:ext cx="8412480" cy="822960"/>
+            <a:off x="365760" y="914400"/>
+            <a:ext cx="3291840" cy="3383280"/>
           </a:xfrm>
           <a:prstGeom prst="rect">
             <a:avLst/>
@@ -29692,7 +29228,7 @@
           <a:p>
             <a:pPr algn="l" marL="182880" indent="-182880">
               <a:spcAft>
-                <a:spcPts val="400"/>
+                <a:spcPts val="1000"/>
               </a:spcAft>
               <a:buClr>
                 <a:srgbClr val="333333"/>
@@ -29700,18 +29236,18 @@
               <a:buChar char="•"/>
             </a:pPr>
             <a:r>
-              <a:rPr sz="1200" b="0" i="0">
+              <a:rPr sz="1250" b="0" i="0">
                 <a:solidFill>
                   <a:srgbClr val="333333"/>
                 </a:solidFill>
               </a:rPr>
-              <a:t>BP, our error / supervised: 0.64 on the faintest pixels, 1.8 at 0.3–1×, 5 at 3–10×, 18 at 10–32×.</a:t>
+              <a:t>BP flare cores: 40% of the solver's emission, peak 23% as high, 0.2 dex too cool.</a:t>
             </a:r>
           </a:p>
           <a:p>
             <a:pPr algn="l" marL="182880" indent="-182880">
               <a:spcAft>
-                <a:spcPts val="400"/>
+                <a:spcPts val="1000"/>
               </a:spcAft>
               <a:buClr>
                 <a:srgbClr val="333333"/>
@@ -29719,40 +29255,97 @@
               <a:buChar char="•"/>
             </a:pPr>
             <a:r>
-              <a:rPr sz="1200" b="0" i="0">
+              <a:rPr sz="1250" b="0" i="0">
                 <a:solidFill>
                   <a:srgbClr val="333333"/>
                 </a:solidFill>
               </a:rPr>
-              <a:t>ElasticNet: ours is ahead from 0.1× to 32× (0.5–1.0), level on the faintest, 1.3 at flare cores.</a:t>
+              <a:t>83% of our flare-core DEMs have extra peaks (solver 18%); those spurious peaks are 42% of our BP error.</a:t>
+            </a:r>
+          </a:p>
+          <a:p>
+            <a:pPr algn="l" marL="182880" indent="-182880">
+              <a:spcAft>
+                <a:spcPts val="1000"/>
+              </a:spcAft>
+              <a:buClr>
+                <a:srgbClr val="333333"/>
+              </a:buClr>
+              <a:buChar char="•"/>
+            </a:pPr>
+            <a:r>
+              <a:rPr sz="1250" b="0" i="0">
+                <a:solidFill>
+                  <a:srgbClr val="333333"/>
+                </a:solidFill>
+              </a:rPr>
+              <a:t>It tracks the solver's peak height up to a peak of ~100, then falls away.</a:t>
             </a:r>
           </a:p>
         </p:txBody>
       </p:sp>
       <p:pic>
         <p:nvPicPr>
-          <p:cNvPr id="4" name="Picture 3" descr="fig2_relative_error_by_brightness.png"/>
+          <p:cNvPr id="4" name="Picture 3" descr="fig4_example_curves_bp.png"/>
           <p:cNvPicPr>
             <a:picLocks noChangeAspect="1"/>
           </p:cNvPicPr>
           <p:nvPr/>
         </p:nvPicPr>
         <p:blipFill>
-          <a:blip r:embed="rId2"/>
+          <a:blip r:embed="rId3"/>
           <a:stretch>
             <a:fillRect/>
           </a:stretch>
         </p:blipFill>
         <p:spPr>
           <a:xfrm>
-            <a:off x="1435395" y="1691640"/>
-            <a:ext cx="6273209" cy="2697480"/>
+            <a:off x="3749039" y="990600"/>
+            <a:ext cx="5029200" cy="3185160"/>
           </a:xfrm>
           <a:prstGeom prst="rect">
             <a:avLst/>
           </a:prstGeom>
         </p:spPr>
       </p:pic>
+      <p:sp>
+        <p:nvSpPr>
+          <p:cNvPr id="5" name="TextBox 4"/>
+          <p:cNvSpPr txBox="1"/>
+          <p:nvPr/>
+        </p:nvSpPr>
+        <p:spPr>
+          <a:xfrm>
+            <a:off x="3749039" y="4206240"/>
+            <a:ext cx="5029200" cy="274320"/>
+          </a:xfrm>
+          <a:prstGeom prst="rect">
+            <a:avLst/>
+          </a:prstGeom>
+          <a:noFill/>
+        </p:spPr>
+        <p:txBody>
+          <a:bodyPr wrap="square" anchor="t" lIns="0" rIns="0" tIns="0" bIns="0">
+            <a:spAutoFit/>
+          </a:bodyPr>
+          <a:lstStyle/>
+          <a:p>
+            <a:pPr algn="l">
+              <a:spcAft>
+                <a:spcPts val="0"/>
+              </a:spcAft>
+            </a:pPr>
+            <a:r>
+              <a:rPr sz="950" b="0" i="1">
+                <a:solidFill>
+                  <a:srgbClr val="6B6B6B"/>
+                </a:solidFill>
+              </a:rPr>
+              <a:t>Random BP pixels, top rows flare cores. Black solver, blue ours, orange supervised.</a:t>
+            </a:r>
+          </a:p>
+        </p:txBody>
+      </p:sp>
     </p:spTree>
   </p:cSld>
   <p:clrMapOvr>
@@ -29804,7 +29397,7 @@
                   <a:srgbClr val="57068C"/>
                 </a:solidFill>
               </a:rPr>
-              <a:t>At BP flare cores, the model under-predicts and runs too cool</a:t>
+              <a:t>At BP flare cores, the model fails its own objective</a:t>
             </a:r>
           </a:p>
         </p:txBody>
@@ -29817,8 +29410,8 @@
         </p:nvSpPr>
         <p:spPr>
           <a:xfrm>
-            <a:off x="365760" y="914400"/>
-            <a:ext cx="3291840" cy="3383280"/>
+            <a:off x="365760" y="868680"/>
+            <a:ext cx="8412480" cy="914400"/>
           </a:xfrm>
           <a:prstGeom prst="rect">
             <a:avLst/>
@@ -29833,7 +29426,7 @@
           <a:p>
             <a:pPr algn="l" marL="182880" indent="-182880">
               <a:spcAft>
-                <a:spcPts val="1000"/>
+                <a:spcPts val="400"/>
               </a:spcAft>
               <a:buClr>
                 <a:srgbClr val="333333"/>
@@ -29841,18 +29434,18 @@
               <a:buChar char="•"/>
             </a:pPr>
             <a:r>
-              <a:rPr sz="1250" b="0" i="0">
+              <a:rPr sz="1200" b="0" i="0">
                 <a:solidFill>
                   <a:srgbClr val="333333"/>
                 </a:solidFill>
               </a:rPr>
-              <a:t>BP flare cores: 40% of the solver's emission, peak 23% as high, 0.2 dex too cool.</a:t>
+              <a:t>BP: the solver's DEM reproduces 92% of the observed 94 Å; ours reproduces 23% (131 Å: 76%). The cool channels are fit to within a few percent.</a:t>
             </a:r>
           </a:p>
           <a:p>
             <a:pPr algn="l" marL="182880" indent="-182880">
               <a:spcAft>
-                <a:spcPts val="1000"/>
+                <a:spcPts val="400"/>
               </a:spcAft>
               <a:buClr>
                 <a:srgbClr val="333333"/>
@@ -29860,38 +29453,19 @@
               <a:buChar char="•"/>
             </a:pPr>
             <a:r>
-              <a:rPr sz="1250" b="0" i="0">
+              <a:rPr sz="1200" b="1" i="0">
                 <a:solidFill>
-                  <a:srgbClr val="333333"/>
+                  <a:srgbClr val="57068C"/>
                 </a:solidFill>
               </a:rPr>
-              <a:t>83% of our flare-core DEMs have extra peaks (solver 18%); those spurious peaks are 42% of our BP error.</a:t>
-            </a:r>
-          </a:p>
-          <a:p>
-            <a:pPr algn="l" marL="182880" indent="-182880">
-              <a:spcAft>
-                <a:spcPts val="1000"/>
-              </a:spcAft>
-              <a:buClr>
-                <a:srgbClr val="333333"/>
-              </a:buClr>
-              <a:buChar char="•"/>
-            </a:pPr>
-            <a:r>
-              <a:rPr sz="1250" b="0" i="0">
-                <a:solidFill>
-                  <a:srgbClr val="333333"/>
-                </a:solidFill>
-              </a:rPr>
-              <a:t>It tracks the solver's peak height up to a peak of ~100, then falls away.</a:t>
+              <a:t>So better DEMs exist inside our basis: a training problem, not a representation limit.</a:t>
             </a:r>
           </a:p>
         </p:txBody>
       </p:sp>
       <p:pic>
         <p:nvPicPr>
-          <p:cNvPr id="4" name="Picture 3" descr="fig4_example_curves_bp.png"/>
+          <p:cNvPr id="4" name="Picture 3" descr="fig5_aia_fit_flare_cores.png"/>
           <p:cNvPicPr>
             <a:picLocks noChangeAspect="1"/>
           </p:cNvPicPr>
@@ -29905,52 +29479,14 @@
         </p:blipFill>
         <p:spPr>
           <a:xfrm>
-            <a:off x="3749039" y="990600"/>
-            <a:ext cx="5029200" cy="3185160"/>
+            <a:off x="1334386" y="1737360"/>
+            <a:ext cx="6475227" cy="2651760"/>
           </a:xfrm>
           <a:prstGeom prst="rect">
             <a:avLst/>
           </a:prstGeom>
         </p:spPr>
       </p:pic>
-      <p:sp>
-        <p:nvSpPr>
-          <p:cNvPr id="5" name="TextBox 4"/>
-          <p:cNvSpPr txBox="1"/>
-          <p:nvPr/>
-        </p:nvSpPr>
-        <p:spPr>
-          <a:xfrm>
-            <a:off x="3749039" y="4206240"/>
-            <a:ext cx="5029200" cy="274320"/>
-          </a:xfrm>
-          <a:prstGeom prst="rect">
-            <a:avLst/>
-          </a:prstGeom>
-          <a:noFill/>
-        </p:spPr>
-        <p:txBody>
-          <a:bodyPr wrap="square" anchor="t" lIns="0" rIns="0" tIns="0" bIns="0">
-            <a:spAutoFit/>
-          </a:bodyPr>
-          <a:lstStyle/>
-          <a:p>
-            <a:pPr algn="l">
-              <a:spcAft>
-                <a:spcPts val="0"/>
-              </a:spcAft>
-            </a:pPr>
-            <a:r>
-              <a:rPr sz="950" b="0" i="1">
-                <a:solidFill>
-                  <a:srgbClr val="6B6B6B"/>
-                </a:solidFill>
-              </a:rPr>
-              <a:t>Random BP pixels, top rows flare cores. Black solver, blue ours, orange supervised.</a:t>
-            </a:r>
-          </a:p>
-        </p:txBody>
-      </p:sp>
     </p:spTree>
   </p:cSld>
   <p:clrMapOvr>
@@ -30002,21 +29538,67 @@
                   <a:srgbClr val="57068C"/>
                 </a:solidFill>
               </a:rPr>
-              <a:t>At BP flare cores, the model fails its own objective</a:t>
+              <a:t>Not solver noise, not missed double peaks</a:t>
             </a:r>
           </a:p>
         </p:txBody>
       </p:sp>
       <p:sp>
         <p:nvSpPr>
-          <p:cNvPr id="3" name="TextBox 2"/>
+          <p:cNvPr id="3" name="Rounded Rectangle 2"/>
+          <p:cNvSpPr/>
+          <p:nvPr/>
+        </p:nvSpPr>
+        <p:spPr>
+          <a:xfrm>
+            <a:off x="365760" y="1005840"/>
+            <a:ext cx="2651760" cy="1325880"/>
+          </a:xfrm>
+          <a:prstGeom prst="roundRect">
+            <a:avLst>
+              <a:gd name="adj" fmla="val 6000"/>
+            </a:avLst>
+          </a:prstGeom>
+          <a:solidFill>
+            <a:srgbClr val="F4F1F8"/>
+          </a:solidFill>
+          <a:ln>
+            <a:noFill/>
+          </a:ln>
+          <a:effectLst/>
+        </p:spPr>
+        <p:style>
+          <a:lnRef idx="1">
+            <a:schemeClr val="accent1"/>
+          </a:lnRef>
+          <a:fillRef idx="3">
+            <a:schemeClr val="accent1"/>
+          </a:fillRef>
+          <a:effectRef idx="2">
+            <a:schemeClr val="accent1"/>
+          </a:effectRef>
+          <a:fontRef idx="minor">
+            <a:schemeClr val="lt1"/>
+          </a:fontRef>
+        </p:style>
+        <p:txBody>
+          <a:bodyPr rtlCol="0" anchor="ctr"/>
+          <a:lstStyle/>
+          <a:p>
+            <a:pPr algn="ctr"/>
+          </a:p>
+        </p:txBody>
+      </p:sp>
+      <p:sp>
+        <p:nvSpPr>
+          <p:cNvPr id="4" name="TextBox 3"/>
           <p:cNvSpPr txBox="1"/>
           <p:nvPr/>
         </p:nvSpPr>
         <p:spPr>
           <a:xfrm>
-            <a:off x="365760" y="868680"/>
-            <a:ext cx="8412480" cy="914400"/>
+            <a:off x="502920" y="1115568"/>
+            <a:ext cx="2377440" cy="548640"/>
           </a:xfrm>
           <a:prstGeom prst="rect">
             <a:avLst/>
@@ -30029,9 +29611,207 @@
           </a:bodyPr>
           <a:lstStyle/>
           <a:p>
+            <a:pPr algn="ctr">
+              <a:spcAft>
+                <a:spcPts val="600"/>
+              </a:spcAft>
+            </a:pPr>
+            <a:r>
+              <a:rPr sz="2600" b="1" i="0">
+                <a:solidFill>
+                  <a:srgbClr val="57068C"/>
+                </a:solidFill>
+              </a:rPr>
+              <a:t>0.4%</a:t>
+            </a:r>
+          </a:p>
+        </p:txBody>
+      </p:sp>
+      <p:sp>
+        <p:nvSpPr>
+          <p:cNvPr id="5" name="TextBox 4"/>
+          <p:cNvSpPr txBox="1"/>
+          <p:nvPr/>
+        </p:nvSpPr>
+        <p:spPr>
+          <a:xfrm>
+            <a:off x="502920" y="1719072"/>
+            <a:ext cx="2377440" cy="548640"/>
+          </a:xfrm>
+          <a:prstGeom prst="rect">
+            <a:avLst/>
+          </a:prstGeom>
+          <a:noFill/>
+        </p:spPr>
+        <p:txBody>
+          <a:bodyPr wrap="square" anchor="t" lIns="0" rIns="0" tIns="0" bIns="0">
+            <a:spAutoFit/>
+          </a:bodyPr>
+          <a:lstStyle/>
+          <a:p>
+            <a:pPr algn="ctr">
+              <a:spcAft>
+                <a:spcPts val="600"/>
+              </a:spcAft>
+            </a:pPr>
+            <a:r>
+              <a:rPr sz="1050" b="0" i="0">
+                <a:solidFill>
+                  <a:srgbClr val="333333"/>
+                </a:solidFill>
+              </a:rPr>
+              <a:t>of our BP Bright error comes from the solver's own spread across its 5 targets (ENet 8%)</a:t>
+            </a:r>
+          </a:p>
+        </p:txBody>
+      </p:sp>
+      <p:sp>
+        <p:nvSpPr>
+          <p:cNvPr id="6" name="Rounded Rectangle 5"/>
+          <p:cNvSpPr/>
+          <p:nvPr/>
+        </p:nvSpPr>
+        <p:spPr>
+          <a:xfrm>
+            <a:off x="365760" y="2514600"/>
+            <a:ext cx="2651760" cy="1325880"/>
+          </a:xfrm>
+          <a:prstGeom prst="roundRect">
+            <a:avLst>
+              <a:gd name="adj" fmla="val 6000"/>
+            </a:avLst>
+          </a:prstGeom>
+          <a:solidFill>
+            <a:srgbClr val="F4F1F8"/>
+          </a:solidFill>
+          <a:ln>
+            <a:noFill/>
+          </a:ln>
+          <a:effectLst/>
+        </p:spPr>
+        <p:style>
+          <a:lnRef idx="1">
+            <a:schemeClr val="accent1"/>
+          </a:lnRef>
+          <a:fillRef idx="3">
+            <a:schemeClr val="accent1"/>
+          </a:fillRef>
+          <a:effectRef idx="2">
+            <a:schemeClr val="accent1"/>
+          </a:effectRef>
+          <a:fontRef idx="minor">
+            <a:schemeClr val="lt1"/>
+          </a:fontRef>
+        </p:style>
+        <p:txBody>
+          <a:bodyPr rtlCol="0" anchor="ctr"/>
+          <a:lstStyle/>
+          <a:p>
+            <a:pPr algn="ctr"/>
+          </a:p>
+        </p:txBody>
+      </p:sp>
+      <p:sp>
+        <p:nvSpPr>
+          <p:cNvPr id="7" name="TextBox 6"/>
+          <p:cNvSpPr txBox="1"/>
+          <p:nvPr/>
+        </p:nvSpPr>
+        <p:spPr>
+          <a:xfrm>
+            <a:off x="502920" y="2624328"/>
+            <a:ext cx="2377440" cy="548640"/>
+          </a:xfrm>
+          <a:prstGeom prst="rect">
+            <a:avLst/>
+          </a:prstGeom>
+          <a:noFill/>
+        </p:spPr>
+        <p:txBody>
+          <a:bodyPr wrap="square" anchor="t" lIns="0" rIns="0" tIns="0" bIns="0">
+            <a:spAutoFit/>
+          </a:bodyPr>
+          <a:lstStyle/>
+          <a:p>
+            <a:pPr algn="ctr">
+              <a:spcAft>
+                <a:spcPts val="600"/>
+              </a:spcAft>
+            </a:pPr>
+            <a:r>
+              <a:rPr sz="2600" b="1" i="0">
+                <a:solidFill>
+                  <a:srgbClr val="57068C"/>
+                </a:solidFill>
+              </a:rPr>
+              <a:t>1.2%</a:t>
+            </a:r>
+          </a:p>
+        </p:txBody>
+      </p:sp>
+      <p:sp>
+        <p:nvSpPr>
+          <p:cNvPr id="8" name="TextBox 7"/>
+          <p:cNvSpPr txBox="1"/>
+          <p:nvPr/>
+        </p:nvSpPr>
+        <p:spPr>
+          <a:xfrm>
+            <a:off x="502920" y="3227832"/>
+            <a:ext cx="2377440" cy="548640"/>
+          </a:xfrm>
+          <a:prstGeom prst="rect">
+            <a:avLst/>
+          </a:prstGeom>
+          <a:noFill/>
+        </p:spPr>
+        <p:txBody>
+          <a:bodyPr wrap="square" anchor="t" lIns="0" rIns="0" tIns="0" bIns="0">
+            <a:spAutoFit/>
+          </a:bodyPr>
+          <a:lstStyle/>
+          <a:p>
+            <a:pPr algn="ctr">
+              <a:spcAft>
+                <a:spcPts val="600"/>
+              </a:spcAft>
+            </a:pPr>
+            <a:r>
+              <a:rPr sz="1050" b="0" i="0">
+                <a:solidFill>
+                  <a:srgbClr val="333333"/>
+                </a:solidFill>
+              </a:rPr>
+              <a:t>of our BP error comes from missing the solver's second peak</a:t>
+            </a:r>
+          </a:p>
+        </p:txBody>
+      </p:sp>
+      <p:sp>
+        <p:nvSpPr>
+          <p:cNvPr id="9" name="TextBox 8"/>
+          <p:cNvSpPr txBox="1"/>
+          <p:nvPr/>
+        </p:nvSpPr>
+        <p:spPr>
+          <a:xfrm>
+            <a:off x="3337560" y="1005840"/>
+            <a:ext cx="5440680" cy="3108960"/>
+          </a:xfrm>
+          <a:prstGeom prst="rect">
+            <a:avLst/>
+          </a:prstGeom>
+          <a:noFill/>
+        </p:spPr>
+        <p:txBody>
+          <a:bodyPr wrap="square" anchor="t" lIns="0" rIns="0" tIns="0" bIns="0">
+            <a:spAutoFit/>
+          </a:bodyPr>
+          <a:lstStyle/>
+          <a:p>
             <a:pPr algn="l" marL="182880" indent="-182880">
               <a:spcAft>
-                <a:spcPts val="400"/>
+                <a:spcPts val="1200"/>
               </a:spcAft>
               <a:buClr>
                 <a:srgbClr val="333333"/>
@@ -30039,18 +29819,18 @@
               <a:buChar char="•"/>
             </a:pPr>
             <a:r>
-              <a:rPr sz="1200" b="0" i="0">
+              <a:rPr sz="1300" b="0" i="0">
                 <a:solidFill>
                   <a:srgbClr val="333333"/>
                 </a:solidFill>
               </a:rPr>
-              <a:t>BP: the solver's DEM reproduces 92% of the observed 94 Å; ours reproduces 23% (131 Å: 76%). The cool channels are fit to within a few percent.</a:t>
+              <a:t>Solver noise: re-solving under photon noise barely moves the solver at bright pixels, so it is not the label.</a:t>
             </a:r>
           </a:p>
           <a:p>
             <a:pPr algn="l" marL="182880" indent="-182880">
               <a:spcAft>
-                <a:spcPts val="400"/>
+                <a:spcPts val="1200"/>
               </a:spcAft>
               <a:buClr>
                 <a:srgbClr val="333333"/>
@@ -30058,40 +29838,35 @@
               <a:buChar char="•"/>
             </a:pPr>
             <a:r>
-              <a:rPr sz="1200" b="1" i="0">
+              <a:rPr sz="1300" b="0" i="0">
+                <a:solidFill>
+                  <a:srgbClr val="333333"/>
+                </a:solidFill>
+              </a:rPr>
+              <a:t>Missed double peaks: small.</a:t>
+            </a:r>
+          </a:p>
+          <a:p>
+            <a:pPr algn="l" marL="182880" indent="-182880">
+              <a:spcAft>
+                <a:spcPts val="1200"/>
+              </a:spcAft>
+              <a:buClr>
+                <a:srgbClr val="333333"/>
+              </a:buClr>
+              <a:buChar char="•"/>
+            </a:pPr>
+            <a:r>
+              <a:rPr sz="1300" b="1" i="0">
                 <a:solidFill>
                   <a:srgbClr val="57068C"/>
                 </a:solidFill>
               </a:rPr>
-              <a:t>So better DEMs exist inside our basis: a training problem, not a representation limit.</a:t>
+              <a:t>What remains is the BP flare-core shortfall and the spurious peaks.</a:t>
             </a:r>
           </a:p>
         </p:txBody>
       </p:sp>
-      <p:pic>
-        <p:nvPicPr>
-          <p:cNvPr id="4" name="Picture 3" descr="fig5_aia_fit_flare_cores.png"/>
-          <p:cNvPicPr>
-            <a:picLocks noChangeAspect="1"/>
-          </p:cNvPicPr>
-          <p:nvPr/>
-        </p:nvPicPr>
-        <p:blipFill>
-          <a:blip r:embed="rId3"/>
-          <a:stretch>
-            <a:fillRect/>
-          </a:stretch>
-        </p:blipFill>
-        <p:spPr>
-          <a:xfrm>
-            <a:off x="1334386" y="1737360"/>
-            <a:ext cx="6475227" cy="2651760"/>
-          </a:xfrm>
-          <a:prstGeom prst="rect">
-            <a:avLst/>
-          </a:prstGeom>
-        </p:spPr>
-      </p:pic>
     </p:spTree>
   </p:cSld>
   <p:clrMapOvr>
@@ -30112,14 +29887,47 @@
       <p:grpSpPr/>
       <p:sp>
         <p:nvSpPr>
-          <p:cNvPr id="2" name="TextBox 1"/>
+          <p:cNvPr id="2" name="Title 1"/>
+          <p:cNvSpPr>
+            <a:spLocks noGrp="1"/>
+          </p:cNvSpPr>
+          <p:nvPr>
+            <p:ph type="title"/>
+          </p:nvPr>
+        </p:nvSpPr>
+        <p:spPr>
+          <a:xfrm>
+            <a:off x="311700" y="846450"/>
+            <a:ext cx="8520600" cy="1671000"/>
+          </a:xfrm>
+        </p:spPr>
+        <p:txBody>
+          <a:bodyPr/>
+          <a:lstStyle/>
+          <a:p>
+            <a:pPr algn="ctr"/>
+            <a:r>
+              <a:rPr sz="4100"/>
+              <a:t>Part 8</a:t>
+            </a:r>
+            <a:br/>
+            <a:r>
+              <a:rPr sz="4100"/>
+              <a:t>Next steps</a:t>
+            </a:r>
+          </a:p>
+        </p:txBody>
+      </p:sp>
+      <p:sp>
+        <p:nvSpPr>
+          <p:cNvPr id="3" name="TextBox 2"/>
           <p:cNvSpPr txBox="1"/>
           <p:nvPr/>
         </p:nvSpPr>
         <p:spPr>
           <a:xfrm>
-            <a:off x="265176" y="219456"/>
-            <a:ext cx="8503920" cy="566928"/>
+            <a:off x="457200" y="2606040"/>
+            <a:ext cx="8229600" cy="457200"/>
           </a:xfrm>
           <a:prstGeom prst="rect">
             <a:avLst/>
@@ -30132,342 +29940,18 @@
           </a:bodyPr>
           <a:lstStyle/>
           <a:p>
-            <a:pPr algn="l">
+            <a:pPr algn="ctr">
               <a:spcAft>
                 <a:spcPts val="600"/>
               </a:spcAft>
             </a:pPr>
             <a:r>
-              <a:rPr sz="2000" b="1" i="0">
+              <a:rPr sz="1800" b="0" i="1">
                 <a:solidFill>
-                  <a:srgbClr val="57068C"/>
+                  <a:srgbClr val="6B6B6B"/>
                 </a:solidFill>
               </a:rPr>
-              <a:t>Not solver noise, not missed double peaks</a:t>
-            </a:r>
-          </a:p>
-        </p:txBody>
-      </p:sp>
-      <p:sp>
-        <p:nvSpPr>
-          <p:cNvPr id="3" name="Rounded Rectangle 2"/>
-          <p:cNvSpPr/>
-          <p:nvPr/>
-        </p:nvSpPr>
-        <p:spPr>
-          <a:xfrm>
-            <a:off x="365760" y="1005840"/>
-            <a:ext cx="2651760" cy="1325880"/>
-          </a:xfrm>
-          <a:prstGeom prst="roundRect">
-            <a:avLst>
-              <a:gd name="adj" fmla="val 6000"/>
-            </a:avLst>
-          </a:prstGeom>
-          <a:solidFill>
-            <a:srgbClr val="F4F1F8"/>
-          </a:solidFill>
-          <a:ln>
-            <a:noFill/>
-          </a:ln>
-          <a:effectLst/>
-        </p:spPr>
-        <p:style>
-          <a:lnRef idx="1">
-            <a:schemeClr val="accent1"/>
-          </a:lnRef>
-          <a:fillRef idx="3">
-            <a:schemeClr val="accent1"/>
-          </a:fillRef>
-          <a:effectRef idx="2">
-            <a:schemeClr val="accent1"/>
-          </a:effectRef>
-          <a:fontRef idx="minor">
-            <a:schemeClr val="lt1"/>
-          </a:fontRef>
-        </p:style>
-        <p:txBody>
-          <a:bodyPr rtlCol="0" anchor="ctr"/>
-          <a:lstStyle/>
-          <a:p>
-            <a:pPr algn="ctr"/>
-          </a:p>
-        </p:txBody>
-      </p:sp>
-      <p:sp>
-        <p:nvSpPr>
-          <p:cNvPr id="4" name="TextBox 3"/>
-          <p:cNvSpPr txBox="1"/>
-          <p:nvPr/>
-        </p:nvSpPr>
-        <p:spPr>
-          <a:xfrm>
-            <a:off x="502920" y="1115568"/>
-            <a:ext cx="2377440" cy="548640"/>
-          </a:xfrm>
-          <a:prstGeom prst="rect">
-            <a:avLst/>
-          </a:prstGeom>
-          <a:noFill/>
-        </p:spPr>
-        <p:txBody>
-          <a:bodyPr wrap="square" anchor="t" lIns="0" rIns="0" tIns="0" bIns="0">
-            <a:spAutoFit/>
-          </a:bodyPr>
-          <a:lstStyle/>
-          <a:p>
-            <a:pPr algn="ctr">
-              <a:spcAft>
-                <a:spcPts val="600"/>
-              </a:spcAft>
-            </a:pPr>
-            <a:r>
-              <a:rPr sz="2600" b="1" i="0">
-                <a:solidFill>
-                  <a:srgbClr val="57068C"/>
-                </a:solidFill>
-              </a:rPr>
-              <a:t>0.4%</a:t>
-            </a:r>
-          </a:p>
-        </p:txBody>
-      </p:sp>
-      <p:sp>
-        <p:nvSpPr>
-          <p:cNvPr id="5" name="TextBox 4"/>
-          <p:cNvSpPr txBox="1"/>
-          <p:nvPr/>
-        </p:nvSpPr>
-        <p:spPr>
-          <a:xfrm>
-            <a:off x="502920" y="1719072"/>
-            <a:ext cx="2377440" cy="548640"/>
-          </a:xfrm>
-          <a:prstGeom prst="rect">
-            <a:avLst/>
-          </a:prstGeom>
-          <a:noFill/>
-        </p:spPr>
-        <p:txBody>
-          <a:bodyPr wrap="square" anchor="t" lIns="0" rIns="0" tIns="0" bIns="0">
-            <a:spAutoFit/>
-          </a:bodyPr>
-          <a:lstStyle/>
-          <a:p>
-            <a:pPr algn="ctr">
-              <a:spcAft>
-                <a:spcPts val="600"/>
-              </a:spcAft>
-            </a:pPr>
-            <a:r>
-              <a:rPr sz="1050" b="0" i="0">
-                <a:solidFill>
-                  <a:srgbClr val="333333"/>
-                </a:solidFill>
-              </a:rPr>
-              <a:t>of our BP Bright error comes from the solver's own spread across its 5 targets (ENet 8%)</a:t>
-            </a:r>
-          </a:p>
-        </p:txBody>
-      </p:sp>
-      <p:sp>
-        <p:nvSpPr>
-          <p:cNvPr id="6" name="Rounded Rectangle 5"/>
-          <p:cNvSpPr/>
-          <p:nvPr/>
-        </p:nvSpPr>
-        <p:spPr>
-          <a:xfrm>
-            <a:off x="365760" y="2514600"/>
-            <a:ext cx="2651760" cy="1325880"/>
-          </a:xfrm>
-          <a:prstGeom prst="roundRect">
-            <a:avLst>
-              <a:gd name="adj" fmla="val 6000"/>
-            </a:avLst>
-          </a:prstGeom>
-          <a:solidFill>
-            <a:srgbClr val="F4F1F8"/>
-          </a:solidFill>
-          <a:ln>
-            <a:noFill/>
-          </a:ln>
-          <a:effectLst/>
-        </p:spPr>
-        <p:style>
-          <a:lnRef idx="1">
-            <a:schemeClr val="accent1"/>
-          </a:lnRef>
-          <a:fillRef idx="3">
-            <a:schemeClr val="accent1"/>
-          </a:fillRef>
-          <a:effectRef idx="2">
-            <a:schemeClr val="accent1"/>
-          </a:effectRef>
-          <a:fontRef idx="minor">
-            <a:schemeClr val="lt1"/>
-          </a:fontRef>
-        </p:style>
-        <p:txBody>
-          <a:bodyPr rtlCol="0" anchor="ctr"/>
-          <a:lstStyle/>
-          <a:p>
-            <a:pPr algn="ctr"/>
-          </a:p>
-        </p:txBody>
-      </p:sp>
-      <p:sp>
-        <p:nvSpPr>
-          <p:cNvPr id="7" name="TextBox 6"/>
-          <p:cNvSpPr txBox="1"/>
-          <p:nvPr/>
-        </p:nvSpPr>
-        <p:spPr>
-          <a:xfrm>
-            <a:off x="502920" y="2624328"/>
-            <a:ext cx="2377440" cy="548640"/>
-          </a:xfrm>
-          <a:prstGeom prst="rect">
-            <a:avLst/>
-          </a:prstGeom>
-          <a:noFill/>
-        </p:spPr>
-        <p:txBody>
-          <a:bodyPr wrap="square" anchor="t" lIns="0" rIns="0" tIns="0" bIns="0">
-            <a:spAutoFit/>
-          </a:bodyPr>
-          <a:lstStyle/>
-          <a:p>
-            <a:pPr algn="ctr">
-              <a:spcAft>
-                <a:spcPts val="600"/>
-              </a:spcAft>
-            </a:pPr>
-            <a:r>
-              <a:rPr sz="2600" b="1" i="0">
-                <a:solidFill>
-                  <a:srgbClr val="57068C"/>
-                </a:solidFill>
-              </a:rPr>
-              <a:t>1.2%</a:t>
-            </a:r>
-          </a:p>
-        </p:txBody>
-      </p:sp>
-      <p:sp>
-        <p:nvSpPr>
-          <p:cNvPr id="8" name="TextBox 7"/>
-          <p:cNvSpPr txBox="1"/>
-          <p:nvPr/>
-        </p:nvSpPr>
-        <p:spPr>
-          <a:xfrm>
-            <a:off x="502920" y="3227832"/>
-            <a:ext cx="2377440" cy="548640"/>
-          </a:xfrm>
-          <a:prstGeom prst="rect">
-            <a:avLst/>
-          </a:prstGeom>
-          <a:noFill/>
-        </p:spPr>
-        <p:txBody>
-          <a:bodyPr wrap="square" anchor="t" lIns="0" rIns="0" tIns="0" bIns="0">
-            <a:spAutoFit/>
-          </a:bodyPr>
-          <a:lstStyle/>
-          <a:p>
-            <a:pPr algn="ctr">
-              <a:spcAft>
-                <a:spcPts val="600"/>
-              </a:spcAft>
-            </a:pPr>
-            <a:r>
-              <a:rPr sz="1050" b="0" i="0">
-                <a:solidFill>
-                  <a:srgbClr val="333333"/>
-                </a:solidFill>
-              </a:rPr>
-              <a:t>of our BP error comes from missing the solver's second peak</a:t>
-            </a:r>
-          </a:p>
-        </p:txBody>
-      </p:sp>
-      <p:sp>
-        <p:nvSpPr>
-          <p:cNvPr id="9" name="TextBox 8"/>
-          <p:cNvSpPr txBox="1"/>
-          <p:nvPr/>
-        </p:nvSpPr>
-        <p:spPr>
-          <a:xfrm>
-            <a:off x="3337560" y="1005840"/>
-            <a:ext cx="5440680" cy="3108960"/>
-          </a:xfrm>
-          <a:prstGeom prst="rect">
-            <a:avLst/>
-          </a:prstGeom>
-          <a:noFill/>
-        </p:spPr>
-        <p:txBody>
-          <a:bodyPr wrap="square" anchor="t" lIns="0" rIns="0" tIns="0" bIns="0">
-            <a:spAutoFit/>
-          </a:bodyPr>
-          <a:lstStyle/>
-          <a:p>
-            <a:pPr algn="l" marL="182880" indent="-182880">
-              <a:spcAft>
-                <a:spcPts val="1200"/>
-              </a:spcAft>
-              <a:buClr>
-                <a:srgbClr val="333333"/>
-              </a:buClr>
-              <a:buChar char="•"/>
-            </a:pPr>
-            <a:r>
-              <a:rPr sz="1300" b="0" i="0">
-                <a:solidFill>
-                  <a:srgbClr val="333333"/>
-                </a:solidFill>
-              </a:rPr>
-              <a:t>Solver noise: re-solving under photon noise barely moves the solver at bright pixels, so it is not the label.</a:t>
-            </a:r>
-          </a:p>
-          <a:p>
-            <a:pPr algn="l" marL="182880" indent="-182880">
-              <a:spcAft>
-                <a:spcPts val="1200"/>
-              </a:spcAft>
-              <a:buClr>
-                <a:srgbClr val="333333"/>
-              </a:buClr>
-              <a:buChar char="•"/>
-            </a:pPr>
-            <a:r>
-              <a:rPr sz="1300" b="0" i="0">
-                <a:solidFill>
-                  <a:srgbClr val="333333"/>
-                </a:solidFill>
-              </a:rPr>
-              <a:t>Missed double peaks: small.</a:t>
-            </a:r>
-          </a:p>
-          <a:p>
-            <a:pPr algn="l" marL="182880" indent="-182880">
-              <a:spcAft>
-                <a:spcPts val="1200"/>
-              </a:spcAft>
-              <a:buClr>
-                <a:srgbClr val="333333"/>
-              </a:buClr>
-              <a:buChar char="•"/>
-            </a:pPr>
-            <a:r>
-              <a:rPr sz="1300" b="1" i="0">
-                <a:solidFill>
-                  <a:srgbClr val="57068C"/>
-                </a:solidFill>
-              </a:rPr>
-              <a:t>What remains is the BP flare-core shortfall and the spurious peaks.</a:t>
+              <a:t>What we learned, and what to decide</a:t>
             </a:r>
           </a:p>
         </p:txBody>
@@ -30581,47 +30065,14 @@
       <p:grpSpPr/>
       <p:sp>
         <p:nvSpPr>
-          <p:cNvPr id="2" name="Title 1"/>
-          <p:cNvSpPr>
-            <a:spLocks noGrp="1"/>
-          </p:cNvSpPr>
-          <p:nvPr>
-            <p:ph type="title"/>
-          </p:nvPr>
-        </p:nvSpPr>
-        <p:spPr>
-          <a:xfrm>
-            <a:off x="311700" y="846450"/>
-            <a:ext cx="8520600" cy="1671000"/>
-          </a:xfrm>
-        </p:spPr>
-        <p:txBody>
-          <a:bodyPr/>
-          <a:lstStyle/>
-          <a:p>
-            <a:pPr algn="ctr"/>
-            <a:r>
-              <a:rPr sz="4100"/>
-              <a:t>Part 8</a:t>
-            </a:r>
-            <a:br/>
-            <a:r>
-              <a:rPr sz="4100"/>
-              <a:t>Lessons and next steps</a:t>
-            </a:r>
-          </a:p>
-        </p:txBody>
-      </p:sp>
-      <p:sp>
-        <p:nvSpPr>
-          <p:cNvPr id="3" name="TextBox 2"/>
+          <p:cNvPr id="2" name="TextBox 1"/>
           <p:cNvSpPr txBox="1"/>
           <p:nvPr/>
         </p:nvSpPr>
         <p:spPr>
           <a:xfrm>
-            <a:off x="457200" y="2606040"/>
-            <a:ext cx="8229600" cy="457200"/>
+            <a:off x="265176" y="219456"/>
+            <a:ext cx="8503920" cy="566928"/>
           </a:xfrm>
           <a:prstGeom prst="rect">
             <a:avLst/>
@@ -30634,18 +30085,750 @@
           </a:bodyPr>
           <a:lstStyle/>
           <a:p>
-            <a:pPr algn="ctr">
+            <a:pPr algn="l">
               <a:spcAft>
                 <a:spcPts val="600"/>
               </a:spcAft>
             </a:pPr>
             <a:r>
-              <a:rPr sz="1800" b="0" i="1">
+              <a:rPr sz="2000" b="1" i="0">
                 <a:solidFill>
-                  <a:srgbClr val="6B6B6B"/>
+                  <a:srgbClr val="57068C"/>
                 </a:solidFill>
               </a:rPr>
-              <a:t>What we learned, and what to decide</a:t>
+              <a:t>What we learned</a:t>
+            </a:r>
+          </a:p>
+        </p:txBody>
+      </p:sp>
+      <p:sp>
+        <p:nvSpPr>
+          <p:cNvPr id="3" name="Rounded Rectangle 2"/>
+          <p:cNvSpPr/>
+          <p:nvPr/>
+        </p:nvSpPr>
+        <p:spPr>
+          <a:xfrm>
+            <a:off x="365760" y="1005840"/>
+            <a:ext cx="2682240" cy="1417320"/>
+          </a:xfrm>
+          <a:prstGeom prst="roundRect">
+            <a:avLst>
+              <a:gd name="adj" fmla="val 6000"/>
+            </a:avLst>
+          </a:prstGeom>
+          <a:solidFill>
+            <a:srgbClr val="F4F1F8"/>
+          </a:solidFill>
+          <a:ln>
+            <a:noFill/>
+          </a:ln>
+          <a:effectLst/>
+        </p:spPr>
+        <p:style>
+          <a:lnRef idx="1">
+            <a:schemeClr val="accent1"/>
+          </a:lnRef>
+          <a:fillRef idx="3">
+            <a:schemeClr val="accent1"/>
+          </a:fillRef>
+          <a:effectRef idx="2">
+            <a:schemeClr val="accent1"/>
+          </a:effectRef>
+          <a:fontRef idx="minor">
+            <a:schemeClr val="lt1"/>
+          </a:fontRef>
+        </p:style>
+        <p:txBody>
+          <a:bodyPr rtlCol="0" anchor="ctr"/>
+          <a:lstStyle/>
+          <a:p>
+            <a:pPr algn="ctr"/>
+          </a:p>
+        </p:txBody>
+      </p:sp>
+      <p:sp>
+        <p:nvSpPr>
+          <p:cNvPr id="4" name="TextBox 3"/>
+          <p:cNvSpPr txBox="1"/>
+          <p:nvPr/>
+        </p:nvSpPr>
+        <p:spPr>
+          <a:xfrm>
+            <a:off x="530352" y="1133856"/>
+            <a:ext cx="2353056" cy="320040"/>
+          </a:xfrm>
+          <a:prstGeom prst="rect">
+            <a:avLst/>
+          </a:prstGeom>
+          <a:noFill/>
+        </p:spPr>
+        <p:txBody>
+          <a:bodyPr wrap="square" anchor="t" lIns="0" rIns="0" tIns="0" bIns="0">
+            <a:spAutoFit/>
+          </a:bodyPr>
+          <a:lstStyle/>
+          <a:p>
+            <a:pPr algn="l">
+              <a:spcAft>
+                <a:spcPts val="600"/>
+              </a:spcAft>
+            </a:pPr>
+            <a:r>
+              <a:rPr sz="1300" b="1" i="0">
+                <a:solidFill>
+                  <a:srgbClr val="57068C"/>
+                </a:solidFill>
+              </a:rPr>
+              <a:t>1. Train on the objective</a:t>
+            </a:r>
+          </a:p>
+        </p:txBody>
+      </p:sp>
+      <p:sp>
+        <p:nvSpPr>
+          <p:cNvPr id="5" name="TextBox 4"/>
+          <p:cNvSpPr txBox="1"/>
+          <p:nvPr/>
+        </p:nvSpPr>
+        <p:spPr>
+          <a:xfrm>
+            <a:off x="530352" y="1481328"/>
+            <a:ext cx="2353056" cy="868680"/>
+          </a:xfrm>
+          <a:prstGeom prst="rect">
+            <a:avLst/>
+          </a:prstGeom>
+          <a:noFill/>
+        </p:spPr>
+        <p:txBody>
+          <a:bodyPr wrap="square" anchor="t" lIns="0" rIns="0" tIns="0" bIns="0">
+            <a:spAutoFit/>
+          </a:bodyPr>
+          <a:lstStyle/>
+          <a:p>
+            <a:pPr algn="l">
+              <a:spcAft>
+                <a:spcPts val="600"/>
+              </a:spcAft>
+            </a:pPr>
+            <a:r>
+              <a:rPr sz="1200" b="0" i="0">
+                <a:solidFill>
+                  <a:srgbClr val="333333"/>
+                </a:solidFill>
+              </a:rPr>
+              <a:t>The solver's own objective reproduces its DEMs without labels.</a:t>
+            </a:r>
+          </a:p>
+        </p:txBody>
+      </p:sp>
+      <p:sp>
+        <p:nvSpPr>
+          <p:cNvPr id="6" name="Rounded Rectangle 5"/>
+          <p:cNvSpPr/>
+          <p:nvPr/>
+        </p:nvSpPr>
+        <p:spPr>
+          <a:xfrm>
+            <a:off x="3230880" y="1005840"/>
+            <a:ext cx="2682240" cy="1417320"/>
+          </a:xfrm>
+          <a:prstGeom prst="roundRect">
+            <a:avLst>
+              <a:gd name="adj" fmla="val 6000"/>
+            </a:avLst>
+          </a:prstGeom>
+          <a:solidFill>
+            <a:srgbClr val="F4F1F8"/>
+          </a:solidFill>
+          <a:ln>
+            <a:noFill/>
+          </a:ln>
+          <a:effectLst/>
+        </p:spPr>
+        <p:style>
+          <a:lnRef idx="1">
+            <a:schemeClr val="accent1"/>
+          </a:lnRef>
+          <a:fillRef idx="3">
+            <a:schemeClr val="accent1"/>
+          </a:fillRef>
+          <a:effectRef idx="2">
+            <a:schemeClr val="accent1"/>
+          </a:effectRef>
+          <a:fontRef idx="minor">
+            <a:schemeClr val="lt1"/>
+          </a:fontRef>
+        </p:style>
+        <p:txBody>
+          <a:bodyPr rtlCol="0" anchor="ctr"/>
+          <a:lstStyle/>
+          <a:p>
+            <a:pPr algn="ctr"/>
+          </a:p>
+        </p:txBody>
+      </p:sp>
+      <p:sp>
+        <p:nvSpPr>
+          <p:cNvPr id="7" name="TextBox 6"/>
+          <p:cNvSpPr txBox="1"/>
+          <p:nvPr/>
+        </p:nvSpPr>
+        <p:spPr>
+          <a:xfrm>
+            <a:off x="3395472" y="1133856"/>
+            <a:ext cx="2353056" cy="320040"/>
+          </a:xfrm>
+          <a:prstGeom prst="rect">
+            <a:avLst/>
+          </a:prstGeom>
+          <a:noFill/>
+        </p:spPr>
+        <p:txBody>
+          <a:bodyPr wrap="square" anchor="t" lIns="0" rIns="0" tIns="0" bIns="0">
+            <a:spAutoFit/>
+          </a:bodyPr>
+          <a:lstStyle/>
+          <a:p>
+            <a:pPr algn="l">
+              <a:spcAft>
+                <a:spcPts val="600"/>
+              </a:spcAft>
+            </a:pPr>
+            <a:r>
+              <a:rPr sz="1300" b="1" i="0">
+                <a:solidFill>
+                  <a:srgbClr val="57068C"/>
+                </a:solidFill>
+              </a:rPr>
+              <a:t>2. Simple scales</a:t>
+            </a:r>
+          </a:p>
+        </p:txBody>
+      </p:sp>
+      <p:sp>
+        <p:nvSpPr>
+          <p:cNvPr id="8" name="TextBox 7"/>
+          <p:cNvSpPr txBox="1"/>
+          <p:nvPr/>
+        </p:nvSpPr>
+        <p:spPr>
+          <a:xfrm>
+            <a:off x="3395472" y="1481328"/>
+            <a:ext cx="2353056" cy="868680"/>
+          </a:xfrm>
+          <a:prstGeom prst="rect">
+            <a:avLst/>
+          </a:prstGeom>
+          <a:noFill/>
+        </p:spPr>
+        <p:txBody>
+          <a:bodyPr wrap="square" anchor="t" lIns="0" rIns="0" tIns="0" bIns="0">
+            <a:spAutoFit/>
+          </a:bodyPr>
+          <a:lstStyle/>
+          <a:p>
+            <a:pPr algn="l">
+              <a:spcAft>
+                <a:spcPts val="600"/>
+              </a:spcAft>
+            </a:pPr>
+            <a:r>
+              <a:rPr sz="1200" b="0" i="0">
+                <a:solidFill>
+                  <a:srgbClr val="333333"/>
+                </a:solidFill>
+              </a:rPr>
+              <a:t>A centre-pixel MLP; the patch CNN never won on unseen days.</a:t>
+            </a:r>
+          </a:p>
+        </p:txBody>
+      </p:sp>
+      <p:sp>
+        <p:nvSpPr>
+          <p:cNvPr id="9" name="Rounded Rectangle 8"/>
+          <p:cNvSpPr/>
+          <p:nvPr/>
+        </p:nvSpPr>
+        <p:spPr>
+          <a:xfrm>
+            <a:off x="6096000" y="1005840"/>
+            <a:ext cx="2682240" cy="1417320"/>
+          </a:xfrm>
+          <a:prstGeom prst="roundRect">
+            <a:avLst>
+              <a:gd name="adj" fmla="val 6000"/>
+            </a:avLst>
+          </a:prstGeom>
+          <a:solidFill>
+            <a:srgbClr val="F4F1F8"/>
+          </a:solidFill>
+          <a:ln>
+            <a:noFill/>
+          </a:ln>
+          <a:effectLst/>
+        </p:spPr>
+        <p:style>
+          <a:lnRef idx="1">
+            <a:schemeClr val="accent1"/>
+          </a:lnRef>
+          <a:fillRef idx="3">
+            <a:schemeClr val="accent1"/>
+          </a:fillRef>
+          <a:effectRef idx="2">
+            <a:schemeClr val="accent1"/>
+          </a:effectRef>
+          <a:fontRef idx="minor">
+            <a:schemeClr val="lt1"/>
+          </a:fontRef>
+        </p:style>
+        <p:txBody>
+          <a:bodyPr rtlCol="0" anchor="ctr"/>
+          <a:lstStyle/>
+          <a:p>
+            <a:pPr algn="ctr"/>
+          </a:p>
+        </p:txBody>
+      </p:sp>
+      <p:sp>
+        <p:nvSpPr>
+          <p:cNvPr id="10" name="TextBox 9"/>
+          <p:cNvSpPr txBox="1"/>
+          <p:nvPr/>
+        </p:nvSpPr>
+        <p:spPr>
+          <a:xfrm>
+            <a:off x="6260592" y="1133856"/>
+            <a:ext cx="2353056" cy="320040"/>
+          </a:xfrm>
+          <a:prstGeom prst="rect">
+            <a:avLst/>
+          </a:prstGeom>
+          <a:noFill/>
+        </p:spPr>
+        <p:txBody>
+          <a:bodyPr wrap="square" anchor="t" lIns="0" rIns="0" tIns="0" bIns="0">
+            <a:spAutoFit/>
+          </a:bodyPr>
+          <a:lstStyle/>
+          <a:p>
+            <a:pPr algn="l">
+              <a:spcAft>
+                <a:spcPts val="600"/>
+              </a:spcAft>
+            </a:pPr>
+            <a:r>
+              <a:rPr sz="1300" b="1" i="0">
+                <a:solidFill>
+                  <a:srgbClr val="57068C"/>
+                </a:solidFill>
+              </a:rPr>
+              <a:t>3. Size needs data</a:t>
+            </a:r>
+          </a:p>
+        </p:txBody>
+      </p:sp>
+      <p:sp>
+        <p:nvSpPr>
+          <p:cNvPr id="11" name="TextBox 10"/>
+          <p:cNvSpPr txBox="1"/>
+          <p:nvPr/>
+        </p:nvSpPr>
+        <p:spPr>
+          <a:xfrm>
+            <a:off x="6260592" y="1481328"/>
+            <a:ext cx="2353056" cy="868680"/>
+          </a:xfrm>
+          <a:prstGeom prst="rect">
+            <a:avLst/>
+          </a:prstGeom>
+          <a:noFill/>
+        </p:spPr>
+        <p:txBody>
+          <a:bodyPr wrap="square" anchor="t" lIns="0" rIns="0" tIns="0" bIns="0">
+            <a:spAutoFit/>
+          </a:bodyPr>
+          <a:lstStyle/>
+          <a:p>
+            <a:pPr algn="l">
+              <a:spcAft>
+                <a:spcPts val="600"/>
+              </a:spcAft>
+            </a:pPr>
+            <a:r>
+              <a:rPr sz="1200" b="0" i="0">
+                <a:solidFill>
+                  <a:srgbClr val="333333"/>
+                </a:solidFill>
+              </a:rPr>
+              <a:t>With one fixed 30M-pixel sample, nothing above 176k helped; with fresh pixels, size pays off up to 360k.</a:t>
+            </a:r>
+          </a:p>
+        </p:txBody>
+      </p:sp>
+      <p:sp>
+        <p:nvSpPr>
+          <p:cNvPr id="12" name="Rounded Rectangle 11"/>
+          <p:cNvSpPr/>
+          <p:nvPr/>
+        </p:nvSpPr>
+        <p:spPr>
+          <a:xfrm>
+            <a:off x="365760" y="2606040"/>
+            <a:ext cx="2682240" cy="1417320"/>
+          </a:xfrm>
+          <a:prstGeom prst="roundRect">
+            <a:avLst>
+              <a:gd name="adj" fmla="val 6000"/>
+            </a:avLst>
+          </a:prstGeom>
+          <a:solidFill>
+            <a:srgbClr val="F4F1F8"/>
+          </a:solidFill>
+          <a:ln>
+            <a:noFill/>
+          </a:ln>
+          <a:effectLst/>
+        </p:spPr>
+        <p:style>
+          <a:lnRef idx="1">
+            <a:schemeClr val="accent1"/>
+          </a:lnRef>
+          <a:fillRef idx="3">
+            <a:schemeClr val="accent1"/>
+          </a:fillRef>
+          <a:effectRef idx="2">
+            <a:schemeClr val="accent1"/>
+          </a:effectRef>
+          <a:fontRef idx="minor">
+            <a:schemeClr val="lt1"/>
+          </a:fontRef>
+        </p:style>
+        <p:txBody>
+          <a:bodyPr rtlCol="0" anchor="ctr"/>
+          <a:lstStyle/>
+          <a:p>
+            <a:pPr algn="ctr"/>
+          </a:p>
+        </p:txBody>
+      </p:sp>
+      <p:sp>
+        <p:nvSpPr>
+          <p:cNvPr id="13" name="TextBox 12"/>
+          <p:cNvSpPr txBox="1"/>
+          <p:nvPr/>
+        </p:nvSpPr>
+        <p:spPr>
+          <a:xfrm>
+            <a:off x="530352" y="2734056"/>
+            <a:ext cx="2353056" cy="320040"/>
+          </a:xfrm>
+          <a:prstGeom prst="rect">
+            <a:avLst/>
+          </a:prstGeom>
+          <a:noFill/>
+        </p:spPr>
+        <p:txBody>
+          <a:bodyPr wrap="square" anchor="t" lIns="0" rIns="0" tIns="0" bIns="0">
+            <a:spAutoFit/>
+          </a:bodyPr>
+          <a:lstStyle/>
+          <a:p>
+            <a:pPr algn="l">
+              <a:spcAft>
+                <a:spcPts val="600"/>
+              </a:spcAft>
+            </a:pPr>
+            <a:r>
+              <a:rPr sz="1300" b="1" i="0">
+                <a:solidFill>
+                  <a:srgbClr val="57068C"/>
+                </a:solidFill>
+              </a:rPr>
+              <a:t>4. Heavy tails</a:t>
+            </a:r>
+          </a:p>
+        </p:txBody>
+      </p:sp>
+      <p:sp>
+        <p:nvSpPr>
+          <p:cNvPr id="14" name="TextBox 13"/>
+          <p:cNvSpPr txBox="1"/>
+          <p:nvPr/>
+        </p:nvSpPr>
+        <p:spPr>
+          <a:xfrm>
+            <a:off x="530352" y="3081528"/>
+            <a:ext cx="2353056" cy="868680"/>
+          </a:xfrm>
+          <a:prstGeom prst="rect">
+            <a:avLst/>
+          </a:prstGeom>
+          <a:noFill/>
+        </p:spPr>
+        <p:txBody>
+          <a:bodyPr wrap="square" anchor="t" lIns="0" rIns="0" tIns="0" bIns="0">
+            <a:spAutoFit/>
+          </a:bodyPr>
+          <a:lstStyle/>
+          <a:p>
+            <a:pPr algn="l">
+              <a:spcAft>
+                <a:spcPts val="600"/>
+              </a:spcAft>
+            </a:pPr>
+            <a:r>
+              <a:rPr sz="1200" b="0" i="0">
+                <a:solidFill>
+                  <a:srgbClr val="333333"/>
+                </a:solidFill>
+              </a:rPr>
+              <a:t>Report medians and percentiles: a handful of pixels can own the mean, or blow up.</a:t>
+            </a:r>
+          </a:p>
+        </p:txBody>
+      </p:sp>
+      <p:sp>
+        <p:nvSpPr>
+          <p:cNvPr id="15" name="Rounded Rectangle 14"/>
+          <p:cNvSpPr/>
+          <p:nvPr/>
+        </p:nvSpPr>
+        <p:spPr>
+          <a:xfrm>
+            <a:off x="3230880" y="2606040"/>
+            <a:ext cx="2682240" cy="1417320"/>
+          </a:xfrm>
+          <a:prstGeom prst="roundRect">
+            <a:avLst>
+              <a:gd name="adj" fmla="val 6000"/>
+            </a:avLst>
+          </a:prstGeom>
+          <a:solidFill>
+            <a:srgbClr val="F4F1F8"/>
+          </a:solidFill>
+          <a:ln>
+            <a:noFill/>
+          </a:ln>
+          <a:effectLst/>
+        </p:spPr>
+        <p:style>
+          <a:lnRef idx="1">
+            <a:schemeClr val="accent1"/>
+          </a:lnRef>
+          <a:fillRef idx="3">
+            <a:schemeClr val="accent1"/>
+          </a:fillRef>
+          <a:effectRef idx="2">
+            <a:schemeClr val="accent1"/>
+          </a:effectRef>
+          <a:fontRef idx="minor">
+            <a:schemeClr val="lt1"/>
+          </a:fontRef>
+        </p:style>
+        <p:txBody>
+          <a:bodyPr rtlCol="0" anchor="ctr"/>
+          <a:lstStyle/>
+          <a:p>
+            <a:pPr algn="ctr"/>
+          </a:p>
+        </p:txBody>
+      </p:sp>
+      <p:sp>
+        <p:nvSpPr>
+          <p:cNvPr id="16" name="TextBox 15"/>
+          <p:cNvSpPr txBox="1"/>
+          <p:nvPr/>
+        </p:nvSpPr>
+        <p:spPr>
+          <a:xfrm>
+            <a:off x="3395472" y="2734056"/>
+            <a:ext cx="2353056" cy="320040"/>
+          </a:xfrm>
+          <a:prstGeom prst="rect">
+            <a:avLst/>
+          </a:prstGeom>
+          <a:noFill/>
+        </p:spPr>
+        <p:txBody>
+          <a:bodyPr wrap="square" anchor="t" lIns="0" rIns="0" tIns="0" bIns="0">
+            <a:spAutoFit/>
+          </a:bodyPr>
+          <a:lstStyle/>
+          <a:p>
+            <a:pPr algn="l">
+              <a:spcAft>
+                <a:spcPts val="600"/>
+              </a:spcAft>
+            </a:pPr>
+            <a:r>
+              <a:rPr sz="1300" b="1" i="0">
+                <a:solidFill>
+                  <a:srgbClr val="57068C"/>
+                </a:solidFill>
+              </a:rPr>
+              <a:t>5. The open failure</a:t>
+            </a:r>
+          </a:p>
+        </p:txBody>
+      </p:sp>
+      <p:sp>
+        <p:nvSpPr>
+          <p:cNvPr id="17" name="TextBox 16"/>
+          <p:cNvSpPr txBox="1"/>
+          <p:nvPr/>
+        </p:nvSpPr>
+        <p:spPr>
+          <a:xfrm>
+            <a:off x="3395472" y="3081528"/>
+            <a:ext cx="2353056" cy="868680"/>
+          </a:xfrm>
+          <a:prstGeom prst="rect">
+            <a:avLst/>
+          </a:prstGeom>
+          <a:noFill/>
+        </p:spPr>
+        <p:txBody>
+          <a:bodyPr wrap="square" anchor="t" lIns="0" rIns="0" tIns="0" bIns="0">
+            <a:spAutoFit/>
+          </a:bodyPr>
+          <a:lstStyle/>
+          <a:p>
+            <a:pPr algn="l">
+              <a:spcAft>
+                <a:spcPts val="600"/>
+              </a:spcAft>
+            </a:pPr>
+            <a:r>
+              <a:rPr sz="1200" b="0" i="0">
+                <a:solidFill>
+                  <a:srgbClr val="333333"/>
+                </a:solidFill>
+              </a:rPr>
+              <a:t>BP flare cores. The model misses the hot channels there: a training problem.</a:t>
+            </a:r>
+          </a:p>
+        </p:txBody>
+      </p:sp>
+      <p:sp>
+        <p:nvSpPr>
+          <p:cNvPr id="18" name="Rounded Rectangle 17"/>
+          <p:cNvSpPr/>
+          <p:nvPr/>
+        </p:nvSpPr>
+        <p:spPr>
+          <a:xfrm>
+            <a:off x="6096000" y="2606040"/>
+            <a:ext cx="2682240" cy="1417320"/>
+          </a:xfrm>
+          <a:prstGeom prst="roundRect">
+            <a:avLst>
+              <a:gd name="adj" fmla="val 6000"/>
+            </a:avLst>
+          </a:prstGeom>
+          <a:solidFill>
+            <a:srgbClr val="F4F1F8"/>
+          </a:solidFill>
+          <a:ln>
+            <a:noFill/>
+          </a:ln>
+          <a:effectLst/>
+        </p:spPr>
+        <p:style>
+          <a:lnRef idx="1">
+            <a:schemeClr val="accent1"/>
+          </a:lnRef>
+          <a:fillRef idx="3">
+            <a:schemeClr val="accent1"/>
+          </a:fillRef>
+          <a:effectRef idx="2">
+            <a:schemeClr val="accent1"/>
+          </a:effectRef>
+          <a:fontRef idx="minor">
+            <a:schemeClr val="lt1"/>
+          </a:fontRef>
+        </p:style>
+        <p:txBody>
+          <a:bodyPr rtlCol="0" anchor="ctr"/>
+          <a:lstStyle/>
+          <a:p>
+            <a:pPr algn="ctr"/>
+          </a:p>
+        </p:txBody>
+      </p:sp>
+      <p:sp>
+        <p:nvSpPr>
+          <p:cNvPr id="19" name="TextBox 18"/>
+          <p:cNvSpPr txBox="1"/>
+          <p:nvPr/>
+        </p:nvSpPr>
+        <p:spPr>
+          <a:xfrm>
+            <a:off x="6260592" y="2734056"/>
+            <a:ext cx="2353056" cy="320040"/>
+          </a:xfrm>
+          <a:prstGeom prst="rect">
+            <a:avLst/>
+          </a:prstGeom>
+          <a:noFill/>
+        </p:spPr>
+        <p:txBody>
+          <a:bodyPr wrap="square" anchor="t" lIns="0" rIns="0" tIns="0" bIns="0">
+            <a:spAutoFit/>
+          </a:bodyPr>
+          <a:lstStyle/>
+          <a:p>
+            <a:pPr algn="l">
+              <a:spcAft>
+                <a:spcPts val="600"/>
+              </a:spcAft>
+            </a:pPr>
+            <a:r>
+              <a:rPr sz="1300" b="1" i="0">
+                <a:solidFill>
+                  <a:srgbClr val="57068C"/>
+                </a:solidFill>
+              </a:rPr>
+              <a:t>6. Input encoding</a:t>
+            </a:r>
+          </a:p>
+        </p:txBody>
+      </p:sp>
+      <p:sp>
+        <p:nvSpPr>
+          <p:cNvPr id="20" name="TextBox 19"/>
+          <p:cNvSpPr txBox="1"/>
+          <p:nvPr/>
+        </p:nvSpPr>
+        <p:spPr>
+          <a:xfrm>
+            <a:off x="6260592" y="3081528"/>
+            <a:ext cx="2353056" cy="868680"/>
+          </a:xfrm>
+          <a:prstGeom prst="rect">
+            <a:avLst/>
+          </a:prstGeom>
+          <a:noFill/>
+        </p:spPr>
+        <p:txBody>
+          <a:bodyPr wrap="square" anchor="t" lIns="0" rIns="0" tIns="0" bIns="0">
+            <a:spAutoFit/>
+          </a:bodyPr>
+          <a:lstStyle/>
+          <a:p>
+            <a:pPr algn="l">
+              <a:spcAft>
+                <a:spcPts val="600"/>
+              </a:spcAft>
+            </a:pPr>
+            <a:r>
+              <a:rPr sz="1200" b="0" i="0">
+                <a:solidFill>
+                  <a:srgbClr val="333333"/>
+                </a:solidFill>
+              </a:rPr>
+              <a:t>The supervised model's √ + Fourier input lifts ElasticNet past the supervised model; on BP it changes nothing.</a:t>
             </a:r>
           </a:p>
         </p:txBody>
@@ -30701,7 +30884,7 @@
                   <a:srgbClr val="57068C"/>
                 </a:solidFill>
               </a:rPr>
-              <a:t>What we learned</a:t>
+              <a:t>Next</a:t>
             </a:r>
           </a:p>
         </p:txBody>
@@ -30715,7 +30898,7 @@
         <p:spPr>
           <a:xfrm>
             <a:off x="365760" y="1005840"/>
-            <a:ext cx="2682240" cy="1417320"/>
+            <a:ext cx="4114800" cy="1463040"/>
           </a:xfrm>
           <a:prstGeom prst="roundRect">
             <a:avLst>
@@ -30761,7 +30944,7 @@
         <p:spPr>
           <a:xfrm>
             <a:off x="530352" y="1133856"/>
-            <a:ext cx="2353056" cy="320040"/>
+            <a:ext cx="3785616" cy="320040"/>
           </a:xfrm>
           <a:prstGeom prst="rect">
             <a:avLst/>
@@ -30785,7 +30968,7 @@
                   <a:srgbClr val="57068C"/>
                 </a:solidFill>
               </a:rPr>
-              <a:t>1. Train on the objective</a:t>
+              <a:t>Flare cores</a:t>
             </a:r>
           </a:p>
         </p:txBody>
@@ -30799,7 +30982,7 @@
         <p:spPr>
           <a:xfrm>
             <a:off x="530352" y="1481328"/>
-            <a:ext cx="2353056" cy="868680"/>
+            <a:ext cx="3785616" cy="914400"/>
           </a:xfrm>
           <a:prstGeom prst="rect">
             <a:avLst/>
@@ -30818,12 +31001,12 @@
               </a:spcAft>
             </a:pPr>
             <a:r>
-              <a:rPr sz="1200" b="0" i="0">
+              <a:rPr sz="1300" b="0" i="0">
                 <a:solidFill>
                   <a:srgbClr val="333333"/>
                 </a:solidFill>
               </a:rPr>
-              <a:t>The solver's own objective reproduces its DEMs without labels.</a:t>
+              <a:t>BP: oversample or up-weight the brightest pixels. ElasticNet: keep big models from blowing up on rare pixels.</a:t>
             </a:r>
           </a:p>
         </p:txBody>
@@ -30836,8 +31019,8 @@
         </p:nvSpPr>
         <p:spPr>
           <a:xfrm>
-            <a:off x="3230880" y="1005840"/>
-            <a:ext cx="2682240" cy="1417320"/>
+            <a:off x="4663440" y="1005840"/>
+            <a:ext cx="4114800" cy="1463040"/>
           </a:xfrm>
           <a:prstGeom prst="roundRect">
             <a:avLst>
@@ -30882,8 +31065,8 @@
         </p:nvSpPr>
         <p:spPr>
           <a:xfrm>
-            <a:off x="3395472" y="1133856"/>
-            <a:ext cx="2353056" cy="320040"/>
+            <a:off x="4828032" y="1133856"/>
+            <a:ext cx="3785616" cy="320040"/>
           </a:xfrm>
           <a:prstGeom prst="rect">
             <a:avLst/>
@@ -30907,7 +31090,7 @@
                   <a:srgbClr val="57068C"/>
                 </a:solidFill>
               </a:rPr>
-              <a:t>2. Simple scales</a:t>
+              <a:t>Validate on every pixel</a:t>
             </a:r>
           </a:p>
         </p:txBody>
@@ -30920,8 +31103,8 @@
         </p:nvSpPr>
         <p:spPr>
           <a:xfrm>
-            <a:off x="3395472" y="1481328"/>
-            <a:ext cx="2353056" cy="868680"/>
+            <a:off x="4828032" y="1481328"/>
+            <a:ext cx="3785616" cy="914400"/>
           </a:xfrm>
           <a:prstGeom prst="rect">
             <a:avLst/>
@@ -30940,12 +31123,12 @@
               </a:spcAft>
             </a:pPr>
             <a:r>
-              <a:rPr sz="1200" b="0" i="0">
+              <a:rPr sz="1300" b="0" i="0">
                 <a:solidFill>
                   <a:srgbClr val="333333"/>
                 </a:solidFill>
               </a:rPr>
-              <a:t>A centre-pixel MLP; the patch CNN never won on unseen days.</a:t>
+              <a:t>A sampled validation set missed the ElasticNet blow-ups; score all pixels.</a:t>
             </a:r>
           </a:p>
         </p:txBody>
@@ -30958,8 +31141,8 @@
         </p:nvSpPr>
         <p:spPr>
           <a:xfrm>
-            <a:off x="6096000" y="1005840"/>
-            <a:ext cx="2682240" cy="1417320"/>
+            <a:off x="365760" y="2651760"/>
+            <a:ext cx="4114800" cy="1463040"/>
           </a:xfrm>
           <a:prstGeom prst="roundRect">
             <a:avLst>
@@ -31004,8 +31187,8 @@
         </p:nvSpPr>
         <p:spPr>
           <a:xfrm>
-            <a:off x="6260592" y="1133856"/>
-            <a:ext cx="2353056" cy="320040"/>
+            <a:off x="530352" y="2779776"/>
+            <a:ext cx="3785616" cy="320040"/>
           </a:xfrm>
           <a:prstGeom prst="rect">
             <a:avLst/>
@@ -31029,7 +31212,7 @@
                   <a:srgbClr val="57068C"/>
                 </a:solidFill>
               </a:rPr>
-              <a:t>3. Size needs data</a:t>
+              <a:t>Direct DEM output</a:t>
             </a:r>
           </a:p>
         </p:txBody>
@@ -31042,8 +31225,8 @@
         </p:nvSpPr>
         <p:spPr>
           <a:xfrm>
-            <a:off x="6260592" y="1481328"/>
-            <a:ext cx="2353056" cy="868680"/>
+            <a:off x="530352" y="3127248"/>
+            <a:ext cx="3785616" cy="914400"/>
           </a:xfrm>
           <a:prstGeom prst="rect">
             <a:avLst/>
@@ -31062,12 +31245,12 @@
               </a:spcAft>
             </a:pPr>
             <a:r>
-              <a:rPr sz="1200" b="0" i="0">
+              <a:rPr sz="1300" b="0" i="0">
                 <a:solidFill>
                   <a:srgbClr val="333333"/>
                 </a:solidFill>
               </a:rPr>
-              <a:t>With one fixed 30M-pixel sample, nothing above 176k helped; with fresh pixels, size pays off up to 360k.</a:t>
+              <a:t>Predict the 18 bins instead of 54 basis weights (deferred).</a:t>
             </a:r>
           </a:p>
         </p:txBody>
@@ -31080,8 +31263,8 @@
         </p:nvSpPr>
         <p:spPr>
           <a:xfrm>
-            <a:off x="365760" y="2606040"/>
-            <a:ext cx="2682240" cy="1417320"/>
+            <a:off x="4663440" y="2651760"/>
+            <a:ext cx="4114800" cy="1463040"/>
           </a:xfrm>
           <a:prstGeom prst="roundRect">
             <a:avLst>
@@ -31126,8 +31309,8 @@
         </p:nvSpPr>
         <p:spPr>
           <a:xfrm>
-            <a:off x="530352" y="2734056"/>
-            <a:ext cx="2353056" cy="320040"/>
+            <a:off x="4828032" y="2779776"/>
+            <a:ext cx="3785616" cy="320040"/>
           </a:xfrm>
           <a:prstGeom prst="rect">
             <a:avLst/>
@@ -31151,7 +31334,7 @@
                   <a:srgbClr val="57068C"/>
                 </a:solidFill>
               </a:rPr>
-              <a:t>4. Heavy tails</a:t>
+              <a:t>Uncertainty, AIA + XRT</a:t>
             </a:r>
           </a:p>
         </p:txBody>
@@ -31164,8 +31347,8 @@
         </p:nvSpPr>
         <p:spPr>
           <a:xfrm>
-            <a:off x="530352" y="3081528"/>
-            <a:ext cx="2353056" cy="868680"/>
+            <a:off x="4828032" y="3127248"/>
+            <a:ext cx="3785616" cy="914400"/>
           </a:xfrm>
           <a:prstGeom prst="rect">
             <a:avLst/>
@@ -31184,256 +31367,12 @@
               </a:spcAft>
             </a:pPr>
             <a:r>
-              <a:rPr sz="1200" b="0" i="0">
+              <a:rPr sz="1300" b="0" i="0">
                 <a:solidFill>
                   <a:srgbClr val="333333"/>
                 </a:solidFill>
               </a:rPr>
-              <a:t>Report medians and percentiles: a handful of pixels can own the mean, or blow up.</a:t>
-            </a:r>
-          </a:p>
-        </p:txBody>
-      </p:sp>
-      <p:sp>
-        <p:nvSpPr>
-          <p:cNvPr id="15" name="Rounded Rectangle 14"/>
-          <p:cNvSpPr/>
-          <p:nvPr/>
-        </p:nvSpPr>
-        <p:spPr>
-          <a:xfrm>
-            <a:off x="3230880" y="2606040"/>
-            <a:ext cx="2682240" cy="1417320"/>
-          </a:xfrm>
-          <a:prstGeom prst="roundRect">
-            <a:avLst>
-              <a:gd name="adj" fmla="val 6000"/>
-            </a:avLst>
-          </a:prstGeom>
-          <a:solidFill>
-            <a:srgbClr val="F4F1F8"/>
-          </a:solidFill>
-          <a:ln>
-            <a:noFill/>
-          </a:ln>
-          <a:effectLst/>
-        </p:spPr>
-        <p:style>
-          <a:lnRef idx="1">
-            <a:schemeClr val="accent1"/>
-          </a:lnRef>
-          <a:fillRef idx="3">
-            <a:schemeClr val="accent1"/>
-          </a:fillRef>
-          <a:effectRef idx="2">
-            <a:schemeClr val="accent1"/>
-          </a:effectRef>
-          <a:fontRef idx="minor">
-            <a:schemeClr val="lt1"/>
-          </a:fontRef>
-        </p:style>
-        <p:txBody>
-          <a:bodyPr rtlCol="0" anchor="ctr"/>
-          <a:lstStyle/>
-          <a:p>
-            <a:pPr algn="ctr"/>
-          </a:p>
-        </p:txBody>
-      </p:sp>
-      <p:sp>
-        <p:nvSpPr>
-          <p:cNvPr id="16" name="TextBox 15"/>
-          <p:cNvSpPr txBox="1"/>
-          <p:nvPr/>
-        </p:nvSpPr>
-        <p:spPr>
-          <a:xfrm>
-            <a:off x="3395472" y="2734056"/>
-            <a:ext cx="2353056" cy="320040"/>
-          </a:xfrm>
-          <a:prstGeom prst="rect">
-            <a:avLst/>
-          </a:prstGeom>
-          <a:noFill/>
-        </p:spPr>
-        <p:txBody>
-          <a:bodyPr wrap="square" anchor="t" lIns="0" rIns="0" tIns="0" bIns="0">
-            <a:spAutoFit/>
-          </a:bodyPr>
-          <a:lstStyle/>
-          <a:p>
-            <a:pPr algn="l">
-              <a:spcAft>
-                <a:spcPts val="600"/>
-              </a:spcAft>
-            </a:pPr>
-            <a:r>
-              <a:rPr sz="1300" b="1" i="0">
-                <a:solidFill>
-                  <a:srgbClr val="57068C"/>
-                </a:solidFill>
-              </a:rPr>
-              <a:t>5. The open failure</a:t>
-            </a:r>
-          </a:p>
-        </p:txBody>
-      </p:sp>
-      <p:sp>
-        <p:nvSpPr>
-          <p:cNvPr id="17" name="TextBox 16"/>
-          <p:cNvSpPr txBox="1"/>
-          <p:nvPr/>
-        </p:nvSpPr>
-        <p:spPr>
-          <a:xfrm>
-            <a:off x="3395472" y="3081528"/>
-            <a:ext cx="2353056" cy="868680"/>
-          </a:xfrm>
-          <a:prstGeom prst="rect">
-            <a:avLst/>
-          </a:prstGeom>
-          <a:noFill/>
-        </p:spPr>
-        <p:txBody>
-          <a:bodyPr wrap="square" anchor="t" lIns="0" rIns="0" tIns="0" bIns="0">
-            <a:spAutoFit/>
-          </a:bodyPr>
-          <a:lstStyle/>
-          <a:p>
-            <a:pPr algn="l">
-              <a:spcAft>
-                <a:spcPts val="600"/>
-              </a:spcAft>
-            </a:pPr>
-            <a:r>
-              <a:rPr sz="1200" b="0" i="0">
-                <a:solidFill>
-                  <a:srgbClr val="333333"/>
-                </a:solidFill>
-              </a:rPr>
-              <a:t>BP flare cores. The model misses the hot channels there: a training problem.</a:t>
-            </a:r>
-          </a:p>
-        </p:txBody>
-      </p:sp>
-      <p:sp>
-        <p:nvSpPr>
-          <p:cNvPr id="18" name="Rounded Rectangle 17"/>
-          <p:cNvSpPr/>
-          <p:nvPr/>
-        </p:nvSpPr>
-        <p:spPr>
-          <a:xfrm>
-            <a:off x="6096000" y="2606040"/>
-            <a:ext cx="2682240" cy="1417320"/>
-          </a:xfrm>
-          <a:prstGeom prst="roundRect">
-            <a:avLst>
-              <a:gd name="adj" fmla="val 6000"/>
-            </a:avLst>
-          </a:prstGeom>
-          <a:solidFill>
-            <a:srgbClr val="F4F1F8"/>
-          </a:solidFill>
-          <a:ln>
-            <a:noFill/>
-          </a:ln>
-          <a:effectLst/>
-        </p:spPr>
-        <p:style>
-          <a:lnRef idx="1">
-            <a:schemeClr val="accent1"/>
-          </a:lnRef>
-          <a:fillRef idx="3">
-            <a:schemeClr val="accent1"/>
-          </a:fillRef>
-          <a:effectRef idx="2">
-            <a:schemeClr val="accent1"/>
-          </a:effectRef>
-          <a:fontRef idx="minor">
-            <a:schemeClr val="lt1"/>
-          </a:fontRef>
-        </p:style>
-        <p:txBody>
-          <a:bodyPr rtlCol="0" anchor="ctr"/>
-          <a:lstStyle/>
-          <a:p>
-            <a:pPr algn="ctr"/>
-          </a:p>
-        </p:txBody>
-      </p:sp>
-      <p:sp>
-        <p:nvSpPr>
-          <p:cNvPr id="19" name="TextBox 18"/>
-          <p:cNvSpPr txBox="1"/>
-          <p:nvPr/>
-        </p:nvSpPr>
-        <p:spPr>
-          <a:xfrm>
-            <a:off x="6260592" y="2734056"/>
-            <a:ext cx="2353056" cy="320040"/>
-          </a:xfrm>
-          <a:prstGeom prst="rect">
-            <a:avLst/>
-          </a:prstGeom>
-          <a:noFill/>
-        </p:spPr>
-        <p:txBody>
-          <a:bodyPr wrap="square" anchor="t" lIns="0" rIns="0" tIns="0" bIns="0">
-            <a:spAutoFit/>
-          </a:bodyPr>
-          <a:lstStyle/>
-          <a:p>
-            <a:pPr algn="l">
-              <a:spcAft>
-                <a:spcPts val="600"/>
-              </a:spcAft>
-            </a:pPr>
-            <a:r>
-              <a:rPr sz="1300" b="1" i="0">
-                <a:solidFill>
-                  <a:srgbClr val="57068C"/>
-                </a:solidFill>
-              </a:rPr>
-              <a:t>6. Input encoding</a:t>
-            </a:r>
-          </a:p>
-        </p:txBody>
-      </p:sp>
-      <p:sp>
-        <p:nvSpPr>
-          <p:cNvPr id="20" name="TextBox 19"/>
-          <p:cNvSpPr txBox="1"/>
-          <p:nvPr/>
-        </p:nvSpPr>
-        <p:spPr>
-          <a:xfrm>
-            <a:off x="6260592" y="3081528"/>
-            <a:ext cx="2353056" cy="868680"/>
-          </a:xfrm>
-          <a:prstGeom prst="rect">
-            <a:avLst/>
-          </a:prstGeom>
-          <a:noFill/>
-        </p:spPr>
-        <p:txBody>
-          <a:bodyPr wrap="square" anchor="t" lIns="0" rIns="0" tIns="0" bIns="0">
-            <a:spAutoFit/>
-          </a:bodyPr>
-          <a:lstStyle/>
-          <a:p>
-            <a:pPr algn="l">
-              <a:spcAft>
-                <a:spcPts val="600"/>
-              </a:spcAft>
-            </a:pPr>
-            <a:r>
-              <a:rPr sz="1200" b="0" i="0">
-                <a:solidFill>
-                  <a:srgbClr val="333333"/>
-                </a:solidFill>
-              </a:rPr>
-              <a:t>The supervised model's √ + Fourier input lifts ElasticNet past the supervised model; on BP it changes nothing.</a:t>
+              <a:t>A distribution over DEMs from the noisy re-solves; XRT for the hot plasma.</a:t>
             </a:r>
           </a:p>
         </p:txBody>
@@ -31447,550 +31386,6 @@
 </file>
 
 <file path=ppt/slides/slide32.xml><?xml version="1.0" encoding="utf-8"?>
-<p:sld xmlns:a="http://schemas.openxmlformats.org/drawingml/2006/main" xmlns:p="http://schemas.openxmlformats.org/presentationml/2006/main" xmlns:r="http://schemas.openxmlformats.org/officeDocument/2006/relationships">
-  <p:cSld>
-    <p:spTree>
-      <p:nvGrpSpPr>
-        <p:cNvPr id="1" name=""/>
-        <p:cNvGrpSpPr/>
-        <p:nvPr/>
-      </p:nvGrpSpPr>
-      <p:grpSpPr/>
-      <p:sp>
-        <p:nvSpPr>
-          <p:cNvPr id="2" name="TextBox 1"/>
-          <p:cNvSpPr txBox="1"/>
-          <p:nvPr/>
-        </p:nvSpPr>
-        <p:spPr>
-          <a:xfrm>
-            <a:off x="265176" y="219456"/>
-            <a:ext cx="8503920" cy="566928"/>
-          </a:xfrm>
-          <a:prstGeom prst="rect">
-            <a:avLst/>
-          </a:prstGeom>
-          <a:noFill/>
-        </p:spPr>
-        <p:txBody>
-          <a:bodyPr wrap="square" anchor="t" lIns="0" rIns="0" tIns="0" bIns="0">
-            <a:spAutoFit/>
-          </a:bodyPr>
-          <a:lstStyle/>
-          <a:p>
-            <a:pPr algn="l">
-              <a:spcAft>
-                <a:spcPts val="600"/>
-              </a:spcAft>
-            </a:pPr>
-            <a:r>
-              <a:rPr sz="2000" b="1" i="0">
-                <a:solidFill>
-                  <a:srgbClr val="57068C"/>
-                </a:solidFill>
-              </a:rPr>
-              <a:t>Next</a:t>
-            </a:r>
-          </a:p>
-        </p:txBody>
-      </p:sp>
-      <p:sp>
-        <p:nvSpPr>
-          <p:cNvPr id="3" name="Rounded Rectangle 2"/>
-          <p:cNvSpPr/>
-          <p:nvPr/>
-        </p:nvSpPr>
-        <p:spPr>
-          <a:xfrm>
-            <a:off x="365760" y="1005840"/>
-            <a:ext cx="4114800" cy="1463040"/>
-          </a:xfrm>
-          <a:prstGeom prst="roundRect">
-            <a:avLst>
-              <a:gd name="adj" fmla="val 6000"/>
-            </a:avLst>
-          </a:prstGeom>
-          <a:solidFill>
-            <a:srgbClr val="F4F1F8"/>
-          </a:solidFill>
-          <a:ln>
-            <a:noFill/>
-          </a:ln>
-          <a:effectLst/>
-        </p:spPr>
-        <p:style>
-          <a:lnRef idx="1">
-            <a:schemeClr val="accent1"/>
-          </a:lnRef>
-          <a:fillRef idx="3">
-            <a:schemeClr val="accent1"/>
-          </a:fillRef>
-          <a:effectRef idx="2">
-            <a:schemeClr val="accent1"/>
-          </a:effectRef>
-          <a:fontRef idx="minor">
-            <a:schemeClr val="lt1"/>
-          </a:fontRef>
-        </p:style>
-        <p:txBody>
-          <a:bodyPr rtlCol="0" anchor="ctr"/>
-          <a:lstStyle/>
-          <a:p>
-            <a:pPr algn="ctr"/>
-          </a:p>
-        </p:txBody>
-      </p:sp>
-      <p:sp>
-        <p:nvSpPr>
-          <p:cNvPr id="4" name="TextBox 3"/>
-          <p:cNvSpPr txBox="1"/>
-          <p:nvPr/>
-        </p:nvSpPr>
-        <p:spPr>
-          <a:xfrm>
-            <a:off x="530352" y="1133856"/>
-            <a:ext cx="3785616" cy="320040"/>
-          </a:xfrm>
-          <a:prstGeom prst="rect">
-            <a:avLst/>
-          </a:prstGeom>
-          <a:noFill/>
-        </p:spPr>
-        <p:txBody>
-          <a:bodyPr wrap="square" anchor="t" lIns="0" rIns="0" tIns="0" bIns="0">
-            <a:spAutoFit/>
-          </a:bodyPr>
-          <a:lstStyle/>
-          <a:p>
-            <a:pPr algn="l">
-              <a:spcAft>
-                <a:spcPts val="600"/>
-              </a:spcAft>
-            </a:pPr>
-            <a:r>
-              <a:rPr sz="1300" b="1" i="0">
-                <a:solidFill>
-                  <a:srgbClr val="57068C"/>
-                </a:solidFill>
-              </a:rPr>
-              <a:t>Flare cores</a:t>
-            </a:r>
-          </a:p>
-        </p:txBody>
-      </p:sp>
-      <p:sp>
-        <p:nvSpPr>
-          <p:cNvPr id="5" name="TextBox 4"/>
-          <p:cNvSpPr txBox="1"/>
-          <p:nvPr/>
-        </p:nvSpPr>
-        <p:spPr>
-          <a:xfrm>
-            <a:off x="530352" y="1481328"/>
-            <a:ext cx="3785616" cy="914400"/>
-          </a:xfrm>
-          <a:prstGeom prst="rect">
-            <a:avLst/>
-          </a:prstGeom>
-          <a:noFill/>
-        </p:spPr>
-        <p:txBody>
-          <a:bodyPr wrap="square" anchor="t" lIns="0" rIns="0" tIns="0" bIns="0">
-            <a:spAutoFit/>
-          </a:bodyPr>
-          <a:lstStyle/>
-          <a:p>
-            <a:pPr algn="l">
-              <a:spcAft>
-                <a:spcPts val="600"/>
-              </a:spcAft>
-            </a:pPr>
-            <a:r>
-              <a:rPr sz="1300" b="0" i="0">
-                <a:solidFill>
-                  <a:srgbClr val="333333"/>
-                </a:solidFill>
-              </a:rPr>
-              <a:t>BP: oversample or up-weight the brightest pixels. ElasticNet: keep big models from blowing up on rare pixels.</a:t>
-            </a:r>
-          </a:p>
-        </p:txBody>
-      </p:sp>
-      <p:sp>
-        <p:nvSpPr>
-          <p:cNvPr id="6" name="Rounded Rectangle 5"/>
-          <p:cNvSpPr/>
-          <p:nvPr/>
-        </p:nvSpPr>
-        <p:spPr>
-          <a:xfrm>
-            <a:off x="4663440" y="1005840"/>
-            <a:ext cx="4114800" cy="1463040"/>
-          </a:xfrm>
-          <a:prstGeom prst="roundRect">
-            <a:avLst>
-              <a:gd name="adj" fmla="val 6000"/>
-            </a:avLst>
-          </a:prstGeom>
-          <a:solidFill>
-            <a:srgbClr val="F4F1F8"/>
-          </a:solidFill>
-          <a:ln>
-            <a:noFill/>
-          </a:ln>
-          <a:effectLst/>
-        </p:spPr>
-        <p:style>
-          <a:lnRef idx="1">
-            <a:schemeClr val="accent1"/>
-          </a:lnRef>
-          <a:fillRef idx="3">
-            <a:schemeClr val="accent1"/>
-          </a:fillRef>
-          <a:effectRef idx="2">
-            <a:schemeClr val="accent1"/>
-          </a:effectRef>
-          <a:fontRef idx="minor">
-            <a:schemeClr val="lt1"/>
-          </a:fontRef>
-        </p:style>
-        <p:txBody>
-          <a:bodyPr rtlCol="0" anchor="ctr"/>
-          <a:lstStyle/>
-          <a:p>
-            <a:pPr algn="ctr"/>
-          </a:p>
-        </p:txBody>
-      </p:sp>
-      <p:sp>
-        <p:nvSpPr>
-          <p:cNvPr id="7" name="TextBox 6"/>
-          <p:cNvSpPr txBox="1"/>
-          <p:nvPr/>
-        </p:nvSpPr>
-        <p:spPr>
-          <a:xfrm>
-            <a:off x="4828032" y="1133856"/>
-            <a:ext cx="3785616" cy="320040"/>
-          </a:xfrm>
-          <a:prstGeom prst="rect">
-            <a:avLst/>
-          </a:prstGeom>
-          <a:noFill/>
-        </p:spPr>
-        <p:txBody>
-          <a:bodyPr wrap="square" anchor="t" lIns="0" rIns="0" tIns="0" bIns="0">
-            <a:spAutoFit/>
-          </a:bodyPr>
-          <a:lstStyle/>
-          <a:p>
-            <a:pPr algn="l">
-              <a:spcAft>
-                <a:spcPts val="600"/>
-              </a:spcAft>
-            </a:pPr>
-            <a:r>
-              <a:rPr sz="1300" b="1" i="0">
-                <a:solidFill>
-                  <a:srgbClr val="57068C"/>
-                </a:solidFill>
-              </a:rPr>
-              <a:t>Validate on every pixel</a:t>
-            </a:r>
-          </a:p>
-        </p:txBody>
-      </p:sp>
-      <p:sp>
-        <p:nvSpPr>
-          <p:cNvPr id="8" name="TextBox 7"/>
-          <p:cNvSpPr txBox="1"/>
-          <p:nvPr/>
-        </p:nvSpPr>
-        <p:spPr>
-          <a:xfrm>
-            <a:off x="4828032" y="1481328"/>
-            <a:ext cx="3785616" cy="914400"/>
-          </a:xfrm>
-          <a:prstGeom prst="rect">
-            <a:avLst/>
-          </a:prstGeom>
-          <a:noFill/>
-        </p:spPr>
-        <p:txBody>
-          <a:bodyPr wrap="square" anchor="t" lIns="0" rIns="0" tIns="0" bIns="0">
-            <a:spAutoFit/>
-          </a:bodyPr>
-          <a:lstStyle/>
-          <a:p>
-            <a:pPr algn="l">
-              <a:spcAft>
-                <a:spcPts val="600"/>
-              </a:spcAft>
-            </a:pPr>
-            <a:r>
-              <a:rPr sz="1300" b="0" i="0">
-                <a:solidFill>
-                  <a:srgbClr val="333333"/>
-                </a:solidFill>
-              </a:rPr>
-              <a:t>A sampled validation set missed the ElasticNet blow-ups; score all pixels.</a:t>
-            </a:r>
-          </a:p>
-        </p:txBody>
-      </p:sp>
-      <p:sp>
-        <p:nvSpPr>
-          <p:cNvPr id="9" name="Rounded Rectangle 8"/>
-          <p:cNvSpPr/>
-          <p:nvPr/>
-        </p:nvSpPr>
-        <p:spPr>
-          <a:xfrm>
-            <a:off x="365760" y="2651760"/>
-            <a:ext cx="4114800" cy="1463040"/>
-          </a:xfrm>
-          <a:prstGeom prst="roundRect">
-            <a:avLst>
-              <a:gd name="adj" fmla="val 6000"/>
-            </a:avLst>
-          </a:prstGeom>
-          <a:solidFill>
-            <a:srgbClr val="F4F1F8"/>
-          </a:solidFill>
-          <a:ln>
-            <a:noFill/>
-          </a:ln>
-          <a:effectLst/>
-        </p:spPr>
-        <p:style>
-          <a:lnRef idx="1">
-            <a:schemeClr val="accent1"/>
-          </a:lnRef>
-          <a:fillRef idx="3">
-            <a:schemeClr val="accent1"/>
-          </a:fillRef>
-          <a:effectRef idx="2">
-            <a:schemeClr val="accent1"/>
-          </a:effectRef>
-          <a:fontRef idx="minor">
-            <a:schemeClr val="lt1"/>
-          </a:fontRef>
-        </p:style>
-        <p:txBody>
-          <a:bodyPr rtlCol="0" anchor="ctr"/>
-          <a:lstStyle/>
-          <a:p>
-            <a:pPr algn="ctr"/>
-          </a:p>
-        </p:txBody>
-      </p:sp>
-      <p:sp>
-        <p:nvSpPr>
-          <p:cNvPr id="10" name="TextBox 9"/>
-          <p:cNvSpPr txBox="1"/>
-          <p:nvPr/>
-        </p:nvSpPr>
-        <p:spPr>
-          <a:xfrm>
-            <a:off x="530352" y="2779776"/>
-            <a:ext cx="3785616" cy="320040"/>
-          </a:xfrm>
-          <a:prstGeom prst="rect">
-            <a:avLst/>
-          </a:prstGeom>
-          <a:noFill/>
-        </p:spPr>
-        <p:txBody>
-          <a:bodyPr wrap="square" anchor="t" lIns="0" rIns="0" tIns="0" bIns="0">
-            <a:spAutoFit/>
-          </a:bodyPr>
-          <a:lstStyle/>
-          <a:p>
-            <a:pPr algn="l">
-              <a:spcAft>
-                <a:spcPts val="600"/>
-              </a:spcAft>
-            </a:pPr>
-            <a:r>
-              <a:rPr sz="1300" b="1" i="0">
-                <a:solidFill>
-                  <a:srgbClr val="57068C"/>
-                </a:solidFill>
-              </a:rPr>
-              <a:t>Direct DEM output</a:t>
-            </a:r>
-          </a:p>
-        </p:txBody>
-      </p:sp>
-      <p:sp>
-        <p:nvSpPr>
-          <p:cNvPr id="11" name="TextBox 10"/>
-          <p:cNvSpPr txBox="1"/>
-          <p:nvPr/>
-        </p:nvSpPr>
-        <p:spPr>
-          <a:xfrm>
-            <a:off x="530352" y="3127248"/>
-            <a:ext cx="3785616" cy="914400"/>
-          </a:xfrm>
-          <a:prstGeom prst="rect">
-            <a:avLst/>
-          </a:prstGeom>
-          <a:noFill/>
-        </p:spPr>
-        <p:txBody>
-          <a:bodyPr wrap="square" anchor="t" lIns="0" rIns="0" tIns="0" bIns="0">
-            <a:spAutoFit/>
-          </a:bodyPr>
-          <a:lstStyle/>
-          <a:p>
-            <a:pPr algn="l">
-              <a:spcAft>
-                <a:spcPts val="600"/>
-              </a:spcAft>
-            </a:pPr>
-            <a:r>
-              <a:rPr sz="1300" b="0" i="0">
-                <a:solidFill>
-                  <a:srgbClr val="333333"/>
-                </a:solidFill>
-              </a:rPr>
-              <a:t>Predict the 18 bins instead of 54 basis weights (deferred).</a:t>
-            </a:r>
-          </a:p>
-        </p:txBody>
-      </p:sp>
-      <p:sp>
-        <p:nvSpPr>
-          <p:cNvPr id="12" name="Rounded Rectangle 11"/>
-          <p:cNvSpPr/>
-          <p:nvPr/>
-        </p:nvSpPr>
-        <p:spPr>
-          <a:xfrm>
-            <a:off x="4663440" y="2651760"/>
-            <a:ext cx="4114800" cy="1463040"/>
-          </a:xfrm>
-          <a:prstGeom prst="roundRect">
-            <a:avLst>
-              <a:gd name="adj" fmla="val 6000"/>
-            </a:avLst>
-          </a:prstGeom>
-          <a:solidFill>
-            <a:srgbClr val="F4F1F8"/>
-          </a:solidFill>
-          <a:ln>
-            <a:noFill/>
-          </a:ln>
-          <a:effectLst/>
-        </p:spPr>
-        <p:style>
-          <a:lnRef idx="1">
-            <a:schemeClr val="accent1"/>
-          </a:lnRef>
-          <a:fillRef idx="3">
-            <a:schemeClr val="accent1"/>
-          </a:fillRef>
-          <a:effectRef idx="2">
-            <a:schemeClr val="accent1"/>
-          </a:effectRef>
-          <a:fontRef idx="minor">
-            <a:schemeClr val="lt1"/>
-          </a:fontRef>
-        </p:style>
-        <p:txBody>
-          <a:bodyPr rtlCol="0" anchor="ctr"/>
-          <a:lstStyle/>
-          <a:p>
-            <a:pPr algn="ctr"/>
-          </a:p>
-        </p:txBody>
-      </p:sp>
-      <p:sp>
-        <p:nvSpPr>
-          <p:cNvPr id="13" name="TextBox 12"/>
-          <p:cNvSpPr txBox="1"/>
-          <p:nvPr/>
-        </p:nvSpPr>
-        <p:spPr>
-          <a:xfrm>
-            <a:off x="4828032" y="2779776"/>
-            <a:ext cx="3785616" cy="320040"/>
-          </a:xfrm>
-          <a:prstGeom prst="rect">
-            <a:avLst/>
-          </a:prstGeom>
-          <a:noFill/>
-        </p:spPr>
-        <p:txBody>
-          <a:bodyPr wrap="square" anchor="t" lIns="0" rIns="0" tIns="0" bIns="0">
-            <a:spAutoFit/>
-          </a:bodyPr>
-          <a:lstStyle/>
-          <a:p>
-            <a:pPr algn="l">
-              <a:spcAft>
-                <a:spcPts val="600"/>
-              </a:spcAft>
-            </a:pPr>
-            <a:r>
-              <a:rPr sz="1300" b="1" i="0">
-                <a:solidFill>
-                  <a:srgbClr val="57068C"/>
-                </a:solidFill>
-              </a:rPr>
-              <a:t>Uncertainty, AIA + XRT</a:t>
-            </a:r>
-          </a:p>
-        </p:txBody>
-      </p:sp>
-      <p:sp>
-        <p:nvSpPr>
-          <p:cNvPr id="14" name="TextBox 13"/>
-          <p:cNvSpPr txBox="1"/>
-          <p:nvPr/>
-        </p:nvSpPr>
-        <p:spPr>
-          <a:xfrm>
-            <a:off x="4828032" y="3127248"/>
-            <a:ext cx="3785616" cy="914400"/>
-          </a:xfrm>
-          <a:prstGeom prst="rect">
-            <a:avLst/>
-          </a:prstGeom>
-          <a:noFill/>
-        </p:spPr>
-        <p:txBody>
-          <a:bodyPr wrap="square" anchor="t" lIns="0" rIns="0" tIns="0" bIns="0">
-            <a:spAutoFit/>
-          </a:bodyPr>
-          <a:lstStyle/>
-          <a:p>
-            <a:pPr algn="l">
-              <a:spcAft>
-                <a:spcPts val="600"/>
-              </a:spcAft>
-            </a:pPr>
-            <a:r>
-              <a:rPr sz="1300" b="0" i="0">
-                <a:solidFill>
-                  <a:srgbClr val="333333"/>
-                </a:solidFill>
-              </a:rPr>
-              <a:t>A distribution over DEMs from the noisy re-solves; XRT for the hot plasma.</a:t>
-            </a:r>
-          </a:p>
-        </p:txBody>
-      </p:sp>
-    </p:spTree>
-  </p:cSld>
-  <p:clrMapOvr>
-    <a:masterClrMapping/>
-  </p:clrMapOvr>
-</p:sld>
-</file>
-
-<file path=ppt/slides/slide33.xml><?xml version="1.0" encoding="utf-8"?>
 <p:sld xmlns:a="http://schemas.openxmlformats.org/drawingml/2006/main" xmlns:p="http://schemas.openxmlformats.org/presentationml/2006/main" xmlns:r="http://schemas.openxmlformats.org/officeDocument/2006/relationships">
   <p:cSld>
     <p:spTree>
@@ -35384,7 +34779,7 @@
                   <a:srgbClr val="333333"/>
                 </a:solidFill>
               </a:rPr>
-              <a:t>Test: ~700M pixel DEMs per solver, the clean solve plus 4 noise re-solves(only supervised).</a:t>
+              <a:t>Test: ~700M pixel DEMs per solver, the clean solve plus 4 noise re-solves.</a:t>
             </a:r>
           </a:p>
         </p:txBody>

</xml_diff>

<commit_message>
deck: sync Hriday's Google Slides edits and the review changes; prep sheet questions from the review
</commit_message>
<xml_diff>
--- a/slides/DEM_deck_v2.pptx
+++ b/slides/DEM_deck_v2.pptx
@@ -327,7 +327,7 @@
           <a:p>
             <a:r>
               <a:rPr sz="1150" b="1"/>
-              <a:t>BP median pixel error by model size, log1p sweep (lower is better)</a:t>
+              <a:t>Median pixel error on test (BP, log1p, μ = 1)</a:t>
             </a:r>
           </a:p>
         </c:rich>
@@ -1185,7 +1185,7 @@
           <a:lstStyle/>
           <a:p>
             <a:r>
-              <a:t>[1 min, a recap: this is where the last meeting left off] The old BP model: flare cores, pixels at 32 times the Bright cutoff, are one in ten thousand and held 90% of its DEM error, supervised's too. There it held 40% of the solver's emission, peaked a quarter as high, 0.2 dex too cool, with extra peaks on 83% of curves. The clue: it fit the cool channels to a few percent but reproduced only 23% of 94 A, so the hot plasma was missing. We read it as a training problem, and that is where the suggestions came from: oversample, train longer, go bigger. If asked: solver noise is 0.4% of the Bright error and missed second peaks 1.2%, both ruled out; the figure is the old model at random flare cores, black solver, blue ours, orange supervised.</a:t>
+              <a:t>[1 min, a recap: this is where the last meeting left off] The old BP model, width 336 with log1p input, mu = 1 and 40 epochs: flare cores, pixels at 32 times the Bright cutoff, are one in ten thousand and held 90% of its DEM error, supervised's too. There it held 40% of the solver's emission, peaked a quarter as high, 0.2 dex too cool, with extra peaks on 83% of curves. The clue: it fit the cool channels to a few percent but reproduced only 23% of 94 A, so the hot plasma was missing. We read it as a training problem, and that is where the suggestions came from: oversample, train longer, go bigger. If asked: solver noise is 0.4% of the Bright error and missed second peaks 1.2%, both ruled out; the figure is the old model at random flare cores, black solver, blue ours, orange supervised.</a:t>
             </a:r>
           </a:p>
         </p:txBody>
@@ -1359,7 +1359,7 @@
           <a:lstStyle/>
           <a:p>
             <a:r>
-              <a:t>[2 min] Why does the loss drop it? The solver's band is a rule; ours is a price: sparsity plus mu times the band penalty, with mu = 1. The response table: a unit of warm plasma lights 171, 193 and 211 A by tens of DN/s, so it has to be in the DEM anyway and its 94 A comes free. A unit of hot plasma lights no channel by more than 0.4 DN/s, so a bright 94 A reading needs hundreds of units, all paid by the sparsity term. The worked example at a typical flare core: putting the hot plasma in costs 616, leaving it out costs 85, so the best answer leaves it out. At mu = 100 leaving it out costs 8,500 and the plasma goes back in. If asked: units are 10^26 cm^-5 of emission measure; the band itself is sound, the noise follows photon counting; brighter pixels draw more of their 94 A from hot plasma, which is why the share dropped grows with brightness: the best answer reproduces 91% at 1 to 1.8x the Bright level, 44% at 10 to 32x, 26% at flare cores.</a:t>
+              <a:t>[2 min] Why does the loss drop it? The solver's band is a rule; ours is a price: sparsity plus mu times the band penalty, with mu = 1. The response table: a unit of warm plasma lights 171, 193 and 211 A by tens of DN/s, so it has to be in the DEM anyway and its 94 A comes free. A unit of hot plasma lights no channel by more than 0.4 DN/s, so a bright 94 A reading needs hundreds of units, all paid by the sparsity term. The worked example at a typical flare core: putting the hot plasma in costs 616, leaving it out costs 85, so the best answer leaves it out. At mu = 100 leaving it out costs 8,500 and the plasma goes back in. If asked: one unit is 10^26 cm^-5 of emission measure, the DEM's own unit; the plasma is never measured, AIA measures DN/s and R is a fixed table; the full response per unit, warm (logT 6.0 to 6.1): 94 A 0.2, 131 A 0.5 to 1.2, 171 A 36 to 95, 193 A 29 to 55, 211 A 5 to 7, 335 A 0.4; hot (logT 6.9): 0.266, 0.40, 0.05, 0.34, 0.08, 0.05; the band itself is sound, the noise follows photon counting; brighter pixels draw more of their 94 A from hot plasma, which is why the share dropped grows with brightness: the best answer reproduces 91% at 1 to 1.8x the Bright level, 44% at 10 to 32x, 26% at flare cores.</a:t>
             </a:r>
           </a:p>
         </p:txBody>
@@ -1707,7 +1707,7 @@
           <a:lstStyle/>
           <a:p>
             <a:r>
-              <a:t>[2 min] Four things to remember; the rest of the talk is the evidence. One: we never train on a solver DEM. The network minimises the solver's own objective, and solver DEMs are only used to score. Two: a 400k-parameter MLP on one pixel's six intensities is enough; bigger models fail on rare pixels. Three: against the supervised model, which trained on the same solver's DEMs and is scored on the same pixels, we are ahead on every ElasticNet measure and on four of six BP measures. Four: the one place BP lost, flare cores, was the loss and not training, and a stiffer noise band fixed it. If asked: the final models are one MLP of width 336 per track, square root plus Fourier input, fresh pixels every epoch; BP trains on the stiff band for 120 plus 120 epochs, ElasticNet for 40.</a:t>
+              <a:t>[2 min] Four things to remember; the rest of the talk is the evidence. One: we never train on a solver DEM. The network minimises the solver's own objective, and solver DEMs are only used to score. Two: a 400k-parameter MLP on one pixel's six intensities is enough; bigger models fail on rare pixels. Three: against the supervised model, which trained on the same solver's DEMs and is scored on the same pixels, we are ahead on every ElasticNet measure and on four of six BP measures. Four: the one place BP lost, flare cores, was the loss and not training, and a stiffer noise band fixed it. If asked: the final models are one MLP of width 336 per track, square root plus Fourier input, fresh pixels every epoch; BP trains on the stiff band for 120 plus 120 epochs, ElasticNet for 40. Without flare cores our BP DEM MSE is 0.102 against supervised's 0.091.</a:t>
             </a:r>
           </a:p>
         </p:txBody>
@@ -1881,7 +1881,7 @@
           <a:lstStyle/>
           <a:p>
             <a:r>
-              <a:t>Before any network, five losses optimised directly per pixel on 4 timestamps. Averages: AIA MAE against the observation, BP 5.2, barrier 5.0, barrier plus fit 2.6, fit-only 0.40 to 0.44. DEM MAE against BP: barrier 0.034, barrier plus fit 0.043, fit-only 0.18 to 0.20. W1 on the brightest 5% of pixels: 0.030 and 0.033 against 0.15 to 0.18. Six equations, eighteen unknowns: many DEMs fit within noise, so whatever breaks the tie decides the shape. L-BFGS and Adam reach the same curves; SGD often fails to converge.</a:t>
+              <a:t>Before any network, five losses optimised directly per pixel on 4 timestamps. Averages: AIA MAE against the observation, BP 5.2, band penalty 5.0, band penalty plus fit 2.6, fit-only 0.40 to 0.44. DEM MAE against BP: band penalty 0.034, band penalty plus fit 0.043, fit-only 0.18 to 0.20. W1 on the brightest 5% of pixels: 0.030 and 0.033 against 0.15 to 0.18. Six equations, eighteen unknowns: many DEMs fit within noise, so whatever breaks the tie decides the shape. L-BFGS and Adam reach the same curves; SGD often fails to converge.</a:t>
             </a:r>
           </a:p>
         </p:txBody>
@@ -2345,7 +2345,7 @@
           <a:lstStyle/>
           <a:p>
             <a:r>
-              <a:t>[1 min] Both solvers run one optimisation per pixel. A supervised network copies their DEMs, so it needs them as labels. A label-free network minimises the same objective directly, so it never sees a solver DEM; we use those only to evaluate. The bold line is the whole point of this slide.</a:t>
+              <a:t>[1 min] Both solvers run one optimisation per pixel. A supervised network copies their DEMs, so it needs them as labels. A label-free network minimises the same objective directly, so it never sees a solver DEM; we use those only to evaluate. That is the point of this slide. If asked: our network outputs 54 basis weights, as the solvers do, and the DEM is B times w; the supervised model outputs the 18 DEM values directly.</a:t>
             </a:r>
           </a:p>
         </p:txBody>
@@ -2519,7 +2519,7 @@
           <a:lstStyle/>
           <a:p>
             <a:r>
-              <a:t>[1.5 min] Two years of full-disk AIA, 1,223 images, deconvolved, with a noise sigma per pixel and channel, split in time: train to June 2015, validation to September, test to December, so every test image is later than anything trained on. Training sees AIA and sigma only, with fresh pixels every epoch. Solver DEMs exist for every image: labels for the supervised model, evaluation only for us. We score on the supervised side's protocol: 153 test days, the same pixels and the same Bright cutoffs, five solver targets per image. Scores: DEM against the solver, AIA reconstruction against the observation, and, because the error is heavy-tailed, medians and percentiles. If asked: 917 training images times 64 blocks, 512 pixels per block per epoch; the test set is about 700M pixel-targets per solver; pixels where deconvolution clamped a bright channel to zero, about 5%, are excluded; runs before October reused one fixed 30M-pixel sample through a seeding bug, fixed since.</a:t>
+              <a:t>[1.5 min] Two years of full-disk AIA, 1,223 images, deconvolved, with a noise sigma per pixel and channel, split in time: train to June 2015, validation to September, test to December, so every test image is later than anything trained on. Training sees AIA and sigma only, with fresh pixels every epoch. Solver DEMs exist for every image: labels for the supervised model, evaluation only for us. We score on the supervised side's protocol: 153 test days, the same pixels and the same Bright cutoffs, five solver targets per image. Scores: DEM against the solver, AIA reconstruction against the observation, and, because the error is heavy-tailed, medians and percentiles. If asked: each image keeps a random 64 of its 256 blocks, chosen once; every epoch takes 512 fresh pixels from each, 30M in all. The noisy targets come from adding Gaussian noise of size sigma to the AIA before the solve; the input stays the clean AIA, so they measure the solver's own scatter, the same floor for both models. About 800M pixel-targets per solver, 705M where BP returned an answer. Pixels where deconvolution clamped a bright channel to zero, about 5%, are left out of training only. Off-disk corona pixels are real data and are used. Runs before October reused one fixed 30M-pixel sample through a seeding bug, fixed since.</a:t>
             </a:r>
           </a:p>
         </p:txBody>
@@ -2577,7 +2577,7 @@
           <a:lstStyle/>
           <a:p>
             <a:r>
-              <a:t>[1.5 min] On four images the patch CNN looked better than a per-pixel MLP, but that edge came from scoring pixels of images it had trained on; on held-out days it disappeared. At full scale, matched at 1.5M parameters, the MLP wins the training objective on both tracks and at every percentile. The CNN only reconstructs BP's AIA slightly better. This is the fifth comparison and none found a CNN advantage on unseen days, so the final model takes one pixel and no neighbourhood. If asked: the small-data story, the ablation and leave-one-day-out are in the appendix; validation agrees with test, BP 2.155 against 2.248, ElasticNet 0.0528 against 0.0683.</a:t>
+              <a:t>[1.5 min] On four images the patch CNN looked better than a per-pixel MLP, but that edge came from scoring pixels of images it had trained on; on held-out days it disappeared. At full scale, matched at 1.5M parameters, the MLP wins the training objective on both tracks and at every percentile. The CNN only reconstructs BP's AIA slightly better. This is the fifth comparison and none found a CNN advantage on unseen days, so the final model takes one pixel and no neighbourhood. On ElasticNet the MLP is lower at every percentile; the 4x gap in the mean is mostly a few CNN pixels, whose worst 0.1% hold 73% of its loss. If asked: the CNN sees a 9 by 9 patch, three 3 by 3 convolutions of 64 channels, then 256, 256 and 54, 1.48M parameters, against the width-680 MLP at 1.43M; the small-data story, the ablation and leave-one-day-out are in the appendix; validation agrees with test, BP 2.155 against 2.248, ElasticNet 0.0528 against 0.0683.</a:t>
             </a:r>
           </a:p>
         </p:txBody>
@@ -2635,7 +2635,7 @@
           <a:lstStyle/>
           <a:p>
             <a:r>
-              <a:t>[1.5 min] Width is chosen by validation loss, never by test numbers. For BP, width 336 is the validation best; 1.43M ties but only nudges the typical pixel at four times the size, and on the stiff band it blows up on a few flare-core pixels. ElasticNet blows up from 722k on a handful of bright pixels, by orders of magnitude, which the sampled validation set never saw. The input encoding is also chosen by validation: square root plus Fourier wins for ElasticNet by 7% and, on the stiff band, for BP. If asked: the chart is the log1p sweep, median pixel error on the test set; BP validation 2.148 at 336 against 2.155 at 1.43M; ElasticNet AIA MSE 41,849 and 908,611 at 722k and 1.43M against 650 at 336; the 10M models blew up on both tracks; 409k parameters with the 150 encoded inputs.</a:t>
+              <a:t>[1.5 min] We choose on the validation days: the training loss computed there, no solver DEM needed. For BP, width 336 is the validation best; 1.43M ties but only nudges the typical pixel at four times the size, and on the stiff band it blows up on a few flare-core pixels. ElasticNet is the one exception, and worth saying plainly: validation preferred the bigger models, but from 722k up they blow up on a handful of bright pixels, by orders of magnitude, that the validation sample never contained. We saw it on the test set, so 336 is the largest width that does not blow up; validating on every pixel is the clean fix. The input encoding is chosen on validation too: square root plus Fourier wins for ElasticNet by 7% and, on the stiff band, for BP. If asked: the chart is test numbers from the log1p sweep; BP validation 2.148 at 336 against 2.155 at 1.43M; ElasticNet validation 0.0575, 0.0533 and 0.0528 at 336, 722k and 1.43M, test DEM MSE 0.48, 3.24 and 36.2, AIA MSE 650, 41,849 and 908,611; the validation sample is about 131k pixels; the 10M models blew up on both tracks; 409k parameters with the 150 encoded inputs.</a:t>
             </a:r>
           </a:p>
         </p:txBody>
@@ -11556,7 +11556,7 @@
           <a:p>
             <a:pPr algn="l" marL="182880" indent="-182880">
               <a:spcAft>
-                <a:spcPts val="700"/>
+                <a:spcPts val="600"/>
               </a:spcAft>
               <a:buClr>
                 <a:srgbClr val="333333"/>
@@ -11564,18 +11564,18 @@
               <a:buChar char="•"/>
             </a:pPr>
             <a:r>
-              <a:rPr sz="1150" b="0" i="0">
+              <a:rPr sz="1100" b="0" i="0">
                 <a:solidFill>
                   <a:srgbClr val="333333"/>
                 </a:solidFill>
               </a:rPr>
-              <a:t>We choose by validation loss.</a:t>
+              <a:t>We choose on the 153 validation days, never on test.</a:t>
             </a:r>
           </a:p>
           <a:p>
             <a:pPr algn="l" marL="182880" indent="-182880">
               <a:spcAft>
-                <a:spcPts val="700"/>
+                <a:spcPts val="600"/>
               </a:spcAft>
               <a:buClr>
                 <a:srgbClr val="333333"/>
@@ -11583,7 +11583,7 @@
               <a:buChar char="•"/>
             </a:pPr>
             <a:r>
-              <a:rPr sz="1150" b="0" i="0">
+              <a:rPr sz="1100" b="0" i="0">
                 <a:solidFill>
                   <a:srgbClr val="333333"/>
                 </a:solidFill>
@@ -11594,7 +11594,7 @@
           <a:p>
             <a:pPr algn="l" marL="182880" indent="-182880">
               <a:spcAft>
-                <a:spcPts val="700"/>
+                <a:spcPts val="600"/>
               </a:spcAft>
               <a:buClr>
                 <a:srgbClr val="333333"/>
@@ -11602,18 +11602,18 @@
               <a:buChar char="•"/>
             </a:pPr>
             <a:r>
-              <a:rPr sz="1150" b="0" i="0">
+              <a:rPr sz="1100" b="0" i="0">
                 <a:solidFill>
                   <a:srgbClr val="333333"/>
                 </a:solidFill>
               </a:rPr>
-              <a:t>ElasticNet: from 722k up, a few bright pixels blow up by orders of magnitude; 336 is the largest stable width.</a:t>
+              <a:t>ElasticNet: validation favours bigger models, but from 722k up a few bright pixels blow up by orders of magnitude on the full test set (too rare for the validation sample); 336 is the largest stable width.</a:t>
             </a:r>
           </a:p>
           <a:p>
             <a:pPr algn="l" marL="182880" indent="-182880">
               <a:spcAft>
-                <a:spcPts val="700"/>
+                <a:spcPts val="600"/>
               </a:spcAft>
               <a:buClr>
                 <a:srgbClr val="333333"/>
@@ -11621,12 +11621,12 @@
               <a:buChar char="•"/>
             </a:pPr>
             <a:r>
-              <a:rPr sz="1150" b="0" i="0">
+              <a:rPr sz="1100" b="0" i="0">
                 <a:solidFill>
                   <a:srgbClr val="333333"/>
                 </a:solidFill>
               </a:rPr>
-              <a:t>Input, also by validation: √ + Fourier for ElasticNet (7% better) and, on the stiff band, for BP (DEM MSE 2.37 vs 3.23).</a:t>
+              <a:t>Input, also by validation: √ + Fourier for ElasticNet (7% better) and, on the stiff band, for BP (validation DEM error 20.1 vs 29.3).</a:t>
             </a:r>
           </a:p>
         </p:txBody>
@@ -11888,7 +11888,7 @@
                             <a:srgbClr val="FFFFFF"/>
                           </a:solidFill>
                         </a:rPr>
-                        <a:t>DEM MAE</a:t>
+                        <a:t>DEM MAE ↓</a:t>
                       </a:r>
                     </a:p>
                   </a:txBody>
@@ -11924,7 +11924,7 @@
                             <a:srgbClr val="FFFFFF"/>
                           </a:solidFill>
                         </a:rPr>
-                        <a:t>DEM MSE</a:t>
+                        <a:t>DEM MSE ↓</a:t>
                       </a:r>
                     </a:p>
                   </a:txBody>
@@ -11960,7 +11960,7 @@
                             <a:srgbClr val="FFFFFF"/>
                           </a:solidFill>
                         </a:rPr>
-                        <a:t>EM error</a:t>
+                        <a:t>EM error ↓</a:t>
                       </a:r>
                     </a:p>
                   </a:txBody>
@@ -11996,7 +11996,7 @@
                             <a:srgbClr val="FFFFFF"/>
                           </a:solidFill>
                         </a:rPr>
-                        <a:t>W1</a:t>
+                        <a:t>W1 ↓</a:t>
                       </a:r>
                     </a:p>
                   </a:txBody>
@@ -12032,7 +12032,7 @@
                             <a:srgbClr val="FFFFFF"/>
                           </a:solidFill>
                         </a:rPr>
-                        <a:t>AIA MAE</a:t>
+                        <a:t>AIA MAE ↓</a:t>
                       </a:r>
                     </a:p>
                   </a:txBody>
@@ -12068,7 +12068,7 @@
                             <a:srgbClr val="FFFFFF"/>
                           </a:solidFill>
                         </a:rPr>
-                        <a:t>AIA MSE</a:t>
+                        <a:t>AIA MSE ↓</a:t>
                       </a:r>
                     </a:p>
                   </a:txBody>
@@ -12162,7 +12162,7 @@
                       </a:solidFill>
                     </a:lnB>
                     <a:solidFill>
-                      <a:srgbClr val="FFFFFF"/>
+                      <a:srgbClr val="E3DFE9"/>
                     </a:solidFill>
                   </a:tcPr>
                 </a:tc>
@@ -12234,7 +12234,7 @@
                       </a:solidFill>
                     </a:lnB>
                     <a:solidFill>
-                      <a:srgbClr val="FFFFFF"/>
+                      <a:srgbClr val="E3DFE9"/>
                     </a:solidFill>
                   </a:tcPr>
                 </a:tc>
@@ -12270,7 +12270,7 @@
                       </a:solidFill>
                     </a:lnB>
                     <a:solidFill>
-                      <a:srgbClr val="FFFFFF"/>
+                      <a:srgbClr val="E3DFE9"/>
                     </a:solidFill>
                   </a:tcPr>
                 </a:tc>
@@ -12342,7 +12342,7 @@
                       </a:solidFill>
                     </a:lnB>
                     <a:solidFill>
-                      <a:srgbClr val="FFFFFF"/>
+                      <a:srgbClr val="E3DFE9"/>
                     </a:solidFill>
                   </a:tcPr>
                 </a:tc>
@@ -12374,9 +12374,9 @@
                     <a:lnT w="0">
                       <a:noFill/>
                     </a:lnT>
-                    <a:lnB w="6350">
+                    <a:lnB w="19050">
                       <a:solidFill>
-                        <a:srgbClr val="D9D3E3"/>
+                        <a:srgbClr val="57068C"/>
                       </a:solidFill>
                     </a:lnB>
                     <a:solidFill>
@@ -12410,9 +12410,9 @@
                     <a:lnT w="0">
                       <a:noFill/>
                     </a:lnT>
-                    <a:lnB w="6350">
+                    <a:lnB w="19050">
                       <a:solidFill>
-                        <a:srgbClr val="D9D3E3"/>
+                        <a:srgbClr val="57068C"/>
                       </a:solidFill>
                     </a:lnB>
                     <a:solidFill>
@@ -12446,13 +12446,13 @@
                     <a:lnT w="0">
                       <a:noFill/>
                     </a:lnT>
-                    <a:lnB w="6350">
+                    <a:lnB w="19050">
                       <a:solidFill>
-                        <a:srgbClr val="D9D3E3"/>
+                        <a:srgbClr val="57068C"/>
                       </a:solidFill>
                     </a:lnB>
                     <a:solidFill>
-                      <a:srgbClr val="FFFFFF"/>
+                      <a:srgbClr val="E3DFE9"/>
                     </a:solidFill>
                   </a:tcPr>
                 </a:tc>
@@ -12482,9 +12482,9 @@
                     <a:lnT w="0">
                       <a:noFill/>
                     </a:lnT>
-                    <a:lnB w="6350">
+                    <a:lnB w="19050">
                       <a:solidFill>
-                        <a:srgbClr val="D9D3E3"/>
+                        <a:srgbClr val="57068C"/>
                       </a:solidFill>
                     </a:lnB>
                     <a:solidFill>
@@ -12518,9 +12518,9 @@
                     <a:lnT w="0">
                       <a:noFill/>
                     </a:lnT>
-                    <a:lnB w="6350">
+                    <a:lnB w="19050">
                       <a:solidFill>
-                        <a:srgbClr val="D9D3E3"/>
+                        <a:srgbClr val="57068C"/>
                       </a:solidFill>
                     </a:lnB>
                     <a:solidFill>
@@ -12554,13 +12554,13 @@
                     <a:lnT w="0">
                       <a:noFill/>
                     </a:lnT>
-                    <a:lnB w="6350">
+                    <a:lnB w="19050">
                       <a:solidFill>
-                        <a:srgbClr val="D9D3E3"/>
+                        <a:srgbClr val="57068C"/>
                       </a:solidFill>
                     </a:lnB>
                     <a:solidFill>
-                      <a:srgbClr val="FFFFFF"/>
+                      <a:srgbClr val="E3DFE9"/>
                     </a:solidFill>
                   </a:tcPr>
                 </a:tc>
@@ -12590,9 +12590,9 @@
                     <a:lnT w="0">
                       <a:noFill/>
                     </a:lnT>
-                    <a:lnB w="6350">
+                    <a:lnB w="19050">
                       <a:solidFill>
-                        <a:srgbClr val="D9D3E3"/>
+                        <a:srgbClr val="57068C"/>
                       </a:solidFill>
                     </a:lnB>
                     <a:solidFill>
@@ -12670,7 +12670,7 @@
                       </a:solidFill>
                     </a:lnB>
                     <a:solidFill>
-                      <a:srgbClr val="FFFFFF"/>
+                      <a:srgbClr val="E3DFE9"/>
                     </a:solidFill>
                   </a:tcPr>
                 </a:tc>
@@ -12706,7 +12706,7 @@
                       </a:solidFill>
                     </a:lnB>
                     <a:solidFill>
-                      <a:srgbClr val="FFFFFF"/>
+                      <a:srgbClr val="E3DFE9"/>
                     </a:solidFill>
                   </a:tcPr>
                 </a:tc>
@@ -12742,7 +12742,7 @@
                       </a:solidFill>
                     </a:lnB>
                     <a:solidFill>
-                      <a:srgbClr val="FFFFFF"/>
+                      <a:srgbClr val="E3DFE9"/>
                     </a:solidFill>
                   </a:tcPr>
                 </a:tc>
@@ -12778,7 +12778,7 @@
                       </a:solidFill>
                     </a:lnB>
                     <a:solidFill>
-                      <a:srgbClr val="FFFFFF"/>
+                      <a:srgbClr val="E3DFE9"/>
                     </a:solidFill>
                   </a:tcPr>
                 </a:tc>
@@ -12814,7 +12814,7 @@
                       </a:solidFill>
                     </a:lnB>
                     <a:solidFill>
-                      <a:srgbClr val="FFFFFF"/>
+                      <a:srgbClr val="E3DFE9"/>
                     </a:solidFill>
                   </a:tcPr>
                 </a:tc>
@@ -12850,7 +12850,7 @@
                       </a:solidFill>
                     </a:lnB>
                     <a:solidFill>
-                      <a:srgbClr val="FFFFFF"/>
+                      <a:srgbClr val="E3DFE9"/>
                     </a:solidFill>
                   </a:tcPr>
                 </a:tc>
@@ -13150,7 +13150,7 @@
                   <a:srgbClr val="333333"/>
                 </a:solidFill>
               </a:rPr>
-              <a:t>Bold = better. ElasticNet: we win all six, DEM MAE and MSE included. BP: we win DEM MAE, EM error, W1 and AIA MSE; supervised keeps DEM MSE (set by flare cores, Part 4) and AIA MAE.</a:t>
+              <a:t>Lower is better in every column; shaded = better. ElasticNet: we win all six, DEM MAE and MSE included. BP: we win DEM MAE, EM error, W1 and AIA MSE; supervised keeps DEM MSE (set by flare cores, Part 4) and AIA MAE.</a:t>
             </a:r>
           </a:p>
         </p:txBody>
@@ -13244,7 +13244,7 @@
                   <a:srgbClr val="57068C"/>
                 </a:solidFill>
               </a:rPr>
-              <a:t>The typical pixel and the average tell different stories</a:t>
+              <a:t>The typical pixel and the average disagree</a:t>
             </a:r>
           </a:p>
         </p:txBody>
@@ -13774,7 +13774,7 @@
                   <a:srgbClr val="333333"/>
                 </a:solidFill>
               </a:rPr>
-              <a:t>Old BP model: 0.01% of pixels, 90% of the DEM error (supervised: 90% too).</a:t>
+              <a:t>Old BP model (width 336, log1p input, μ = 1, 40 epochs): 0.01% of pixels, 90% of the DEM error (supervised: 90% too).</a:t>
             </a:r>
           </a:p>
           <a:p>
@@ -16375,20 +16375,15 @@
         </p:nvGraphicFramePr>
         <p:xfrm>
           <a:off x="365760" y="1554480"/>
-          <a:ext cx="5120637" cy="987552"/>
+          <a:ext cx="5120640" cy="987552"/>
         </p:xfrm>
         <a:graphic>
           <a:graphicData uri="http://schemas.openxmlformats.org/drawingml/2006/table">
             <a:tbl>
               <a:tblPr firstRow="1" bandRow="1"/>
               <a:tblGrid>
-                <a:gridCol w="1815829"/>
-                <a:gridCol w="472115"/>
-                <a:gridCol w="617382"/>
-                <a:gridCol w="617382"/>
-                <a:gridCol w="617382"/>
-                <a:gridCol w="508432"/>
-                <a:gridCol w="472115"/>
+                <a:gridCol w="1737360"/>
+                <a:gridCol w="3383280"/>
               </a:tblGrid>
               <a:tr h="329184">
                 <a:tc>
@@ -16403,7 +16398,7 @@
                             <a:srgbClr val="FFFFFF"/>
                           </a:solidFill>
                         </a:rPr>
-                        <a:t>DN/s per unit of plasma</a:t>
+                        <a:t>One unit of plasma at</a:t>
                       </a:r>
                     </a:p>
                   </a:txBody>
@@ -16432,194 +16427,14 @@
                     <a:bodyPr wrap="square"/>
                     <a:lstStyle/>
                     <a:p>
-                      <a:pPr algn="r"/>
+                      <a:pPr algn="l"/>
                       <a:r>
                         <a:rPr sz="1050" b="1">
                           <a:solidFill>
                             <a:srgbClr val="FFFFFF"/>
                           </a:solidFill>
                         </a:rPr>
-                        <a:t>94 Å</a:t>
-                      </a:r>
-                    </a:p>
-                  </a:txBody>
-                  <a:tcPr marL="54864" marR="54864" marT="27432" marB="27432" anchor="ctr">
-                    <a:lnL w="0">
-                      <a:noFill/>
-                    </a:lnL>
-                    <a:lnR w="0">
-                      <a:noFill/>
-                    </a:lnR>
-                    <a:lnT w="0">
-                      <a:noFill/>
-                    </a:lnT>
-                    <a:lnB w="6350">
-                      <a:solidFill>
-                        <a:srgbClr val="D9D3E3"/>
-                      </a:solidFill>
-                    </a:lnB>
-                    <a:solidFill>
-                      <a:srgbClr val="57068C"/>
-                    </a:solidFill>
-                  </a:tcPr>
-                </a:tc>
-                <a:tc>
-                  <a:txBody>
-                    <a:bodyPr wrap="square"/>
-                    <a:lstStyle/>
-                    <a:p>
-                      <a:pPr algn="r"/>
-                      <a:r>
-                        <a:rPr sz="1050" b="1">
-                          <a:solidFill>
-                            <a:srgbClr val="FFFFFF"/>
-                          </a:solidFill>
-                        </a:rPr>
-                        <a:t>131 Å</a:t>
-                      </a:r>
-                    </a:p>
-                  </a:txBody>
-                  <a:tcPr marL="54864" marR="54864" marT="27432" marB="27432" anchor="ctr">
-                    <a:lnL w="0">
-                      <a:noFill/>
-                    </a:lnL>
-                    <a:lnR w="0">
-                      <a:noFill/>
-                    </a:lnR>
-                    <a:lnT w="0">
-                      <a:noFill/>
-                    </a:lnT>
-                    <a:lnB w="6350">
-                      <a:solidFill>
-                        <a:srgbClr val="D9D3E3"/>
-                      </a:solidFill>
-                    </a:lnB>
-                    <a:solidFill>
-                      <a:srgbClr val="57068C"/>
-                    </a:solidFill>
-                  </a:tcPr>
-                </a:tc>
-                <a:tc>
-                  <a:txBody>
-                    <a:bodyPr wrap="square"/>
-                    <a:lstStyle/>
-                    <a:p>
-                      <a:pPr algn="r"/>
-                      <a:r>
-                        <a:rPr sz="1050" b="1">
-                          <a:solidFill>
-                            <a:srgbClr val="FFFFFF"/>
-                          </a:solidFill>
-                        </a:rPr>
-                        <a:t>171 Å</a:t>
-                      </a:r>
-                    </a:p>
-                  </a:txBody>
-                  <a:tcPr marL="54864" marR="54864" marT="27432" marB="27432" anchor="ctr">
-                    <a:lnL w="0">
-                      <a:noFill/>
-                    </a:lnL>
-                    <a:lnR w="0">
-                      <a:noFill/>
-                    </a:lnR>
-                    <a:lnT w="0">
-                      <a:noFill/>
-                    </a:lnT>
-                    <a:lnB w="6350">
-                      <a:solidFill>
-                        <a:srgbClr val="D9D3E3"/>
-                      </a:solidFill>
-                    </a:lnB>
-                    <a:solidFill>
-                      <a:srgbClr val="57068C"/>
-                    </a:solidFill>
-                  </a:tcPr>
-                </a:tc>
-                <a:tc>
-                  <a:txBody>
-                    <a:bodyPr wrap="square"/>
-                    <a:lstStyle/>
-                    <a:p>
-                      <a:pPr algn="r"/>
-                      <a:r>
-                        <a:rPr sz="1050" b="1">
-                          <a:solidFill>
-                            <a:srgbClr val="FFFFFF"/>
-                          </a:solidFill>
-                        </a:rPr>
-                        <a:t>193 Å</a:t>
-                      </a:r>
-                    </a:p>
-                  </a:txBody>
-                  <a:tcPr marL="54864" marR="54864" marT="27432" marB="27432" anchor="ctr">
-                    <a:lnL w="0">
-                      <a:noFill/>
-                    </a:lnL>
-                    <a:lnR w="0">
-                      <a:noFill/>
-                    </a:lnR>
-                    <a:lnT w="0">
-                      <a:noFill/>
-                    </a:lnT>
-                    <a:lnB w="6350">
-                      <a:solidFill>
-                        <a:srgbClr val="D9D3E3"/>
-                      </a:solidFill>
-                    </a:lnB>
-                    <a:solidFill>
-                      <a:srgbClr val="57068C"/>
-                    </a:solidFill>
-                  </a:tcPr>
-                </a:tc>
-                <a:tc>
-                  <a:txBody>
-                    <a:bodyPr wrap="square"/>
-                    <a:lstStyle/>
-                    <a:p>
-                      <a:pPr algn="r"/>
-                      <a:r>
-                        <a:rPr sz="1050" b="1">
-                          <a:solidFill>
-                            <a:srgbClr val="FFFFFF"/>
-                          </a:solidFill>
-                        </a:rPr>
-                        <a:t>211 Å</a:t>
-                      </a:r>
-                    </a:p>
-                  </a:txBody>
-                  <a:tcPr marL="54864" marR="54864" marT="27432" marB="27432" anchor="ctr">
-                    <a:lnL w="0">
-                      <a:noFill/>
-                    </a:lnL>
-                    <a:lnR w="0">
-                      <a:noFill/>
-                    </a:lnR>
-                    <a:lnT w="0">
-                      <a:noFill/>
-                    </a:lnT>
-                    <a:lnB w="6350">
-                      <a:solidFill>
-                        <a:srgbClr val="D9D3E3"/>
-                      </a:solidFill>
-                    </a:lnB>
-                    <a:solidFill>
-                      <a:srgbClr val="57068C"/>
-                    </a:solidFill>
-                  </a:tcPr>
-                </a:tc>
-                <a:tc>
-                  <a:txBody>
-                    <a:bodyPr wrap="square"/>
-                    <a:lstStyle/>
-                    <a:p>
-                      <a:pPr algn="r"/>
-                      <a:r>
-                        <a:rPr sz="1050" b="1">
-                          <a:solidFill>
-                            <a:srgbClr val="FFFFFF"/>
-                          </a:solidFill>
-                        </a:rPr>
-                        <a:t>335 Å</a:t>
+                        <a:t>What AIA sees</a:t>
                       </a:r>
                     </a:p>
                   </a:txBody>
@@ -16657,7 +16472,7 @@
                             <a:srgbClr val="333333"/>
                           </a:solidFill>
                         </a:rPr>
-                        <a:t>Warm, 1 to 1.3 MK (logT 6.0–6.1)</a:t>
+                        <a:t>1 to 1.3 MK (warm)</a:t>
                       </a:r>
                     </a:p>
                   </a:txBody>
@@ -16686,194 +16501,14 @@
                     <a:bodyPr wrap="square"/>
                     <a:lstStyle/>
                     <a:p>
-                      <a:pPr algn="r"/>
+                      <a:pPr algn="l"/>
                       <a:r>
                         <a:rPr sz="1050" b="0">
                           <a:solidFill>
                             <a:srgbClr val="333333"/>
                           </a:solidFill>
                         </a:rPr>
-                        <a:t>0.2</a:t>
-                      </a:r>
-                    </a:p>
-                  </a:txBody>
-                  <a:tcPr marL="54864" marR="54864" marT="27432" marB="27432" anchor="ctr">
-                    <a:lnL w="0">
-                      <a:noFill/>
-                    </a:lnL>
-                    <a:lnR w="0">
-                      <a:noFill/>
-                    </a:lnR>
-                    <a:lnT w="0">
-                      <a:noFill/>
-                    </a:lnT>
-                    <a:lnB w="6350">
-                      <a:solidFill>
-                        <a:srgbClr val="D9D3E3"/>
-                      </a:solidFill>
-                    </a:lnB>
-                    <a:solidFill>
-                      <a:srgbClr val="FFFFFF"/>
-                    </a:solidFill>
-                  </a:tcPr>
-                </a:tc>
-                <a:tc>
-                  <a:txBody>
-                    <a:bodyPr wrap="square"/>
-                    <a:lstStyle/>
-                    <a:p>
-                      <a:pPr algn="r"/>
-                      <a:r>
-                        <a:rPr sz="1050" b="0">
-                          <a:solidFill>
-                            <a:srgbClr val="333333"/>
-                          </a:solidFill>
-                        </a:rPr>
-                        <a:t>0.5–1.2</a:t>
-                      </a:r>
-                    </a:p>
-                  </a:txBody>
-                  <a:tcPr marL="54864" marR="54864" marT="27432" marB="27432" anchor="ctr">
-                    <a:lnL w="0">
-                      <a:noFill/>
-                    </a:lnL>
-                    <a:lnR w="0">
-                      <a:noFill/>
-                    </a:lnR>
-                    <a:lnT w="0">
-                      <a:noFill/>
-                    </a:lnT>
-                    <a:lnB w="6350">
-                      <a:solidFill>
-                        <a:srgbClr val="D9D3E3"/>
-                      </a:solidFill>
-                    </a:lnB>
-                    <a:solidFill>
-                      <a:srgbClr val="FFFFFF"/>
-                    </a:solidFill>
-                  </a:tcPr>
-                </a:tc>
-                <a:tc>
-                  <a:txBody>
-                    <a:bodyPr wrap="square"/>
-                    <a:lstStyle/>
-                    <a:p>
-                      <a:pPr algn="r"/>
-                      <a:r>
-                        <a:rPr sz="1050" b="0">
-                          <a:solidFill>
-                            <a:srgbClr val="333333"/>
-                          </a:solidFill>
-                        </a:rPr>
-                        <a:t>36–95</a:t>
-                      </a:r>
-                    </a:p>
-                  </a:txBody>
-                  <a:tcPr marL="54864" marR="54864" marT="27432" marB="27432" anchor="ctr">
-                    <a:lnL w="0">
-                      <a:noFill/>
-                    </a:lnL>
-                    <a:lnR w="0">
-                      <a:noFill/>
-                    </a:lnR>
-                    <a:lnT w="0">
-                      <a:noFill/>
-                    </a:lnT>
-                    <a:lnB w="6350">
-                      <a:solidFill>
-                        <a:srgbClr val="D9D3E3"/>
-                      </a:solidFill>
-                    </a:lnB>
-                    <a:solidFill>
-                      <a:srgbClr val="FFFFFF"/>
-                    </a:solidFill>
-                  </a:tcPr>
-                </a:tc>
-                <a:tc>
-                  <a:txBody>
-                    <a:bodyPr wrap="square"/>
-                    <a:lstStyle/>
-                    <a:p>
-                      <a:pPr algn="r"/>
-                      <a:r>
-                        <a:rPr sz="1050" b="0">
-                          <a:solidFill>
-                            <a:srgbClr val="333333"/>
-                          </a:solidFill>
-                        </a:rPr>
-                        <a:t>29–55</a:t>
-                      </a:r>
-                    </a:p>
-                  </a:txBody>
-                  <a:tcPr marL="54864" marR="54864" marT="27432" marB="27432" anchor="ctr">
-                    <a:lnL w="0">
-                      <a:noFill/>
-                    </a:lnL>
-                    <a:lnR w="0">
-                      <a:noFill/>
-                    </a:lnR>
-                    <a:lnT w="0">
-                      <a:noFill/>
-                    </a:lnT>
-                    <a:lnB w="6350">
-                      <a:solidFill>
-                        <a:srgbClr val="D9D3E3"/>
-                      </a:solidFill>
-                    </a:lnB>
-                    <a:solidFill>
-                      <a:srgbClr val="FFFFFF"/>
-                    </a:solidFill>
-                  </a:tcPr>
-                </a:tc>
-                <a:tc>
-                  <a:txBody>
-                    <a:bodyPr wrap="square"/>
-                    <a:lstStyle/>
-                    <a:p>
-                      <a:pPr algn="r"/>
-                      <a:r>
-                        <a:rPr sz="1050" b="0">
-                          <a:solidFill>
-                            <a:srgbClr val="333333"/>
-                          </a:solidFill>
-                        </a:rPr>
-                        <a:t>5–7</a:t>
-                      </a:r>
-                    </a:p>
-                  </a:txBody>
-                  <a:tcPr marL="54864" marR="54864" marT="27432" marB="27432" anchor="ctr">
-                    <a:lnL w="0">
-                      <a:noFill/>
-                    </a:lnL>
-                    <a:lnR w="0">
-                      <a:noFill/>
-                    </a:lnR>
-                    <a:lnT w="0">
-                      <a:noFill/>
-                    </a:lnT>
-                    <a:lnB w="6350">
-                      <a:solidFill>
-                        <a:srgbClr val="D9D3E3"/>
-                      </a:solidFill>
-                    </a:lnB>
-                    <a:solidFill>
-                      <a:srgbClr val="FFFFFF"/>
-                    </a:solidFill>
-                  </a:tcPr>
-                </a:tc>
-                <a:tc>
-                  <a:txBody>
-                    <a:bodyPr wrap="square"/>
-                    <a:lstStyle/>
-                    <a:p>
-                      <a:pPr algn="r"/>
-                      <a:r>
-                        <a:rPr sz="1050" b="0">
-                          <a:solidFill>
-                            <a:srgbClr val="333333"/>
-                          </a:solidFill>
-                        </a:rPr>
-                        <a:t>0.4</a:t>
+                        <a:t>171 Å: 36 to 95 DN/s; 193 Å: 29 to 55</a:t>
                       </a:r>
                     </a:p>
                   </a:txBody>
@@ -16911,7 +16546,7 @@
                             <a:srgbClr val="333333"/>
                           </a:solidFill>
                         </a:rPr>
-                        <a:t>Hot, 8 MK (logT 6.9)</a:t>
+                        <a:t>8 MK (hot)</a:t>
                       </a:r>
                     </a:p>
                   </a:txBody>
@@ -16940,194 +16575,14 @@
                     <a:bodyPr wrap="square"/>
                     <a:lstStyle/>
                     <a:p>
-                      <a:pPr algn="r"/>
+                      <a:pPr algn="l"/>
                       <a:r>
                         <a:rPr sz="1050" b="0">
                           <a:solidFill>
                             <a:srgbClr val="333333"/>
                           </a:solidFill>
                         </a:rPr>
-                        <a:t>0.27</a:t>
-                      </a:r>
-                    </a:p>
-                  </a:txBody>
-                  <a:tcPr marL="54864" marR="54864" marT="27432" marB="27432" anchor="ctr">
-                    <a:lnL w="0">
-                      <a:noFill/>
-                    </a:lnL>
-                    <a:lnR w="0">
-                      <a:noFill/>
-                    </a:lnR>
-                    <a:lnT w="0">
-                      <a:noFill/>
-                    </a:lnT>
-                    <a:lnB w="6350">
-                      <a:solidFill>
-                        <a:srgbClr val="D9D3E3"/>
-                      </a:solidFill>
-                    </a:lnB>
-                    <a:solidFill>
-                      <a:srgbClr val="FFFFFF"/>
-                    </a:solidFill>
-                  </a:tcPr>
-                </a:tc>
-                <a:tc>
-                  <a:txBody>
-                    <a:bodyPr wrap="square"/>
-                    <a:lstStyle/>
-                    <a:p>
-                      <a:pPr algn="r"/>
-                      <a:r>
-                        <a:rPr sz="1050" b="0">
-                          <a:solidFill>
-                            <a:srgbClr val="333333"/>
-                          </a:solidFill>
-                        </a:rPr>
-                        <a:t>0.40</a:t>
-                      </a:r>
-                    </a:p>
-                  </a:txBody>
-                  <a:tcPr marL="54864" marR="54864" marT="27432" marB="27432" anchor="ctr">
-                    <a:lnL w="0">
-                      <a:noFill/>
-                    </a:lnL>
-                    <a:lnR w="0">
-                      <a:noFill/>
-                    </a:lnR>
-                    <a:lnT w="0">
-                      <a:noFill/>
-                    </a:lnT>
-                    <a:lnB w="6350">
-                      <a:solidFill>
-                        <a:srgbClr val="D9D3E3"/>
-                      </a:solidFill>
-                    </a:lnB>
-                    <a:solidFill>
-                      <a:srgbClr val="FFFFFF"/>
-                    </a:solidFill>
-                  </a:tcPr>
-                </a:tc>
-                <a:tc>
-                  <a:txBody>
-                    <a:bodyPr wrap="square"/>
-                    <a:lstStyle/>
-                    <a:p>
-                      <a:pPr algn="r"/>
-                      <a:r>
-                        <a:rPr sz="1050" b="0">
-                          <a:solidFill>
-                            <a:srgbClr val="333333"/>
-                          </a:solidFill>
-                        </a:rPr>
-                        <a:t>0.05</a:t>
-                      </a:r>
-                    </a:p>
-                  </a:txBody>
-                  <a:tcPr marL="54864" marR="54864" marT="27432" marB="27432" anchor="ctr">
-                    <a:lnL w="0">
-                      <a:noFill/>
-                    </a:lnL>
-                    <a:lnR w="0">
-                      <a:noFill/>
-                    </a:lnR>
-                    <a:lnT w="0">
-                      <a:noFill/>
-                    </a:lnT>
-                    <a:lnB w="6350">
-                      <a:solidFill>
-                        <a:srgbClr val="D9D3E3"/>
-                      </a:solidFill>
-                    </a:lnB>
-                    <a:solidFill>
-                      <a:srgbClr val="FFFFFF"/>
-                    </a:solidFill>
-                  </a:tcPr>
-                </a:tc>
-                <a:tc>
-                  <a:txBody>
-                    <a:bodyPr wrap="square"/>
-                    <a:lstStyle/>
-                    <a:p>
-                      <a:pPr algn="r"/>
-                      <a:r>
-                        <a:rPr sz="1050" b="0">
-                          <a:solidFill>
-                            <a:srgbClr val="333333"/>
-                          </a:solidFill>
-                        </a:rPr>
-                        <a:t>0.34</a:t>
-                      </a:r>
-                    </a:p>
-                  </a:txBody>
-                  <a:tcPr marL="54864" marR="54864" marT="27432" marB="27432" anchor="ctr">
-                    <a:lnL w="0">
-                      <a:noFill/>
-                    </a:lnL>
-                    <a:lnR w="0">
-                      <a:noFill/>
-                    </a:lnR>
-                    <a:lnT w="0">
-                      <a:noFill/>
-                    </a:lnT>
-                    <a:lnB w="6350">
-                      <a:solidFill>
-                        <a:srgbClr val="D9D3E3"/>
-                      </a:solidFill>
-                    </a:lnB>
-                    <a:solidFill>
-                      <a:srgbClr val="FFFFFF"/>
-                    </a:solidFill>
-                  </a:tcPr>
-                </a:tc>
-                <a:tc>
-                  <a:txBody>
-                    <a:bodyPr wrap="square"/>
-                    <a:lstStyle/>
-                    <a:p>
-                      <a:pPr algn="r"/>
-                      <a:r>
-                        <a:rPr sz="1050" b="0">
-                          <a:solidFill>
-                            <a:srgbClr val="333333"/>
-                          </a:solidFill>
-                        </a:rPr>
-                        <a:t>0.08</a:t>
-                      </a:r>
-                    </a:p>
-                  </a:txBody>
-                  <a:tcPr marL="54864" marR="54864" marT="27432" marB="27432" anchor="ctr">
-                    <a:lnL w="0">
-                      <a:noFill/>
-                    </a:lnL>
-                    <a:lnR w="0">
-                      <a:noFill/>
-                    </a:lnR>
-                    <a:lnT w="0">
-                      <a:noFill/>
-                    </a:lnT>
-                    <a:lnB w="6350">
-                      <a:solidFill>
-                        <a:srgbClr val="D9D3E3"/>
-                      </a:solidFill>
-                    </a:lnB>
-                    <a:solidFill>
-                      <a:srgbClr val="FFFFFF"/>
-                    </a:solidFill>
-                  </a:tcPr>
-                </a:tc>
-                <a:tc>
-                  <a:txBody>
-                    <a:bodyPr wrap="square"/>
-                    <a:lstStyle/>
-                    <a:p>
-                      <a:pPr algn="r"/>
-                      <a:r>
-                        <a:rPr sz="1050" b="0">
-                          <a:solidFill>
-                            <a:srgbClr val="333333"/>
-                          </a:solidFill>
-                        </a:rPr>
-                        <a:t>0.05</a:t>
+                        <a:t>94 Å: 0.266 DN/s; no channel above 0.4</a:t>
                       </a:r>
                     </a:p>
                   </a:txBody>
@@ -17166,17 +16621,17 @@
         </p:nvGraphicFramePr>
         <p:xfrm>
           <a:off x="365760" y="2697480"/>
-          <a:ext cx="5120638" cy="987552"/>
+          <a:ext cx="5120640" cy="987552"/>
         </p:xfrm>
         <a:graphic>
           <a:graphicData uri="http://schemas.openxmlformats.org/drawingml/2006/table">
             <a:tbl>
               <a:tblPr firstRow="1" bandRow="1"/>
               <a:tblGrid>
-                <a:gridCol w="2605237"/>
-                <a:gridCol w="718686"/>
-                <a:gridCol w="1167865"/>
-                <a:gridCol w="628850"/>
+                <a:gridCol w="2514600"/>
+                <a:gridCol w="685800"/>
+                <a:gridCol w="1371600"/>
+                <a:gridCol w="548640"/>
               </a:tblGrid>
               <a:tr h="329184">
                 <a:tc>
@@ -17337,7 +16792,7 @@
                             <a:srgbClr val="333333"/>
                           </a:solidFill>
                         </a:rPr>
-                        <a:t>Hot plasma in: 164 ÷ 0.27 ≈ 616 units</a:t>
+                        <a:t>Hot plasma in: 164 ÷ 0.266 ≈ 616 units</a:t>
                       </a:r>
                     </a:p>
                   </a:txBody>
@@ -17628,8 +17083,8 @@
         </p:nvSpPr>
         <p:spPr>
           <a:xfrm>
-            <a:off x="365760" y="3767328"/>
-            <a:ext cx="5120640" cy="640080"/>
+            <a:off x="365760" y="3858768"/>
+            <a:ext cx="5120640" cy="548640"/>
           </a:xfrm>
           <a:prstGeom prst="rect">
             <a:avLst/>
@@ -19283,7 +18738,7 @@
                   <a:srgbClr val="57068C"/>
                 </a:solidFill>
               </a:rPr>
-              <a:t>In one slide</a:t>
+              <a:t>Brief Summary</a:t>
             </a:r>
           </a:p>
         </p:txBody>
@@ -19297,7 +18752,7 @@
         <p:spPr>
           <a:xfrm>
             <a:off x="365760" y="1005840"/>
-            <a:ext cx="4114800" cy="1463040"/>
+            <a:ext cx="4114800" cy="1554480"/>
           </a:xfrm>
           <a:prstGeom prst="roundRect">
             <a:avLst>
@@ -19381,7 +18836,7 @@
         <p:spPr>
           <a:xfrm>
             <a:off x="530352" y="1481328"/>
-            <a:ext cx="3785616" cy="914400"/>
+            <a:ext cx="3785616" cy="1005840"/>
           </a:xfrm>
           <a:prstGeom prst="rect">
             <a:avLst/>
@@ -19400,7 +18855,7 @@
               </a:spcAft>
             </a:pPr>
             <a:r>
-              <a:rPr sz="1350" b="0" i="0">
+              <a:rPr sz="1300" b="0" i="0">
                 <a:solidFill>
                   <a:srgbClr val="333333"/>
                 </a:solidFill>
@@ -19419,7 +18874,7 @@
         <p:spPr>
           <a:xfrm>
             <a:off x="4663440" y="1005840"/>
-            <a:ext cx="4114800" cy="1463040"/>
+            <a:ext cx="4114800" cy="1554480"/>
           </a:xfrm>
           <a:prstGeom prst="roundRect">
             <a:avLst>
@@ -19503,7 +18958,7 @@
         <p:spPr>
           <a:xfrm>
             <a:off x="4828032" y="1481328"/>
-            <a:ext cx="3785616" cy="914400"/>
+            <a:ext cx="3785616" cy="1005840"/>
           </a:xfrm>
           <a:prstGeom prst="rect">
             <a:avLst/>
@@ -19522,7 +18977,7 @@
               </a:spcAft>
             </a:pPr>
             <a:r>
-              <a:rPr sz="1350" b="0" i="0">
+              <a:rPr sz="1300" b="0" i="0">
                 <a:solidFill>
                   <a:srgbClr val="333333"/>
                 </a:solidFill>
@@ -19540,8 +18995,8 @@
         </p:nvSpPr>
         <p:spPr>
           <a:xfrm>
-            <a:off x="365760" y="2651760"/>
-            <a:ext cx="4114800" cy="1463040"/>
+            <a:off x="365760" y="2743200"/>
+            <a:ext cx="4114800" cy="1554480"/>
           </a:xfrm>
           <a:prstGeom prst="roundRect">
             <a:avLst>
@@ -19586,7 +19041,7 @@
         </p:nvSpPr>
         <p:spPr>
           <a:xfrm>
-            <a:off x="530352" y="2779776"/>
+            <a:off x="530352" y="2871216"/>
             <a:ext cx="3785616" cy="320040"/>
           </a:xfrm>
           <a:prstGeom prst="rect">
@@ -19624,8 +19079,8 @@
         </p:nvSpPr>
         <p:spPr>
           <a:xfrm>
-            <a:off x="530352" y="3127248"/>
-            <a:ext cx="3785616" cy="914400"/>
+            <a:off x="530352" y="3218688"/>
+            <a:ext cx="3785616" cy="1005840"/>
           </a:xfrm>
           <a:prstGeom prst="rect">
             <a:avLst/>
@@ -19644,7 +19099,7 @@
               </a:spcAft>
             </a:pPr>
             <a:r>
-              <a:rPr sz="1350" b="0" i="0">
+              <a:rPr sz="1300" b="0" i="0">
                 <a:solidFill>
                   <a:srgbClr val="333333"/>
                 </a:solidFill>
@@ -19662,8 +19117,8 @@
         </p:nvSpPr>
         <p:spPr>
           <a:xfrm>
-            <a:off x="4663440" y="2651760"/>
-            <a:ext cx="4114800" cy="1463040"/>
+            <a:off x="4663440" y="2743200"/>
+            <a:ext cx="4114800" cy="1554480"/>
           </a:xfrm>
           <a:prstGeom prst="roundRect">
             <a:avLst>
@@ -19708,7 +19163,7 @@
         </p:nvSpPr>
         <p:spPr>
           <a:xfrm>
-            <a:off x="4828032" y="2779776"/>
+            <a:off x="4828032" y="2871216"/>
             <a:ext cx="3785616" cy="320040"/>
           </a:xfrm>
           <a:prstGeom prst="rect">
@@ -19746,8 +19201,8 @@
         </p:nvSpPr>
         <p:spPr>
           <a:xfrm>
-            <a:off x="4828032" y="3127248"/>
-            <a:ext cx="3785616" cy="914400"/>
+            <a:off x="4828032" y="3218688"/>
+            <a:ext cx="3785616" cy="1005840"/>
           </a:xfrm>
           <a:prstGeom prst="rect">
             <a:avLst/>
@@ -19766,12 +19221,12 @@
               </a:spcAft>
             </a:pPr>
             <a:r>
-              <a:rPr sz="1350" b="0" i="0">
+              <a:rPr sz="1300" b="0" i="0">
                 <a:solidFill>
                   <a:srgbClr val="333333"/>
                 </a:solidFill>
               </a:rPr>
-              <a:t>0.01% of pixels, ~90% of the BP error. The BP loss priced hot plasma out; a stiffer band puts it back (emission 40% → 93%).</a:t>
+              <a:t>0.01% of pixels, ~94% of the BP error. The BP loss priced hot plasma out; a stiffer band puts it back (emission 40% → 93%). Without flare cores, our BP DEM MSE is only 1.1× the supervised model's.</a:t>
             </a:r>
           </a:p>
         </p:txBody>
@@ -43234,7 +42689,7 @@
                   <a:srgbClr val="6B6B6B"/>
                 </a:solidFill>
               </a:rPr>
-              <a:t>learns the solver's objective implicitly</a:t>
+              <a:t>optimises the solver's objective directly</a:t>
             </a:r>
           </a:p>
         </p:txBody>
@@ -43356,6 +42811,17 @@
               <a:t>Model</a:t>
             </a:r>
           </a:p>
+          <a:p>
+            <a:pPr algn="ctr"/>
+            <a:r>
+              <a:rPr sz="900">
+                <a:solidFill>
+                  <a:srgbClr val="FFFFFF"/>
+                </a:solidFill>
+              </a:rPr>
+              <a:t>54 basis weights</a:t>
+            </a:r>
+          </a:p>
         </p:txBody>
       </p:sp>
       <p:sp>
@@ -43419,6 +42885,17 @@
                 </a:solidFill>
               </a:rPr>
               <a:t>18 bins</a:t>
+            </a:r>
+          </a:p>
+          <a:p>
+            <a:pPr algn="ctr"/>
+            <a:r>
+              <a:rPr sz="900">
+                <a:solidFill>
+                  <a:srgbClr val="333333"/>
+                </a:solidFill>
+              </a:rPr>
+              <a:t>via basis B</a:t>
             </a:r>
           </a:p>
         </p:txBody>
@@ -43747,44 +43224,6 @@
                 </a:solidFill>
               </a:rPr>
               <a:t>loss</a:t>
-            </a:r>
-          </a:p>
-        </p:txBody>
-      </p:sp>
-      <p:sp>
-        <p:nvSpPr>
-          <p:cNvPr id="24" name="TextBox 23"/>
-          <p:cNvSpPr txBox="1"/>
-          <p:nvPr/>
-        </p:nvSpPr>
-        <p:spPr>
-          <a:xfrm>
-            <a:off x="365760" y="3566160"/>
-            <a:ext cx="8412480" cy="457200"/>
-          </a:xfrm>
-          <a:prstGeom prst="rect">
-            <a:avLst/>
-          </a:prstGeom>
-          <a:noFill/>
-        </p:spPr>
-        <p:txBody>
-          <a:bodyPr wrap="square" anchor="t" lIns="0" rIns="0" tIns="0" bIns="0">
-            <a:spAutoFit/>
-          </a:bodyPr>
-          <a:lstStyle/>
-          <a:p>
-            <a:pPr algn="l">
-              <a:spcAft>
-                <a:spcPts val="600"/>
-              </a:spcAft>
-            </a:pPr>
-            <a:r>
-              <a:rPr sz="1250" b="1" i="0">
-                <a:solidFill>
-                  <a:srgbClr val="57068C"/>
-                </a:solidFill>
-              </a:rPr>
-              <a:t>We never train on the solver's DEMs; we use them only to evaluate.</a:t>
             </a:r>
           </a:p>
         </p:txBody>
@@ -44531,7 +43970,7 @@
                   <a:srgbClr val="333333"/>
                 </a:solidFill>
               </a:rPr>
-              <a:t>BP and ElasticNet solve for the same 54 weights (at each of 18 bins, a spike and Gaussians 0.1 and 0.2 dex wide), and their L1 term acts on those weights.</a:t>
+              <a:t>BP and ElasticNet solve for the same 54 weights (at each of 18 bins, a spike and Gaussians 0.1 and 0.2 dex wide), and their penalty terms act on those weights: L1 for BP, L1 and L2 for ElasticNet.</a:t>
             </a:r>
           </a:p>
           <a:p>
@@ -45808,7 +45247,7 @@
                   <a:srgbClr val="333333"/>
                 </a:solidFill>
               </a:rPr>
-              <a:t>Training sees AIA and σ only: 917 images, each cut into 64 blocks of 256²; every epoch draws 512 fresh pixels per block. 40 epochs (the final BP model: 240, Part 4).</a:t>
+              <a:t>Training sees AIA and σ only, no noise added: 917 images, each cut into 256 blocks of 128²; a random 64 kept per image (a quarter, fixed). Every epoch draws 512 fresh pixels per block. 40 epochs (final BP model: 240, Part 4).</a:t>
             </a:r>
           </a:p>
           <a:p>
@@ -45827,7 +45266,7 @@
                   <a:srgbClr val="333333"/>
                 </a:solidFill>
               </a:rPr>
-              <a:t>Test: 153 later days on the supervised side's protocol, the same pixels and Bright cutoffs (any channel above its top-5% cutoff, ~10% of pixels); 5 solver targets per image (the clean solve + 4 noisy re-solves), ~700M pixel DEMs per solver.</a:t>
+              <a:t>Test: 153 later days on the supervised side's protocol, the same for both models. Input: the clean AIA. Targets: 5 solver runs per image (the clean solve + 4 on noise-added copies), each scored on its own random quarter of the image: ~800M pixel DEMs (705M with a BP answer). Bright: any channel above its top-5% cutoff, ~10% of pixels.</a:t>
             </a:r>
           </a:p>
           <a:p>
@@ -46066,21 +45505,19 @@
           <p:nvPr/>
         </p:nvGraphicFramePr>
         <p:xfrm>
-          <a:off x="365760" y="1417320"/>
-          <a:ext cx="8412477" cy="1645920"/>
+          <a:off x="365760" y="1463040"/>
+          <a:ext cx="4069080" cy="1865376"/>
         </p:xfrm>
         <a:graphic>
           <a:graphicData uri="http://schemas.openxmlformats.org/drawingml/2006/table">
             <a:tbl>
               <a:tblPr firstRow="1" bandRow="1"/>
               <a:tblGrid>
-                <a:gridCol w="2877953"/>
-                <a:gridCol w="1438976"/>
-                <a:gridCol w="1438976"/>
-                <a:gridCol w="1328286"/>
-                <a:gridCol w="1328286"/>
+                <a:gridCol w="2260600"/>
+                <a:gridCol w="904240"/>
+                <a:gridCol w="904240"/>
               </a:tblGrid>
-              <a:tr h="329184">
+              <a:tr h="310896">
                 <a:tc>
                   <a:txBody>
                     <a:bodyPr wrap="square"/>
@@ -46088,12 +45525,12 @@
                     <a:p>
                       <a:pPr algn="l"/>
                       <a:r>
-                        <a:rPr sz="1150" b="1">
+                        <a:rPr sz="1100" b="1">
                           <a:solidFill>
                             <a:srgbClr val="FFFFFF"/>
                           </a:solidFill>
                         </a:rPr>
-                        <a:t/>
+                        <a:t>BP track</a:t>
                       </a:r>
                     </a:p>
                   </a:txBody>
@@ -46124,12 +45561,12 @@
                     <a:p>
                       <a:pPr algn="r"/>
                       <a:r>
-                        <a:rPr sz="1150" b="1">
+                        <a:rPr sz="1100" b="1">
                           <a:solidFill>
                             <a:srgbClr val="FFFFFF"/>
                           </a:solidFill>
                         </a:rPr>
-                        <a:t>BP: MLP</a:t>
+                        <a:t>MLP</a:t>
                       </a:r>
                     </a:p>
                   </a:txBody>
@@ -46160,12 +45597,625 @@
                     <a:p>
                       <a:pPr algn="r"/>
                       <a:r>
-                        <a:rPr sz="1150" b="1">
+                        <a:rPr sz="1100" b="1">
                           <a:solidFill>
                             <a:srgbClr val="FFFFFF"/>
                           </a:solidFill>
                         </a:rPr>
-                        <a:t>BP: CNN</a:t>
+                        <a:t>CNN</a:t>
+                      </a:r>
+                    </a:p>
+                  </a:txBody>
+                  <a:tcPr marL="54864" marR="54864" marT="27432" marB="27432" anchor="ctr">
+                    <a:lnL w="0">
+                      <a:noFill/>
+                    </a:lnL>
+                    <a:lnR w="0">
+                      <a:noFill/>
+                    </a:lnR>
+                    <a:lnT w="0">
+                      <a:noFill/>
+                    </a:lnT>
+                    <a:lnB w="6350">
+                      <a:solidFill>
+                        <a:srgbClr val="D9D3E3"/>
+                      </a:solidFill>
+                    </a:lnB>
+                    <a:solidFill>
+                      <a:srgbClr val="57068C"/>
+                    </a:solidFill>
+                  </a:tcPr>
+                </a:tc>
+              </a:tr>
+              <a:tr h="310896">
+                <a:tc>
+                  <a:txBody>
+                    <a:bodyPr wrap="square"/>
+                    <a:lstStyle/>
+                    <a:p>
+                      <a:pPr algn="l"/>
+                      <a:r>
+                        <a:rPr sz="1100" b="0">
+                          <a:solidFill>
+                            <a:srgbClr val="333333"/>
+                          </a:solidFill>
+                        </a:rPr>
+                        <a:t>Loss, typical pixel (median)</a:t>
+                      </a:r>
+                    </a:p>
+                  </a:txBody>
+                  <a:tcPr marL="54864" marR="54864" marT="27432" marB="27432" anchor="ctr">
+                    <a:lnL w="0">
+                      <a:noFill/>
+                    </a:lnL>
+                    <a:lnR w="0">
+                      <a:noFill/>
+                    </a:lnR>
+                    <a:lnT w="0">
+                      <a:noFill/>
+                    </a:lnT>
+                    <a:lnB w="6350">
+                      <a:solidFill>
+                        <a:srgbClr val="D9D3E3"/>
+                      </a:solidFill>
+                    </a:lnB>
+                    <a:solidFill>
+                      <a:srgbClr val="FFFFFF"/>
+                    </a:solidFill>
+                  </a:tcPr>
+                </a:tc>
+                <a:tc>
+                  <a:txBody>
+                    <a:bodyPr wrap="square"/>
+                    <a:lstStyle/>
+                    <a:p>
+                      <a:pPr algn="r"/>
+                      <a:r>
+                        <a:rPr sz="1100" b="1">
+                          <a:solidFill>
+                            <a:srgbClr val="333333"/>
+                          </a:solidFill>
+                        </a:rPr>
+                        <a:t>0.98</a:t>
+                      </a:r>
+                    </a:p>
+                  </a:txBody>
+                  <a:tcPr marL="54864" marR="54864" marT="27432" marB="27432" anchor="ctr">
+                    <a:lnL w="0">
+                      <a:noFill/>
+                    </a:lnL>
+                    <a:lnR w="0">
+                      <a:noFill/>
+                    </a:lnR>
+                    <a:lnT w="0">
+                      <a:noFill/>
+                    </a:lnT>
+                    <a:lnB w="6350">
+                      <a:solidFill>
+                        <a:srgbClr val="D9D3E3"/>
+                      </a:solidFill>
+                    </a:lnB>
+                    <a:solidFill>
+                      <a:srgbClr val="E3DFE9"/>
+                    </a:solidFill>
+                  </a:tcPr>
+                </a:tc>
+                <a:tc>
+                  <a:txBody>
+                    <a:bodyPr wrap="square"/>
+                    <a:lstStyle/>
+                    <a:p>
+                      <a:pPr algn="r"/>
+                      <a:r>
+                        <a:rPr sz="1100" b="0">
+                          <a:solidFill>
+                            <a:srgbClr val="333333"/>
+                          </a:solidFill>
+                        </a:rPr>
+                        <a:t>1.01</a:t>
+                      </a:r>
+                    </a:p>
+                  </a:txBody>
+                  <a:tcPr marL="54864" marR="54864" marT="27432" marB="27432" anchor="ctr">
+                    <a:lnL w="0">
+                      <a:noFill/>
+                    </a:lnL>
+                    <a:lnR w="0">
+                      <a:noFill/>
+                    </a:lnR>
+                    <a:lnT w="0">
+                      <a:noFill/>
+                    </a:lnT>
+                    <a:lnB w="6350">
+                      <a:solidFill>
+                        <a:srgbClr val="D9D3E3"/>
+                      </a:solidFill>
+                    </a:lnB>
+                    <a:solidFill>
+                      <a:srgbClr val="FFFFFF"/>
+                    </a:solidFill>
+                  </a:tcPr>
+                </a:tc>
+              </a:tr>
+              <a:tr h="310896">
+                <a:tc>
+                  <a:txBody>
+                    <a:bodyPr wrap="square"/>
+                    <a:lstStyle/>
+                    <a:p>
+                      <a:pPr algn="l"/>
+                      <a:r>
+                        <a:rPr sz="1100" b="0">
+                          <a:solidFill>
+                            <a:srgbClr val="333333"/>
+                          </a:solidFill>
+                        </a:rPr>
+                        <a:t>Loss, worst 1% (p99)</a:t>
+                      </a:r>
+                    </a:p>
+                  </a:txBody>
+                  <a:tcPr marL="54864" marR="54864" marT="27432" marB="27432" anchor="ctr">
+                    <a:lnL w="0">
+                      <a:noFill/>
+                    </a:lnL>
+                    <a:lnR w="0">
+                      <a:noFill/>
+                    </a:lnR>
+                    <a:lnT w="0">
+                      <a:noFill/>
+                    </a:lnT>
+                    <a:lnB w="6350">
+                      <a:solidFill>
+                        <a:srgbClr val="D9D3E3"/>
+                      </a:solidFill>
+                    </a:lnB>
+                    <a:solidFill>
+                      <a:srgbClr val="FFFFFF"/>
+                    </a:solidFill>
+                  </a:tcPr>
+                </a:tc>
+                <a:tc>
+                  <a:txBody>
+                    <a:bodyPr wrap="square"/>
+                    <a:lstStyle/>
+                    <a:p>
+                      <a:pPr algn="r"/>
+                      <a:r>
+                        <a:rPr sz="1100" b="1">
+                          <a:solidFill>
+                            <a:srgbClr val="333333"/>
+                          </a:solidFill>
+                        </a:rPr>
+                        <a:t>17.9</a:t>
+                      </a:r>
+                    </a:p>
+                  </a:txBody>
+                  <a:tcPr marL="54864" marR="54864" marT="27432" marB="27432" anchor="ctr">
+                    <a:lnL w="0">
+                      <a:noFill/>
+                    </a:lnL>
+                    <a:lnR w="0">
+                      <a:noFill/>
+                    </a:lnR>
+                    <a:lnT w="0">
+                      <a:noFill/>
+                    </a:lnT>
+                    <a:lnB w="6350">
+                      <a:solidFill>
+                        <a:srgbClr val="D9D3E3"/>
+                      </a:solidFill>
+                    </a:lnB>
+                    <a:solidFill>
+                      <a:srgbClr val="E3DFE9"/>
+                    </a:solidFill>
+                  </a:tcPr>
+                </a:tc>
+                <a:tc>
+                  <a:txBody>
+                    <a:bodyPr wrap="square"/>
+                    <a:lstStyle/>
+                    <a:p>
+                      <a:pPr algn="r"/>
+                      <a:r>
+                        <a:rPr sz="1100" b="0">
+                          <a:solidFill>
+                            <a:srgbClr val="333333"/>
+                          </a:solidFill>
+                        </a:rPr>
+                        <a:t>18.8</a:t>
+                      </a:r>
+                    </a:p>
+                  </a:txBody>
+                  <a:tcPr marL="54864" marR="54864" marT="27432" marB="27432" anchor="ctr">
+                    <a:lnL w="0">
+                      <a:noFill/>
+                    </a:lnL>
+                    <a:lnR w="0">
+                      <a:noFill/>
+                    </a:lnR>
+                    <a:lnT w="0">
+                      <a:noFill/>
+                    </a:lnT>
+                    <a:lnB w="6350">
+                      <a:solidFill>
+                        <a:srgbClr val="D9D3E3"/>
+                      </a:solidFill>
+                    </a:lnB>
+                    <a:solidFill>
+                      <a:srgbClr val="FFFFFF"/>
+                    </a:solidFill>
+                  </a:tcPr>
+                </a:tc>
+              </a:tr>
+              <a:tr h="310896">
+                <a:tc>
+                  <a:txBody>
+                    <a:bodyPr wrap="square"/>
+                    <a:lstStyle/>
+                    <a:p>
+                      <a:pPr algn="l"/>
+                      <a:r>
+                        <a:rPr sz="1100" b="0">
+                          <a:solidFill>
+                            <a:srgbClr val="333333"/>
+                          </a:solidFill>
+                        </a:rPr>
+                        <a:t>Loss, mean</a:t>
+                      </a:r>
+                    </a:p>
+                  </a:txBody>
+                  <a:tcPr marL="54864" marR="54864" marT="27432" marB="27432" anchor="ctr">
+                    <a:lnL w="0">
+                      <a:noFill/>
+                    </a:lnL>
+                    <a:lnR w="0">
+                      <a:noFill/>
+                    </a:lnR>
+                    <a:lnT w="0">
+                      <a:noFill/>
+                    </a:lnT>
+                    <a:lnB w="6350">
+                      <a:solidFill>
+                        <a:srgbClr val="D9D3E3"/>
+                      </a:solidFill>
+                    </a:lnB>
+                    <a:solidFill>
+                      <a:srgbClr val="FFFFFF"/>
+                    </a:solidFill>
+                  </a:tcPr>
+                </a:tc>
+                <a:tc>
+                  <a:txBody>
+                    <a:bodyPr wrap="square"/>
+                    <a:lstStyle/>
+                    <a:p>
+                      <a:pPr algn="r"/>
+                      <a:r>
+                        <a:rPr sz="1100" b="1">
+                          <a:solidFill>
+                            <a:srgbClr val="333333"/>
+                          </a:solidFill>
+                        </a:rPr>
+                        <a:t>2.07</a:t>
+                      </a:r>
+                    </a:p>
+                  </a:txBody>
+                  <a:tcPr marL="54864" marR="54864" marT="27432" marB="27432" anchor="ctr">
+                    <a:lnL w="0">
+                      <a:noFill/>
+                    </a:lnL>
+                    <a:lnR w="0">
+                      <a:noFill/>
+                    </a:lnR>
+                    <a:lnT w="0">
+                      <a:noFill/>
+                    </a:lnT>
+                    <a:lnB w="6350">
+                      <a:solidFill>
+                        <a:srgbClr val="D9D3E3"/>
+                      </a:solidFill>
+                    </a:lnB>
+                    <a:solidFill>
+                      <a:srgbClr val="E3DFE9"/>
+                    </a:solidFill>
+                  </a:tcPr>
+                </a:tc>
+                <a:tc>
+                  <a:txBody>
+                    <a:bodyPr wrap="square"/>
+                    <a:lstStyle/>
+                    <a:p>
+                      <a:pPr algn="r"/>
+                      <a:r>
+                        <a:rPr sz="1100" b="0">
+                          <a:solidFill>
+                            <a:srgbClr val="333333"/>
+                          </a:solidFill>
+                        </a:rPr>
+                        <a:t>2.24</a:t>
+                      </a:r>
+                    </a:p>
+                  </a:txBody>
+                  <a:tcPr marL="54864" marR="54864" marT="27432" marB="27432" anchor="ctr">
+                    <a:lnL w="0">
+                      <a:noFill/>
+                    </a:lnL>
+                    <a:lnR w="0">
+                      <a:noFill/>
+                    </a:lnR>
+                    <a:lnT w="0">
+                      <a:noFill/>
+                    </a:lnT>
+                    <a:lnB w="6350">
+                      <a:solidFill>
+                        <a:srgbClr val="D9D3E3"/>
+                      </a:solidFill>
+                    </a:lnB>
+                    <a:solidFill>
+                      <a:srgbClr val="FFFFFF"/>
+                    </a:solidFill>
+                  </a:tcPr>
+                </a:tc>
+              </a:tr>
+              <a:tr h="310896">
+                <a:tc>
+                  <a:txBody>
+                    <a:bodyPr wrap="square"/>
+                    <a:lstStyle/>
+                    <a:p>
+                      <a:pPr algn="l"/>
+                      <a:r>
+                        <a:rPr sz="1100" b="0">
+                          <a:solidFill>
+                            <a:srgbClr val="333333"/>
+                          </a:solidFill>
+                        </a:rPr>
+                        <a:t>AIA MAE</a:t>
+                      </a:r>
+                    </a:p>
+                  </a:txBody>
+                  <a:tcPr marL="54864" marR="54864" marT="27432" marB="27432" anchor="ctr">
+                    <a:lnL w="0">
+                      <a:noFill/>
+                    </a:lnL>
+                    <a:lnR w="0">
+                      <a:noFill/>
+                    </a:lnR>
+                    <a:lnT w="0">
+                      <a:noFill/>
+                    </a:lnT>
+                    <a:lnB w="6350">
+                      <a:solidFill>
+                        <a:srgbClr val="D9D3E3"/>
+                      </a:solidFill>
+                    </a:lnB>
+                    <a:solidFill>
+                      <a:srgbClr val="FFFFFF"/>
+                    </a:solidFill>
+                  </a:tcPr>
+                </a:tc>
+                <a:tc>
+                  <a:txBody>
+                    <a:bodyPr wrap="square"/>
+                    <a:lstStyle/>
+                    <a:p>
+                      <a:pPr algn="r"/>
+                      <a:r>
+                        <a:rPr sz="1100" b="0">
+                          <a:solidFill>
+                            <a:srgbClr val="333333"/>
+                          </a:solidFill>
+                        </a:rPr>
+                        <a:t>4.93</a:t>
+                      </a:r>
+                    </a:p>
+                  </a:txBody>
+                  <a:tcPr marL="54864" marR="54864" marT="27432" marB="27432" anchor="ctr">
+                    <a:lnL w="0">
+                      <a:noFill/>
+                    </a:lnL>
+                    <a:lnR w="0">
+                      <a:noFill/>
+                    </a:lnR>
+                    <a:lnT w="0">
+                      <a:noFill/>
+                    </a:lnT>
+                    <a:lnB w="6350">
+                      <a:solidFill>
+                        <a:srgbClr val="D9D3E3"/>
+                      </a:solidFill>
+                    </a:lnB>
+                    <a:solidFill>
+                      <a:srgbClr val="FFFFFF"/>
+                    </a:solidFill>
+                  </a:tcPr>
+                </a:tc>
+                <a:tc>
+                  <a:txBody>
+                    <a:bodyPr wrap="square"/>
+                    <a:lstStyle/>
+                    <a:p>
+                      <a:pPr algn="r"/>
+                      <a:r>
+                        <a:rPr sz="1100" b="1">
+                          <a:solidFill>
+                            <a:srgbClr val="333333"/>
+                          </a:solidFill>
+                        </a:rPr>
+                        <a:t>4.73</a:t>
+                      </a:r>
+                    </a:p>
+                  </a:txBody>
+                  <a:tcPr marL="54864" marR="54864" marT="27432" marB="27432" anchor="ctr">
+                    <a:lnL w="0">
+                      <a:noFill/>
+                    </a:lnL>
+                    <a:lnR w="0">
+                      <a:noFill/>
+                    </a:lnR>
+                    <a:lnT w="0">
+                      <a:noFill/>
+                    </a:lnT>
+                    <a:lnB w="6350">
+                      <a:solidFill>
+                        <a:srgbClr val="D9D3E3"/>
+                      </a:solidFill>
+                    </a:lnB>
+                    <a:solidFill>
+                      <a:srgbClr val="E3DFE9"/>
+                    </a:solidFill>
+                  </a:tcPr>
+                </a:tc>
+              </a:tr>
+              <a:tr h="310896">
+                <a:tc>
+                  <a:txBody>
+                    <a:bodyPr wrap="square"/>
+                    <a:lstStyle/>
+                    <a:p>
+                      <a:pPr algn="l"/>
+                      <a:r>
+                        <a:rPr sz="1100" b="0">
+                          <a:solidFill>
+                            <a:srgbClr val="333333"/>
+                          </a:solidFill>
+                        </a:rPr>
+                        <a:t>Sparsity (solver: 1.79)</a:t>
+                      </a:r>
+                    </a:p>
+                  </a:txBody>
+                  <a:tcPr marL="54864" marR="54864" marT="27432" marB="27432" anchor="ctr">
+                    <a:lnL w="0">
+                      <a:noFill/>
+                    </a:lnL>
+                    <a:lnR w="0">
+                      <a:noFill/>
+                    </a:lnR>
+                    <a:lnT w="0">
+                      <a:noFill/>
+                    </a:lnT>
+                    <a:lnB w="6350">
+                      <a:solidFill>
+                        <a:srgbClr val="D9D3E3"/>
+                      </a:solidFill>
+                    </a:lnB>
+                    <a:solidFill>
+                      <a:srgbClr val="FFFFFF"/>
+                    </a:solidFill>
+                  </a:tcPr>
+                </a:tc>
+                <a:tc>
+                  <a:txBody>
+                    <a:bodyPr wrap="square"/>
+                    <a:lstStyle/>
+                    <a:p>
+                      <a:pPr algn="r"/>
+                      <a:r>
+                        <a:rPr sz="1100" b="1">
+                          <a:solidFill>
+                            <a:srgbClr val="333333"/>
+                          </a:solidFill>
+                        </a:rPr>
+                        <a:t>1.90</a:t>
+                      </a:r>
+                    </a:p>
+                  </a:txBody>
+                  <a:tcPr marL="54864" marR="54864" marT="27432" marB="27432" anchor="ctr">
+                    <a:lnL w="0">
+                      <a:noFill/>
+                    </a:lnL>
+                    <a:lnR w="0">
+                      <a:noFill/>
+                    </a:lnR>
+                    <a:lnT w="0">
+                      <a:noFill/>
+                    </a:lnT>
+                    <a:lnB w="6350">
+                      <a:solidFill>
+                        <a:srgbClr val="D9D3E3"/>
+                      </a:solidFill>
+                    </a:lnB>
+                    <a:solidFill>
+                      <a:srgbClr val="E3DFE9"/>
+                    </a:solidFill>
+                  </a:tcPr>
+                </a:tc>
+                <a:tc>
+                  <a:txBody>
+                    <a:bodyPr wrap="square"/>
+                    <a:lstStyle/>
+                    <a:p>
+                      <a:pPr algn="r"/>
+                      <a:r>
+                        <a:rPr sz="1100" b="0">
+                          <a:solidFill>
+                            <a:srgbClr val="333333"/>
+                          </a:solidFill>
+                        </a:rPr>
+                        <a:t>2.03</a:t>
+                      </a:r>
+                    </a:p>
+                  </a:txBody>
+                  <a:tcPr marL="54864" marR="54864" marT="27432" marB="27432" anchor="ctr">
+                    <a:lnL w="0">
+                      <a:noFill/>
+                    </a:lnL>
+                    <a:lnR w="0">
+                      <a:noFill/>
+                    </a:lnR>
+                    <a:lnT w="0">
+                      <a:noFill/>
+                    </a:lnT>
+                    <a:lnB w="6350">
+                      <a:solidFill>
+                        <a:srgbClr val="D9D3E3"/>
+                      </a:solidFill>
+                    </a:lnB>
+                    <a:solidFill>
+                      <a:srgbClr val="FFFFFF"/>
+                    </a:solidFill>
+                  </a:tcPr>
+                </a:tc>
+              </a:tr>
+            </a:tbl>
+          </a:graphicData>
+        </a:graphic>
+      </p:graphicFrame>
+      <p:graphicFrame>
+        <p:nvGraphicFramePr>
+          <p:cNvPr id="5" name="Table 4"/>
+          <p:cNvGraphicFramePr>
+            <a:graphicFrameLocks noGrp="1"/>
+          </p:cNvGraphicFramePr>
+          <p:nvPr/>
+        </p:nvGraphicFramePr>
+        <p:xfrm>
+          <a:off x="4709160" y="1463040"/>
+          <a:ext cx="4069080" cy="1554480"/>
+        </p:xfrm>
+        <a:graphic>
+          <a:graphicData uri="http://schemas.openxmlformats.org/drawingml/2006/table">
+            <a:tbl>
+              <a:tblPr firstRow="1" bandRow="1"/>
+              <a:tblGrid>
+                <a:gridCol w="2260600"/>
+                <a:gridCol w="904240"/>
+                <a:gridCol w="904240"/>
+              </a:tblGrid>
+              <a:tr h="310896">
+                <a:tc>
+                  <a:txBody>
+                    <a:bodyPr wrap="square"/>
+                    <a:lstStyle/>
+                    <a:p>
+                      <a:pPr algn="l"/>
+                      <a:r>
+                        <a:rPr sz="1100" b="1">
+                          <a:solidFill>
+                            <a:srgbClr val="FFFFFF"/>
+                          </a:solidFill>
+                        </a:rPr>
+                        <a:t>ElasticNet track</a:t>
                       </a:r>
                     </a:p>
                   </a:txBody>
@@ -46196,12 +46246,12 @@
                     <a:p>
                       <a:pPr algn="r"/>
                       <a:r>
-                        <a:rPr sz="1150" b="1">
+                        <a:rPr sz="1100" b="1">
                           <a:solidFill>
                             <a:srgbClr val="FFFFFF"/>
                           </a:solidFill>
                         </a:rPr>
-                        <a:t>ENet: MLP</a:t>
+                        <a:t>MLP</a:t>
                       </a:r>
                     </a:p>
                   </a:txBody>
@@ -46232,12 +46282,12 @@
                     <a:p>
                       <a:pPr algn="r"/>
                       <a:r>
-                        <a:rPr sz="1150" b="1">
+                        <a:rPr sz="1100" b="1">
                           <a:solidFill>
                             <a:srgbClr val="FFFFFF"/>
                           </a:solidFill>
                         </a:rPr>
-                        <a:t>ENet: CNN</a:t>
+                        <a:t>CNN</a:t>
                       </a:r>
                     </a:p>
                   </a:txBody>
@@ -46262,7 +46312,7 @@
                   </a:tcPr>
                 </a:tc>
               </a:tr>
-              <a:tr h="329184">
+              <a:tr h="310896">
                 <a:tc>
                   <a:txBody>
                     <a:bodyPr wrap="square"/>
@@ -46270,12 +46320,12 @@
                     <a:p>
                       <a:pPr algn="l"/>
                       <a:r>
-                        <a:rPr sz="1150" b="0">
+                        <a:rPr sz="1100" b="0">
                           <a:solidFill>
                             <a:srgbClr val="333333"/>
                           </a:solidFill>
                         </a:rPr>
-                        <a:t>Training objective (test)</a:t>
+                        <a:t>Loss, typical pixel (median)</a:t>
                       </a:r>
                     </a:p>
                   </a:txBody>
@@ -46306,12 +46356,86 @@
                     <a:p>
                       <a:pPr algn="r"/>
                       <a:r>
-                        <a:rPr sz="1150" b="1">
+                        <a:rPr sz="1100" b="1">
                           <a:solidFill>
                             <a:srgbClr val="333333"/>
                           </a:solidFill>
                         </a:rPr>
-                        <a:t>2.07</a:t>
+                        <a:t>0.020</a:t>
+                      </a:r>
+                    </a:p>
+                  </a:txBody>
+                  <a:tcPr marL="54864" marR="54864" marT="27432" marB="27432" anchor="ctr">
+                    <a:lnL w="0">
+                      <a:noFill/>
+                    </a:lnL>
+                    <a:lnR w="0">
+                      <a:noFill/>
+                    </a:lnR>
+                    <a:lnT w="0">
+                      <a:noFill/>
+                    </a:lnT>
+                    <a:lnB w="6350">
+                      <a:solidFill>
+                        <a:srgbClr val="D9D3E3"/>
+                      </a:solidFill>
+                    </a:lnB>
+                    <a:solidFill>
+                      <a:srgbClr val="E3DFE9"/>
+                    </a:solidFill>
+                  </a:tcPr>
+                </a:tc>
+                <a:tc>
+                  <a:txBody>
+                    <a:bodyPr wrap="square"/>
+                    <a:lstStyle/>
+                    <a:p>
+                      <a:pPr algn="r"/>
+                      <a:r>
+                        <a:rPr sz="1100" b="0">
+                          <a:solidFill>
+                            <a:srgbClr val="333333"/>
+                          </a:solidFill>
+                        </a:rPr>
+                        <a:t>0.033</a:t>
+                      </a:r>
+                    </a:p>
+                  </a:txBody>
+                  <a:tcPr marL="54864" marR="54864" marT="27432" marB="27432" anchor="ctr">
+                    <a:lnL w="0">
+                      <a:noFill/>
+                    </a:lnL>
+                    <a:lnR w="0">
+                      <a:noFill/>
+                    </a:lnR>
+                    <a:lnT w="0">
+                      <a:noFill/>
+                    </a:lnT>
+                    <a:lnB w="6350">
+                      <a:solidFill>
+                        <a:srgbClr val="D9D3E3"/>
+                      </a:solidFill>
+                    </a:lnB>
+                    <a:solidFill>
+                      <a:srgbClr val="FFFFFF"/>
+                    </a:solidFill>
+                  </a:tcPr>
+                </a:tc>
+              </a:tr>
+              <a:tr h="310896">
+                <a:tc>
+                  <a:txBody>
+                    <a:bodyPr wrap="square"/>
+                    <a:lstStyle/>
+                    <a:p>
+                      <a:pPr algn="l"/>
+                      <a:r>
+                        <a:rPr sz="1100" b="0">
+                          <a:solidFill>
+                            <a:srgbClr val="333333"/>
+                          </a:solidFill>
+                        </a:rPr>
+                        <a:t>Loss, worst 1% (p99)</a:t>
                       </a:r>
                     </a:p>
                   </a:txBody>
@@ -46342,12 +46466,86 @@
                     <a:p>
                       <a:pPr algn="r"/>
                       <a:r>
-                        <a:rPr sz="1150" b="0">
+                        <a:rPr sz="1100" b="1">
                           <a:solidFill>
                             <a:srgbClr val="333333"/>
                           </a:solidFill>
                         </a:rPr>
-                        <a:t>2.24</a:t>
+                        <a:t>0.47</a:t>
+                      </a:r>
+                    </a:p>
+                  </a:txBody>
+                  <a:tcPr marL="54864" marR="54864" marT="27432" marB="27432" anchor="ctr">
+                    <a:lnL w="0">
+                      <a:noFill/>
+                    </a:lnL>
+                    <a:lnR w="0">
+                      <a:noFill/>
+                    </a:lnR>
+                    <a:lnT w="0">
+                      <a:noFill/>
+                    </a:lnT>
+                    <a:lnB w="6350">
+                      <a:solidFill>
+                        <a:srgbClr val="D9D3E3"/>
+                      </a:solidFill>
+                    </a:lnB>
+                    <a:solidFill>
+                      <a:srgbClr val="E3DFE9"/>
+                    </a:solidFill>
+                  </a:tcPr>
+                </a:tc>
+                <a:tc>
+                  <a:txBody>
+                    <a:bodyPr wrap="square"/>
+                    <a:lstStyle/>
+                    <a:p>
+                      <a:pPr algn="r"/>
+                      <a:r>
+                        <a:rPr sz="1100" b="0">
+                          <a:solidFill>
+                            <a:srgbClr val="333333"/>
+                          </a:solidFill>
+                        </a:rPr>
+                        <a:t>0.52</a:t>
+                      </a:r>
+                    </a:p>
+                  </a:txBody>
+                  <a:tcPr marL="54864" marR="54864" marT="27432" marB="27432" anchor="ctr">
+                    <a:lnL w="0">
+                      <a:noFill/>
+                    </a:lnL>
+                    <a:lnR w="0">
+                      <a:noFill/>
+                    </a:lnR>
+                    <a:lnT w="0">
+                      <a:noFill/>
+                    </a:lnT>
+                    <a:lnB w="6350">
+                      <a:solidFill>
+                        <a:srgbClr val="D9D3E3"/>
+                      </a:solidFill>
+                    </a:lnB>
+                    <a:solidFill>
+                      <a:srgbClr val="FFFFFF"/>
+                    </a:solidFill>
+                  </a:tcPr>
+                </a:tc>
+              </a:tr>
+              <a:tr h="310896">
+                <a:tc>
+                  <a:txBody>
+                    <a:bodyPr wrap="square"/>
+                    <a:lstStyle/>
+                    <a:p>
+                      <a:pPr algn="l"/>
+                      <a:r>
+                        <a:rPr sz="1100" b="0">
+                          <a:solidFill>
+                            <a:srgbClr val="333333"/>
+                          </a:solidFill>
+                        </a:rPr>
+                        <a:t>Loss, mean</a:t>
                       </a:r>
                     </a:p>
                   </a:txBody>
@@ -46378,12 +46576,86 @@
                     <a:p>
                       <a:pPr algn="r"/>
                       <a:r>
-                        <a:rPr sz="1150" b="1">
+                        <a:rPr sz="1100" b="1">
                           <a:solidFill>
                             <a:srgbClr val="333333"/>
                           </a:solidFill>
                         </a:rPr>
                         <a:t>0.057</a:t>
+                      </a:r>
+                    </a:p>
+                  </a:txBody>
+                  <a:tcPr marL="54864" marR="54864" marT="27432" marB="27432" anchor="ctr">
+                    <a:lnL w="0">
+                      <a:noFill/>
+                    </a:lnL>
+                    <a:lnR w="0">
+                      <a:noFill/>
+                    </a:lnR>
+                    <a:lnT w="0">
+                      <a:noFill/>
+                    </a:lnT>
+                    <a:lnB w="6350">
+                      <a:solidFill>
+                        <a:srgbClr val="D9D3E3"/>
+                      </a:solidFill>
+                    </a:lnB>
+                    <a:solidFill>
+                      <a:srgbClr val="E3DFE9"/>
+                    </a:solidFill>
+                  </a:tcPr>
+                </a:tc>
+                <a:tc>
+                  <a:txBody>
+                    <a:bodyPr wrap="square"/>
+                    <a:lstStyle/>
+                    <a:p>
+                      <a:pPr algn="r"/>
+                      <a:r>
+                        <a:rPr sz="1100" b="0">
+                          <a:solidFill>
+                            <a:srgbClr val="333333"/>
+                          </a:solidFill>
+                        </a:rPr>
+                        <a:t>0.245</a:t>
+                      </a:r>
+                    </a:p>
+                  </a:txBody>
+                  <a:tcPr marL="54864" marR="54864" marT="27432" marB="27432" anchor="ctr">
+                    <a:lnL w="0">
+                      <a:noFill/>
+                    </a:lnL>
+                    <a:lnR w="0">
+                      <a:noFill/>
+                    </a:lnR>
+                    <a:lnT w="0">
+                      <a:noFill/>
+                    </a:lnT>
+                    <a:lnB w="6350">
+                      <a:solidFill>
+                        <a:srgbClr val="D9D3E3"/>
+                      </a:solidFill>
+                    </a:lnB>
+                    <a:solidFill>
+                      <a:srgbClr val="FFFFFF"/>
+                    </a:solidFill>
+                  </a:tcPr>
+                </a:tc>
+              </a:tr>
+              <a:tr h="310896">
+                <a:tc>
+                  <a:txBody>
+                    <a:bodyPr wrap="square"/>
+                    <a:lstStyle/>
+                    <a:p>
+                      <a:pPr algn="l"/>
+                      <a:r>
+                        <a:rPr sz="1100" b="0">
+                          <a:solidFill>
+                            <a:srgbClr val="333333"/>
+                          </a:solidFill>
+                        </a:rPr>
+                        <a:t>AIA MAE</a:t>
                       </a:r>
                     </a:p>
                   </a:txBody>
@@ -46414,12 +46686,12 @@
                     <a:p>
                       <a:pPr algn="r"/>
                       <a:r>
-                        <a:rPr sz="1150" b="0">
+                        <a:rPr sz="1100" b="1">
                           <a:solidFill>
                             <a:srgbClr val="333333"/>
                           </a:solidFill>
                         </a:rPr>
-                        <a:t>0.245</a:t>
+                        <a:t>0.54</a:t>
                       </a:r>
                     </a:p>
                   </a:txBody>
@@ -46439,45 +46711,7 @@
                       </a:solidFill>
                     </a:lnB>
                     <a:solidFill>
-                      <a:srgbClr val="FFFFFF"/>
-                    </a:solidFill>
-                  </a:tcPr>
-                </a:tc>
-              </a:tr>
-              <a:tr h="329184">
-                <a:tc>
-                  <a:txBody>
-                    <a:bodyPr wrap="square"/>
-                    <a:lstStyle/>
-                    <a:p>
-                      <a:pPr algn="l"/>
-                      <a:r>
-                        <a:rPr sz="1150" b="0">
-                          <a:solidFill>
-                            <a:srgbClr val="333333"/>
-                          </a:solidFill>
-                        </a:rPr>
-                        <a:t>BP objective: median / p99</a:t>
-                      </a:r>
-                    </a:p>
-                  </a:txBody>
-                  <a:tcPr marL="54864" marR="54864" marT="27432" marB="27432" anchor="ctr">
-                    <a:lnL w="0">
-                      <a:noFill/>
-                    </a:lnL>
-                    <a:lnR w="0">
-                      <a:noFill/>
-                    </a:lnR>
-                    <a:lnT w="0">
-                      <a:noFill/>
-                    </a:lnT>
-                    <a:lnB w="6350">
-                      <a:solidFill>
-                        <a:srgbClr val="D9D3E3"/>
-                      </a:solidFill>
-                    </a:lnB>
-                    <a:solidFill>
-                      <a:srgbClr val="FFFFFF"/>
+                      <a:srgbClr val="E3DFE9"/>
                     </a:solidFill>
                   </a:tcPr>
                 </a:tc>
@@ -46488,479 +46722,7 @@
                     <a:p>
                       <a:pPr algn="r"/>
                       <a:r>
-                        <a:rPr sz="1150" b="1">
-                          <a:solidFill>
-                            <a:srgbClr val="333333"/>
-                          </a:solidFill>
-                        </a:rPr>
-                        <a:t>0.98 / 17.9</a:t>
-                      </a:r>
-                    </a:p>
-                  </a:txBody>
-                  <a:tcPr marL="54864" marR="54864" marT="27432" marB="27432" anchor="ctr">
-                    <a:lnL w="0">
-                      <a:noFill/>
-                    </a:lnL>
-                    <a:lnR w="0">
-                      <a:noFill/>
-                    </a:lnR>
-                    <a:lnT w="0">
-                      <a:noFill/>
-                    </a:lnT>
-                    <a:lnB w="6350">
-                      <a:solidFill>
-                        <a:srgbClr val="D9D3E3"/>
-                      </a:solidFill>
-                    </a:lnB>
-                    <a:solidFill>
-                      <a:srgbClr val="FFFFFF"/>
-                    </a:solidFill>
-                  </a:tcPr>
-                </a:tc>
-                <a:tc>
-                  <a:txBody>
-                    <a:bodyPr wrap="square"/>
-                    <a:lstStyle/>
-                    <a:p>
-                      <a:pPr algn="r"/>
-                      <a:r>
-                        <a:rPr sz="1150" b="0">
-                          <a:solidFill>
-                            <a:srgbClr val="333333"/>
-                          </a:solidFill>
-                        </a:rPr>
-                        <a:t>1.01 / 18.8</a:t>
-                      </a:r>
-                    </a:p>
-                  </a:txBody>
-                  <a:tcPr marL="54864" marR="54864" marT="27432" marB="27432" anchor="ctr">
-                    <a:lnL w="0">
-                      <a:noFill/>
-                    </a:lnL>
-                    <a:lnR w="0">
-                      <a:noFill/>
-                    </a:lnR>
-                    <a:lnT w="0">
-                      <a:noFill/>
-                    </a:lnT>
-                    <a:lnB w="6350">
-                      <a:solidFill>
-                        <a:srgbClr val="D9D3E3"/>
-                      </a:solidFill>
-                    </a:lnB>
-                    <a:solidFill>
-                      <a:srgbClr val="FFFFFF"/>
-                    </a:solidFill>
-                  </a:tcPr>
-                </a:tc>
-                <a:tc>
-                  <a:txBody>
-                    <a:bodyPr wrap="square"/>
-                    <a:lstStyle/>
-                    <a:p>
-                      <a:pPr algn="r"/>
-                      <a:r>
-                        <a:rPr sz="1150" b="0">
-                          <a:solidFill>
-                            <a:srgbClr val="333333"/>
-                          </a:solidFill>
-                        </a:rPr>
-                        <a:t/>
-                      </a:r>
-                    </a:p>
-                  </a:txBody>
-                  <a:tcPr marL="54864" marR="54864" marT="27432" marB="27432" anchor="ctr">
-                    <a:lnL w="0">
-                      <a:noFill/>
-                    </a:lnL>
-                    <a:lnR w="0">
-                      <a:noFill/>
-                    </a:lnR>
-                    <a:lnT w="0">
-                      <a:noFill/>
-                    </a:lnT>
-                    <a:lnB w="6350">
-                      <a:solidFill>
-                        <a:srgbClr val="D9D3E3"/>
-                      </a:solidFill>
-                    </a:lnB>
-                    <a:solidFill>
-                      <a:srgbClr val="FFFFFF"/>
-                    </a:solidFill>
-                  </a:tcPr>
-                </a:tc>
-                <a:tc>
-                  <a:txBody>
-                    <a:bodyPr wrap="square"/>
-                    <a:lstStyle/>
-                    <a:p>
-                      <a:pPr algn="r"/>
-                      <a:r>
-                        <a:rPr sz="1150" b="0">
-                          <a:solidFill>
-                            <a:srgbClr val="333333"/>
-                          </a:solidFill>
-                        </a:rPr>
-                        <a:t/>
-                      </a:r>
-                    </a:p>
-                  </a:txBody>
-                  <a:tcPr marL="54864" marR="54864" marT="27432" marB="27432" anchor="ctr">
-                    <a:lnL w="0">
-                      <a:noFill/>
-                    </a:lnL>
-                    <a:lnR w="0">
-                      <a:noFill/>
-                    </a:lnR>
-                    <a:lnT w="0">
-                      <a:noFill/>
-                    </a:lnT>
-                    <a:lnB w="6350">
-                      <a:solidFill>
-                        <a:srgbClr val="D9D3E3"/>
-                      </a:solidFill>
-                    </a:lnB>
-                    <a:solidFill>
-                      <a:srgbClr val="FFFFFF"/>
-                    </a:solidFill>
-                  </a:tcPr>
-                </a:tc>
-              </a:tr>
-              <a:tr h="329184">
-                <a:tc>
-                  <a:txBody>
-                    <a:bodyPr wrap="square"/>
-                    <a:lstStyle/>
-                    <a:p>
-                      <a:pPr algn="l"/>
-                      <a:r>
-                        <a:rPr sz="1150" b="0">
-                          <a:solidFill>
-                            <a:srgbClr val="333333"/>
-                          </a:solidFill>
-                        </a:rPr>
-                        <a:t>Sparsity (BP 1.79)</a:t>
-                      </a:r>
-                    </a:p>
-                  </a:txBody>
-                  <a:tcPr marL="54864" marR="54864" marT="27432" marB="27432" anchor="ctr">
-                    <a:lnL w="0">
-                      <a:noFill/>
-                    </a:lnL>
-                    <a:lnR w="0">
-                      <a:noFill/>
-                    </a:lnR>
-                    <a:lnT w="0">
-                      <a:noFill/>
-                    </a:lnT>
-                    <a:lnB w="6350">
-                      <a:solidFill>
-                        <a:srgbClr val="D9D3E3"/>
-                      </a:solidFill>
-                    </a:lnB>
-                    <a:solidFill>
-                      <a:srgbClr val="FFFFFF"/>
-                    </a:solidFill>
-                  </a:tcPr>
-                </a:tc>
-                <a:tc>
-                  <a:txBody>
-                    <a:bodyPr wrap="square"/>
-                    <a:lstStyle/>
-                    <a:p>
-                      <a:pPr algn="r"/>
-                      <a:r>
-                        <a:rPr sz="1150" b="1">
-                          <a:solidFill>
-                            <a:srgbClr val="333333"/>
-                          </a:solidFill>
-                        </a:rPr>
-                        <a:t>1.90</a:t>
-                      </a:r>
-                    </a:p>
-                  </a:txBody>
-                  <a:tcPr marL="54864" marR="54864" marT="27432" marB="27432" anchor="ctr">
-                    <a:lnL w="0">
-                      <a:noFill/>
-                    </a:lnL>
-                    <a:lnR w="0">
-                      <a:noFill/>
-                    </a:lnR>
-                    <a:lnT w="0">
-                      <a:noFill/>
-                    </a:lnT>
-                    <a:lnB w="6350">
-                      <a:solidFill>
-                        <a:srgbClr val="D9D3E3"/>
-                      </a:solidFill>
-                    </a:lnB>
-                    <a:solidFill>
-                      <a:srgbClr val="FFFFFF"/>
-                    </a:solidFill>
-                  </a:tcPr>
-                </a:tc>
-                <a:tc>
-                  <a:txBody>
-                    <a:bodyPr wrap="square"/>
-                    <a:lstStyle/>
-                    <a:p>
-                      <a:pPr algn="r"/>
-                      <a:r>
-                        <a:rPr sz="1150" b="0">
-                          <a:solidFill>
-                            <a:srgbClr val="333333"/>
-                          </a:solidFill>
-                        </a:rPr>
-                        <a:t>2.03</a:t>
-                      </a:r>
-                    </a:p>
-                  </a:txBody>
-                  <a:tcPr marL="54864" marR="54864" marT="27432" marB="27432" anchor="ctr">
-                    <a:lnL w="0">
-                      <a:noFill/>
-                    </a:lnL>
-                    <a:lnR w="0">
-                      <a:noFill/>
-                    </a:lnR>
-                    <a:lnT w="0">
-                      <a:noFill/>
-                    </a:lnT>
-                    <a:lnB w="6350">
-                      <a:solidFill>
-                        <a:srgbClr val="D9D3E3"/>
-                      </a:solidFill>
-                    </a:lnB>
-                    <a:solidFill>
-                      <a:srgbClr val="FFFFFF"/>
-                    </a:solidFill>
-                  </a:tcPr>
-                </a:tc>
-                <a:tc>
-                  <a:txBody>
-                    <a:bodyPr wrap="square"/>
-                    <a:lstStyle/>
-                    <a:p>
-                      <a:pPr algn="r"/>
-                      <a:r>
-                        <a:rPr sz="1150" b="0">
-                          <a:solidFill>
-                            <a:srgbClr val="333333"/>
-                          </a:solidFill>
-                        </a:rPr>
-                        <a:t>5.53</a:t>
-                      </a:r>
-                    </a:p>
-                  </a:txBody>
-                  <a:tcPr marL="54864" marR="54864" marT="27432" marB="27432" anchor="ctr">
-                    <a:lnL w="0">
-                      <a:noFill/>
-                    </a:lnL>
-                    <a:lnR w="0">
-                      <a:noFill/>
-                    </a:lnR>
-                    <a:lnT w="0">
-                      <a:noFill/>
-                    </a:lnT>
-                    <a:lnB w="6350">
-                      <a:solidFill>
-                        <a:srgbClr val="D9D3E3"/>
-                      </a:solidFill>
-                    </a:lnB>
-                    <a:solidFill>
-                      <a:srgbClr val="FFFFFF"/>
-                    </a:solidFill>
-                  </a:tcPr>
-                </a:tc>
-                <a:tc>
-                  <a:txBody>
-                    <a:bodyPr wrap="square"/>
-                    <a:lstStyle/>
-                    <a:p>
-                      <a:pPr algn="r"/>
-                      <a:r>
-                        <a:rPr sz="1150" b="0">
-                          <a:solidFill>
-                            <a:srgbClr val="333333"/>
-                          </a:solidFill>
-                        </a:rPr>
-                        <a:t>5.17</a:t>
-                      </a:r>
-                    </a:p>
-                  </a:txBody>
-                  <a:tcPr marL="54864" marR="54864" marT="27432" marB="27432" anchor="ctr">
-                    <a:lnL w="0">
-                      <a:noFill/>
-                    </a:lnL>
-                    <a:lnR w="0">
-                      <a:noFill/>
-                    </a:lnR>
-                    <a:lnT w="0">
-                      <a:noFill/>
-                    </a:lnT>
-                    <a:lnB w="6350">
-                      <a:solidFill>
-                        <a:srgbClr val="D9D3E3"/>
-                      </a:solidFill>
-                    </a:lnB>
-                    <a:solidFill>
-                      <a:srgbClr val="FFFFFF"/>
-                    </a:solidFill>
-                  </a:tcPr>
-                </a:tc>
-              </a:tr>
-              <a:tr h="329184">
-                <a:tc>
-                  <a:txBody>
-                    <a:bodyPr wrap="square"/>
-                    <a:lstStyle/>
-                    <a:p>
-                      <a:pPr algn="l"/>
-                      <a:r>
-                        <a:rPr sz="1150" b="0">
-                          <a:solidFill>
-                            <a:srgbClr val="333333"/>
-                          </a:solidFill>
-                        </a:rPr>
-                        <a:t>AIA MAE</a:t>
-                      </a:r>
-                    </a:p>
-                  </a:txBody>
-                  <a:tcPr marL="54864" marR="54864" marT="27432" marB="27432" anchor="ctr">
-                    <a:lnL w="0">
-                      <a:noFill/>
-                    </a:lnL>
-                    <a:lnR w="0">
-                      <a:noFill/>
-                    </a:lnR>
-                    <a:lnT w="0">
-                      <a:noFill/>
-                    </a:lnT>
-                    <a:lnB w="6350">
-                      <a:solidFill>
-                        <a:srgbClr val="D9D3E3"/>
-                      </a:solidFill>
-                    </a:lnB>
-                    <a:solidFill>
-                      <a:srgbClr val="FFFFFF"/>
-                    </a:solidFill>
-                  </a:tcPr>
-                </a:tc>
-                <a:tc>
-                  <a:txBody>
-                    <a:bodyPr wrap="square"/>
-                    <a:lstStyle/>
-                    <a:p>
-                      <a:pPr algn="r"/>
-                      <a:r>
-                        <a:rPr sz="1150" b="0">
-                          <a:solidFill>
-                            <a:srgbClr val="333333"/>
-                          </a:solidFill>
-                        </a:rPr>
-                        <a:t>4.93</a:t>
-                      </a:r>
-                    </a:p>
-                  </a:txBody>
-                  <a:tcPr marL="54864" marR="54864" marT="27432" marB="27432" anchor="ctr">
-                    <a:lnL w="0">
-                      <a:noFill/>
-                    </a:lnL>
-                    <a:lnR w="0">
-                      <a:noFill/>
-                    </a:lnR>
-                    <a:lnT w="0">
-                      <a:noFill/>
-                    </a:lnT>
-                    <a:lnB w="6350">
-                      <a:solidFill>
-                        <a:srgbClr val="D9D3E3"/>
-                      </a:solidFill>
-                    </a:lnB>
-                    <a:solidFill>
-                      <a:srgbClr val="FFFFFF"/>
-                    </a:solidFill>
-                  </a:tcPr>
-                </a:tc>
-                <a:tc>
-                  <a:txBody>
-                    <a:bodyPr wrap="square"/>
-                    <a:lstStyle/>
-                    <a:p>
-                      <a:pPr algn="r"/>
-                      <a:r>
-                        <a:rPr sz="1150" b="1">
-                          <a:solidFill>
-                            <a:srgbClr val="333333"/>
-                          </a:solidFill>
-                        </a:rPr>
-                        <a:t>4.73</a:t>
-                      </a:r>
-                    </a:p>
-                  </a:txBody>
-                  <a:tcPr marL="54864" marR="54864" marT="27432" marB="27432" anchor="ctr">
-                    <a:lnL w="0">
-                      <a:noFill/>
-                    </a:lnL>
-                    <a:lnR w="0">
-                      <a:noFill/>
-                    </a:lnR>
-                    <a:lnT w="0">
-                      <a:noFill/>
-                    </a:lnT>
-                    <a:lnB w="6350">
-                      <a:solidFill>
-                        <a:srgbClr val="D9D3E3"/>
-                      </a:solidFill>
-                    </a:lnB>
-                    <a:solidFill>
-                      <a:srgbClr val="FFFFFF"/>
-                    </a:solidFill>
-                  </a:tcPr>
-                </a:tc>
-                <a:tc>
-                  <a:txBody>
-                    <a:bodyPr wrap="square"/>
-                    <a:lstStyle/>
-                    <a:p>
-                      <a:pPr algn="r"/>
-                      <a:r>
-                        <a:rPr sz="1150" b="1">
-                          <a:solidFill>
-                            <a:srgbClr val="333333"/>
-                          </a:solidFill>
-                        </a:rPr>
-                        <a:t>0.54</a:t>
-                      </a:r>
-                    </a:p>
-                  </a:txBody>
-                  <a:tcPr marL="54864" marR="54864" marT="27432" marB="27432" anchor="ctr">
-                    <a:lnL w="0">
-                      <a:noFill/>
-                    </a:lnL>
-                    <a:lnR w="0">
-                      <a:noFill/>
-                    </a:lnR>
-                    <a:lnT w="0">
-                      <a:noFill/>
-                    </a:lnT>
-                    <a:lnB w="6350">
-                      <a:solidFill>
-                        <a:srgbClr val="D9D3E3"/>
-                      </a:solidFill>
-                    </a:lnB>
-                    <a:solidFill>
-                      <a:srgbClr val="FFFFFF"/>
-                    </a:solidFill>
-                  </a:tcPr>
-                </a:tc>
-                <a:tc>
-                  <a:txBody>
-                    <a:bodyPr wrap="square"/>
-                    <a:lstStyle/>
-                    <a:p>
-                      <a:pPr algn="r"/>
-                      <a:r>
-                        <a:rPr sz="1150" b="0">
+                        <a:rPr sz="1100" b="0">
                           <a:solidFill>
                             <a:srgbClr val="333333"/>
                           </a:solidFill>
@@ -46996,13 +46758,51 @@
       </p:graphicFrame>
       <p:sp>
         <p:nvSpPr>
-          <p:cNvPr id="5" name="TextBox 4"/>
+          <p:cNvPr id="6" name="TextBox 5"/>
           <p:cNvSpPr txBox="1"/>
           <p:nvPr/>
         </p:nvSpPr>
         <p:spPr>
           <a:xfrm>
-            <a:off x="365760" y="3246120"/>
+            <a:off x="365760" y="3429000"/>
+            <a:ext cx="8412480" cy="274320"/>
+          </a:xfrm>
+          <a:prstGeom prst="rect">
+            <a:avLst/>
+          </a:prstGeom>
+          <a:noFill/>
+        </p:spPr>
+        <p:txBody>
+          <a:bodyPr wrap="square" anchor="t" lIns="0" rIns="0" tIns="0" bIns="0">
+            <a:spAutoFit/>
+          </a:bodyPr>
+          <a:lstStyle/>
+          <a:p>
+            <a:pPr algn="l">
+              <a:spcAft>
+                <a:spcPts val="0"/>
+              </a:spcAft>
+            </a:pPr>
+            <a:r>
+              <a:rPr sz="950" b="0" i="1">
+                <a:solidFill>
+                  <a:srgbClr val="6B6B6B"/>
+                </a:solidFill>
+              </a:rPr>
+              <a:t>Loss = each track's own training loss on the 153 test days. Lower is better, except sparsity (closer to the solver's 1.79). Shaded = better.</a:t>
+            </a:r>
+          </a:p>
+        </p:txBody>
+      </p:sp>
+      <p:sp>
+        <p:nvSpPr>
+          <p:cNvPr id="7" name="TextBox 6"/>
+          <p:cNvSpPr txBox="1"/>
+          <p:nvPr/>
+        </p:nvSpPr>
+        <p:spPr>
+          <a:xfrm>
+            <a:off x="365760" y="3794760"/>
             <a:ext cx="8412480" cy="365760"/>
           </a:xfrm>
           <a:prstGeom prst="rect">

</xml_diff>

<commit_message>
deck: slide 18 uses the cheapest shape's price (245); re-solves add half sigma
</commit_message>
<xml_diff>
--- a/slides/DEM_deck_v2.pptx
+++ b/slides/DEM_deck_v2.pptx
@@ -1359,7 +1359,7 @@
           <a:lstStyle/>
           <a:p>
             <a:r>
-              <a:t>[2 min] Why does the loss drop it? The solver's band is a rule; ours is a price: sparsity plus mu times the band penalty, with mu = 1. The response table: a unit of warm plasma lights 171, 193 and 211 A by tens of DN/s, so it has to be in the DEM anyway and its 94 A comes free. A unit of hot plasma lights no channel by more than 0.4 DN/s, so a bright 94 A reading needs hundreds of units, all paid by the sparsity term. The worked example at a typical flare core: putting the hot plasma in costs 616, leaving it out costs 85, so the best answer leaves it out. At mu = 100 leaving it out costs 8,500 and the plasma goes back in. If asked: one unit is 10^26 cm^-5 of emission measure, the DEM's own unit; the plasma is never measured, AIA measures DN/s and R is a fixed table; the full response per unit, warm (logT 6.0 to 6.1): 94 A 0.2, 131 A 0.5 to 1.2, 171 A 36 to 95, 193 A 29 to 55, 211 A 5 to 7, 335 A 0.4; hot (logT 6.9): 0.266, 0.40, 0.05, 0.34, 0.08, 0.05; the band itself is sound, the noise follows photon counting; brighter pixels draw more of their 94 A from hot plasma, which is why the share dropped grows with brightness: the best answer reproduces 91% at 1 to 1.8x the Bright level, 44% at 10 to 32x, 26% at flare cores.</a:t>
+              <a:t>[2 min] Why does the loss drop it? The solver's band is a rule; ours is a price: sparsity plus mu times the band penalty, with mu = 1. The response table: a unit of warm plasma lights 171, 193 and 211 A by tens of DN/s, so it has to be in the DEM anyway and its 94 A comes free. A unit of hot plasma lights no channel by more than 0.4 DN/s, so a bright 94 A reading needs hundreds of units, all paid by the sparsity term. The worked example at a typical flare core: putting the hot plasma in costs 245 by the cheapest shape (616 as a single spike), leaving it out costs 85, so the best answer leaves it out. At mu = 100 leaving it out costs 8,500 and the plasma goes back in. If asked: one unit is 10^26 cm^-5 of emission measure, the DEM's own unit; the plasma is never measured, AIA measures DN/s and R is a fixed table; the full response per unit, warm (logT 6.0 to 6.1): 94 A 0.2, 131 A 0.5 to 1.2, 171 A 36 to 95, 193 A 29 to 55, 211 A 5 to 7, 335 A 0.4; hot (logT 6.9): 0.266, 0.40, 0.05, 0.34, 0.08, 0.05; the band itself is sound, the noise follows photon counting; brighter pixels draw more of their 94 A from hot plasma, which is why the share dropped grows with brightness: the best answer reproduces 91% at 1 to 1.8x the Bright level, 44% at 10 to 32x, 26% at flare cores.</a:t>
             </a:r>
           </a:p>
         </p:txBody>
@@ -2519,7 +2519,7 @@
           <a:lstStyle/>
           <a:p>
             <a:r>
-              <a:t>[1.5 min] Two years of full-disk AIA, 1,223 images, deconvolved, with a noise sigma per pixel and channel, split in time: train to June 2015, validation to September, test to December, so every test image is later than anything trained on. Training sees AIA and sigma only, with fresh pixels every epoch. Solver DEMs exist for every image: labels for the supervised model, evaluation only for us. We score on the supervised side's protocol: 153 test days, the same pixels and the same Bright cutoffs, five solver targets per image. Scores: DEM against the solver, AIA reconstruction against the observation, and, because the error is heavy-tailed, medians and percentiles. If asked: each image keeps a random 64 of its 256 blocks, chosen once; every epoch takes 512 fresh pixels from each, 30M in all. The noisy targets come from adding Gaussian noise of size sigma to the AIA before the solve; the input stays the clean AIA, so they measure the solver's own scatter, the same floor for both models. About 800M pixel-targets per solver, 705M where BP returned an answer. Pixels where deconvolution clamped a bright channel to zero, about 5%, are left out of training only. Off-disk corona pixels are real data and are used. Runs before October reused one fixed 30M-pixel sample through a seeding bug, fixed since.</a:t>
+              <a:t>[1.5 min] Two years of full-disk AIA, 1,223 images, deconvolved, with a noise sigma per pixel and channel, split in time: train to June 2015, validation to September, test to December, so every test image is later than anything trained on. Training sees AIA and sigma only, with fresh pixels every epoch. Solver DEMs exist for every image: labels for the supervised model, evaluation only for us. We score on the supervised side's protocol: 153 test days, the same pixels and the same Bright cutoffs, five solver targets per image. Scores: DEM against the solver, AIA reconstruction against the observation, and, because the error is heavy-tailed, medians and percentiles. If asked: each image keeps a random 64 of its 256 blocks, chosen once; every epoch takes 512 fresh pixels from each, 30M in all. The noisy targets come from adding Gaussian noise of half sigma to the AIA before the solve; the input stays the clean AIA, so they measure the solver's own scatter, the same floor for both models. About 800M pixel-targets per solver, 705M where BP returned an answer. Pixels where deconvolution clamped a bright channel to zero, about 5%, are left out of training only. Off-disk corona pixels are real data and are used. Runs before October reused one fixed 30M-pixel sample through a seeding bug, fixed since.</a:t>
             </a:r>
           </a:p>
         </p:txBody>
@@ -16792,7 +16792,7 @@
                             <a:srgbClr val="333333"/>
                           </a:solidFill>
                         </a:rPr>
-                        <a:t>Hot plasma in: 164 ÷ 0.266 ≈ 616 units</a:t>
+                        <a:t>Hot plasma in, cheapest shape: 164 ÷ 0.67 ≈ 245 units</a:t>
                       </a:r>
                     </a:p>
                   </a:txBody>
@@ -16828,7 +16828,7 @@
                             <a:srgbClr val="333333"/>
                           </a:solidFill>
                         </a:rPr>
-                        <a:t>616</a:t>
+                        <a:t>245</a:t>
                       </a:r>
                     </a:p>
                   </a:txBody>
@@ -16900,7 +16900,7 @@
                             <a:srgbClr val="333333"/>
                           </a:solidFill>
                         </a:rPr>
-                        <a:t>616</a:t>
+                        <a:t>245</a:t>
                       </a:r>
                     </a:p>
                   </a:txBody>
@@ -17188,7 +17188,7 @@
                   <a:srgbClr val="333333"/>
                 </a:solidFill>
               </a:rPr>
-              <a:t>Leaving it out costs 85; putting it in costs 616. The best answer leaves it out.</a:t>
+              <a:t>Leaving it out costs 85; putting it in costs at least 245. The best answer leaves it out.</a:t>
             </a:r>
           </a:p>
           <a:p>

</xml_diff>